<commit_message>
Fix PowerPoint 2013 "found a problem with content" on the budget deck
pptxgenjs wrote chart XML that PowerPoint 2013 rejects: the combo chart
on slide 8 gave its average line a bar-only label position (outEnd) and
a bar-only invertIfNegative element, left out the required <c:grouping>,
and put series children out of schema order. Every bar chart also
referenced a third axis that doesn't exist.

sanitize_charts.py now rewrites each chart to the strict chart schema
and, when CHART_XSD is set, fails the build if any chart is still
invalid. All six charts now validate. The embedded Excel table's
picture also gets its own shape id instead of sharing the frame's.

Co-Authored-By: Claude Opus 5.5 <noreply@anthropic.com>
Claude-Session: https://claude.ai/code/session_01WToQxHdrdWhM7bKqXvUa59
</commit_message>
<xml_diff>
--- a/marketing-budget/Marketing_Department_Budget.pptx
+++ b/marketing-budget/Marketing_Department_Budget.pptx
@@ -565,7 +565,6 @@
         <c:overlap val="0"/>
         <c:axId val="2094734554"/>
         <c:axId val="2094734552"/>
-        <c:axId val="2094734556"/>
       </c:barChart>
       <c:catAx>
         <c:axId val="2094734554"/>
@@ -824,7 +823,6 @@
         <c:overlap val="0"/>
         <c:axId val="2094734554"/>
         <c:axId val="2094734552"/>
-        <c:axId val="2094734556"/>
       </c:barChart>
       <c:catAx>
         <c:axId val="2094734554"/>
@@ -1083,7 +1081,6 @@
         <c:overlap val="0"/>
         <c:axId val="2094734554"/>
         <c:axId val="2094734552"/>
-        <c:axId val="2094734556"/>
       </c:barChart>
       <c:catAx>
         <c:axId val="2094734554"/>
@@ -1342,7 +1339,6 @@
         <c:overlap val="0"/>
         <c:axId val="2094734554"/>
         <c:axId val="2094734552"/>
-        <c:axId val="2094734556"/>
       </c:barChart>
       <c:catAx>
         <c:axId val="2094734554"/>
@@ -1481,31 +1477,6 @@
             <a:effectLst/>
           </c:spPr>
           <c:invertIfNegative val="0"/>
-          <c:dLbls>
-            <c:numFmt formatCode="$#,##0" sourceLinked="0"/>
-            <c:txPr>
-              <a:bodyPr/>
-              <a:lstStyle/>
-              <a:p>
-                <a:pPr>
-                  <a:defRPr b="1" i="0" strike="noStrike" sz="1200" u="none">
-                    <a:solidFill>
-                      <a:srgbClr val="1B2436"/>
-                    </a:solidFill>
-                    <a:latin typeface="Arial"/>
-                  </a:defRPr>
-                </a:pPr>
-              </a:p>
-            </c:txPr>
-            <c:dLblPos val="outEnd"/>
-            <c:showLegendKey val="0"/>
-            <c:showVal val="1"/>
-            <c:showCatName val="0"/>
-            <c:showSerName val="0"/>
-            <c:showPercent val="0"/>
-            <c:showBubbleSize val="0"/>
-            <c:showLeaderLines val="0"/>
-          </c:dLbls>
           <c:dPt>
             <c:idx val="0"/>
             <c:invertIfNegative val="0"/>
@@ -1550,6 +1521,31 @@
               <a:effectLst/>
             </c:spPr>
           </c:dPt>
+          <c:dLbls>
+            <c:numFmt formatCode="$#,##0" sourceLinked="0"/>
+            <c:txPr>
+              <a:bodyPr/>
+              <a:lstStyle/>
+              <a:p>
+                <a:pPr>
+                  <a:defRPr b="1" i="0" strike="noStrike" sz="1200" u="none">
+                    <a:solidFill>
+                      <a:srgbClr val="1B2436"/>
+                    </a:solidFill>
+                    <a:latin typeface="Arial"/>
+                  </a:defRPr>
+                </a:pPr>
+              </a:p>
+            </c:txPr>
+            <c:dLblPos val="outEnd"/>
+            <c:showLegendKey val="0"/>
+            <c:showVal val="1"/>
+            <c:showCatName val="0"/>
+            <c:showSerName val="0"/>
+            <c:showPercent val="0"/>
+            <c:showBubbleSize val="0"/>
+            <c:showLeaderLines val="0"/>
+          </c:dLbls>
           <c:cat>
             <c:multiLvlStrRef>
               <c:f>Sheet1!$A$2:$A$5</c:f>
@@ -1623,9 +1619,9 @@
         <c:overlap val="0"/>
         <c:axId val="2094734554"/>
         <c:axId val="2094734552"/>
-        <c:axId val="2094734556"/>
       </c:barChart>
       <c:lineChart>
+        <c:grouping val="standard"/>
         <c:varyColors val="0"/>
         <c:ser>
           <c:idx val="1"/>
@@ -1654,7 +1650,23 @@
             </a:ln>
             <a:effectLst/>
           </c:spPr>
-          <c:invertIfNegative val="0"/>
+          <c:marker>
+            <c:symbol val="none"/>
+            <c:size val="6"/>
+            <c:spPr>
+              <a:solidFill>
+                <a:srgbClr val="1B2436"/>
+              </a:solidFill>
+              <a:ln w="9525" cap="flat">
+                <a:solidFill>
+                  <a:srgbClr val="1B2436"/>
+                </a:solidFill>
+                <a:prstDash val="solid"/>
+                <a:round/>
+              </a:ln>
+              <a:effectLst/>
+            </c:spPr>
+          </c:marker>
           <c:dLbls>
             <c:numFmt formatCode="$#,##0" sourceLinked="0"/>
             <c:txPr>
@@ -1671,7 +1683,6 @@
                 </a:pPr>
               </a:p>
             </c:txPr>
-            <c:dLblPos val="outEnd"/>
             <c:showLegendKey val="0"/>
             <c:showVal val="0"/>
             <c:showCatName val="0"/>
@@ -1680,23 +1691,6 @@
             <c:showBubbleSize val="0"/>
             <c:showLeaderLines val="0"/>
           </c:dLbls>
-          <c:marker>
-            <c:symbol val="none"/>
-            <c:size val="6"/>
-            <c:spPr>
-              <a:solidFill>
-                <a:srgbClr val="1B2436"/>
-              </a:solidFill>
-              <a:ln w="9525" cap="flat">
-                <a:solidFill>
-                  <a:srgbClr val="1B2436"/>
-                </a:solidFill>
-                <a:prstDash val="solid"/>
-                <a:round/>
-              </a:ln>
-              <a:effectLst/>
-            </c:spPr>
-          </c:marker>
           <c:cat>
             <c:multiLvlStrRef>
               <c:f>Sheet1!$A$2:$A$5</c:f>
@@ -1758,7 +1752,6 @@
               </a:pPr>
             </a:p>
           </c:txPr>
-          <c:dLblPos val="outEnd"/>
           <c:showLegendKey val="0"/>
           <c:showVal val="0"/>
           <c:showCatName val="0"/>
@@ -1770,7 +1763,6 @@
         <c:marker val="1"/>
         <c:axId val="2094734554"/>
         <c:axId val="2094734552"/>
-        <c:axId val="2094734556"/>
       </c:lineChart>
       <c:catAx>
         <c:axId val="2094734554"/>
@@ -8122,7 +8114,7 @@
               <p:embed/>
               <p:pic>
                 <p:nvPicPr>
-                  <p:cNvPr id="9" name="Excel Budget Table"/>
+                  <p:cNvPr id="10" name="Excel Budget Table picture"/>
                   <p:cNvPicPr/>
                   <p:nvPr/>
                 </p:nvPicPr>

</xml_diff>

<commit_message>
Use one simple font and fewer text colours in the budget deck
Every slide now uses Arial only (the font of the embedded Excel table),
in regular and bold: no Garamond, italics or text shadows. Text is
black, slide titles and rules are dark blue, and all boxes share one
light fill. Colour otherwise appears only in the charts, one per unit.
The doughnut's percentages now sit in its legend instead of on the
ring.

Co-Authored-By: Claude Opus 5.5 <noreply@anthropic.com>
Claude-Session: https://claude.ai/code/session_01WToQxHdrdWhM7bKqXvUa59
</commit_message>
<xml_diff>
--- a/marketing-budget/Marketing_Department_Budget.pptx
+++ b/marketing-budget/Marketing_Department_Budget.pptx
@@ -223,18 +223,18 @@
           <c:dLbls>
             <c:dLbl>
               <c:idx val="0"/>
-              <c:numFmt formatCode="0.0%" sourceLinked="0"/>
+              <c:numFmt formatCode="General" sourceLinked="0"/>
               <c:spPr/>
               <c:txPr>
                 <a:bodyPr/>
                 <a:lstStyle/>
                 <a:p>
                   <a:pPr>
-                    <a:defRPr sz="1400" b="1" i="0" u="none" strike="noStrike">
+                    <a:defRPr sz="1200" b="0" i="0" u="none" strike="noStrike">
                       <a:solidFill>
-                        <a:srgbClr val="FFFFFF"/>
+                        <a:srgbClr val="000000"/>
                       </a:solidFill>
-                      <a:latin typeface="Garamond"/>
+                      <a:latin typeface="Arial"/>
                     </a:defRPr>
                   </a:pPr>
                 </a:p>
@@ -243,23 +243,23 @@
               <c:showVal val="0"/>
               <c:showCatName val="0"/>
               <c:showSerName val="0"/>
-              <c:showPercent val="1"/>
+              <c:showPercent val="0"/>
               <c:showBubbleSize val="0"/>
             </c:dLbl>
             <c:dLbl>
               <c:idx val="1"/>
-              <c:numFmt formatCode="0.0%" sourceLinked="0"/>
+              <c:numFmt formatCode="General" sourceLinked="0"/>
               <c:spPr/>
               <c:txPr>
                 <a:bodyPr/>
                 <a:lstStyle/>
                 <a:p>
                   <a:pPr>
-                    <a:defRPr sz="1400" b="1" i="0" u="none" strike="noStrike">
+                    <a:defRPr sz="1200" b="0" i="0" u="none" strike="noStrike">
                       <a:solidFill>
-                        <a:srgbClr val="FFFFFF"/>
+                        <a:srgbClr val="000000"/>
                       </a:solidFill>
-                      <a:latin typeface="Garamond"/>
+                      <a:latin typeface="Arial"/>
                     </a:defRPr>
                   </a:pPr>
                 </a:p>
@@ -268,23 +268,23 @@
               <c:showVal val="0"/>
               <c:showCatName val="0"/>
               <c:showSerName val="0"/>
-              <c:showPercent val="1"/>
+              <c:showPercent val="0"/>
               <c:showBubbleSize val="0"/>
             </c:dLbl>
             <c:dLbl>
               <c:idx val="2"/>
-              <c:numFmt formatCode="0.0%" sourceLinked="0"/>
+              <c:numFmt formatCode="General" sourceLinked="0"/>
               <c:spPr/>
               <c:txPr>
                 <a:bodyPr/>
                 <a:lstStyle/>
                 <a:p>
                   <a:pPr>
-                    <a:defRPr sz="1400" b="1" i="0" u="none" strike="noStrike">
+                    <a:defRPr sz="1200" b="0" i="0" u="none" strike="noStrike">
                       <a:solidFill>
-                        <a:srgbClr val="FFFFFF"/>
+                        <a:srgbClr val="000000"/>
                       </a:solidFill>
-                      <a:latin typeface="Garamond"/>
+                      <a:latin typeface="Arial"/>
                     </a:defRPr>
                   </a:pPr>
                 </a:p>
@@ -293,23 +293,23 @@
               <c:showVal val="0"/>
               <c:showCatName val="0"/>
               <c:showSerName val="0"/>
-              <c:showPercent val="1"/>
+              <c:showPercent val="0"/>
               <c:showBubbleSize val="0"/>
             </c:dLbl>
             <c:dLbl>
               <c:idx val="3"/>
-              <c:numFmt formatCode="0.0%" sourceLinked="0"/>
+              <c:numFmt formatCode="General" sourceLinked="0"/>
               <c:spPr/>
               <c:txPr>
                 <a:bodyPr/>
                 <a:lstStyle/>
                 <a:p>
                   <a:pPr>
-                    <a:defRPr sz="1400" b="1" i="0" u="none" strike="noStrike">
+                    <a:defRPr sz="1200" b="0" i="0" u="none" strike="noStrike">
                       <a:solidFill>
-                        <a:srgbClr val="FFFFFF"/>
+                        <a:srgbClr val="000000"/>
                       </a:solidFill>
-                      <a:latin typeface="Garamond"/>
+                      <a:latin typeface="Arial"/>
                     </a:defRPr>
                   </a:pPr>
                 </a:p>
@@ -318,16 +318,16 @@
               <c:showVal val="0"/>
               <c:showCatName val="0"/>
               <c:showSerName val="0"/>
-              <c:showPercent val="1"/>
+              <c:showPercent val="0"/>
               <c:showBubbleSize val="0"/>
             </c:dLbl>
-            <c:numFmt formatCode="0.0%" sourceLinked="0"/>
+            <c:numFmt formatCode="General" sourceLinked="0"/>
             <c:txPr>
               <a:bodyPr/>
               <a:lstStyle/>
               <a:p>
                 <a:pPr>
-                  <a:defRPr sz="1800" b="1" i="0" u="none" strike="noStrike">
+                  <a:defRPr sz="1800" b="0" i="0" u="none" strike="noStrike">
                     <a:solidFill>
                       <a:srgbClr val="000000"/>
                     </a:solidFill>
@@ -452,11 +452,11 @@
               <a:lstStyle/>
               <a:p>
                 <a:pPr>
-                  <a:defRPr b="1" i="0" strike="noStrike" sz="1400" u="none">
+                  <a:defRPr b="1" i="0" strike="noStrike" sz="1200" u="none">
                     <a:solidFill>
-                      <a:srgbClr val="262626"/>
+                      <a:srgbClr val="000000"/>
                     </a:solidFill>
-                    <a:latin typeface="Garamond"/>
+                    <a:latin typeface="Arial"/>
                   </a:defRPr>
                 </a:pPr>
               </a:p>
@@ -544,11 +544,11 @@
             <a:lstStyle/>
             <a:p>
               <a:pPr>
-                <a:defRPr b="1" i="0" strike="noStrike" sz="1400" u="none">
+                <a:defRPr b="1" i="0" strike="noStrike" sz="1200" u="none">
                   <a:solidFill>
-                    <a:srgbClr val="262626"/>
+                    <a:srgbClr val="000000"/>
                   </a:solidFill>
-                  <a:latin typeface="Garamond"/>
+                  <a:latin typeface="Arial"/>
                 </a:defRPr>
               </a:pPr>
             </a:p>
@@ -589,11 +589,11 @@
           <a:lstStyle/>
           <a:p>
             <a:pPr>
-              <a:defRPr sz="1400" b="0" i="0" u="none" strike="noStrike">
-                <a:solidFill>
-                  <a:srgbClr val="262626"/>
-                </a:solidFill>
-                <a:latin typeface="Garamond"/>
+              <a:defRPr sz="1200" b="0" i="0" u="none" strike="noStrike">
+                <a:solidFill>
+                  <a:srgbClr val="000000"/>
+                </a:solidFill>
+                <a:latin typeface="Arial"/>
               </a:defRPr>
             </a:pPr>
             <a:endParaRPr lang="en-US"/>
@@ -710,11 +710,11 @@
               <a:lstStyle/>
               <a:p>
                 <a:pPr>
-                  <a:defRPr b="1" i="0" strike="noStrike" sz="1400" u="none">
+                  <a:defRPr b="1" i="0" strike="noStrike" sz="1200" u="none">
                     <a:solidFill>
-                      <a:srgbClr val="262626"/>
+                      <a:srgbClr val="000000"/>
                     </a:solidFill>
-                    <a:latin typeface="Garamond"/>
+                    <a:latin typeface="Arial"/>
                   </a:defRPr>
                 </a:pPr>
               </a:p>
@@ -802,11 +802,11 @@
             <a:lstStyle/>
             <a:p>
               <a:pPr>
-                <a:defRPr b="1" i="0" strike="noStrike" sz="1400" u="none">
+                <a:defRPr b="1" i="0" strike="noStrike" sz="1200" u="none">
                   <a:solidFill>
-                    <a:srgbClr val="262626"/>
+                    <a:srgbClr val="000000"/>
                   </a:solidFill>
-                  <a:latin typeface="Garamond"/>
+                  <a:latin typeface="Arial"/>
                 </a:defRPr>
               </a:pPr>
             </a:p>
@@ -847,11 +847,11 @@
           <a:lstStyle/>
           <a:p>
             <a:pPr>
-              <a:defRPr sz="1400" b="0" i="0" u="none" strike="noStrike">
-                <a:solidFill>
-                  <a:srgbClr val="262626"/>
-                </a:solidFill>
-                <a:latin typeface="Garamond"/>
+              <a:defRPr sz="1200" b="0" i="0" u="none" strike="noStrike">
+                <a:solidFill>
+                  <a:srgbClr val="000000"/>
+                </a:solidFill>
+                <a:latin typeface="Arial"/>
               </a:defRPr>
             </a:pPr>
             <a:endParaRPr lang="en-US"/>
@@ -968,11 +968,11 @@
               <a:lstStyle/>
               <a:p>
                 <a:pPr>
-                  <a:defRPr b="1" i="0" strike="noStrike" sz="1400" u="none">
+                  <a:defRPr b="1" i="0" strike="noStrike" sz="1200" u="none">
                     <a:solidFill>
-                      <a:srgbClr val="262626"/>
+                      <a:srgbClr val="000000"/>
                     </a:solidFill>
-                    <a:latin typeface="Garamond"/>
+                    <a:latin typeface="Arial"/>
                   </a:defRPr>
                 </a:pPr>
               </a:p>
@@ -1060,11 +1060,11 @@
             <a:lstStyle/>
             <a:p>
               <a:pPr>
-                <a:defRPr b="1" i="0" strike="noStrike" sz="1400" u="none">
+                <a:defRPr b="1" i="0" strike="noStrike" sz="1200" u="none">
                   <a:solidFill>
-                    <a:srgbClr val="262626"/>
+                    <a:srgbClr val="000000"/>
                   </a:solidFill>
-                  <a:latin typeface="Garamond"/>
+                  <a:latin typeface="Arial"/>
                 </a:defRPr>
               </a:pPr>
             </a:p>
@@ -1105,11 +1105,11 @@
           <a:lstStyle/>
           <a:p>
             <a:pPr>
-              <a:defRPr sz="1400" b="0" i="0" u="none" strike="noStrike">
-                <a:solidFill>
-                  <a:srgbClr val="262626"/>
-                </a:solidFill>
-                <a:latin typeface="Garamond"/>
+              <a:defRPr sz="1200" b="0" i="0" u="none" strike="noStrike">
+                <a:solidFill>
+                  <a:srgbClr val="000000"/>
+                </a:solidFill>
+                <a:latin typeface="Arial"/>
               </a:defRPr>
             </a:pPr>
             <a:endParaRPr lang="en-US"/>
@@ -1226,11 +1226,11 @@
               <a:lstStyle/>
               <a:p>
                 <a:pPr>
-                  <a:defRPr b="1" i="0" strike="noStrike" sz="1400" u="none">
+                  <a:defRPr b="1" i="0" strike="noStrike" sz="1200" u="none">
                     <a:solidFill>
-                      <a:srgbClr val="262626"/>
+                      <a:srgbClr val="000000"/>
                     </a:solidFill>
-                    <a:latin typeface="Garamond"/>
+                    <a:latin typeface="Arial"/>
                   </a:defRPr>
                 </a:pPr>
               </a:p>
@@ -1318,11 +1318,11 @@
             <a:lstStyle/>
             <a:p>
               <a:pPr>
-                <a:defRPr b="1" i="0" strike="noStrike" sz="1400" u="none">
+                <a:defRPr b="1" i="0" strike="noStrike" sz="1200" u="none">
                   <a:solidFill>
-                    <a:srgbClr val="262626"/>
+                    <a:srgbClr val="000000"/>
                   </a:solidFill>
-                  <a:latin typeface="Garamond"/>
+                  <a:latin typeface="Arial"/>
                 </a:defRPr>
               </a:pPr>
             </a:p>
@@ -1363,11 +1363,11 @@
           <a:lstStyle/>
           <a:p>
             <a:pPr>
-              <a:defRPr sz="1400" b="0" i="0" u="none" strike="noStrike">
-                <a:solidFill>
-                  <a:srgbClr val="262626"/>
-                </a:solidFill>
-                <a:latin typeface="Garamond"/>
+              <a:defRPr sz="1200" b="0" i="0" u="none" strike="noStrike">
+                <a:solidFill>
+                  <a:srgbClr val="000000"/>
+                </a:solidFill>
+                <a:latin typeface="Arial"/>
               </a:defRPr>
             </a:pPr>
             <a:endParaRPr lang="en-US"/>
@@ -1528,11 +1528,11 @@
               <a:lstStyle/>
               <a:p>
                 <a:pPr>
-                  <a:defRPr b="1" i="0" strike="noStrike" sz="1400" u="none">
+                  <a:defRPr b="1" i="0" strike="noStrike" sz="1200" u="none">
                     <a:solidFill>
-                      <a:srgbClr val="262626"/>
+                      <a:srgbClr val="000000"/>
                     </a:solidFill>
-                    <a:latin typeface="Garamond"/>
+                    <a:latin typeface="Arial"/>
                   </a:defRPr>
                 </a:pPr>
               </a:p>
@@ -1597,11 +1597,11 @@
             <a:lstStyle/>
             <a:p>
               <a:pPr>
-                <a:defRPr b="1" i="0" strike="noStrike" sz="1400" u="none">
+                <a:defRPr b="1" i="0" strike="noStrike" sz="1200" u="none">
                   <a:solidFill>
-                    <a:srgbClr val="262626"/>
+                    <a:srgbClr val="000000"/>
                   </a:solidFill>
-                  <a:latin typeface="Garamond"/>
+                  <a:latin typeface="Arial"/>
                 </a:defRPr>
               </a:pPr>
             </a:p>
@@ -1639,11 +1639,11 @@
           </c:tx>
           <c:spPr>
             <a:solidFill>
-              <a:srgbClr val="1F3864"/>
+              <a:srgbClr val="000000"/>
             </a:solidFill>
             <a:ln w="25400" cap="flat">
               <a:solidFill>
-                <a:srgbClr val="1F3864"/>
+                <a:srgbClr val="000000"/>
               </a:solidFill>
               <a:prstDash val="dash"/>
               <a:round/>
@@ -1655,11 +1655,11 @@
             <c:size val="6"/>
             <c:spPr>
               <a:solidFill>
-                <a:srgbClr val="1F3864"/>
+                <a:srgbClr val="000000"/>
               </a:solidFill>
               <a:ln w="9525" cap="flat">
                 <a:solidFill>
-                  <a:srgbClr val="1F3864"/>
+                  <a:srgbClr val="000000"/>
                 </a:solidFill>
                 <a:prstDash val="solid"/>
                 <a:round/>
@@ -1674,11 +1674,11 @@
               <a:lstStyle/>
               <a:p>
                 <a:pPr>
-                  <a:defRPr b="1" i="0" strike="noStrike" sz="1400" u="none">
+                  <a:defRPr b="1" i="0" strike="noStrike" sz="1200" u="none">
                     <a:solidFill>
-                      <a:srgbClr val="262626"/>
+                      <a:srgbClr val="000000"/>
                     </a:solidFill>
-                    <a:latin typeface="Garamond"/>
+                    <a:latin typeface="Arial"/>
                   </a:defRPr>
                 </a:pPr>
               </a:p>
@@ -1744,11 +1744,11 @@
             <a:lstStyle/>
             <a:p>
               <a:pPr>
-                <a:defRPr b="1" i="0" strike="noStrike" sz="1400" u="none">
+                <a:defRPr b="1" i="0" strike="noStrike" sz="1200" u="none">
                   <a:solidFill>
-                    <a:srgbClr val="262626"/>
+                    <a:srgbClr val="000000"/>
                   </a:solidFill>
-                  <a:latin typeface="Garamond"/>
+                  <a:latin typeface="Arial"/>
                 </a:defRPr>
               </a:pPr>
             </a:p>
@@ -1791,11 +1791,11 @@
           <a:lstStyle/>
           <a:p>
             <a:pPr>
-              <a:defRPr sz="1500" b="0" i="0" u="none" strike="noStrike">
-                <a:solidFill>
-                  <a:srgbClr val="262626"/>
-                </a:solidFill>
-                <a:latin typeface="Garamond"/>
+              <a:defRPr sz="1300" b="0" i="0" u="none" strike="noStrike">
+                <a:solidFill>
+                  <a:srgbClr val="000000"/>
+                </a:solidFill>
+                <a:latin typeface="Arial"/>
               </a:defRPr>
             </a:pPr>
             <a:endParaRPr lang="en-US"/>
@@ -1843,11 +1843,11 @@
           <a:lstStyle/>
           <a:p>
             <a:pPr>
-              <a:defRPr sz="1300" b="0" i="0" u="none" strike="noStrike">
-                <a:solidFill>
-                  <a:srgbClr val="595959"/>
-                </a:solidFill>
-                <a:latin typeface="Garamond"/>
+              <a:defRPr sz="1200" b="0" i="0" u="none" strike="noStrike">
+                <a:solidFill>
+                  <a:srgbClr val="000000"/>
+                </a:solidFill>
+                <a:latin typeface="Arial"/>
               </a:defRPr>
             </a:pPr>
             <a:endParaRPr lang="en-US"/>
@@ -3409,24 +3409,61 @@
       </p:grpSpPr>
       <p:sp>
         <p:nvSpPr>
-          <p:cNvPr id="2" name="Shape 0"/>
+          <p:cNvPr id="2" name="Text 0"/>
+          <p:cNvSpPr txBox="1"/>
+          <p:nvPr/>
+        </p:nvSpPr>
+        <p:spPr>
+          <a:xfrm>
+            <a:off x="731520" y="1737360"/>
+            <a:ext cx="10728655" cy="868680"/>
+          </a:xfrm>
+          <a:prstGeom prst="rect">
+            <a:avLst/>
+          </a:prstGeom>
+          <a:noFill/>
+          <a:ln/>
+        </p:spPr>
+        <p:txBody>
+          <a:bodyPr wrap="square" lIns="0" tIns="0" rIns="0" bIns="0" rtlCol="0" anchor="ctr"/>
+          <a:lstStyle/>
+          <a:p>
+            <a:pPr algn="ctr" indent="0" marL="0">
+              <a:buNone/>
+            </a:pPr>
+            <a:r>
+              <a:rPr lang="en-US" sz="4400" b="1" dirty="0">
+                <a:solidFill>
+                  <a:srgbClr val="1F3864"/>
+                </a:solidFill>
+                <a:latin typeface="Arial" pitchFamily="34" charset="0"/>
+                <a:ea typeface="Arial" pitchFamily="34" charset="-122"/>
+                <a:cs typeface="Arial" pitchFamily="34" charset="-120"/>
+              </a:rPr>
+              <a:t>MARKETING DEPARTMENT</a:t>
+            </a:r>
+            <a:endParaRPr lang="en-US" sz="4400" dirty="0"/>
+          </a:p>
+        </p:txBody>
+      </p:sp>
+      <p:sp>
+        <p:nvSpPr>
+          <p:cNvPr id="3" name="Shape 1"/>
           <p:cNvSpPr/>
           <p:nvPr/>
         </p:nvSpPr>
         <p:spPr>
           <a:xfrm>
-            <a:off x="1097280" y="1600200"/>
-            <a:ext cx="9997135" cy="1325880"/>
-          </a:xfrm>
-          <a:prstGeom prst="rect">
-            <a:avLst/>
-          </a:prstGeom>
-          <a:solidFill>
-            <a:srgbClr val="F2F2F2"/>
-          </a:solidFill>
-          <a:ln w="12700">
+            <a:off x="2286000" y="2743200"/>
+            <a:ext cx="7619695" cy="0"/>
+          </a:xfrm>
+          <a:prstGeom prst="line">
+            <a:avLst/>
+          </a:prstGeom>
+          <a:noFill/>
+          <a:ln w="19050">
             <a:solidFill>
-              <a:srgbClr val="F2F2F2"/>
+              <a:srgbClr val="1F3864"/>
             </a:solidFill>
             <a:prstDash val="solid"/>
           </a:ln>
@@ -3434,14 +3471,14 @@
       </p:sp>
       <p:sp>
         <p:nvSpPr>
-          <p:cNvPr id="3" name="Shadow title"/>
+          <p:cNvPr id="4" name="Text 2"/>
           <p:cNvSpPr txBox="1"/>
           <p:nvPr/>
         </p:nvSpPr>
         <p:spPr>
           <a:xfrm>
-            <a:off x="1097280" y="1600200"/>
-            <a:ext cx="9997135" cy="1325880"/>
+            <a:off x="731520" y="2880360"/>
+            <a:ext cx="10728655" cy="640080"/>
           </a:xfrm>
           <a:prstGeom prst="rect">
             <a:avLst/>
@@ -3457,124 +3494,30 @@
               <a:buNone/>
             </a:pPr>
             <a:r>
-              <a:rPr lang="en-US" sz="4800" b="1" dirty="0">
-                <a:solidFill>
-                  <a:srgbClr val="1F3864"/>
-                </a:solidFill>
-                <a:effectLst>
-                  <a:outerShdw blurRad="38100" dist="38100" dir="2700000" algn="tl">
-                    <a:srgbClr val="000000">
-                      <a:alpha val="43137"/>
-                    </a:srgbClr>
-                  </a:outerShdw>
-                </a:effectLst>
-                <a:latin typeface="Garamond" pitchFamily="34" charset="0"/>
-                <a:ea typeface="Garamond" pitchFamily="34" charset="-122"/>
-                <a:cs typeface="Garamond" pitchFamily="34" charset="-120"/>
-              </a:rPr>
-              <a:t>MARKETING DEPARTMENT</a:t>
-            </a:r>
-            <a:endParaRPr lang="en-US" sz="4800" dirty="0"/>
+              <a:rPr lang="en-US" sz="3200" dirty="0">
+                <a:solidFill>
+                  <a:srgbClr val="000000"/>
+                </a:solidFill>
+                <a:latin typeface="Arial" pitchFamily="34" charset="0"/>
+                <a:ea typeface="Arial" pitchFamily="34" charset="-122"/>
+                <a:cs typeface="Arial" pitchFamily="34" charset="-120"/>
+              </a:rPr>
+              <a:t>Annual Budget 2026</a:t>
+            </a:r>
+            <a:endParaRPr lang="en-US" sz="3200" dirty="0"/>
           </a:p>
         </p:txBody>
       </p:sp>
       <p:sp>
         <p:nvSpPr>
-          <p:cNvPr id="4" name="Shape 2"/>
-          <p:cNvSpPr/>
-          <p:nvPr/>
-        </p:nvSpPr>
-        <p:spPr>
-          <a:xfrm>
-            <a:off x="1097280" y="3017520"/>
-            <a:ext cx="9997135" cy="0"/>
-          </a:xfrm>
-          <a:prstGeom prst="line">
-            <a:avLst/>
-          </a:prstGeom>
-          <a:noFill/>
-          <a:ln w="19050">
-            <a:solidFill>
-              <a:srgbClr val="2F5597"/>
-            </a:solidFill>
-            <a:prstDash val="solid"/>
-          </a:ln>
-        </p:spPr>
-      </p:sp>
-      <p:sp>
-        <p:nvSpPr>
-          <p:cNvPr id="5" name="Shape 3"/>
-          <p:cNvSpPr/>
-          <p:nvPr/>
-        </p:nvSpPr>
-        <p:spPr>
-          <a:xfrm>
-            <a:off x="1097280" y="3127248"/>
-            <a:ext cx="9997135" cy="822960"/>
-          </a:xfrm>
-          <a:prstGeom prst="rect">
-            <a:avLst/>
-          </a:prstGeom>
-          <a:solidFill>
-            <a:srgbClr val="DAE3F3"/>
-          </a:solidFill>
-          <a:ln w="12700">
-            <a:solidFill>
-              <a:srgbClr val="DAE3F3"/>
-            </a:solidFill>
-            <a:prstDash val="solid"/>
-          </a:ln>
-        </p:spPr>
-      </p:sp>
-      <p:sp>
-        <p:nvSpPr>
-          <p:cNvPr id="6" name="Text 4"/>
+          <p:cNvPr id="5" name="Text 3"/>
           <p:cNvSpPr txBox="1"/>
           <p:nvPr/>
         </p:nvSpPr>
         <p:spPr>
           <a:xfrm>
-            <a:off x="1097280" y="3127248"/>
-            <a:ext cx="9997135" cy="822960"/>
-          </a:xfrm>
-          <a:prstGeom prst="rect">
-            <a:avLst/>
-          </a:prstGeom>
-          <a:noFill/>
-          <a:ln/>
-        </p:spPr>
-        <p:txBody>
-          <a:bodyPr wrap="square" lIns="0" tIns="0" rIns="0" bIns="0" rtlCol="0" anchor="ctr"/>
-          <a:lstStyle/>
-          <a:p>
-            <a:pPr algn="ctr" indent="0" marL="0">
-              <a:buNone/>
-            </a:pPr>
-            <a:r>
-              <a:rPr lang="en-US" sz="3200" dirty="0">
-                <a:solidFill>
-                  <a:srgbClr val="262626"/>
-                </a:solidFill>
-                <a:latin typeface="Garamond" pitchFamily="34" charset="0"/>
-                <a:ea typeface="Garamond" pitchFamily="34" charset="-122"/>
-                <a:cs typeface="Garamond" pitchFamily="34" charset="-120"/>
-              </a:rPr>
-              <a:t>Annual Budget 2026</a:t>
-            </a:r>
-            <a:endParaRPr lang="en-US" sz="3200" dirty="0"/>
-          </a:p>
-        </p:txBody>
-      </p:sp>
-      <p:sp>
-        <p:nvSpPr>
-          <p:cNvPr id="7" name="Text 5"/>
-          <p:cNvSpPr txBox="1"/>
-          <p:nvPr/>
-        </p:nvSpPr>
-        <p:spPr>
-          <a:xfrm>
-            <a:off x="1097280" y="4160520"/>
-            <a:ext cx="9997135" cy="1143000"/>
+            <a:off x="914400" y="3931920"/>
+            <a:ext cx="10362895" cy="1005840"/>
           </a:xfrm>
           <a:prstGeom prst="rect">
             <a:avLst/>
@@ -3593,17 +3536,17 @@
               <a:buNone/>
             </a:pPr>
             <a:r>
-              <a:rPr lang="en-US" sz="2200" dirty="0">
-                <a:solidFill>
-                  <a:srgbClr val="262626"/>
-                </a:solidFill>
-                <a:latin typeface="Garamond" pitchFamily="34" charset="0"/>
-                <a:ea typeface="Garamond" pitchFamily="34" charset="-122"/>
-                <a:cs typeface="Garamond" pitchFamily="34" charset="-120"/>
+              <a:rPr lang="en-US" sz="2000" dirty="0">
+                <a:solidFill>
+                  <a:srgbClr val="000000"/>
+                </a:solidFill>
+                <a:latin typeface="Arial" pitchFamily="34" charset="0"/>
+                <a:ea typeface="Arial" pitchFamily="34" charset="-122"/>
+                <a:cs typeface="Arial" pitchFamily="34" charset="-120"/>
               </a:rPr>
               <a:t>How the department's budget is planned and shared across its four units:</a:t>
             </a:r>
-            <a:endParaRPr lang="en-US" sz="2200" dirty="0"/>
+            <a:endParaRPr lang="en-US" sz="2000" dirty="0"/>
           </a:p>
           <a:p>
             <a:pPr algn="ctr" indent="0" marL="0">
@@ -3613,30 +3556,30 @@
               <a:buNone/>
             </a:pPr>
             <a:r>
-              <a:rPr lang="en-US" sz="2200" b="1" dirty="0">
-                <a:solidFill>
-                  <a:srgbClr val="1F3864"/>
-                </a:solidFill>
-                <a:latin typeface="Garamond" pitchFamily="34" charset="0"/>
-                <a:ea typeface="Garamond" pitchFamily="34" charset="-122"/>
-                <a:cs typeface="Garamond" pitchFamily="34" charset="-120"/>
+              <a:rPr lang="en-US" sz="2000" b="1" dirty="0">
+                <a:solidFill>
+                  <a:srgbClr val="000000"/>
+                </a:solidFill>
+                <a:latin typeface="Arial" pitchFamily="34" charset="0"/>
+                <a:ea typeface="Arial" pitchFamily="34" charset="-122"/>
+                <a:cs typeface="Arial" pitchFamily="34" charset="-120"/>
               </a:rPr>
               <a:t>Advertising   •   Marketing   •   Public Relations   •   e-Business</a:t>
             </a:r>
-            <a:endParaRPr lang="en-US" sz="2200" dirty="0"/>
+            <a:endParaRPr lang="en-US" sz="2000" dirty="0"/>
           </a:p>
         </p:txBody>
       </p:sp>
       <p:sp>
         <p:nvSpPr>
-          <p:cNvPr id="8" name="Text 6"/>
+          <p:cNvPr id="6" name="Text 4"/>
           <p:cNvSpPr txBox="1"/>
           <p:nvPr/>
         </p:nvSpPr>
         <p:spPr>
           <a:xfrm>
-            <a:off x="1097280" y="5760720"/>
-            <a:ext cx="9997135" cy="365760"/>
+            <a:off x="731520" y="5760720"/>
+            <a:ext cx="10728655" cy="365760"/>
           </a:xfrm>
           <a:prstGeom prst="rect">
             <a:avLst/>
@@ -3652,17 +3595,17 @@
               <a:buNone/>
             </a:pPr>
             <a:r>
-              <a:rPr lang="en-US" sz="1600" i="1" dirty="0">
-                <a:solidFill>
-                  <a:srgbClr val="595959"/>
-                </a:solidFill>
-                <a:latin typeface="Garamond" pitchFamily="34" charset="0"/>
-                <a:ea typeface="Garamond" pitchFamily="34" charset="-122"/>
-                <a:cs typeface="Garamond" pitchFamily="34" charset="-120"/>
+              <a:rPr lang="en-US" sz="1400" dirty="0">
+                <a:solidFill>
+                  <a:srgbClr val="000000"/>
+                </a:solidFill>
+                <a:latin typeface="Arial" pitchFamily="34" charset="0"/>
+                <a:ea typeface="Arial" pitchFamily="34" charset="-122"/>
+                <a:cs typeface="Arial" pitchFamily="34" charset="-120"/>
               </a:rPr>
               <a:t>Amounts in US$  ·  Source: Marketing_Department_Budget.xlsx</a:t>
             </a:r>
-            <a:endParaRPr lang="en-US" sz="1600" dirty="0"/>
+            <a:endParaRPr lang="en-US" sz="1400" dirty="0"/>
           </a:p>
         </p:txBody>
       </p:sp>
@@ -3703,7 +3646,7 @@
         <p:spPr>
           <a:xfrm>
             <a:off x="731520" y="457200"/>
-            <a:ext cx="10728655" cy="777240"/>
+            <a:ext cx="10728655" cy="731520"/>
           </a:xfrm>
           <a:prstGeom prst="rect">
             <a:avLst/>
@@ -3719,17 +3662,17 @@
               <a:buNone/>
             </a:pPr>
             <a:r>
-              <a:rPr lang="en-US" sz="4000" dirty="0">
+              <a:rPr lang="en-US" sz="3600" b="1" dirty="0">
                 <a:solidFill>
                   <a:srgbClr val="1F3864"/>
                 </a:solidFill>
-                <a:latin typeface="Garamond" pitchFamily="34" charset="0"/>
-                <a:ea typeface="Garamond" pitchFamily="34" charset="-122"/>
-                <a:cs typeface="Garamond" pitchFamily="34" charset="-120"/>
+                <a:latin typeface="Arial" pitchFamily="34" charset="0"/>
+                <a:ea typeface="Arial" pitchFamily="34" charset="-122"/>
+                <a:cs typeface="Arial" pitchFamily="34" charset="-120"/>
               </a:rPr>
               <a:t>Budget at a Glance</a:t>
             </a:r>
-            <a:endParaRPr lang="en-US" sz="4000" dirty="0"/>
+            <a:endParaRPr lang="en-US" sz="3600" dirty="0"/>
           </a:p>
         </p:txBody>
       </p:sp>
@@ -3741,7 +3684,7 @@
         </p:nvSpPr>
         <p:spPr>
           <a:xfrm>
-            <a:off x="914400" y="1325880"/>
+            <a:off x="914400" y="1298448"/>
             <a:ext cx="10362895" cy="0"/>
           </a:xfrm>
           <a:prstGeom prst="line">
@@ -3750,7 +3693,7 @@
           <a:noFill/>
           <a:ln w="19050">
             <a:solidFill>
-              <a:srgbClr val="2F5597"/>
+              <a:srgbClr val="1F3864"/>
             </a:solidFill>
             <a:prstDash val="solid"/>
           </a:ln>
@@ -3781,13 +3724,13 @@
               <a:buNone/>
             </a:pPr>
             <a:r>
-              <a:rPr lang="en-US" sz="1800" i="1" dirty="0">
-                <a:solidFill>
-                  <a:srgbClr val="595959"/>
-                </a:solidFill>
-                <a:latin typeface="Garamond" pitchFamily="34" charset="0"/>
-                <a:ea typeface="Garamond" pitchFamily="34" charset="-122"/>
-                <a:cs typeface="Garamond" pitchFamily="34" charset="-120"/>
+              <a:rPr lang="en-US" sz="1800" dirty="0">
+                <a:solidFill>
+                  <a:srgbClr val="000000"/>
+                </a:solidFill>
+                <a:latin typeface="Arial" pitchFamily="34" charset="0"/>
+                <a:ea typeface="Arial" pitchFamily="34" charset="-122"/>
+                <a:cs typeface="Arial" pitchFamily="34" charset="-120"/>
               </a:rPr>
               <a:t>How the $890,000 department budget is shared across the four units</a:t>
             </a:r>
@@ -3810,11 +3753,11 @@
             <a:avLst/>
           </a:prstGeom>
           <a:solidFill>
-            <a:srgbClr val="DAE3F3"/>
+            <a:srgbClr val="DEEBF7"/>
           </a:solidFill>
           <a:ln w="12700">
             <a:solidFill>
-              <a:srgbClr val="DAE3F3"/>
+              <a:srgbClr val="DEEBF7"/>
             </a:solidFill>
             <a:prstDash val="solid"/>
           </a:ln>
@@ -3822,14 +3765,14 @@
       </p:sp>
       <p:sp>
         <p:nvSpPr>
-          <p:cNvPr id="6" name="Shadow figure"/>
+          <p:cNvPr id="6" name="Text 4"/>
           <p:cNvSpPr txBox="1"/>
           <p:nvPr/>
         </p:nvSpPr>
         <p:spPr>
           <a:xfrm>
-            <a:off x="822960" y="2194560"/>
-            <a:ext cx="3931920" cy="777240"/>
+            <a:off x="822960" y="2212848"/>
+            <a:ext cx="3931920" cy="731520"/>
           </a:xfrm>
           <a:prstGeom prst="rect">
             <a:avLst/>
@@ -3845,24 +3788,17 @@
               <a:buNone/>
             </a:pPr>
             <a:r>
-              <a:rPr lang="en-US" sz="4400" b="1" dirty="0">
-                <a:solidFill>
-                  <a:srgbClr val="1F3864"/>
-                </a:solidFill>
-                <a:effectLst>
-                  <a:outerShdw blurRad="38100" dist="38100" dir="2700000" algn="tl">
-                    <a:srgbClr val="000000">
-                      <a:alpha val="43137"/>
-                    </a:srgbClr>
-                  </a:outerShdw>
-                </a:effectLst>
-                <a:latin typeface="Garamond" pitchFamily="34" charset="0"/>
-                <a:ea typeface="Garamond" pitchFamily="34" charset="-122"/>
-                <a:cs typeface="Garamond" pitchFamily="34" charset="-120"/>
+              <a:rPr lang="en-US" sz="4000" b="1" dirty="0">
+                <a:solidFill>
+                  <a:srgbClr val="000000"/>
+                </a:solidFill>
+                <a:latin typeface="Arial" pitchFamily="34" charset="0"/>
+                <a:ea typeface="Arial" pitchFamily="34" charset="-122"/>
+                <a:cs typeface="Arial" pitchFamily="34" charset="-120"/>
               </a:rPr>
               <a:t>$890,000</a:t>
             </a:r>
-            <a:endParaRPr lang="en-US" sz="4400" dirty="0"/>
+            <a:endParaRPr lang="en-US" sz="4000" dirty="0"/>
           </a:p>
         </p:txBody>
       </p:sp>
@@ -3875,7 +3811,7 @@
         <p:spPr>
           <a:xfrm>
             <a:off x="822960" y="2999232"/>
-            <a:ext cx="3931920" cy="411480"/>
+            <a:ext cx="3931920" cy="384048"/>
           </a:xfrm>
           <a:prstGeom prst="rect">
             <a:avLst/>
@@ -3891,17 +3827,17 @@
               <a:buNone/>
             </a:pPr>
             <a:r>
-              <a:rPr lang="en-US" sz="2200" dirty="0">
-                <a:solidFill>
-                  <a:srgbClr val="262626"/>
-                </a:solidFill>
-                <a:latin typeface="Garamond" pitchFamily="34" charset="0"/>
-                <a:ea typeface="Garamond" pitchFamily="34" charset="-122"/>
-                <a:cs typeface="Garamond" pitchFamily="34" charset="-120"/>
+              <a:rPr lang="en-US" sz="2000" dirty="0">
+                <a:solidFill>
+                  <a:srgbClr val="000000"/>
+                </a:solidFill>
+                <a:latin typeface="Arial" pitchFamily="34" charset="0"/>
+                <a:ea typeface="Arial" pitchFamily="34" charset="-122"/>
+                <a:cs typeface="Arial" pitchFamily="34" charset="-120"/>
               </a:rPr>
               <a:t>Total department budget</a:t>
             </a:r>
-            <a:endParaRPr lang="en-US" sz="2200" dirty="0"/>
+            <a:endParaRPr lang="en-US" sz="2000" dirty="0"/>
           </a:p>
         </p:txBody>
       </p:sp>
@@ -3914,7 +3850,7 @@
         <p:spPr>
           <a:xfrm>
             <a:off x="822960" y="3401568"/>
-            <a:ext cx="3931920" cy="365760"/>
+            <a:ext cx="3931920" cy="347472"/>
           </a:xfrm>
           <a:prstGeom prst="rect">
             <a:avLst/>
@@ -3930,13 +3866,13 @@
               <a:buNone/>
             </a:pPr>
             <a:r>
-              <a:rPr lang="en-US" sz="1600" i="1" dirty="0">
-                <a:solidFill>
-                  <a:srgbClr val="595959"/>
-                </a:solidFill>
-                <a:latin typeface="Garamond" pitchFamily="34" charset="0"/>
-                <a:ea typeface="Garamond" pitchFamily="34" charset="-122"/>
-                <a:cs typeface="Garamond" pitchFamily="34" charset="-120"/>
+              <a:rPr lang="en-US" sz="1600" dirty="0">
+                <a:solidFill>
+                  <a:srgbClr val="000000"/>
+                </a:solidFill>
+                <a:latin typeface="Arial" pitchFamily="34" charset="0"/>
+                <a:ea typeface="Arial" pitchFamily="34" charset="-122"/>
+                <a:cs typeface="Arial" pitchFamily="34" charset="-120"/>
               </a:rPr>
               <a:t>Excel: =SUM(B13:E13)</a:t>
             </a:r>
@@ -3959,11 +3895,11 @@
             <a:avLst/>
           </a:prstGeom>
           <a:solidFill>
-            <a:srgbClr val="FBE5D6"/>
+            <a:srgbClr val="DEEBF7"/>
           </a:solidFill>
           <a:ln w="12700">
             <a:solidFill>
-              <a:srgbClr val="FBE5D6"/>
+              <a:srgbClr val="DEEBF7"/>
             </a:solidFill>
             <a:prstDash val="solid"/>
           </a:ln>
@@ -3971,14 +3907,14 @@
       </p:sp>
       <p:sp>
         <p:nvSpPr>
-          <p:cNvPr id="10" name="Shadow figure"/>
+          <p:cNvPr id="10" name="Text 8"/>
           <p:cNvSpPr txBox="1"/>
           <p:nvPr/>
         </p:nvSpPr>
         <p:spPr>
           <a:xfrm>
-            <a:off x="822960" y="4343400"/>
-            <a:ext cx="3931920" cy="777240"/>
+            <a:off x="822960" y="4361688"/>
+            <a:ext cx="3931920" cy="731520"/>
           </a:xfrm>
           <a:prstGeom prst="rect">
             <a:avLst/>
@@ -3994,24 +3930,17 @@
               <a:buNone/>
             </a:pPr>
             <a:r>
-              <a:rPr lang="en-US" sz="4400" b="1" dirty="0">
-                <a:solidFill>
-                  <a:srgbClr val="1F3864"/>
-                </a:solidFill>
-                <a:effectLst>
-                  <a:outerShdw blurRad="38100" dist="38100" dir="2700000" algn="tl">
-                    <a:srgbClr val="000000">
-                      <a:alpha val="43137"/>
-                    </a:srgbClr>
-                  </a:outerShdw>
-                </a:effectLst>
-                <a:latin typeface="Garamond" pitchFamily="34" charset="0"/>
-                <a:ea typeface="Garamond" pitchFamily="34" charset="-122"/>
-                <a:cs typeface="Garamond" pitchFamily="34" charset="-120"/>
+              <a:rPr lang="en-US" sz="4000" b="1" dirty="0">
+                <a:solidFill>
+                  <a:srgbClr val="000000"/>
+                </a:solidFill>
+                <a:latin typeface="Arial" pitchFamily="34" charset="0"/>
+                <a:ea typeface="Arial" pitchFamily="34" charset="-122"/>
+                <a:cs typeface="Arial" pitchFamily="34" charset="-120"/>
               </a:rPr>
               <a:t>$222,500</a:t>
             </a:r>
-            <a:endParaRPr lang="en-US" sz="4400" dirty="0"/>
+            <a:endParaRPr lang="en-US" sz="4000" dirty="0"/>
           </a:p>
         </p:txBody>
       </p:sp>
@@ -4024,7 +3953,7 @@
         <p:spPr>
           <a:xfrm>
             <a:off x="822960" y="5148072"/>
-            <a:ext cx="3931920" cy="411480"/>
+            <a:ext cx="3931920" cy="384048"/>
           </a:xfrm>
           <a:prstGeom prst="rect">
             <a:avLst/>
@@ -4040,17 +3969,17 @@
               <a:buNone/>
             </a:pPr>
             <a:r>
-              <a:rPr lang="en-US" sz="2200" dirty="0">
-                <a:solidFill>
-                  <a:srgbClr val="262626"/>
-                </a:solidFill>
-                <a:latin typeface="Garamond" pitchFamily="34" charset="0"/>
-                <a:ea typeface="Garamond" pitchFamily="34" charset="-122"/>
-                <a:cs typeface="Garamond" pitchFamily="34" charset="-120"/>
+              <a:rPr lang="en-US" sz="2000" dirty="0">
+                <a:solidFill>
+                  <a:srgbClr val="000000"/>
+                </a:solidFill>
+                <a:latin typeface="Arial" pitchFamily="34" charset="0"/>
+                <a:ea typeface="Arial" pitchFamily="34" charset="-122"/>
+                <a:cs typeface="Arial" pitchFamily="34" charset="-120"/>
               </a:rPr>
               <a:t>Average budget per unit</a:t>
             </a:r>
-            <a:endParaRPr lang="en-US" sz="2200" dirty="0"/>
+            <a:endParaRPr lang="en-US" sz="2000" dirty="0"/>
           </a:p>
         </p:txBody>
       </p:sp>
@@ -4063,7 +3992,7 @@
         <p:spPr>
           <a:xfrm>
             <a:off x="822960" y="5550408"/>
-            <a:ext cx="3931920" cy="365760"/>
+            <a:ext cx="3931920" cy="347472"/>
           </a:xfrm>
           <a:prstGeom prst="rect">
             <a:avLst/>
@@ -4079,13 +4008,13 @@
               <a:buNone/>
             </a:pPr>
             <a:r>
-              <a:rPr lang="en-US" sz="1600" i="1" dirty="0">
-                <a:solidFill>
-                  <a:srgbClr val="595959"/>
-                </a:solidFill>
-                <a:latin typeface="Garamond" pitchFamily="34" charset="0"/>
-                <a:ea typeface="Garamond" pitchFamily="34" charset="-122"/>
-                <a:cs typeface="Garamond" pitchFamily="34" charset="-120"/>
+              <a:rPr lang="en-US" sz="1600" dirty="0">
+                <a:solidFill>
+                  <a:srgbClr val="000000"/>
+                </a:solidFill>
+                <a:latin typeface="Arial" pitchFamily="34" charset="0"/>
+                <a:ea typeface="Arial" pitchFamily="34" charset="-122"/>
+                <a:cs typeface="Arial" pitchFamily="34" charset="-120"/>
               </a:rPr>
               <a:t>Excel: =AVERAGE(B13:E13)</a:t>
             </a:r>
@@ -4136,11 +4065,11 @@
             <a:r>
               <a:rPr lang="en-US" sz="1600" b="1" dirty="0">
                 <a:solidFill>
-                  <a:srgbClr val="595959"/>
-                </a:solidFill>
-                <a:latin typeface="Garamond" pitchFamily="34" charset="0"/>
-                <a:ea typeface="Garamond" pitchFamily="34" charset="-122"/>
-                <a:cs typeface="Garamond" pitchFamily="34" charset="-120"/>
+                  <a:srgbClr val="000000"/>
+                </a:solidFill>
+                <a:latin typeface="Arial" pitchFamily="34" charset="0"/>
+                <a:ea typeface="Arial" pitchFamily="34" charset="-122"/>
+                <a:cs typeface="Arial" pitchFamily="34" charset="-120"/>
               </a:rPr>
               <a:t>Share of</a:t>
             </a:r>
@@ -4153,11 +4082,11 @@
             <a:r>
               <a:rPr lang="en-US" sz="1600" b="1" dirty="0">
                 <a:solidFill>
-                  <a:srgbClr val="595959"/>
-                </a:solidFill>
-                <a:latin typeface="Garamond" pitchFamily="34" charset="0"/>
-                <a:ea typeface="Garamond" pitchFamily="34" charset="-122"/>
-                <a:cs typeface="Garamond" pitchFamily="34" charset="-120"/>
+                  <a:srgbClr val="000000"/>
+                </a:solidFill>
+                <a:latin typeface="Arial" pitchFamily="34" charset="0"/>
+                <a:ea typeface="Arial" pitchFamily="34" charset="-122"/>
+                <a:cs typeface="Arial" pitchFamily="34" charset="-120"/>
               </a:rPr>
               <a:t>total budget</a:t>
             </a:r>
@@ -4173,7 +4102,7 @@
         </p:nvSpPr>
         <p:spPr>
           <a:xfrm>
-            <a:off x="9052560" y="2322576"/>
+            <a:off x="9052560" y="2304288"/>
             <a:ext cx="219456" cy="219456"/>
           </a:xfrm>
           <a:prstGeom prst="rect">
@@ -4199,7 +4128,7 @@
         <p:spPr>
           <a:xfrm>
             <a:off x="9400032" y="2240280"/>
-            <a:ext cx="2240280" cy="868680"/>
+            <a:ext cx="2240280" cy="822960"/>
           </a:xfrm>
           <a:prstGeom prst="rect">
             <a:avLst/>
@@ -4215,34 +4144,34 @@
               <a:buNone/>
             </a:pPr>
             <a:r>
-              <a:rPr lang="en-US" sz="1900" b="1" dirty="0">
-                <a:solidFill>
-                  <a:srgbClr val="262626"/>
-                </a:solidFill>
-                <a:latin typeface="Garamond" pitchFamily="34" charset="0"/>
-                <a:ea typeface="Garamond" pitchFamily="34" charset="-122"/>
-                <a:cs typeface="Garamond" pitchFamily="34" charset="-120"/>
+              <a:rPr lang="en-US" sz="1700" b="1" dirty="0">
+                <a:solidFill>
+                  <a:srgbClr val="000000"/>
+                </a:solidFill>
+                <a:latin typeface="Arial" pitchFamily="34" charset="0"/>
+                <a:ea typeface="Arial" pitchFamily="34" charset="-122"/>
+                <a:cs typeface="Arial" pitchFamily="34" charset="-120"/>
               </a:rPr>
               <a:t>Advertising</a:t>
             </a:r>
-            <a:endParaRPr lang="en-US" sz="1900" dirty="0"/>
+            <a:endParaRPr lang="en-US" sz="1700" dirty="0"/>
           </a:p>
           <a:p>
             <a:pPr indent="0" marL="0">
               <a:buNone/>
             </a:pPr>
             <a:r>
-              <a:rPr lang="en-US" sz="1600" dirty="0">
-                <a:solidFill>
-                  <a:srgbClr val="595959"/>
-                </a:solidFill>
-                <a:latin typeface="Garamond" pitchFamily="34" charset="0"/>
-                <a:ea typeface="Garamond" pitchFamily="34" charset="-122"/>
-                <a:cs typeface="Garamond" pitchFamily="34" charset="-120"/>
+              <a:rPr lang="en-US" sz="1700" dirty="0">
+                <a:solidFill>
+                  <a:srgbClr val="000000"/>
+                </a:solidFill>
+                <a:latin typeface="Arial" pitchFamily="34" charset="0"/>
+                <a:ea typeface="Arial" pitchFamily="34" charset="-122"/>
+                <a:cs typeface="Arial" pitchFamily="34" charset="-120"/>
               </a:rPr>
               <a:t>$320,000  ·  36.0%</a:t>
             </a:r>
-            <a:endParaRPr lang="en-US" sz="1900" dirty="0"/>
+            <a:endParaRPr lang="en-US" sz="1700" dirty="0"/>
           </a:p>
         </p:txBody>
       </p:sp>
@@ -4254,7 +4183,7 @@
         </p:nvSpPr>
         <p:spPr>
           <a:xfrm>
-            <a:off x="9052560" y="3282696"/>
+            <a:off x="9052560" y="3264408"/>
             <a:ext cx="219456" cy="219456"/>
           </a:xfrm>
           <a:prstGeom prst="rect">
@@ -4280,7 +4209,7 @@
         <p:spPr>
           <a:xfrm>
             <a:off x="9400032" y="3200400"/>
-            <a:ext cx="2240280" cy="868680"/>
+            <a:ext cx="2240280" cy="822960"/>
           </a:xfrm>
           <a:prstGeom prst="rect">
             <a:avLst/>
@@ -4296,34 +4225,34 @@
               <a:buNone/>
             </a:pPr>
             <a:r>
-              <a:rPr lang="en-US" sz="1900" b="1" dirty="0">
-                <a:solidFill>
-                  <a:srgbClr val="262626"/>
-                </a:solidFill>
-                <a:latin typeface="Garamond" pitchFamily="34" charset="0"/>
-                <a:ea typeface="Garamond" pitchFamily="34" charset="-122"/>
-                <a:cs typeface="Garamond" pitchFamily="34" charset="-120"/>
+              <a:rPr lang="en-US" sz="1700" b="1" dirty="0">
+                <a:solidFill>
+                  <a:srgbClr val="000000"/>
+                </a:solidFill>
+                <a:latin typeface="Arial" pitchFamily="34" charset="0"/>
+                <a:ea typeface="Arial" pitchFamily="34" charset="-122"/>
+                <a:cs typeface="Arial" pitchFamily="34" charset="-120"/>
               </a:rPr>
               <a:t>Marketing</a:t>
             </a:r>
-            <a:endParaRPr lang="en-US" sz="1900" dirty="0"/>
+            <a:endParaRPr lang="en-US" sz="1700" dirty="0"/>
           </a:p>
           <a:p>
             <a:pPr indent="0" marL="0">
               <a:buNone/>
             </a:pPr>
             <a:r>
-              <a:rPr lang="en-US" sz="1600" dirty="0">
-                <a:solidFill>
-                  <a:srgbClr val="595959"/>
-                </a:solidFill>
-                <a:latin typeface="Garamond" pitchFamily="34" charset="0"/>
-                <a:ea typeface="Garamond" pitchFamily="34" charset="-122"/>
-                <a:cs typeface="Garamond" pitchFamily="34" charset="-120"/>
+              <a:rPr lang="en-US" sz="1700" dirty="0">
+                <a:solidFill>
+                  <a:srgbClr val="000000"/>
+                </a:solidFill>
+                <a:latin typeface="Arial" pitchFamily="34" charset="0"/>
+                <a:ea typeface="Arial" pitchFamily="34" charset="-122"/>
+                <a:cs typeface="Arial" pitchFamily="34" charset="-120"/>
               </a:rPr>
               <a:t>$260,000  ·  29.2%</a:t>
             </a:r>
-            <a:endParaRPr lang="en-US" sz="1900" dirty="0"/>
+            <a:endParaRPr lang="en-US" sz="1700" dirty="0"/>
           </a:p>
         </p:txBody>
       </p:sp>
@@ -4335,7 +4264,7 @@
         </p:nvSpPr>
         <p:spPr>
           <a:xfrm>
-            <a:off x="9052560" y="4242816"/>
+            <a:off x="9052560" y="4224528"/>
             <a:ext cx="219456" cy="219456"/>
           </a:xfrm>
           <a:prstGeom prst="rect">
@@ -4361,7 +4290,7 @@
         <p:spPr>
           <a:xfrm>
             <a:off x="9400032" y="4160520"/>
-            <a:ext cx="2240280" cy="868680"/>
+            <a:ext cx="2240280" cy="822960"/>
           </a:xfrm>
           <a:prstGeom prst="rect">
             <a:avLst/>
@@ -4377,34 +4306,34 @@
               <a:buNone/>
             </a:pPr>
             <a:r>
-              <a:rPr lang="en-US" sz="1900" b="1" dirty="0">
-                <a:solidFill>
-                  <a:srgbClr val="262626"/>
-                </a:solidFill>
-                <a:latin typeface="Garamond" pitchFamily="34" charset="0"/>
-                <a:ea typeface="Garamond" pitchFamily="34" charset="-122"/>
-                <a:cs typeface="Garamond" pitchFamily="34" charset="-120"/>
+              <a:rPr lang="en-US" sz="1700" b="1" dirty="0">
+                <a:solidFill>
+                  <a:srgbClr val="000000"/>
+                </a:solidFill>
+                <a:latin typeface="Arial" pitchFamily="34" charset="0"/>
+                <a:ea typeface="Arial" pitchFamily="34" charset="-122"/>
+                <a:cs typeface="Arial" pitchFamily="34" charset="-120"/>
               </a:rPr>
               <a:t>Public Relations</a:t>
             </a:r>
-            <a:endParaRPr lang="en-US" sz="1900" dirty="0"/>
+            <a:endParaRPr lang="en-US" sz="1700" dirty="0"/>
           </a:p>
           <a:p>
             <a:pPr indent="0" marL="0">
               <a:buNone/>
             </a:pPr>
             <a:r>
-              <a:rPr lang="en-US" sz="1600" dirty="0">
-                <a:solidFill>
-                  <a:srgbClr val="595959"/>
-                </a:solidFill>
-                <a:latin typeface="Garamond" pitchFamily="34" charset="0"/>
-                <a:ea typeface="Garamond" pitchFamily="34" charset="-122"/>
-                <a:cs typeface="Garamond" pitchFamily="34" charset="-120"/>
+              <a:rPr lang="en-US" sz="1700" dirty="0">
+                <a:solidFill>
+                  <a:srgbClr val="000000"/>
+                </a:solidFill>
+                <a:latin typeface="Arial" pitchFamily="34" charset="0"/>
+                <a:ea typeface="Arial" pitchFamily="34" charset="-122"/>
+                <a:cs typeface="Arial" pitchFamily="34" charset="-120"/>
               </a:rPr>
               <a:t>$130,000  ·  14.6%</a:t>
             </a:r>
-            <a:endParaRPr lang="en-US" sz="1900" dirty="0"/>
+            <a:endParaRPr lang="en-US" sz="1700" dirty="0"/>
           </a:p>
         </p:txBody>
       </p:sp>
@@ -4416,7 +4345,7 @@
         </p:nvSpPr>
         <p:spPr>
           <a:xfrm>
-            <a:off x="9052560" y="5202936"/>
+            <a:off x="9052560" y="5184648"/>
             <a:ext cx="219456" cy="219456"/>
           </a:xfrm>
           <a:prstGeom prst="rect">
@@ -4442,7 +4371,7 @@
         <p:spPr>
           <a:xfrm>
             <a:off x="9400032" y="5120640"/>
-            <a:ext cx="2240280" cy="868680"/>
+            <a:ext cx="2240280" cy="822960"/>
           </a:xfrm>
           <a:prstGeom prst="rect">
             <a:avLst/>
@@ -4458,34 +4387,34 @@
               <a:buNone/>
             </a:pPr>
             <a:r>
-              <a:rPr lang="en-US" sz="1900" b="1" dirty="0">
-                <a:solidFill>
-                  <a:srgbClr val="262626"/>
-                </a:solidFill>
-                <a:latin typeface="Garamond" pitchFamily="34" charset="0"/>
-                <a:ea typeface="Garamond" pitchFamily="34" charset="-122"/>
-                <a:cs typeface="Garamond" pitchFamily="34" charset="-120"/>
+              <a:rPr lang="en-US" sz="1700" b="1" dirty="0">
+                <a:solidFill>
+                  <a:srgbClr val="000000"/>
+                </a:solidFill>
+                <a:latin typeface="Arial" pitchFamily="34" charset="0"/>
+                <a:ea typeface="Arial" pitchFamily="34" charset="-122"/>
+                <a:cs typeface="Arial" pitchFamily="34" charset="-120"/>
               </a:rPr>
               <a:t>e-Business</a:t>
             </a:r>
-            <a:endParaRPr lang="en-US" sz="1900" dirty="0"/>
+            <a:endParaRPr lang="en-US" sz="1700" dirty="0"/>
           </a:p>
           <a:p>
             <a:pPr indent="0" marL="0">
               <a:buNone/>
             </a:pPr>
             <a:r>
-              <a:rPr lang="en-US" sz="1600" dirty="0">
-                <a:solidFill>
-                  <a:srgbClr val="595959"/>
-                </a:solidFill>
-                <a:latin typeface="Garamond" pitchFamily="34" charset="0"/>
-                <a:ea typeface="Garamond" pitchFamily="34" charset="-122"/>
-                <a:cs typeface="Garamond" pitchFamily="34" charset="-120"/>
+              <a:rPr lang="en-US" sz="1700" dirty="0">
+                <a:solidFill>
+                  <a:srgbClr val="000000"/>
+                </a:solidFill>
+                <a:latin typeface="Arial" pitchFamily="34" charset="0"/>
+                <a:ea typeface="Arial" pitchFamily="34" charset="-122"/>
+                <a:cs typeface="Arial" pitchFamily="34" charset="-120"/>
               </a:rPr>
               <a:t>$180,000  ·  20.2%</a:t>
             </a:r>
-            <a:endParaRPr lang="en-US" sz="1900" dirty="0"/>
+            <a:endParaRPr lang="en-US" sz="1700" dirty="0"/>
           </a:p>
         </p:txBody>
       </p:sp>
@@ -4526,7 +4455,7 @@
         <p:spPr>
           <a:xfrm>
             <a:off x="731520" y="457200"/>
-            <a:ext cx="10728655" cy="777240"/>
+            <a:ext cx="10728655" cy="731520"/>
           </a:xfrm>
           <a:prstGeom prst="rect">
             <a:avLst/>
@@ -4542,17 +4471,17 @@
               <a:buNone/>
             </a:pPr>
             <a:r>
-              <a:rPr lang="en-US" sz="4000" dirty="0">
+              <a:rPr lang="en-US" sz="3600" b="1" dirty="0">
                 <a:solidFill>
                   <a:srgbClr val="1F3864"/>
                 </a:solidFill>
-                <a:latin typeface="Garamond" pitchFamily="34" charset="0"/>
-                <a:ea typeface="Garamond" pitchFamily="34" charset="-122"/>
-                <a:cs typeface="Garamond" pitchFamily="34" charset="-120"/>
+                <a:latin typeface="Arial" pitchFamily="34" charset="0"/>
+                <a:ea typeface="Arial" pitchFamily="34" charset="-122"/>
+                <a:cs typeface="Arial" pitchFamily="34" charset="-120"/>
               </a:rPr>
               <a:t>Advertising (Ads)</a:t>
             </a:r>
-            <a:endParaRPr lang="en-US" sz="4000" dirty="0"/>
+            <a:endParaRPr lang="en-US" sz="3600" dirty="0"/>
           </a:p>
         </p:txBody>
       </p:sp>
@@ -4564,7 +4493,7 @@
         </p:nvSpPr>
         <p:spPr>
           <a:xfrm>
-            <a:off x="914400" y="1325880"/>
+            <a:off x="914400" y="1298448"/>
             <a:ext cx="10362895" cy="0"/>
           </a:xfrm>
           <a:prstGeom prst="line">
@@ -4573,7 +4502,7 @@
           <a:noFill/>
           <a:ln w="19050">
             <a:solidFill>
-              <a:srgbClr val="2F5597"/>
+              <a:srgbClr val="1F3864"/>
             </a:solidFill>
             <a:prstDash val="solid"/>
           </a:ln>
@@ -4604,13 +4533,13 @@
               <a:buNone/>
             </a:pPr>
             <a:r>
-              <a:rPr lang="en-US" sz="1800" i="1" dirty="0">
-                <a:solidFill>
-                  <a:srgbClr val="595959"/>
-                </a:solidFill>
-                <a:latin typeface="Garamond" pitchFamily="34" charset="0"/>
-                <a:ea typeface="Garamond" pitchFamily="34" charset="-122"/>
-                <a:cs typeface="Garamond" pitchFamily="34" charset="-120"/>
+              <a:rPr lang="en-US" sz="1800" dirty="0">
+                <a:solidFill>
+                  <a:srgbClr val="000000"/>
+                </a:solidFill>
+                <a:latin typeface="Arial" pitchFamily="34" charset="0"/>
+                <a:ea typeface="Arial" pitchFamily="34" charset="-122"/>
+                <a:cs typeface="Arial" pitchFamily="34" charset="-120"/>
               </a:rPr>
               <a:t>Paid media campaigns on TV, radio, print, outdoor and online channels</a:t>
             </a:r>
@@ -4633,11 +4562,11 @@
             <a:avLst/>
           </a:prstGeom>
           <a:solidFill>
-            <a:srgbClr val="DAE3F3"/>
+            <a:srgbClr val="DEEBF7"/>
           </a:solidFill>
           <a:ln w="12700">
             <a:solidFill>
-              <a:srgbClr val="DAE3F3"/>
+              <a:srgbClr val="DEEBF7"/>
             </a:solidFill>
             <a:prstDash val="solid"/>
           </a:ln>
@@ -4668,17 +4597,17 @@
               <a:buNone/>
             </a:pPr>
             <a:r>
-              <a:rPr lang="en-US" sz="2400" b="1" dirty="0">
-                <a:solidFill>
-                  <a:srgbClr val="4472C4"/>
-                </a:solidFill>
-                <a:latin typeface="Garamond" pitchFamily="34" charset="0"/>
-                <a:ea typeface="Garamond" pitchFamily="34" charset="-122"/>
-                <a:cs typeface="Garamond" pitchFamily="34" charset="-120"/>
+              <a:rPr lang="en-US" sz="2200" b="1" dirty="0">
+                <a:solidFill>
+                  <a:srgbClr val="000000"/>
+                </a:solidFill>
+                <a:latin typeface="Arial" pitchFamily="34" charset="0"/>
+                <a:ea typeface="Arial" pitchFamily="34" charset="-122"/>
+                <a:cs typeface="Arial" pitchFamily="34" charset="-120"/>
               </a:rPr>
               <a:t>Key Figures</a:t>
             </a:r>
-            <a:endParaRPr lang="en-US" sz="2400" dirty="0"/>
+            <a:endParaRPr lang="en-US" sz="2200" dirty="0"/>
           </a:p>
         </p:txBody>
       </p:sp>
@@ -4711,28 +4640,28 @@
               <a:buChar char="•"/>
             </a:pPr>
             <a:r>
-              <a:rPr lang="en-US" sz="1900" dirty="0">
-                <a:solidFill>
-                  <a:srgbClr val="262626"/>
-                </a:solidFill>
-                <a:latin typeface="Garamond" pitchFamily="34" charset="0"/>
-                <a:ea typeface="Garamond" pitchFamily="34" charset="-122"/>
-                <a:cs typeface="Garamond" pitchFamily="34" charset="-120"/>
+              <a:rPr lang="en-US" sz="1700" dirty="0">
+                <a:solidFill>
+                  <a:srgbClr val="000000"/>
+                </a:solidFill>
+                <a:latin typeface="Arial" pitchFamily="34" charset="0"/>
+                <a:ea typeface="Arial" pitchFamily="34" charset="-122"/>
+                <a:cs typeface="Arial" pitchFamily="34" charset="-120"/>
               </a:rPr>
               <a:t>Total budget: </a:t>
             </a:r>
             <a:r>
-              <a:rPr lang="en-US" sz="1900" b="1" dirty="0">
-                <a:solidFill>
-                  <a:srgbClr val="262626"/>
-                </a:solidFill>
-                <a:latin typeface="Garamond" pitchFamily="34" charset="0"/>
-                <a:ea typeface="Garamond" pitchFamily="34" charset="-122"/>
-                <a:cs typeface="Garamond" pitchFamily="34" charset="-120"/>
+              <a:rPr lang="en-US" sz="1700" b="1" dirty="0">
+                <a:solidFill>
+                  <a:srgbClr val="000000"/>
+                </a:solidFill>
+                <a:latin typeface="Arial" pitchFamily="34" charset="0"/>
+                <a:ea typeface="Arial" pitchFamily="34" charset="-122"/>
+                <a:cs typeface="Arial" pitchFamily="34" charset="-120"/>
               </a:rPr>
               <a:t>$320,000</a:t>
             </a:r>
-            <a:endParaRPr lang="en-US" sz="1900" dirty="0"/>
+            <a:endParaRPr lang="en-US" sz="1700" dirty="0"/>
           </a:p>
           <a:p>
             <a:pPr marL="228600" indent="-228600">
@@ -4743,28 +4672,17 @@
               <a:buChar char="•"/>
             </a:pPr>
             <a:r>
-              <a:rPr lang="en-US" sz="1900" dirty="0">
-                <a:solidFill>
-                  <a:srgbClr val="262626"/>
-                </a:solidFill>
-                <a:latin typeface="Garamond" pitchFamily="34" charset="0"/>
-                <a:ea typeface="Garamond" pitchFamily="34" charset="-122"/>
-                <a:cs typeface="Garamond" pitchFamily="34" charset="-120"/>
-              </a:rPr>
-              <a:t>Excel formula: </a:t>
-            </a:r>
-            <a:r>
-              <a:rPr lang="en-US" sz="1900" i="1" dirty="0">
-                <a:solidFill>
-                  <a:srgbClr val="262626"/>
-                </a:solidFill>
-                <a:latin typeface="Garamond" pitchFamily="34" charset="0"/>
-                <a:ea typeface="Garamond" pitchFamily="34" charset="-122"/>
-                <a:cs typeface="Garamond" pitchFamily="34" charset="-120"/>
-              </a:rPr>
-              <a:t>=SUM(B5:B12)</a:t>
-            </a:r>
-            <a:endParaRPr lang="en-US" sz="1900" dirty="0"/>
+              <a:rPr lang="en-US" sz="1700" dirty="0">
+                <a:solidFill>
+                  <a:srgbClr val="000000"/>
+                </a:solidFill>
+                <a:latin typeface="Arial" pitchFamily="34" charset="0"/>
+                <a:ea typeface="Arial" pitchFamily="34" charset="-122"/>
+                <a:cs typeface="Arial" pitchFamily="34" charset="-120"/>
+              </a:rPr>
+              <a:t>Excel formula: =SUM(B5:B12)</a:t>
+            </a:r>
+            <a:endParaRPr lang="en-US" sz="1700" dirty="0"/>
           </a:p>
           <a:p>
             <a:pPr marL="228600" indent="-228600">
@@ -4775,39 +4693,39 @@
               <a:buChar char="•"/>
             </a:pPr>
             <a:r>
-              <a:rPr lang="en-US" sz="1900" dirty="0">
-                <a:solidFill>
-                  <a:srgbClr val="262626"/>
-                </a:solidFill>
-                <a:latin typeface="Garamond" pitchFamily="34" charset="0"/>
-                <a:ea typeface="Garamond" pitchFamily="34" charset="-122"/>
-                <a:cs typeface="Garamond" pitchFamily="34" charset="-120"/>
+              <a:rPr lang="en-US" sz="1700" dirty="0">
+                <a:solidFill>
+                  <a:srgbClr val="000000"/>
+                </a:solidFill>
+                <a:latin typeface="Arial" pitchFamily="34" charset="0"/>
+                <a:ea typeface="Arial" pitchFamily="34" charset="-122"/>
+                <a:cs typeface="Arial" pitchFamily="34" charset="-120"/>
               </a:rPr>
               <a:t>Share of the department: </a:t>
             </a:r>
             <a:r>
-              <a:rPr lang="en-US" sz="1900" b="1" dirty="0">
-                <a:solidFill>
-                  <a:srgbClr val="262626"/>
-                </a:solidFill>
-                <a:latin typeface="Garamond" pitchFamily="34" charset="0"/>
-                <a:ea typeface="Garamond" pitchFamily="34" charset="-122"/>
-                <a:cs typeface="Garamond" pitchFamily="34" charset="-120"/>
+              <a:rPr lang="en-US" sz="1700" b="1" dirty="0">
+                <a:solidFill>
+                  <a:srgbClr val="000000"/>
+                </a:solidFill>
+                <a:latin typeface="Arial" pitchFamily="34" charset="0"/>
+                <a:ea typeface="Arial" pitchFamily="34" charset="-122"/>
+                <a:cs typeface="Arial" pitchFamily="34" charset="-120"/>
               </a:rPr>
               <a:t>36.0%</a:t>
             </a:r>
             <a:r>
-              <a:rPr lang="en-US" sz="1900" dirty="0">
-                <a:solidFill>
-                  <a:srgbClr val="262626"/>
-                </a:solidFill>
-                <a:latin typeface="Garamond" pitchFamily="34" charset="0"/>
-                <a:ea typeface="Garamond" pitchFamily="34" charset="-122"/>
-                <a:cs typeface="Garamond" pitchFamily="34" charset="-120"/>
+              <a:rPr lang="en-US" sz="1700" dirty="0">
+                <a:solidFill>
+                  <a:srgbClr val="000000"/>
+                </a:solidFill>
+                <a:latin typeface="Arial" pitchFamily="34" charset="0"/>
+                <a:ea typeface="Arial" pitchFamily="34" charset="-122"/>
+                <a:cs typeface="Arial" pitchFamily="34" charset="-120"/>
               </a:rPr>
               <a:t> (rank 1 of 4)</a:t>
             </a:r>
-            <a:endParaRPr lang="en-US" sz="1900" dirty="0"/>
+            <a:endParaRPr lang="en-US" sz="1700" dirty="0"/>
           </a:p>
           <a:p>
             <a:pPr marL="228600" indent="-228600">
@@ -4818,28 +4736,28 @@
               <a:buChar char="•"/>
             </a:pPr>
             <a:r>
-              <a:rPr lang="en-US" sz="1900" dirty="0">
-                <a:solidFill>
-                  <a:srgbClr val="262626"/>
-                </a:solidFill>
-                <a:latin typeface="Garamond" pitchFamily="34" charset="0"/>
-                <a:ea typeface="Garamond" pitchFamily="34" charset="-122"/>
-                <a:cs typeface="Garamond" pitchFamily="34" charset="-120"/>
+              <a:rPr lang="en-US" sz="1700" dirty="0">
+                <a:solidFill>
+                  <a:srgbClr val="000000"/>
+                </a:solidFill>
+                <a:latin typeface="Arial" pitchFamily="34" charset="0"/>
+                <a:ea typeface="Arial" pitchFamily="34" charset="-122"/>
+                <a:cs typeface="Arial" pitchFamily="34" charset="-120"/>
               </a:rPr>
               <a:t>Average per budget item: </a:t>
             </a:r>
             <a:r>
-              <a:rPr lang="en-US" sz="1900" b="1" dirty="0">
-                <a:solidFill>
-                  <a:srgbClr val="262626"/>
-                </a:solidFill>
-                <a:latin typeface="Garamond" pitchFamily="34" charset="0"/>
-                <a:ea typeface="Garamond" pitchFamily="34" charset="-122"/>
-                <a:cs typeface="Garamond" pitchFamily="34" charset="-120"/>
+              <a:rPr lang="en-US" sz="1700" b="1" dirty="0">
+                <a:solidFill>
+                  <a:srgbClr val="000000"/>
+                </a:solidFill>
+                <a:latin typeface="Arial" pitchFamily="34" charset="0"/>
+                <a:ea typeface="Arial" pitchFamily="34" charset="-122"/>
+                <a:cs typeface="Arial" pitchFamily="34" charset="-120"/>
               </a:rPr>
               <a:t>$40,000</a:t>
             </a:r>
-            <a:endParaRPr lang="en-US" sz="1900" dirty="0"/>
+            <a:endParaRPr lang="en-US" sz="1700" dirty="0"/>
           </a:p>
           <a:p>
             <a:pPr marL="228600" indent="-228600">
@@ -4850,39 +4768,28 @@
               <a:buChar char="•"/>
             </a:pPr>
             <a:r>
-              <a:rPr lang="en-US" sz="1900" dirty="0">
-                <a:solidFill>
-                  <a:srgbClr val="262626"/>
-                </a:solidFill>
-                <a:latin typeface="Garamond" pitchFamily="34" charset="0"/>
-                <a:ea typeface="Garamond" pitchFamily="34" charset="-122"/>
-                <a:cs typeface="Garamond" pitchFamily="34" charset="-120"/>
+              <a:rPr lang="en-US" sz="1700" dirty="0">
+                <a:solidFill>
+                  <a:srgbClr val="000000"/>
+                </a:solidFill>
+                <a:latin typeface="Arial" pitchFamily="34" charset="0"/>
+                <a:ea typeface="Arial" pitchFamily="34" charset="-122"/>
+                <a:cs typeface="Arial" pitchFamily="34" charset="-120"/>
               </a:rPr>
               <a:t>Largest item: </a:t>
             </a:r>
             <a:r>
-              <a:rPr lang="en-US" sz="1900" b="1" dirty="0">
-                <a:solidFill>
-                  <a:srgbClr val="262626"/>
-                </a:solidFill>
-                <a:latin typeface="Garamond" pitchFamily="34" charset="0"/>
-                <a:ea typeface="Garamond" pitchFamily="34" charset="-122"/>
-                <a:cs typeface="Garamond" pitchFamily="34" charset="-120"/>
-              </a:rPr>
-              <a:t>Media &amp; Advertising Space</a:t>
-            </a:r>
-            <a:r>
-              <a:rPr lang="en-US" sz="1900" dirty="0">
-                <a:solidFill>
-                  <a:srgbClr val="262626"/>
-                </a:solidFill>
-                <a:latin typeface="Garamond" pitchFamily="34" charset="0"/>
-                <a:ea typeface="Garamond" pitchFamily="34" charset="-122"/>
-                <a:cs typeface="Garamond" pitchFamily="34" charset="-120"/>
-              </a:rPr>
-              <a:t>, $150,000</a:t>
-            </a:r>
-            <a:endParaRPr lang="en-US" sz="1900" dirty="0"/>
+              <a:rPr lang="en-US" sz="1700" b="1" dirty="0">
+                <a:solidFill>
+                  <a:srgbClr val="000000"/>
+                </a:solidFill>
+                <a:latin typeface="Arial" pitchFamily="34" charset="0"/>
+                <a:ea typeface="Arial" pitchFamily="34" charset="-122"/>
+                <a:cs typeface="Arial" pitchFamily="34" charset="-120"/>
+              </a:rPr>
+              <a:t>Media &amp; Advertising Space, $150,000</a:t>
+            </a:r>
+            <a:endParaRPr lang="en-US" sz="1700" dirty="0"/>
           </a:p>
         </p:txBody>
       </p:sp>
@@ -4911,17 +4818,17 @@
               <a:buNone/>
             </a:pPr>
             <a:r>
-              <a:rPr lang="en-US" sz="2400" b="1" dirty="0">
-                <a:solidFill>
-                  <a:srgbClr val="1F3864"/>
-                </a:solidFill>
-                <a:latin typeface="Garamond" pitchFamily="34" charset="0"/>
-                <a:ea typeface="Garamond" pitchFamily="34" charset="-122"/>
-                <a:cs typeface="Garamond" pitchFamily="34" charset="-120"/>
+              <a:rPr lang="en-US" sz="2200" b="1" dirty="0">
+                <a:solidFill>
+                  <a:srgbClr val="000000"/>
+                </a:solidFill>
+                <a:latin typeface="Arial" pitchFamily="34" charset="0"/>
+                <a:ea typeface="Arial" pitchFamily="34" charset="-122"/>
+                <a:cs typeface="Arial" pitchFamily="34" charset="-120"/>
               </a:rPr>
               <a:t>Where the Money Goes (US$)</a:t>
             </a:r>
-            <a:endParaRPr lang="en-US" sz="2400" dirty="0"/>
+            <a:endParaRPr lang="en-US" sz="2200" dirty="0"/>
           </a:p>
         </p:txBody>
       </p:sp>
@@ -4978,7 +4885,7 @@
         <p:spPr>
           <a:xfrm>
             <a:off x="731520" y="457200"/>
-            <a:ext cx="10728655" cy="777240"/>
+            <a:ext cx="10728655" cy="731520"/>
           </a:xfrm>
           <a:prstGeom prst="rect">
             <a:avLst/>
@@ -4994,17 +4901,17 @@
               <a:buNone/>
             </a:pPr>
             <a:r>
-              <a:rPr lang="en-US" sz="4000" dirty="0">
+              <a:rPr lang="en-US" sz="3600" b="1" dirty="0">
                 <a:solidFill>
                   <a:srgbClr val="1F3864"/>
                 </a:solidFill>
-                <a:latin typeface="Garamond" pitchFamily="34" charset="0"/>
-                <a:ea typeface="Garamond" pitchFamily="34" charset="-122"/>
-                <a:cs typeface="Garamond" pitchFamily="34" charset="-120"/>
+                <a:latin typeface="Arial" pitchFamily="34" charset="0"/>
+                <a:ea typeface="Arial" pitchFamily="34" charset="-122"/>
+                <a:cs typeface="Arial" pitchFamily="34" charset="-120"/>
               </a:rPr>
               <a:t>Marketing</a:t>
             </a:r>
-            <a:endParaRPr lang="en-US" sz="4000" dirty="0"/>
+            <a:endParaRPr lang="en-US" sz="3600" dirty="0"/>
           </a:p>
         </p:txBody>
       </p:sp>
@@ -5016,7 +4923,7 @@
         </p:nvSpPr>
         <p:spPr>
           <a:xfrm>
-            <a:off x="914400" y="1325880"/>
+            <a:off x="914400" y="1298448"/>
             <a:ext cx="10362895" cy="0"/>
           </a:xfrm>
           <a:prstGeom prst="line">
@@ -5025,7 +4932,7 @@
           <a:noFill/>
           <a:ln w="19050">
             <a:solidFill>
-              <a:srgbClr val="2F5597"/>
+              <a:srgbClr val="1F3864"/>
             </a:solidFill>
             <a:prstDash val="solid"/>
           </a:ln>
@@ -5056,13 +4963,13 @@
               <a:buNone/>
             </a:pPr>
             <a:r>
-              <a:rPr lang="en-US" sz="1800" i="1" dirty="0">
-                <a:solidFill>
-                  <a:srgbClr val="595959"/>
-                </a:solidFill>
-                <a:latin typeface="Garamond" pitchFamily="34" charset="0"/>
-                <a:ea typeface="Garamond" pitchFamily="34" charset="-122"/>
-                <a:cs typeface="Garamond" pitchFamily="34" charset="-120"/>
+              <a:rPr lang="en-US" sz="1800" dirty="0">
+                <a:solidFill>
+                  <a:srgbClr val="000000"/>
+                </a:solidFill>
+                <a:latin typeface="Arial" pitchFamily="34" charset="0"/>
+                <a:ea typeface="Arial" pitchFamily="34" charset="-122"/>
+                <a:cs typeface="Arial" pitchFamily="34" charset="-120"/>
               </a:rPr>
               <a:t>Market research, sales promotions, product launches and trade shows</a:t>
             </a:r>
@@ -5085,11 +4992,11 @@
             <a:avLst/>
           </a:prstGeom>
           <a:solidFill>
-            <a:srgbClr val="FBE5D6"/>
+            <a:srgbClr val="DEEBF7"/>
           </a:solidFill>
           <a:ln w="12700">
             <a:solidFill>
-              <a:srgbClr val="FBE5D6"/>
+              <a:srgbClr val="DEEBF7"/>
             </a:solidFill>
             <a:prstDash val="solid"/>
           </a:ln>
@@ -5120,17 +5027,17 @@
               <a:buNone/>
             </a:pPr>
             <a:r>
-              <a:rPr lang="en-US" sz="2400" b="1" dirty="0">
-                <a:solidFill>
-                  <a:srgbClr val="C55A11"/>
-                </a:solidFill>
-                <a:latin typeface="Garamond" pitchFamily="34" charset="0"/>
-                <a:ea typeface="Garamond" pitchFamily="34" charset="-122"/>
-                <a:cs typeface="Garamond" pitchFamily="34" charset="-120"/>
+              <a:rPr lang="en-US" sz="2200" b="1" dirty="0">
+                <a:solidFill>
+                  <a:srgbClr val="000000"/>
+                </a:solidFill>
+                <a:latin typeface="Arial" pitchFamily="34" charset="0"/>
+                <a:ea typeface="Arial" pitchFamily="34" charset="-122"/>
+                <a:cs typeface="Arial" pitchFamily="34" charset="-120"/>
               </a:rPr>
               <a:t>Key Figures</a:t>
             </a:r>
-            <a:endParaRPr lang="en-US" sz="2400" dirty="0"/>
+            <a:endParaRPr lang="en-US" sz="2200" dirty="0"/>
           </a:p>
         </p:txBody>
       </p:sp>
@@ -5163,28 +5070,28 @@
               <a:buChar char="•"/>
             </a:pPr>
             <a:r>
-              <a:rPr lang="en-US" sz="1900" dirty="0">
-                <a:solidFill>
-                  <a:srgbClr val="262626"/>
-                </a:solidFill>
-                <a:latin typeface="Garamond" pitchFamily="34" charset="0"/>
-                <a:ea typeface="Garamond" pitchFamily="34" charset="-122"/>
-                <a:cs typeface="Garamond" pitchFamily="34" charset="-120"/>
+              <a:rPr lang="en-US" sz="1700" dirty="0">
+                <a:solidFill>
+                  <a:srgbClr val="000000"/>
+                </a:solidFill>
+                <a:latin typeface="Arial" pitchFamily="34" charset="0"/>
+                <a:ea typeface="Arial" pitchFamily="34" charset="-122"/>
+                <a:cs typeface="Arial" pitchFamily="34" charset="-120"/>
               </a:rPr>
               <a:t>Total budget: </a:t>
             </a:r>
             <a:r>
-              <a:rPr lang="en-US" sz="1900" b="1" dirty="0">
-                <a:solidFill>
-                  <a:srgbClr val="262626"/>
-                </a:solidFill>
-                <a:latin typeface="Garamond" pitchFamily="34" charset="0"/>
-                <a:ea typeface="Garamond" pitchFamily="34" charset="-122"/>
-                <a:cs typeface="Garamond" pitchFamily="34" charset="-120"/>
+              <a:rPr lang="en-US" sz="1700" b="1" dirty="0">
+                <a:solidFill>
+                  <a:srgbClr val="000000"/>
+                </a:solidFill>
+                <a:latin typeface="Arial" pitchFamily="34" charset="0"/>
+                <a:ea typeface="Arial" pitchFamily="34" charset="-122"/>
+                <a:cs typeface="Arial" pitchFamily="34" charset="-120"/>
               </a:rPr>
               <a:t>$260,000</a:t>
             </a:r>
-            <a:endParaRPr lang="en-US" sz="1900" dirty="0"/>
+            <a:endParaRPr lang="en-US" sz="1700" dirty="0"/>
           </a:p>
           <a:p>
             <a:pPr marL="228600" indent="-228600">
@@ -5195,28 +5102,17 @@
               <a:buChar char="•"/>
             </a:pPr>
             <a:r>
-              <a:rPr lang="en-US" sz="1900" dirty="0">
-                <a:solidFill>
-                  <a:srgbClr val="262626"/>
-                </a:solidFill>
-                <a:latin typeface="Garamond" pitchFamily="34" charset="0"/>
-                <a:ea typeface="Garamond" pitchFamily="34" charset="-122"/>
-                <a:cs typeface="Garamond" pitchFamily="34" charset="-120"/>
-              </a:rPr>
-              <a:t>Excel formula: </a:t>
-            </a:r>
-            <a:r>
-              <a:rPr lang="en-US" sz="1900" i="1" dirty="0">
-                <a:solidFill>
-                  <a:srgbClr val="262626"/>
-                </a:solidFill>
-                <a:latin typeface="Garamond" pitchFamily="34" charset="0"/>
-                <a:ea typeface="Garamond" pitchFamily="34" charset="-122"/>
-                <a:cs typeface="Garamond" pitchFamily="34" charset="-120"/>
-              </a:rPr>
-              <a:t>=SUM(C5:C12)</a:t>
-            </a:r>
-            <a:endParaRPr lang="en-US" sz="1900" dirty="0"/>
+              <a:rPr lang="en-US" sz="1700" dirty="0">
+                <a:solidFill>
+                  <a:srgbClr val="000000"/>
+                </a:solidFill>
+                <a:latin typeface="Arial" pitchFamily="34" charset="0"/>
+                <a:ea typeface="Arial" pitchFamily="34" charset="-122"/>
+                <a:cs typeface="Arial" pitchFamily="34" charset="-120"/>
+              </a:rPr>
+              <a:t>Excel formula: =SUM(C5:C12)</a:t>
+            </a:r>
+            <a:endParaRPr lang="en-US" sz="1700" dirty="0"/>
           </a:p>
           <a:p>
             <a:pPr marL="228600" indent="-228600">
@@ -5227,39 +5123,39 @@
               <a:buChar char="•"/>
             </a:pPr>
             <a:r>
-              <a:rPr lang="en-US" sz="1900" dirty="0">
-                <a:solidFill>
-                  <a:srgbClr val="262626"/>
-                </a:solidFill>
-                <a:latin typeface="Garamond" pitchFamily="34" charset="0"/>
-                <a:ea typeface="Garamond" pitchFamily="34" charset="-122"/>
-                <a:cs typeface="Garamond" pitchFamily="34" charset="-120"/>
+              <a:rPr lang="en-US" sz="1700" dirty="0">
+                <a:solidFill>
+                  <a:srgbClr val="000000"/>
+                </a:solidFill>
+                <a:latin typeface="Arial" pitchFamily="34" charset="0"/>
+                <a:ea typeface="Arial" pitchFamily="34" charset="-122"/>
+                <a:cs typeface="Arial" pitchFamily="34" charset="-120"/>
               </a:rPr>
               <a:t>Share of the department: </a:t>
             </a:r>
             <a:r>
-              <a:rPr lang="en-US" sz="1900" b="1" dirty="0">
-                <a:solidFill>
-                  <a:srgbClr val="262626"/>
-                </a:solidFill>
-                <a:latin typeface="Garamond" pitchFamily="34" charset="0"/>
-                <a:ea typeface="Garamond" pitchFamily="34" charset="-122"/>
-                <a:cs typeface="Garamond" pitchFamily="34" charset="-120"/>
+              <a:rPr lang="en-US" sz="1700" b="1" dirty="0">
+                <a:solidFill>
+                  <a:srgbClr val="000000"/>
+                </a:solidFill>
+                <a:latin typeface="Arial" pitchFamily="34" charset="0"/>
+                <a:ea typeface="Arial" pitchFamily="34" charset="-122"/>
+                <a:cs typeface="Arial" pitchFamily="34" charset="-120"/>
               </a:rPr>
               <a:t>29.2%</a:t>
             </a:r>
             <a:r>
-              <a:rPr lang="en-US" sz="1900" dirty="0">
-                <a:solidFill>
-                  <a:srgbClr val="262626"/>
-                </a:solidFill>
-                <a:latin typeface="Garamond" pitchFamily="34" charset="0"/>
-                <a:ea typeface="Garamond" pitchFamily="34" charset="-122"/>
-                <a:cs typeface="Garamond" pitchFamily="34" charset="-120"/>
+              <a:rPr lang="en-US" sz="1700" dirty="0">
+                <a:solidFill>
+                  <a:srgbClr val="000000"/>
+                </a:solidFill>
+                <a:latin typeface="Arial" pitchFamily="34" charset="0"/>
+                <a:ea typeface="Arial" pitchFamily="34" charset="-122"/>
+                <a:cs typeface="Arial" pitchFamily="34" charset="-120"/>
               </a:rPr>
               <a:t> (rank 2 of 4)</a:t>
             </a:r>
-            <a:endParaRPr lang="en-US" sz="1900" dirty="0"/>
+            <a:endParaRPr lang="en-US" sz="1700" dirty="0"/>
           </a:p>
           <a:p>
             <a:pPr marL="228600" indent="-228600">
@@ -5270,28 +5166,28 @@
               <a:buChar char="•"/>
             </a:pPr>
             <a:r>
-              <a:rPr lang="en-US" sz="1900" dirty="0">
-                <a:solidFill>
-                  <a:srgbClr val="262626"/>
-                </a:solidFill>
-                <a:latin typeface="Garamond" pitchFamily="34" charset="0"/>
-                <a:ea typeface="Garamond" pitchFamily="34" charset="-122"/>
-                <a:cs typeface="Garamond" pitchFamily="34" charset="-120"/>
+              <a:rPr lang="en-US" sz="1700" dirty="0">
+                <a:solidFill>
+                  <a:srgbClr val="000000"/>
+                </a:solidFill>
+                <a:latin typeface="Arial" pitchFamily="34" charset="0"/>
+                <a:ea typeface="Arial" pitchFamily="34" charset="-122"/>
+                <a:cs typeface="Arial" pitchFamily="34" charset="-120"/>
               </a:rPr>
               <a:t>Average per budget item: </a:t>
             </a:r>
             <a:r>
-              <a:rPr lang="en-US" sz="1900" b="1" dirty="0">
-                <a:solidFill>
-                  <a:srgbClr val="262626"/>
-                </a:solidFill>
-                <a:latin typeface="Garamond" pitchFamily="34" charset="0"/>
-                <a:ea typeface="Garamond" pitchFamily="34" charset="-122"/>
-                <a:cs typeface="Garamond" pitchFamily="34" charset="-120"/>
+              <a:rPr lang="en-US" sz="1700" b="1" dirty="0">
+                <a:solidFill>
+                  <a:srgbClr val="000000"/>
+                </a:solidFill>
+                <a:latin typeface="Arial" pitchFamily="34" charset="0"/>
+                <a:ea typeface="Arial" pitchFamily="34" charset="-122"/>
+                <a:cs typeface="Arial" pitchFamily="34" charset="-120"/>
               </a:rPr>
               <a:t>$32,500</a:t>
             </a:r>
-            <a:endParaRPr lang="en-US" sz="1900" dirty="0"/>
+            <a:endParaRPr lang="en-US" sz="1700" dirty="0"/>
           </a:p>
           <a:p>
             <a:pPr marL="228600" indent="-228600">
@@ -5302,39 +5198,28 @@
               <a:buChar char="•"/>
             </a:pPr>
             <a:r>
-              <a:rPr lang="en-US" sz="1900" dirty="0">
-                <a:solidFill>
-                  <a:srgbClr val="262626"/>
-                </a:solidFill>
-                <a:latin typeface="Garamond" pitchFamily="34" charset="0"/>
-                <a:ea typeface="Garamond" pitchFamily="34" charset="-122"/>
-                <a:cs typeface="Garamond" pitchFamily="34" charset="-120"/>
+              <a:rPr lang="en-US" sz="1700" dirty="0">
+                <a:solidFill>
+                  <a:srgbClr val="000000"/>
+                </a:solidFill>
+                <a:latin typeface="Arial" pitchFamily="34" charset="0"/>
+                <a:ea typeface="Arial" pitchFamily="34" charset="-122"/>
+                <a:cs typeface="Arial" pitchFamily="34" charset="-120"/>
               </a:rPr>
               <a:t>Largest item: </a:t>
             </a:r>
             <a:r>
-              <a:rPr lang="en-US" sz="1900" b="1" dirty="0">
-                <a:solidFill>
-                  <a:srgbClr val="262626"/>
-                </a:solidFill>
-                <a:latin typeface="Garamond" pitchFamily="34" charset="0"/>
-                <a:ea typeface="Garamond" pitchFamily="34" charset="-122"/>
-                <a:cs typeface="Garamond" pitchFamily="34" charset="-120"/>
-              </a:rPr>
-              <a:t>Events, Sponsorships &amp; Promotions</a:t>
-            </a:r>
-            <a:r>
-              <a:rPr lang="en-US" sz="1900" dirty="0">
-                <a:solidFill>
-                  <a:srgbClr val="262626"/>
-                </a:solidFill>
-                <a:latin typeface="Garamond" pitchFamily="34" charset="0"/>
-                <a:ea typeface="Garamond" pitchFamily="34" charset="-122"/>
-                <a:cs typeface="Garamond" pitchFamily="34" charset="-120"/>
-              </a:rPr>
-              <a:t>, $70,000</a:t>
-            </a:r>
-            <a:endParaRPr lang="en-US" sz="1900" dirty="0"/>
+              <a:rPr lang="en-US" sz="1700" b="1" dirty="0">
+                <a:solidFill>
+                  <a:srgbClr val="000000"/>
+                </a:solidFill>
+                <a:latin typeface="Arial" pitchFamily="34" charset="0"/>
+                <a:ea typeface="Arial" pitchFamily="34" charset="-122"/>
+                <a:cs typeface="Arial" pitchFamily="34" charset="-120"/>
+              </a:rPr>
+              <a:t>Events, Sponsorships &amp; Promotions, $70,000</a:t>
+            </a:r>
+            <a:endParaRPr lang="en-US" sz="1700" dirty="0"/>
           </a:p>
         </p:txBody>
       </p:sp>
@@ -5363,17 +5248,17 @@
               <a:buNone/>
             </a:pPr>
             <a:r>
-              <a:rPr lang="en-US" sz="2400" b="1" dirty="0">
-                <a:solidFill>
-                  <a:srgbClr val="1F3864"/>
-                </a:solidFill>
-                <a:latin typeface="Garamond" pitchFamily="34" charset="0"/>
-                <a:ea typeface="Garamond" pitchFamily="34" charset="-122"/>
-                <a:cs typeface="Garamond" pitchFamily="34" charset="-120"/>
+              <a:rPr lang="en-US" sz="2200" b="1" dirty="0">
+                <a:solidFill>
+                  <a:srgbClr val="000000"/>
+                </a:solidFill>
+                <a:latin typeface="Arial" pitchFamily="34" charset="0"/>
+                <a:ea typeface="Arial" pitchFamily="34" charset="-122"/>
+                <a:cs typeface="Arial" pitchFamily="34" charset="-120"/>
               </a:rPr>
               <a:t>Where the Money Goes (US$)</a:t>
             </a:r>
-            <a:endParaRPr lang="en-US" sz="2400" dirty="0"/>
+            <a:endParaRPr lang="en-US" sz="2200" dirty="0"/>
           </a:p>
         </p:txBody>
       </p:sp>
@@ -5430,7 +5315,7 @@
         <p:spPr>
           <a:xfrm>
             <a:off x="731520" y="457200"/>
-            <a:ext cx="10728655" cy="777240"/>
+            <a:ext cx="10728655" cy="731520"/>
           </a:xfrm>
           <a:prstGeom prst="rect">
             <a:avLst/>
@@ -5446,17 +5331,17 @@
               <a:buNone/>
             </a:pPr>
             <a:r>
-              <a:rPr lang="en-US" sz="4000" dirty="0">
+              <a:rPr lang="en-US" sz="3600" b="1" dirty="0">
                 <a:solidFill>
                   <a:srgbClr val="1F3864"/>
                 </a:solidFill>
-                <a:latin typeface="Garamond" pitchFamily="34" charset="0"/>
-                <a:ea typeface="Garamond" pitchFamily="34" charset="-122"/>
-                <a:cs typeface="Garamond" pitchFamily="34" charset="-120"/>
+                <a:latin typeface="Arial" pitchFamily="34" charset="0"/>
+                <a:ea typeface="Arial" pitchFamily="34" charset="-122"/>
+                <a:cs typeface="Arial" pitchFamily="34" charset="-120"/>
               </a:rPr>
               <a:t>Public Relations (PR)</a:t>
             </a:r>
-            <a:endParaRPr lang="en-US" sz="4000" dirty="0"/>
+            <a:endParaRPr lang="en-US" sz="3600" dirty="0"/>
           </a:p>
         </p:txBody>
       </p:sp>
@@ -5468,7 +5353,7 @@
         </p:nvSpPr>
         <p:spPr>
           <a:xfrm>
-            <a:off x="914400" y="1325880"/>
+            <a:off x="914400" y="1298448"/>
             <a:ext cx="10362895" cy="0"/>
           </a:xfrm>
           <a:prstGeom prst="line">
@@ -5477,7 +5362,7 @@
           <a:noFill/>
           <a:ln w="19050">
             <a:solidFill>
-              <a:srgbClr val="2F5597"/>
+              <a:srgbClr val="1F3864"/>
             </a:solidFill>
             <a:prstDash val="solid"/>
           </a:ln>
@@ -5508,13 +5393,13 @@
               <a:buNone/>
             </a:pPr>
             <a:r>
-              <a:rPr lang="en-US" sz="1800" i="1" dirty="0">
-                <a:solidFill>
-                  <a:srgbClr val="595959"/>
-                </a:solidFill>
-                <a:latin typeface="Garamond" pitchFamily="34" charset="0"/>
-                <a:ea typeface="Garamond" pitchFamily="34" charset="-122"/>
-                <a:cs typeface="Garamond" pitchFamily="34" charset="-120"/>
+              <a:rPr lang="en-US" sz="1800" dirty="0">
+                <a:solidFill>
+                  <a:srgbClr val="000000"/>
+                </a:solidFill>
+                <a:latin typeface="Arial" pitchFamily="34" charset="0"/>
+                <a:ea typeface="Arial" pitchFamily="34" charset="-122"/>
+                <a:cs typeface="Arial" pitchFamily="34" charset="-120"/>
               </a:rPr>
               <a:t>Media relations, corporate events, sponsorships and community relations</a:t>
             </a:r>
@@ -5537,11 +5422,11 @@
             <a:avLst/>
           </a:prstGeom>
           <a:solidFill>
-            <a:srgbClr val="E9DDF2"/>
+            <a:srgbClr val="DEEBF7"/>
           </a:solidFill>
           <a:ln w="12700">
             <a:solidFill>
-              <a:srgbClr val="E9DDF2"/>
+              <a:srgbClr val="DEEBF7"/>
             </a:solidFill>
             <a:prstDash val="solid"/>
           </a:ln>
@@ -5572,17 +5457,17 @@
               <a:buNone/>
             </a:pPr>
             <a:r>
-              <a:rPr lang="en-US" sz="2400" b="1" dirty="0">
-                <a:solidFill>
-                  <a:srgbClr val="7030A0"/>
-                </a:solidFill>
-                <a:latin typeface="Garamond" pitchFamily="34" charset="0"/>
-                <a:ea typeface="Garamond" pitchFamily="34" charset="-122"/>
-                <a:cs typeface="Garamond" pitchFamily="34" charset="-120"/>
+              <a:rPr lang="en-US" sz="2200" b="1" dirty="0">
+                <a:solidFill>
+                  <a:srgbClr val="000000"/>
+                </a:solidFill>
+                <a:latin typeface="Arial" pitchFamily="34" charset="0"/>
+                <a:ea typeface="Arial" pitchFamily="34" charset="-122"/>
+                <a:cs typeface="Arial" pitchFamily="34" charset="-120"/>
               </a:rPr>
               <a:t>Key Figures</a:t>
             </a:r>
-            <a:endParaRPr lang="en-US" sz="2400" dirty="0"/>
+            <a:endParaRPr lang="en-US" sz="2200" dirty="0"/>
           </a:p>
         </p:txBody>
       </p:sp>
@@ -5615,28 +5500,28 @@
               <a:buChar char="•"/>
             </a:pPr>
             <a:r>
-              <a:rPr lang="en-US" sz="1900" dirty="0">
-                <a:solidFill>
-                  <a:srgbClr val="262626"/>
-                </a:solidFill>
-                <a:latin typeface="Garamond" pitchFamily="34" charset="0"/>
-                <a:ea typeface="Garamond" pitchFamily="34" charset="-122"/>
-                <a:cs typeface="Garamond" pitchFamily="34" charset="-120"/>
+              <a:rPr lang="en-US" sz="1700" dirty="0">
+                <a:solidFill>
+                  <a:srgbClr val="000000"/>
+                </a:solidFill>
+                <a:latin typeface="Arial" pitchFamily="34" charset="0"/>
+                <a:ea typeface="Arial" pitchFamily="34" charset="-122"/>
+                <a:cs typeface="Arial" pitchFamily="34" charset="-120"/>
               </a:rPr>
               <a:t>Total budget: </a:t>
             </a:r>
             <a:r>
-              <a:rPr lang="en-US" sz="1900" b="1" dirty="0">
-                <a:solidFill>
-                  <a:srgbClr val="262626"/>
-                </a:solidFill>
-                <a:latin typeface="Garamond" pitchFamily="34" charset="0"/>
-                <a:ea typeface="Garamond" pitchFamily="34" charset="-122"/>
-                <a:cs typeface="Garamond" pitchFamily="34" charset="-120"/>
+              <a:rPr lang="en-US" sz="1700" b="1" dirty="0">
+                <a:solidFill>
+                  <a:srgbClr val="000000"/>
+                </a:solidFill>
+                <a:latin typeface="Arial" pitchFamily="34" charset="0"/>
+                <a:ea typeface="Arial" pitchFamily="34" charset="-122"/>
+                <a:cs typeface="Arial" pitchFamily="34" charset="-120"/>
               </a:rPr>
               <a:t>$130,000</a:t>
             </a:r>
-            <a:endParaRPr lang="en-US" sz="1900" dirty="0"/>
+            <a:endParaRPr lang="en-US" sz="1700" dirty="0"/>
           </a:p>
           <a:p>
             <a:pPr marL="228600" indent="-228600">
@@ -5647,28 +5532,17 @@
               <a:buChar char="•"/>
             </a:pPr>
             <a:r>
-              <a:rPr lang="en-US" sz="1900" dirty="0">
-                <a:solidFill>
-                  <a:srgbClr val="262626"/>
-                </a:solidFill>
-                <a:latin typeface="Garamond" pitchFamily="34" charset="0"/>
-                <a:ea typeface="Garamond" pitchFamily="34" charset="-122"/>
-                <a:cs typeface="Garamond" pitchFamily="34" charset="-120"/>
-              </a:rPr>
-              <a:t>Excel formula: </a:t>
-            </a:r>
-            <a:r>
-              <a:rPr lang="en-US" sz="1900" i="1" dirty="0">
-                <a:solidFill>
-                  <a:srgbClr val="262626"/>
-                </a:solidFill>
-                <a:latin typeface="Garamond" pitchFamily="34" charset="0"/>
-                <a:ea typeface="Garamond" pitchFamily="34" charset="-122"/>
-                <a:cs typeface="Garamond" pitchFamily="34" charset="-120"/>
-              </a:rPr>
-              <a:t>=SUM(D5:D12)</a:t>
-            </a:r>
-            <a:endParaRPr lang="en-US" sz="1900" dirty="0"/>
+              <a:rPr lang="en-US" sz="1700" dirty="0">
+                <a:solidFill>
+                  <a:srgbClr val="000000"/>
+                </a:solidFill>
+                <a:latin typeface="Arial" pitchFamily="34" charset="0"/>
+                <a:ea typeface="Arial" pitchFamily="34" charset="-122"/>
+                <a:cs typeface="Arial" pitchFamily="34" charset="-120"/>
+              </a:rPr>
+              <a:t>Excel formula: =SUM(D5:D12)</a:t>
+            </a:r>
+            <a:endParaRPr lang="en-US" sz="1700" dirty="0"/>
           </a:p>
           <a:p>
             <a:pPr marL="228600" indent="-228600">
@@ -5679,39 +5553,39 @@
               <a:buChar char="•"/>
             </a:pPr>
             <a:r>
-              <a:rPr lang="en-US" sz="1900" dirty="0">
-                <a:solidFill>
-                  <a:srgbClr val="262626"/>
-                </a:solidFill>
-                <a:latin typeface="Garamond" pitchFamily="34" charset="0"/>
-                <a:ea typeface="Garamond" pitchFamily="34" charset="-122"/>
-                <a:cs typeface="Garamond" pitchFamily="34" charset="-120"/>
+              <a:rPr lang="en-US" sz="1700" dirty="0">
+                <a:solidFill>
+                  <a:srgbClr val="000000"/>
+                </a:solidFill>
+                <a:latin typeface="Arial" pitchFamily="34" charset="0"/>
+                <a:ea typeface="Arial" pitchFamily="34" charset="-122"/>
+                <a:cs typeface="Arial" pitchFamily="34" charset="-120"/>
               </a:rPr>
               <a:t>Share of the department: </a:t>
             </a:r>
             <a:r>
-              <a:rPr lang="en-US" sz="1900" b="1" dirty="0">
-                <a:solidFill>
-                  <a:srgbClr val="262626"/>
-                </a:solidFill>
-                <a:latin typeface="Garamond" pitchFamily="34" charset="0"/>
-                <a:ea typeface="Garamond" pitchFamily="34" charset="-122"/>
-                <a:cs typeface="Garamond" pitchFamily="34" charset="-120"/>
+              <a:rPr lang="en-US" sz="1700" b="1" dirty="0">
+                <a:solidFill>
+                  <a:srgbClr val="000000"/>
+                </a:solidFill>
+                <a:latin typeface="Arial" pitchFamily="34" charset="0"/>
+                <a:ea typeface="Arial" pitchFamily="34" charset="-122"/>
+                <a:cs typeface="Arial" pitchFamily="34" charset="-120"/>
               </a:rPr>
               <a:t>14.6%</a:t>
             </a:r>
             <a:r>
-              <a:rPr lang="en-US" sz="1900" dirty="0">
-                <a:solidFill>
-                  <a:srgbClr val="262626"/>
-                </a:solidFill>
-                <a:latin typeface="Garamond" pitchFamily="34" charset="0"/>
-                <a:ea typeface="Garamond" pitchFamily="34" charset="-122"/>
-                <a:cs typeface="Garamond" pitchFamily="34" charset="-120"/>
+              <a:rPr lang="en-US" sz="1700" dirty="0">
+                <a:solidFill>
+                  <a:srgbClr val="000000"/>
+                </a:solidFill>
+                <a:latin typeface="Arial" pitchFamily="34" charset="0"/>
+                <a:ea typeface="Arial" pitchFamily="34" charset="-122"/>
+                <a:cs typeface="Arial" pitchFamily="34" charset="-120"/>
               </a:rPr>
               <a:t> (rank 4 of 4)</a:t>
             </a:r>
-            <a:endParaRPr lang="en-US" sz="1900" dirty="0"/>
+            <a:endParaRPr lang="en-US" sz="1700" dirty="0"/>
           </a:p>
           <a:p>
             <a:pPr marL="228600" indent="-228600">
@@ -5722,28 +5596,28 @@
               <a:buChar char="•"/>
             </a:pPr>
             <a:r>
-              <a:rPr lang="en-US" sz="1900" dirty="0">
-                <a:solidFill>
-                  <a:srgbClr val="262626"/>
-                </a:solidFill>
-                <a:latin typeface="Garamond" pitchFamily="34" charset="0"/>
-                <a:ea typeface="Garamond" pitchFamily="34" charset="-122"/>
-                <a:cs typeface="Garamond" pitchFamily="34" charset="-120"/>
+              <a:rPr lang="en-US" sz="1700" dirty="0">
+                <a:solidFill>
+                  <a:srgbClr val="000000"/>
+                </a:solidFill>
+                <a:latin typeface="Arial" pitchFamily="34" charset="0"/>
+                <a:ea typeface="Arial" pitchFamily="34" charset="-122"/>
+                <a:cs typeface="Arial" pitchFamily="34" charset="-120"/>
               </a:rPr>
               <a:t>Average per budget item: </a:t>
             </a:r>
             <a:r>
-              <a:rPr lang="en-US" sz="1900" b="1" dirty="0">
-                <a:solidFill>
-                  <a:srgbClr val="262626"/>
-                </a:solidFill>
-                <a:latin typeface="Garamond" pitchFamily="34" charset="0"/>
-                <a:ea typeface="Garamond" pitchFamily="34" charset="-122"/>
-                <a:cs typeface="Garamond" pitchFamily="34" charset="-120"/>
+              <a:rPr lang="en-US" sz="1700" b="1" dirty="0">
+                <a:solidFill>
+                  <a:srgbClr val="000000"/>
+                </a:solidFill>
+                <a:latin typeface="Arial" pitchFamily="34" charset="0"/>
+                <a:ea typeface="Arial" pitchFamily="34" charset="-122"/>
+                <a:cs typeface="Arial" pitchFamily="34" charset="-120"/>
               </a:rPr>
               <a:t>$16,250</a:t>
             </a:r>
-            <a:endParaRPr lang="en-US" sz="1900" dirty="0"/>
+            <a:endParaRPr lang="en-US" sz="1700" dirty="0"/>
           </a:p>
           <a:p>
             <a:pPr marL="228600" indent="-228600">
@@ -5754,39 +5628,28 @@
               <a:buChar char="•"/>
             </a:pPr>
             <a:r>
-              <a:rPr lang="en-US" sz="1900" dirty="0">
-                <a:solidFill>
-                  <a:srgbClr val="262626"/>
-                </a:solidFill>
-                <a:latin typeface="Garamond" pitchFamily="34" charset="0"/>
-                <a:ea typeface="Garamond" pitchFamily="34" charset="-122"/>
-                <a:cs typeface="Garamond" pitchFamily="34" charset="-120"/>
+              <a:rPr lang="en-US" sz="1700" dirty="0">
+                <a:solidFill>
+                  <a:srgbClr val="000000"/>
+                </a:solidFill>
+                <a:latin typeface="Arial" pitchFamily="34" charset="0"/>
+                <a:ea typeface="Arial" pitchFamily="34" charset="-122"/>
+                <a:cs typeface="Arial" pitchFamily="34" charset="-120"/>
               </a:rPr>
               <a:t>Largest item: </a:t>
             </a:r>
             <a:r>
-              <a:rPr lang="en-US" sz="1900" b="1" dirty="0">
-                <a:solidFill>
-                  <a:srgbClr val="262626"/>
-                </a:solidFill>
-                <a:latin typeface="Garamond" pitchFamily="34" charset="0"/>
-                <a:ea typeface="Garamond" pitchFamily="34" charset="-122"/>
-                <a:cs typeface="Garamond" pitchFamily="34" charset="-120"/>
-              </a:rPr>
-              <a:t>Staff Salaries &amp; Benefits</a:t>
-            </a:r>
-            <a:r>
-              <a:rPr lang="en-US" sz="1900" dirty="0">
-                <a:solidFill>
-                  <a:srgbClr val="262626"/>
-                </a:solidFill>
-                <a:latin typeface="Garamond" pitchFamily="34" charset="0"/>
-                <a:ea typeface="Garamond" pitchFamily="34" charset="-122"/>
-                <a:cs typeface="Garamond" pitchFamily="34" charset="-120"/>
-              </a:rPr>
-              <a:t>, $44,000</a:t>
-            </a:r>
-            <a:endParaRPr lang="en-US" sz="1900" dirty="0"/>
+              <a:rPr lang="en-US" sz="1700" b="1" dirty="0">
+                <a:solidFill>
+                  <a:srgbClr val="000000"/>
+                </a:solidFill>
+                <a:latin typeface="Arial" pitchFamily="34" charset="0"/>
+                <a:ea typeface="Arial" pitchFamily="34" charset="-122"/>
+                <a:cs typeface="Arial" pitchFamily="34" charset="-120"/>
+              </a:rPr>
+              <a:t>Staff Salaries &amp; Benefits, $44,000</a:t>
+            </a:r>
+            <a:endParaRPr lang="en-US" sz="1700" dirty="0"/>
           </a:p>
         </p:txBody>
       </p:sp>
@@ -5815,17 +5678,17 @@
               <a:buNone/>
             </a:pPr>
             <a:r>
-              <a:rPr lang="en-US" sz="2400" b="1" dirty="0">
-                <a:solidFill>
-                  <a:srgbClr val="1F3864"/>
-                </a:solidFill>
-                <a:latin typeface="Garamond" pitchFamily="34" charset="0"/>
-                <a:ea typeface="Garamond" pitchFamily="34" charset="-122"/>
-                <a:cs typeface="Garamond" pitchFamily="34" charset="-120"/>
+              <a:rPr lang="en-US" sz="2200" b="1" dirty="0">
+                <a:solidFill>
+                  <a:srgbClr val="000000"/>
+                </a:solidFill>
+                <a:latin typeface="Arial" pitchFamily="34" charset="0"/>
+                <a:ea typeface="Arial" pitchFamily="34" charset="-122"/>
+                <a:cs typeface="Arial" pitchFamily="34" charset="-120"/>
               </a:rPr>
               <a:t>Where the Money Goes (US$)</a:t>
             </a:r>
-            <a:endParaRPr lang="en-US" sz="2400" dirty="0"/>
+            <a:endParaRPr lang="en-US" sz="2200" dirty="0"/>
           </a:p>
         </p:txBody>
       </p:sp>
@@ -5882,7 +5745,7 @@
         <p:spPr>
           <a:xfrm>
             <a:off x="731520" y="457200"/>
-            <a:ext cx="10728655" cy="777240"/>
+            <a:ext cx="10728655" cy="731520"/>
           </a:xfrm>
           <a:prstGeom prst="rect">
             <a:avLst/>
@@ -5898,17 +5761,17 @@
               <a:buNone/>
             </a:pPr>
             <a:r>
-              <a:rPr lang="en-US" sz="4000" dirty="0">
+              <a:rPr lang="en-US" sz="3600" b="1" dirty="0">
                 <a:solidFill>
                   <a:srgbClr val="1F3864"/>
                 </a:solidFill>
-                <a:latin typeface="Garamond" pitchFamily="34" charset="0"/>
-                <a:ea typeface="Garamond" pitchFamily="34" charset="-122"/>
-                <a:cs typeface="Garamond" pitchFamily="34" charset="-120"/>
+                <a:latin typeface="Arial" pitchFamily="34" charset="0"/>
+                <a:ea typeface="Arial" pitchFamily="34" charset="-122"/>
+                <a:cs typeface="Arial" pitchFamily="34" charset="-120"/>
               </a:rPr>
               <a:t>e-Business</a:t>
             </a:r>
-            <a:endParaRPr lang="en-US" sz="4000" dirty="0"/>
+            <a:endParaRPr lang="en-US" sz="3600" dirty="0"/>
           </a:p>
         </p:txBody>
       </p:sp>
@@ -5920,7 +5783,7 @@
         </p:nvSpPr>
         <p:spPr>
           <a:xfrm>
-            <a:off x="914400" y="1325880"/>
+            <a:off x="914400" y="1298448"/>
             <a:ext cx="10362895" cy="0"/>
           </a:xfrm>
           <a:prstGeom prst="line">
@@ -5929,7 +5792,7 @@
           <a:noFill/>
           <a:ln w="19050">
             <a:solidFill>
-              <a:srgbClr val="2F5597"/>
+              <a:srgbClr val="1F3864"/>
             </a:solidFill>
             <a:prstDash val="solid"/>
           </a:ln>
@@ -5960,13 +5823,13 @@
               <a:buNone/>
             </a:pPr>
             <a:r>
-              <a:rPr lang="en-US" sz="1800" i="1" dirty="0">
-                <a:solidFill>
-                  <a:srgbClr val="595959"/>
-                </a:solidFill>
-                <a:latin typeface="Garamond" pitchFamily="34" charset="0"/>
-                <a:ea typeface="Garamond" pitchFamily="34" charset="-122"/>
-                <a:cs typeface="Garamond" pitchFamily="34" charset="-120"/>
+              <a:rPr lang="en-US" sz="1800" dirty="0">
+                <a:solidFill>
+                  <a:srgbClr val="000000"/>
+                </a:solidFill>
+                <a:latin typeface="Arial" pitchFamily="34" charset="0"/>
+                <a:ea typeface="Arial" pitchFamily="34" charset="-122"/>
+                <a:cs typeface="Arial" pitchFamily="34" charset="-120"/>
               </a:rPr>
               <a:t>Company website, e-commerce platform, search and social media marketing</a:t>
             </a:r>
@@ -5989,11 +5852,11 @@
             <a:avLst/>
           </a:prstGeom>
           <a:solidFill>
-            <a:srgbClr val="E2F0D9"/>
+            <a:srgbClr val="DEEBF7"/>
           </a:solidFill>
           <a:ln w="12700">
             <a:solidFill>
-              <a:srgbClr val="E2F0D9"/>
+              <a:srgbClr val="DEEBF7"/>
             </a:solidFill>
             <a:prstDash val="solid"/>
           </a:ln>
@@ -6024,17 +5887,17 @@
               <a:buNone/>
             </a:pPr>
             <a:r>
-              <a:rPr lang="en-US" sz="2400" b="1" dirty="0">
-                <a:solidFill>
-                  <a:srgbClr val="548235"/>
-                </a:solidFill>
-                <a:latin typeface="Garamond" pitchFamily="34" charset="0"/>
-                <a:ea typeface="Garamond" pitchFamily="34" charset="-122"/>
-                <a:cs typeface="Garamond" pitchFamily="34" charset="-120"/>
+              <a:rPr lang="en-US" sz="2200" b="1" dirty="0">
+                <a:solidFill>
+                  <a:srgbClr val="000000"/>
+                </a:solidFill>
+                <a:latin typeface="Arial" pitchFamily="34" charset="0"/>
+                <a:ea typeface="Arial" pitchFamily="34" charset="-122"/>
+                <a:cs typeface="Arial" pitchFamily="34" charset="-120"/>
               </a:rPr>
               <a:t>Key Figures</a:t>
             </a:r>
-            <a:endParaRPr lang="en-US" sz="2400" dirty="0"/>
+            <a:endParaRPr lang="en-US" sz="2200" dirty="0"/>
           </a:p>
         </p:txBody>
       </p:sp>
@@ -6067,28 +5930,28 @@
               <a:buChar char="•"/>
             </a:pPr>
             <a:r>
-              <a:rPr lang="en-US" sz="1900" dirty="0">
-                <a:solidFill>
-                  <a:srgbClr val="262626"/>
-                </a:solidFill>
-                <a:latin typeface="Garamond" pitchFamily="34" charset="0"/>
-                <a:ea typeface="Garamond" pitchFamily="34" charset="-122"/>
-                <a:cs typeface="Garamond" pitchFamily="34" charset="-120"/>
+              <a:rPr lang="en-US" sz="1700" dirty="0">
+                <a:solidFill>
+                  <a:srgbClr val="000000"/>
+                </a:solidFill>
+                <a:latin typeface="Arial" pitchFamily="34" charset="0"/>
+                <a:ea typeface="Arial" pitchFamily="34" charset="-122"/>
+                <a:cs typeface="Arial" pitchFamily="34" charset="-120"/>
               </a:rPr>
               <a:t>Total budget: </a:t>
             </a:r>
             <a:r>
-              <a:rPr lang="en-US" sz="1900" b="1" dirty="0">
-                <a:solidFill>
-                  <a:srgbClr val="262626"/>
-                </a:solidFill>
-                <a:latin typeface="Garamond" pitchFamily="34" charset="0"/>
-                <a:ea typeface="Garamond" pitchFamily="34" charset="-122"/>
-                <a:cs typeface="Garamond" pitchFamily="34" charset="-120"/>
+              <a:rPr lang="en-US" sz="1700" b="1" dirty="0">
+                <a:solidFill>
+                  <a:srgbClr val="000000"/>
+                </a:solidFill>
+                <a:latin typeface="Arial" pitchFamily="34" charset="0"/>
+                <a:ea typeface="Arial" pitchFamily="34" charset="-122"/>
+                <a:cs typeface="Arial" pitchFamily="34" charset="-120"/>
               </a:rPr>
               <a:t>$180,000</a:t>
             </a:r>
-            <a:endParaRPr lang="en-US" sz="1900" dirty="0"/>
+            <a:endParaRPr lang="en-US" sz="1700" dirty="0"/>
           </a:p>
           <a:p>
             <a:pPr marL="228600" indent="-228600">
@@ -6099,28 +5962,17 @@
               <a:buChar char="•"/>
             </a:pPr>
             <a:r>
-              <a:rPr lang="en-US" sz="1900" dirty="0">
-                <a:solidFill>
-                  <a:srgbClr val="262626"/>
-                </a:solidFill>
-                <a:latin typeface="Garamond" pitchFamily="34" charset="0"/>
-                <a:ea typeface="Garamond" pitchFamily="34" charset="-122"/>
-                <a:cs typeface="Garamond" pitchFamily="34" charset="-120"/>
-              </a:rPr>
-              <a:t>Excel formula: </a:t>
-            </a:r>
-            <a:r>
-              <a:rPr lang="en-US" sz="1900" i="1" dirty="0">
-                <a:solidFill>
-                  <a:srgbClr val="262626"/>
-                </a:solidFill>
-                <a:latin typeface="Garamond" pitchFamily="34" charset="0"/>
-                <a:ea typeface="Garamond" pitchFamily="34" charset="-122"/>
-                <a:cs typeface="Garamond" pitchFamily="34" charset="-120"/>
-              </a:rPr>
-              <a:t>=SUM(E5:E12)</a:t>
-            </a:r>
-            <a:endParaRPr lang="en-US" sz="1900" dirty="0"/>
+              <a:rPr lang="en-US" sz="1700" dirty="0">
+                <a:solidFill>
+                  <a:srgbClr val="000000"/>
+                </a:solidFill>
+                <a:latin typeface="Arial" pitchFamily="34" charset="0"/>
+                <a:ea typeface="Arial" pitchFamily="34" charset="-122"/>
+                <a:cs typeface="Arial" pitchFamily="34" charset="-120"/>
+              </a:rPr>
+              <a:t>Excel formula: =SUM(E5:E12)</a:t>
+            </a:r>
+            <a:endParaRPr lang="en-US" sz="1700" dirty="0"/>
           </a:p>
           <a:p>
             <a:pPr marL="228600" indent="-228600">
@@ -6131,39 +5983,39 @@
               <a:buChar char="•"/>
             </a:pPr>
             <a:r>
-              <a:rPr lang="en-US" sz="1900" dirty="0">
-                <a:solidFill>
-                  <a:srgbClr val="262626"/>
-                </a:solidFill>
-                <a:latin typeface="Garamond" pitchFamily="34" charset="0"/>
-                <a:ea typeface="Garamond" pitchFamily="34" charset="-122"/>
-                <a:cs typeface="Garamond" pitchFamily="34" charset="-120"/>
+              <a:rPr lang="en-US" sz="1700" dirty="0">
+                <a:solidFill>
+                  <a:srgbClr val="000000"/>
+                </a:solidFill>
+                <a:latin typeface="Arial" pitchFamily="34" charset="0"/>
+                <a:ea typeface="Arial" pitchFamily="34" charset="-122"/>
+                <a:cs typeface="Arial" pitchFamily="34" charset="-120"/>
               </a:rPr>
               <a:t>Share of the department: </a:t>
             </a:r>
             <a:r>
-              <a:rPr lang="en-US" sz="1900" b="1" dirty="0">
-                <a:solidFill>
-                  <a:srgbClr val="262626"/>
-                </a:solidFill>
-                <a:latin typeface="Garamond" pitchFamily="34" charset="0"/>
-                <a:ea typeface="Garamond" pitchFamily="34" charset="-122"/>
-                <a:cs typeface="Garamond" pitchFamily="34" charset="-120"/>
+              <a:rPr lang="en-US" sz="1700" b="1" dirty="0">
+                <a:solidFill>
+                  <a:srgbClr val="000000"/>
+                </a:solidFill>
+                <a:latin typeface="Arial" pitchFamily="34" charset="0"/>
+                <a:ea typeface="Arial" pitchFamily="34" charset="-122"/>
+                <a:cs typeface="Arial" pitchFamily="34" charset="-120"/>
               </a:rPr>
               <a:t>20.2%</a:t>
             </a:r>
             <a:r>
-              <a:rPr lang="en-US" sz="1900" dirty="0">
-                <a:solidFill>
-                  <a:srgbClr val="262626"/>
-                </a:solidFill>
-                <a:latin typeface="Garamond" pitchFamily="34" charset="0"/>
-                <a:ea typeface="Garamond" pitchFamily="34" charset="-122"/>
-                <a:cs typeface="Garamond" pitchFamily="34" charset="-120"/>
+              <a:rPr lang="en-US" sz="1700" dirty="0">
+                <a:solidFill>
+                  <a:srgbClr val="000000"/>
+                </a:solidFill>
+                <a:latin typeface="Arial" pitchFamily="34" charset="0"/>
+                <a:ea typeface="Arial" pitchFamily="34" charset="-122"/>
+                <a:cs typeface="Arial" pitchFamily="34" charset="-120"/>
               </a:rPr>
               <a:t> (rank 3 of 4)</a:t>
             </a:r>
-            <a:endParaRPr lang="en-US" sz="1900" dirty="0"/>
+            <a:endParaRPr lang="en-US" sz="1700" dirty="0"/>
           </a:p>
           <a:p>
             <a:pPr marL="228600" indent="-228600">
@@ -6174,28 +6026,28 @@
               <a:buChar char="•"/>
             </a:pPr>
             <a:r>
-              <a:rPr lang="en-US" sz="1900" dirty="0">
-                <a:solidFill>
-                  <a:srgbClr val="262626"/>
-                </a:solidFill>
-                <a:latin typeface="Garamond" pitchFamily="34" charset="0"/>
-                <a:ea typeface="Garamond" pitchFamily="34" charset="-122"/>
-                <a:cs typeface="Garamond" pitchFamily="34" charset="-120"/>
+              <a:rPr lang="en-US" sz="1700" dirty="0">
+                <a:solidFill>
+                  <a:srgbClr val="000000"/>
+                </a:solidFill>
+                <a:latin typeface="Arial" pitchFamily="34" charset="0"/>
+                <a:ea typeface="Arial" pitchFamily="34" charset="-122"/>
+                <a:cs typeface="Arial" pitchFamily="34" charset="-120"/>
               </a:rPr>
               <a:t>Average per budget item: </a:t>
             </a:r>
             <a:r>
-              <a:rPr lang="en-US" sz="1900" b="1" dirty="0">
-                <a:solidFill>
-                  <a:srgbClr val="262626"/>
-                </a:solidFill>
-                <a:latin typeface="Garamond" pitchFamily="34" charset="0"/>
-                <a:ea typeface="Garamond" pitchFamily="34" charset="-122"/>
-                <a:cs typeface="Garamond" pitchFamily="34" charset="-120"/>
+              <a:rPr lang="en-US" sz="1700" b="1" dirty="0">
+                <a:solidFill>
+                  <a:srgbClr val="000000"/>
+                </a:solidFill>
+                <a:latin typeface="Arial" pitchFamily="34" charset="0"/>
+                <a:ea typeface="Arial" pitchFamily="34" charset="-122"/>
+                <a:cs typeface="Arial" pitchFamily="34" charset="-120"/>
               </a:rPr>
               <a:t>$22,500</a:t>
             </a:r>
-            <a:endParaRPr lang="en-US" sz="1900" dirty="0"/>
+            <a:endParaRPr lang="en-US" sz="1700" dirty="0"/>
           </a:p>
           <a:p>
             <a:pPr marL="228600" indent="-228600">
@@ -6206,39 +6058,28 @@
               <a:buChar char="•"/>
             </a:pPr>
             <a:r>
-              <a:rPr lang="en-US" sz="1900" dirty="0">
-                <a:solidFill>
-                  <a:srgbClr val="262626"/>
-                </a:solidFill>
-                <a:latin typeface="Garamond" pitchFamily="34" charset="0"/>
-                <a:ea typeface="Garamond" pitchFamily="34" charset="-122"/>
-                <a:cs typeface="Garamond" pitchFamily="34" charset="-120"/>
+              <a:rPr lang="en-US" sz="1700" dirty="0">
+                <a:solidFill>
+                  <a:srgbClr val="000000"/>
+                </a:solidFill>
+                <a:latin typeface="Arial" pitchFamily="34" charset="0"/>
+                <a:ea typeface="Arial" pitchFamily="34" charset="-122"/>
+                <a:cs typeface="Arial" pitchFamily="34" charset="-120"/>
               </a:rPr>
               <a:t>Largest item: </a:t>
             </a:r>
             <a:r>
-              <a:rPr lang="en-US" sz="1900" b="1" dirty="0">
-                <a:solidFill>
-                  <a:srgbClr val="262626"/>
-                </a:solidFill>
-                <a:latin typeface="Garamond" pitchFamily="34" charset="0"/>
-                <a:ea typeface="Garamond" pitchFamily="34" charset="-122"/>
-                <a:cs typeface="Garamond" pitchFamily="34" charset="-120"/>
-              </a:rPr>
-              <a:t>Digital Platforms &amp; Technology</a:t>
-            </a:r>
-            <a:r>
-              <a:rPr lang="en-US" sz="1900" dirty="0">
-                <a:solidFill>
-                  <a:srgbClr val="262626"/>
-                </a:solidFill>
-                <a:latin typeface="Garamond" pitchFamily="34" charset="0"/>
-                <a:ea typeface="Garamond" pitchFamily="34" charset="-122"/>
-                <a:cs typeface="Garamond" pitchFamily="34" charset="-120"/>
-              </a:rPr>
-              <a:t>, $60,000</a:t>
-            </a:r>
-            <a:endParaRPr lang="en-US" sz="1900" dirty="0"/>
+              <a:rPr lang="en-US" sz="1700" b="1" dirty="0">
+                <a:solidFill>
+                  <a:srgbClr val="000000"/>
+                </a:solidFill>
+                <a:latin typeface="Arial" pitchFamily="34" charset="0"/>
+                <a:ea typeface="Arial" pitchFamily="34" charset="-122"/>
+                <a:cs typeface="Arial" pitchFamily="34" charset="-120"/>
+              </a:rPr>
+              <a:t>Digital Platforms &amp; Technology, $60,000</a:t>
+            </a:r>
+            <a:endParaRPr lang="en-US" sz="1700" dirty="0"/>
           </a:p>
         </p:txBody>
       </p:sp>
@@ -6267,17 +6108,17 @@
               <a:buNone/>
             </a:pPr>
             <a:r>
-              <a:rPr lang="en-US" sz="2400" b="1" dirty="0">
-                <a:solidFill>
-                  <a:srgbClr val="1F3864"/>
-                </a:solidFill>
-                <a:latin typeface="Garamond" pitchFamily="34" charset="0"/>
-                <a:ea typeface="Garamond" pitchFamily="34" charset="-122"/>
-                <a:cs typeface="Garamond" pitchFamily="34" charset="-120"/>
+              <a:rPr lang="en-US" sz="2200" b="1" dirty="0">
+                <a:solidFill>
+                  <a:srgbClr val="000000"/>
+                </a:solidFill>
+                <a:latin typeface="Arial" pitchFamily="34" charset="0"/>
+                <a:ea typeface="Arial" pitchFamily="34" charset="-122"/>
+                <a:cs typeface="Arial" pitchFamily="34" charset="-120"/>
               </a:rPr>
               <a:t>Where the Money Goes (US$)</a:t>
             </a:r>
-            <a:endParaRPr lang="en-US" sz="2400" dirty="0"/>
+            <a:endParaRPr lang="en-US" sz="2200" dirty="0"/>
           </a:p>
         </p:txBody>
       </p:sp>
@@ -6334,7 +6175,7 @@
         <p:spPr>
           <a:xfrm>
             <a:off x="731520" y="457200"/>
-            <a:ext cx="10728655" cy="777240"/>
+            <a:ext cx="10728655" cy="731520"/>
           </a:xfrm>
           <a:prstGeom prst="rect">
             <a:avLst/>
@@ -6350,17 +6191,17 @@
               <a:buNone/>
             </a:pPr>
             <a:r>
-              <a:rPr lang="en-US" sz="4000" dirty="0">
+              <a:rPr lang="en-US" sz="3600" b="1" dirty="0">
                 <a:solidFill>
                   <a:srgbClr val="1F3864"/>
                 </a:solidFill>
-                <a:latin typeface="Garamond" pitchFamily="34" charset="0"/>
-                <a:ea typeface="Garamond" pitchFamily="34" charset="-122"/>
-                <a:cs typeface="Garamond" pitchFamily="34" charset="-120"/>
+                <a:latin typeface="Arial" pitchFamily="34" charset="0"/>
+                <a:ea typeface="Arial" pitchFamily="34" charset="-122"/>
+                <a:cs typeface="Arial" pitchFamily="34" charset="-120"/>
               </a:rPr>
               <a:t>Budget Table from Excel</a:t>
             </a:r>
-            <a:endParaRPr lang="en-US" sz="4000" dirty="0"/>
+            <a:endParaRPr lang="en-US" sz="3600" dirty="0"/>
           </a:p>
         </p:txBody>
       </p:sp>
@@ -6372,7 +6213,7 @@
         </p:nvSpPr>
         <p:spPr>
           <a:xfrm>
-            <a:off x="914400" y="1325880"/>
+            <a:off x="914400" y="1298448"/>
             <a:ext cx="10362895" cy="0"/>
           </a:xfrm>
           <a:prstGeom prst="line">
@@ -6381,7 +6222,7 @@
           <a:noFill/>
           <a:ln w="19050">
             <a:solidFill>
-              <a:srgbClr val="2F5597"/>
+              <a:srgbClr val="1F3864"/>
             </a:solidFill>
             <a:prstDash val="solid"/>
           </a:ln>
@@ -6412,13 +6253,13 @@
               <a:buNone/>
             </a:pPr>
             <a:r>
-              <a:rPr lang="en-US" sz="1800" i="1" dirty="0">
-                <a:solidFill>
-                  <a:srgbClr val="595959"/>
-                </a:solidFill>
-                <a:latin typeface="Garamond" pitchFamily="34" charset="0"/>
-                <a:ea typeface="Garamond" pitchFamily="34" charset="-122"/>
-                <a:cs typeface="Garamond" pitchFamily="34" charset="-120"/>
+              <a:rPr lang="en-US" sz="1800" dirty="0">
+                <a:solidFill>
+                  <a:srgbClr val="000000"/>
+                </a:solidFill>
+                <a:latin typeface="Arial" pitchFamily="34" charset="0"/>
+                <a:ea typeface="Arial" pitchFamily="34" charset="-122"/>
+                <a:cs typeface="Arial" pitchFamily="34" charset="-120"/>
               </a:rPr>
               <a:t>Imported from Marketing_Department_Budget.xlsx, sheet “Marketing Budget”, cells A4:G15</a:t>
             </a:r>
@@ -6493,28 +6334,28 @@
               <a:buNone/>
             </a:pPr>
             <a:r>
-              <a:rPr lang="en-US" sz="1600" b="1" dirty="0">
-                <a:solidFill>
-                  <a:srgbClr val="1F3864"/>
-                </a:solidFill>
-                <a:latin typeface="Garamond" pitchFamily="34" charset="0"/>
-                <a:ea typeface="Garamond" pitchFamily="34" charset="-122"/>
-                <a:cs typeface="Garamond" pitchFamily="34" charset="-120"/>
+              <a:rPr lang="en-US" sz="1500" b="1" dirty="0">
+                <a:solidFill>
+                  <a:srgbClr val="000000"/>
+                </a:solidFill>
+                <a:latin typeface="Arial" pitchFamily="34" charset="0"/>
+                <a:ea typeface="Arial" pitchFamily="34" charset="-122"/>
+                <a:cs typeface="Arial" pitchFamily="34" charset="-120"/>
               </a:rPr>
               <a:t>Double-click the table to open it in Excel. </a:t>
             </a:r>
             <a:r>
-              <a:rPr lang="en-US" sz="1600" dirty="0">
-                <a:solidFill>
-                  <a:srgbClr val="595959"/>
-                </a:solidFill>
-                <a:latin typeface="Garamond" pitchFamily="34" charset="0"/>
-                <a:ea typeface="Garamond" pitchFamily="34" charset="-122"/>
-                <a:cs typeface="Garamond" pitchFamily="34" charset="-120"/>
+              <a:rPr lang="en-US" sz="1500" dirty="0">
+                <a:solidFill>
+                  <a:srgbClr val="000000"/>
+                </a:solidFill>
+                <a:latin typeface="Arial" pitchFamily="34" charset="0"/>
+                <a:ea typeface="Arial" pitchFamily="34" charset="-122"/>
+                <a:cs typeface="Arial" pitchFamily="34" charset="-120"/>
               </a:rPr>
               <a:t>Blue figures are the budget inputs; black figures are SUM and AVERAGE formulas.</a:t>
             </a:r>
-            <a:endParaRPr lang="en-US" sz="1600" dirty="0"/>
+            <a:endParaRPr lang="en-US" sz="1500" dirty="0"/>
           </a:p>
         </p:txBody>
       </p:sp>
@@ -6555,7 +6396,7 @@
         <p:spPr>
           <a:xfrm>
             <a:off x="731520" y="457200"/>
-            <a:ext cx="10728655" cy="777240"/>
+            <a:ext cx="10728655" cy="731520"/>
           </a:xfrm>
           <a:prstGeom prst="rect">
             <a:avLst/>
@@ -6571,17 +6412,17 @@
               <a:buNone/>
             </a:pPr>
             <a:r>
-              <a:rPr lang="en-US" sz="4000" dirty="0">
+              <a:rPr lang="en-US" sz="3600" b="1" dirty="0">
                 <a:solidFill>
                   <a:srgbClr val="1F3864"/>
                 </a:solidFill>
-                <a:latin typeface="Garamond" pitchFamily="34" charset="0"/>
-                <a:ea typeface="Garamond" pitchFamily="34" charset="-122"/>
-                <a:cs typeface="Garamond" pitchFamily="34" charset="-120"/>
+                <a:latin typeface="Arial" pitchFamily="34" charset="0"/>
+                <a:ea typeface="Arial" pitchFamily="34" charset="-122"/>
+                <a:cs typeface="Arial" pitchFamily="34" charset="-120"/>
               </a:rPr>
               <a:t>Unit Budgets vs. the Average</a:t>
             </a:r>
-            <a:endParaRPr lang="en-US" sz="4000" dirty="0"/>
+            <a:endParaRPr lang="en-US" sz="3600" dirty="0"/>
           </a:p>
         </p:txBody>
       </p:sp>
@@ -6593,7 +6434,7 @@
         </p:nvSpPr>
         <p:spPr>
           <a:xfrm>
-            <a:off x="914400" y="1325880"/>
+            <a:off x="914400" y="1298448"/>
             <a:ext cx="10362895" cy="0"/>
           </a:xfrm>
           <a:prstGeom prst="line">
@@ -6602,7 +6443,7 @@
           <a:noFill/>
           <a:ln w="19050">
             <a:solidFill>
-              <a:srgbClr val="2F5597"/>
+              <a:srgbClr val="1F3864"/>
             </a:solidFill>
             <a:prstDash val="solid"/>
           </a:ln>
@@ -6633,13 +6474,13 @@
               <a:buNone/>
             </a:pPr>
             <a:r>
-              <a:rPr lang="en-US" sz="1800" i="1" dirty="0">
-                <a:solidFill>
-                  <a:srgbClr val="595959"/>
-                </a:solidFill>
-                <a:latin typeface="Garamond" pitchFamily="34" charset="0"/>
-                <a:ea typeface="Garamond" pitchFamily="34" charset="-122"/>
-                <a:cs typeface="Garamond" pitchFamily="34" charset="-120"/>
+              <a:rPr lang="en-US" sz="1800" dirty="0">
+                <a:solidFill>
+                  <a:srgbClr val="000000"/>
+                </a:solidFill>
+                <a:latin typeface="Arial" pitchFamily="34" charset="0"/>
+                <a:ea typeface="Arial" pitchFamily="34" charset="-122"/>
+                <a:cs typeface="Arial" pitchFamily="34" charset="-120"/>
               </a:rPr>
               <a:t>Each unit's total (SUM) compared with the average of $222,500 per unit (AVERAGE)</a:t>
             </a:r>
@@ -6678,11 +6519,11 @@
             <a:avLst/>
           </a:prstGeom>
           <a:solidFill>
-            <a:srgbClr val="F2F2F2"/>
+            <a:srgbClr val="DEEBF7"/>
           </a:solidFill>
           <a:ln w="12700">
             <a:solidFill>
-              <a:srgbClr val="F2F2F2"/>
+              <a:srgbClr val="DEEBF7"/>
             </a:solidFill>
             <a:prstDash val="solid"/>
           </a:ln>
@@ -6697,7 +6538,7 @@
         <p:spPr>
           <a:xfrm>
             <a:off x="8001000" y="2487168"/>
-            <a:ext cx="502920" cy="0"/>
+            <a:ext cx="457200" cy="0"/>
           </a:xfrm>
           <a:prstGeom prst="line">
             <a:avLst/>
@@ -6705,7 +6546,7 @@
           <a:noFill/>
           <a:ln w="25400">
             <a:solidFill>
-              <a:srgbClr val="1F3864"/>
+              <a:srgbClr val="000000"/>
             </a:solidFill>
             <a:prstDash val="dash"/>
           </a:ln>
@@ -6719,8 +6560,8 @@
         </p:nvSpPr>
         <p:spPr>
           <a:xfrm>
-            <a:off x="8595360" y="2240280"/>
-            <a:ext cx="2743200" cy="502920"/>
+            <a:off x="8549640" y="2240280"/>
+            <a:ext cx="2788920" cy="502920"/>
           </a:xfrm>
           <a:prstGeom prst="rect">
             <a:avLst/>
@@ -6736,17 +6577,17 @@
               <a:buNone/>
             </a:pPr>
             <a:r>
-              <a:rPr lang="en-US" sz="1900" b="1" dirty="0">
-                <a:solidFill>
-                  <a:srgbClr val="1F3864"/>
-                </a:solidFill>
-                <a:latin typeface="Garamond" pitchFamily="34" charset="0"/>
-                <a:ea typeface="Garamond" pitchFamily="34" charset="-122"/>
-                <a:cs typeface="Garamond" pitchFamily="34" charset="-120"/>
+              <a:rPr lang="en-US" sz="1600" b="1" dirty="0">
+                <a:solidFill>
+                  <a:srgbClr val="000000"/>
+                </a:solidFill>
+                <a:latin typeface="Arial" pitchFamily="34" charset="0"/>
+                <a:ea typeface="Arial" pitchFamily="34" charset="-122"/>
+                <a:cs typeface="Arial" pitchFamily="34" charset="-120"/>
               </a:rPr>
               <a:t>Average per unit: $222,500</a:t>
             </a:r>
-            <a:endParaRPr lang="en-US" sz="1900" dirty="0"/>
+            <a:endParaRPr lang="en-US" sz="1600" dirty="0"/>
           </a:p>
         </p:txBody>
       </p:sp>
@@ -6779,28 +6620,28 @@
               <a:buChar char="•"/>
             </a:pPr>
             <a:r>
-              <a:rPr lang="en-US" sz="1900" b="1" dirty="0">
-                <a:solidFill>
-                  <a:srgbClr val="262626"/>
-                </a:solidFill>
-                <a:latin typeface="Garamond" pitchFamily="34" charset="0"/>
-                <a:ea typeface="Garamond" pitchFamily="34" charset="-122"/>
-                <a:cs typeface="Garamond" pitchFamily="34" charset="-120"/>
+              <a:rPr lang="en-US" sz="1700" b="1" dirty="0">
+                <a:solidFill>
+                  <a:srgbClr val="000000"/>
+                </a:solidFill>
+                <a:latin typeface="Arial" pitchFamily="34" charset="0"/>
+                <a:ea typeface="Arial" pitchFamily="34" charset="-122"/>
+                <a:cs typeface="Arial" pitchFamily="34" charset="-120"/>
               </a:rPr>
               <a:t>Advertising: </a:t>
             </a:r>
             <a:r>
-              <a:rPr lang="en-US" sz="1900" dirty="0">
-                <a:solidFill>
-                  <a:srgbClr val="262626"/>
-                </a:solidFill>
-                <a:latin typeface="Garamond" pitchFamily="34" charset="0"/>
-                <a:ea typeface="Garamond" pitchFamily="34" charset="-122"/>
-                <a:cs typeface="Garamond" pitchFamily="34" charset="-120"/>
+              <a:rPr lang="en-US" sz="1700" dirty="0">
+                <a:solidFill>
+                  <a:srgbClr val="000000"/>
+                </a:solidFill>
+                <a:latin typeface="Arial" pitchFamily="34" charset="0"/>
+                <a:ea typeface="Arial" pitchFamily="34" charset="-122"/>
+                <a:cs typeface="Arial" pitchFamily="34" charset="-120"/>
               </a:rPr>
               <a:t>$97,500 above the average</a:t>
             </a:r>
-            <a:endParaRPr lang="en-US" sz="1900" dirty="0"/>
+            <a:endParaRPr lang="en-US" sz="1700" dirty="0"/>
           </a:p>
           <a:p>
             <a:pPr marL="228600" indent="-228600">
@@ -6811,28 +6652,28 @@
               <a:buChar char="•"/>
             </a:pPr>
             <a:r>
-              <a:rPr lang="en-US" sz="1900" b="1" dirty="0">
-                <a:solidFill>
-                  <a:srgbClr val="262626"/>
-                </a:solidFill>
-                <a:latin typeface="Garamond" pitchFamily="34" charset="0"/>
-                <a:ea typeface="Garamond" pitchFamily="34" charset="-122"/>
-                <a:cs typeface="Garamond" pitchFamily="34" charset="-120"/>
+              <a:rPr lang="en-US" sz="1700" b="1" dirty="0">
+                <a:solidFill>
+                  <a:srgbClr val="000000"/>
+                </a:solidFill>
+                <a:latin typeface="Arial" pitchFamily="34" charset="0"/>
+                <a:ea typeface="Arial" pitchFamily="34" charset="-122"/>
+                <a:cs typeface="Arial" pitchFamily="34" charset="-120"/>
               </a:rPr>
               <a:t>Marketing: </a:t>
             </a:r>
             <a:r>
-              <a:rPr lang="en-US" sz="1900" dirty="0">
-                <a:solidFill>
-                  <a:srgbClr val="262626"/>
-                </a:solidFill>
-                <a:latin typeface="Garamond" pitchFamily="34" charset="0"/>
-                <a:ea typeface="Garamond" pitchFamily="34" charset="-122"/>
-                <a:cs typeface="Garamond" pitchFamily="34" charset="-120"/>
+              <a:rPr lang="en-US" sz="1700" dirty="0">
+                <a:solidFill>
+                  <a:srgbClr val="000000"/>
+                </a:solidFill>
+                <a:latin typeface="Arial" pitchFamily="34" charset="0"/>
+                <a:ea typeface="Arial" pitchFamily="34" charset="-122"/>
+                <a:cs typeface="Arial" pitchFamily="34" charset="-120"/>
               </a:rPr>
               <a:t>$37,500 above the average</a:t>
             </a:r>
-            <a:endParaRPr lang="en-US" sz="1900" dirty="0"/>
+            <a:endParaRPr lang="en-US" sz="1700" dirty="0"/>
           </a:p>
           <a:p>
             <a:pPr marL="228600" indent="-228600">
@@ -6843,28 +6684,28 @@
               <a:buChar char="•"/>
             </a:pPr>
             <a:r>
-              <a:rPr lang="en-US" sz="1900" b="1" dirty="0">
-                <a:solidFill>
-                  <a:srgbClr val="262626"/>
-                </a:solidFill>
-                <a:latin typeface="Garamond" pitchFamily="34" charset="0"/>
-                <a:ea typeface="Garamond" pitchFamily="34" charset="-122"/>
-                <a:cs typeface="Garamond" pitchFamily="34" charset="-120"/>
+              <a:rPr lang="en-US" sz="1700" b="1" dirty="0">
+                <a:solidFill>
+                  <a:srgbClr val="000000"/>
+                </a:solidFill>
+                <a:latin typeface="Arial" pitchFamily="34" charset="0"/>
+                <a:ea typeface="Arial" pitchFamily="34" charset="-122"/>
+                <a:cs typeface="Arial" pitchFamily="34" charset="-120"/>
               </a:rPr>
               <a:t>Public Relations: </a:t>
             </a:r>
             <a:r>
-              <a:rPr lang="en-US" sz="1900" dirty="0">
-                <a:solidFill>
-                  <a:srgbClr val="262626"/>
-                </a:solidFill>
-                <a:latin typeface="Garamond" pitchFamily="34" charset="0"/>
-                <a:ea typeface="Garamond" pitchFamily="34" charset="-122"/>
-                <a:cs typeface="Garamond" pitchFamily="34" charset="-120"/>
+              <a:rPr lang="en-US" sz="1700" dirty="0">
+                <a:solidFill>
+                  <a:srgbClr val="000000"/>
+                </a:solidFill>
+                <a:latin typeface="Arial" pitchFamily="34" charset="0"/>
+                <a:ea typeface="Arial" pitchFamily="34" charset="-122"/>
+                <a:cs typeface="Arial" pitchFamily="34" charset="-120"/>
               </a:rPr>
               <a:t>$92,500 below the average</a:t>
             </a:r>
-            <a:endParaRPr lang="en-US" sz="1900" dirty="0"/>
+            <a:endParaRPr lang="en-US" sz="1700" dirty="0"/>
           </a:p>
           <a:p>
             <a:pPr marL="228600" indent="-228600">
@@ -6875,28 +6716,28 @@
               <a:buChar char="•"/>
             </a:pPr>
             <a:r>
-              <a:rPr lang="en-US" sz="1900" b="1" dirty="0">
-                <a:solidFill>
-                  <a:srgbClr val="262626"/>
-                </a:solidFill>
-                <a:latin typeface="Garamond" pitchFamily="34" charset="0"/>
-                <a:ea typeface="Garamond" pitchFamily="34" charset="-122"/>
-                <a:cs typeface="Garamond" pitchFamily="34" charset="-120"/>
+              <a:rPr lang="en-US" sz="1700" b="1" dirty="0">
+                <a:solidFill>
+                  <a:srgbClr val="000000"/>
+                </a:solidFill>
+                <a:latin typeface="Arial" pitchFamily="34" charset="0"/>
+                <a:ea typeface="Arial" pitchFamily="34" charset="-122"/>
+                <a:cs typeface="Arial" pitchFamily="34" charset="-120"/>
               </a:rPr>
               <a:t>e-Business: </a:t>
             </a:r>
             <a:r>
-              <a:rPr lang="en-US" sz="1900" dirty="0">
-                <a:solidFill>
-                  <a:srgbClr val="262626"/>
-                </a:solidFill>
-                <a:latin typeface="Garamond" pitchFamily="34" charset="0"/>
-                <a:ea typeface="Garamond" pitchFamily="34" charset="-122"/>
-                <a:cs typeface="Garamond" pitchFamily="34" charset="-120"/>
+              <a:rPr lang="en-US" sz="1700" dirty="0">
+                <a:solidFill>
+                  <a:srgbClr val="000000"/>
+                </a:solidFill>
+                <a:latin typeface="Arial" pitchFamily="34" charset="0"/>
+                <a:ea typeface="Arial" pitchFamily="34" charset="-122"/>
+                <a:cs typeface="Arial" pitchFamily="34" charset="-120"/>
               </a:rPr>
               <a:t>$42,500 below the average</a:t>
             </a:r>
-            <a:endParaRPr lang="en-US" sz="1900" dirty="0"/>
+            <a:endParaRPr lang="en-US" sz="1700" dirty="0"/>
           </a:p>
         </p:txBody>
       </p:sp>
@@ -6937,7 +6778,7 @@
         <p:spPr>
           <a:xfrm>
             <a:off x="731520" y="457200"/>
-            <a:ext cx="10728655" cy="777240"/>
+            <a:ext cx="10728655" cy="731520"/>
           </a:xfrm>
           <a:prstGeom prst="rect">
             <a:avLst/>
@@ -6953,17 +6794,17 @@
               <a:buNone/>
             </a:pPr>
             <a:r>
-              <a:rPr lang="en-US" sz="4000" dirty="0">
+              <a:rPr lang="en-US" sz="3600" b="1" dirty="0">
                 <a:solidFill>
                   <a:srgbClr val="1F3864"/>
                 </a:solidFill>
-                <a:latin typeface="Garamond" pitchFamily="34" charset="0"/>
-                <a:ea typeface="Garamond" pitchFamily="34" charset="-122"/>
-                <a:cs typeface="Garamond" pitchFamily="34" charset="-120"/>
+                <a:latin typeface="Arial" pitchFamily="34" charset="0"/>
+                <a:ea typeface="Arial" pitchFamily="34" charset="-122"/>
+                <a:cs typeface="Arial" pitchFamily="34" charset="-120"/>
               </a:rPr>
               <a:t>Key Takeaways</a:t>
             </a:r>
-            <a:endParaRPr lang="en-US" sz="4000" dirty="0"/>
+            <a:endParaRPr lang="en-US" sz="3600" dirty="0"/>
           </a:p>
         </p:txBody>
       </p:sp>
@@ -6975,7 +6816,7 @@
         </p:nvSpPr>
         <p:spPr>
           <a:xfrm>
-            <a:off x="914400" y="1325880"/>
+            <a:off x="914400" y="1298448"/>
             <a:ext cx="10362895" cy="0"/>
           </a:xfrm>
           <a:prstGeom prst="line">
@@ -6984,7 +6825,7 @@
           <a:noFill/>
           <a:ln w="19050">
             <a:solidFill>
-              <a:srgbClr val="2F5597"/>
+              <a:srgbClr val="1F3864"/>
             </a:solidFill>
             <a:prstDash val="solid"/>
           </a:ln>
@@ -6999,17 +6840,17 @@
         <p:spPr>
           <a:xfrm>
             <a:off x="822960" y="1691640"/>
-            <a:ext cx="2464994" cy="868680"/>
+            <a:ext cx="2464994" cy="2788920"/>
           </a:xfrm>
           <a:prstGeom prst="rect">
             <a:avLst/>
           </a:prstGeom>
           <a:solidFill>
-            <a:srgbClr val="2F5597"/>
+            <a:srgbClr val="DEEBF7"/>
           </a:solidFill>
           <a:ln w="12700">
             <a:solidFill>
-              <a:srgbClr val="2F5597"/>
+              <a:srgbClr val="DEEBF7"/>
             </a:solidFill>
             <a:prstDash val="solid"/>
           </a:ln>
@@ -7023,8 +6864,8 @@
         </p:nvSpPr>
         <p:spPr>
           <a:xfrm>
-            <a:off x="932688" y="1691640"/>
-            <a:ext cx="2245538" cy="868680"/>
+            <a:off x="960120" y="1828800"/>
+            <a:ext cx="2190674" cy="685800"/>
           </a:xfrm>
           <a:prstGeom prst="rect">
             <a:avLst/>
@@ -7040,17 +6881,17 @@
               <a:buNone/>
             </a:pPr>
             <a:r>
-              <a:rPr lang="en-US" sz="1900" b="1" dirty="0">
-                <a:solidFill>
-                  <a:srgbClr val="FFFFFF"/>
-                </a:solidFill>
-                <a:latin typeface="Garamond" pitchFamily="34" charset="0"/>
-                <a:ea typeface="Garamond" pitchFamily="34" charset="-122"/>
-                <a:cs typeface="Garamond" pitchFamily="34" charset="-120"/>
+              <a:rPr lang="en-US" sz="1800" b="1" dirty="0">
+                <a:solidFill>
+                  <a:srgbClr val="000000"/>
+                </a:solidFill>
+                <a:latin typeface="Arial" pitchFamily="34" charset="0"/>
+                <a:ea typeface="Arial" pitchFamily="34" charset="-122"/>
+                <a:cs typeface="Arial" pitchFamily="34" charset="-120"/>
               </a:rPr>
               <a:t>$890,000 in Total</a:t>
             </a:r>
-            <a:endParaRPr lang="en-US" sz="1900" dirty="0"/>
+            <a:endParaRPr lang="en-US" sz="1800" dirty="0"/>
           </a:p>
         </p:txBody>
       </p:sp>
@@ -7062,18 +6903,80 @@
         </p:nvSpPr>
         <p:spPr>
           <a:xfrm>
-            <a:off x="822960" y="2560320"/>
-            <a:ext cx="2464994" cy="2148840"/>
+            <a:off x="1188720" y="2606040"/>
+            <a:ext cx="1733474" cy="0"/>
+          </a:xfrm>
+          <a:prstGeom prst="line">
+            <a:avLst/>
+          </a:prstGeom>
+          <a:noFill/>
+          <a:ln w="19050">
+            <a:solidFill>
+              <a:srgbClr val="1F3864"/>
+            </a:solidFill>
+            <a:prstDash val="solid"/>
+          </a:ln>
+        </p:spPr>
+      </p:sp>
+      <p:sp>
+        <p:nvSpPr>
+          <p:cNvPr id="7" name="Text 5"/>
+          <p:cNvSpPr txBox="1"/>
+          <p:nvPr/>
+        </p:nvSpPr>
+        <p:spPr>
+          <a:xfrm>
+            <a:off x="1005840" y="2743200"/>
+            <a:ext cx="2099234" cy="1645920"/>
           </a:xfrm>
           <a:prstGeom prst="rect">
             <a:avLst/>
           </a:prstGeom>
+          <a:noFill/>
+          <a:ln/>
+        </p:spPr>
+        <p:txBody>
+          <a:bodyPr wrap="square" lIns="0" tIns="0" rIns="0" bIns="0" rtlCol="0" anchor="t"/>
+          <a:lstStyle/>
+          <a:p>
+            <a:pPr indent="0" marL="0">
+              <a:buNone/>
+            </a:pPr>
+            <a:r>
+              <a:rPr lang="en-US" sz="1700" dirty="0">
+                <a:solidFill>
+                  <a:srgbClr val="000000"/>
+                </a:solidFill>
+                <a:latin typeface="Arial" pitchFamily="34" charset="0"/>
+                <a:ea typeface="Arial" pitchFamily="34" charset="-122"/>
+                <a:cs typeface="Arial" pitchFamily="34" charset="-120"/>
+              </a:rPr>
+              <a:t>The SUM of the four unit budgets. The AVERAGE budget per unit is $222,500.</a:t>
+            </a:r>
+            <a:endParaRPr lang="en-US" sz="1700" dirty="0"/>
+          </a:p>
+        </p:txBody>
+      </p:sp>
+      <p:sp>
+        <p:nvSpPr>
+          <p:cNvPr id="8" name="Shape 6"/>
+          <p:cNvSpPr/>
+          <p:nvPr/>
+        </p:nvSpPr>
+        <p:spPr>
+          <a:xfrm>
+            <a:off x="3516554" y="1691640"/>
+            <a:ext cx="2464994" cy="2788920"/>
+          </a:xfrm>
+          <a:prstGeom prst="rect">
+            <a:avLst/>
+          </a:prstGeom>
           <a:solidFill>
-            <a:srgbClr val="DAE3F3"/>
+            <a:srgbClr val="DEEBF7"/>
           </a:solidFill>
           <a:ln w="12700">
             <a:solidFill>
-              <a:srgbClr val="DAE3F3"/>
+              <a:srgbClr val="DEEBF7"/>
             </a:solidFill>
             <a:prstDash val="solid"/>
           </a:ln>
@@ -7081,14 +6984,14 @@
       </p:sp>
       <p:sp>
         <p:nvSpPr>
-          <p:cNvPr id="7" name="Text 5"/>
+          <p:cNvPr id="9" name="Text 7"/>
           <p:cNvSpPr txBox="1"/>
           <p:nvPr/>
         </p:nvSpPr>
         <p:spPr>
           <a:xfrm>
-            <a:off x="1005840" y="2743200"/>
-            <a:ext cx="2099234" cy="1828800"/>
+            <a:off x="3653714" y="1828800"/>
+            <a:ext cx="2190674" cy="685800"/>
           </a:xfrm>
           <a:prstGeom prst="rect">
             <a:avLst/>
@@ -7097,6 +7000,85 @@
           <a:ln/>
         </p:spPr>
         <p:txBody>
+          <a:bodyPr wrap="square" lIns="0" tIns="0" rIns="0" bIns="0" rtlCol="0" anchor="ctr"/>
+          <a:lstStyle/>
+          <a:p>
+            <a:pPr algn="ctr" indent="0" marL="0">
+              <a:buNone/>
+            </a:pPr>
+            <a:r>
+              <a:rPr lang="en-US" sz="1800" b="1" dirty="0">
+                <a:solidFill>
+                  <a:srgbClr val="000000"/>
+                </a:solidFill>
+                <a:latin typeface="Arial" pitchFamily="34" charset="0"/>
+                <a:ea typeface="Arial" pitchFamily="34" charset="-122"/>
+                <a:cs typeface="Arial" pitchFamily="34" charset="-120"/>
+              </a:rPr>
+              <a:t>Advertising Is the</a:t>
+            </a:r>
+            <a:endParaRPr lang="en-US" sz="1800" dirty="0"/>
+          </a:p>
+          <a:p>
+            <a:pPr algn="ctr" indent="0" marL="0">
+              <a:buNone/>
+            </a:pPr>
+            <a:r>
+              <a:rPr lang="en-US" sz="1800" b="1" dirty="0">
+                <a:solidFill>
+                  <a:srgbClr val="000000"/>
+                </a:solidFill>
+                <a:latin typeface="Arial" pitchFamily="34" charset="0"/>
+                <a:ea typeface="Arial" pitchFamily="34" charset="-122"/>
+                <a:cs typeface="Arial" pitchFamily="34" charset="-120"/>
+              </a:rPr>
+              <a:t>Largest Unit</a:t>
+            </a:r>
+            <a:endParaRPr lang="en-US" sz="1800" dirty="0"/>
+          </a:p>
+        </p:txBody>
+      </p:sp>
+      <p:sp>
+        <p:nvSpPr>
+          <p:cNvPr id="10" name="Shape 8"/>
+          <p:cNvSpPr/>
+          <p:nvPr/>
+        </p:nvSpPr>
+        <p:spPr>
+          <a:xfrm>
+            <a:off x="3882314" y="2606040"/>
+            <a:ext cx="1733474" cy="0"/>
+          </a:xfrm>
+          <a:prstGeom prst="line">
+            <a:avLst/>
+          </a:prstGeom>
+          <a:noFill/>
+          <a:ln w="19050">
+            <a:solidFill>
+              <a:srgbClr val="1F3864"/>
+            </a:solidFill>
+            <a:prstDash val="solid"/>
+          </a:ln>
+        </p:spPr>
+      </p:sp>
+      <p:sp>
+        <p:nvSpPr>
+          <p:cNvPr id="11" name="Text 9"/>
+          <p:cNvSpPr txBox="1"/>
+          <p:nvPr/>
+        </p:nvSpPr>
+        <p:spPr>
+          <a:xfrm>
+            <a:off x="3699434" y="2743200"/>
+            <a:ext cx="2099234" cy="1645920"/>
+          </a:xfrm>
+          <a:prstGeom prst="rect">
+            <a:avLst/>
+          </a:prstGeom>
+          <a:noFill/>
+          <a:ln/>
+        </p:spPr>
+        <p:txBody>
           <a:bodyPr wrap="square" lIns="0" tIns="0" rIns="0" bIns="0" rtlCol="0" anchor="t"/>
           <a:lstStyle/>
           <a:p>
@@ -7104,40 +7086,40 @@
               <a:buNone/>
             </a:pPr>
             <a:r>
-              <a:rPr lang="en-US" sz="2000" dirty="0">
-                <a:solidFill>
-                  <a:srgbClr val="262626"/>
-                </a:solidFill>
-                <a:latin typeface="Garamond" pitchFamily="34" charset="0"/>
-                <a:ea typeface="Garamond" pitchFamily="34" charset="-122"/>
-                <a:cs typeface="Garamond" pitchFamily="34" charset="-120"/>
-              </a:rPr>
-              <a:t>The SUM of the four unit budgets. The AVERAGE budget per unit is $222,500.</a:t>
-            </a:r>
-            <a:endParaRPr lang="en-US" sz="2000" dirty="0"/>
+              <a:rPr lang="en-US" sz="1700" dirty="0">
+                <a:solidFill>
+                  <a:srgbClr val="000000"/>
+                </a:solidFill>
+                <a:latin typeface="Arial" pitchFamily="34" charset="0"/>
+                <a:ea typeface="Arial" pitchFamily="34" charset="-122"/>
+                <a:cs typeface="Arial" pitchFamily="34" charset="-120"/>
+              </a:rPr>
+              <a:t>$320,000 (36.0% of the total). Media space alone costs $150,000.</a:t>
+            </a:r>
+            <a:endParaRPr lang="en-US" sz="1700" dirty="0"/>
           </a:p>
         </p:txBody>
       </p:sp>
       <p:sp>
         <p:nvSpPr>
-          <p:cNvPr id="8" name="Shape 6"/>
+          <p:cNvPr id="12" name="Shape 10"/>
           <p:cNvSpPr/>
           <p:nvPr/>
         </p:nvSpPr>
         <p:spPr>
           <a:xfrm>
-            <a:off x="3516554" y="1691640"/>
-            <a:ext cx="2464994" cy="868680"/>
+            <a:off x="6210148" y="1691640"/>
+            <a:ext cx="2464994" cy="2788920"/>
           </a:xfrm>
           <a:prstGeom prst="rect">
             <a:avLst/>
           </a:prstGeom>
           <a:solidFill>
-            <a:srgbClr val="2F5597"/>
+            <a:srgbClr val="DEEBF7"/>
           </a:solidFill>
           <a:ln w="12700">
             <a:solidFill>
-              <a:srgbClr val="2F5597"/>
+              <a:srgbClr val="DEEBF7"/>
             </a:solidFill>
             <a:prstDash val="solid"/>
           </a:ln>
@@ -7145,14 +7127,14 @@
       </p:sp>
       <p:sp>
         <p:nvSpPr>
-          <p:cNvPr id="9" name="Text 7"/>
+          <p:cNvPr id="13" name="Text 11"/>
           <p:cNvSpPr txBox="1"/>
           <p:nvPr/>
         </p:nvSpPr>
         <p:spPr>
           <a:xfrm>
-            <a:off x="3626282" y="1691640"/>
-            <a:ext cx="2245538" cy="868680"/>
+            <a:off x="6347308" y="1828800"/>
+            <a:ext cx="2190674" cy="685800"/>
           </a:xfrm>
           <a:prstGeom prst="rect">
             <a:avLst/>
@@ -7168,40 +7150,119 @@
               <a:buNone/>
             </a:pPr>
             <a:r>
-              <a:rPr lang="en-US" sz="1900" b="1" dirty="0">
-                <a:solidFill>
-                  <a:srgbClr val="FFFFFF"/>
-                </a:solidFill>
-                <a:latin typeface="Garamond" pitchFamily="34" charset="0"/>
-                <a:ea typeface="Garamond" pitchFamily="34" charset="-122"/>
-                <a:cs typeface="Garamond" pitchFamily="34" charset="-120"/>
-              </a:rPr>
-              <a:t>Advertising Is the Largest Unit</a:t>
-            </a:r>
-            <a:endParaRPr lang="en-US" sz="1900" dirty="0"/>
+              <a:rPr lang="en-US" sz="1800" b="1" dirty="0">
+                <a:solidFill>
+                  <a:srgbClr val="000000"/>
+                </a:solidFill>
+                <a:latin typeface="Arial" pitchFamily="34" charset="0"/>
+                <a:ea typeface="Arial" pitchFamily="34" charset="-122"/>
+                <a:cs typeface="Arial" pitchFamily="34" charset="-120"/>
+              </a:rPr>
+              <a:t>Staff Costs Are the</a:t>
+            </a:r>
+            <a:endParaRPr lang="en-US" sz="1800" dirty="0"/>
+          </a:p>
+          <a:p>
+            <a:pPr algn="ctr" indent="0" marL="0">
+              <a:buNone/>
+            </a:pPr>
+            <a:r>
+              <a:rPr lang="en-US" sz="1800" b="1" dirty="0">
+                <a:solidFill>
+                  <a:srgbClr val="000000"/>
+                </a:solidFill>
+                <a:latin typeface="Arial" pitchFamily="34" charset="0"/>
+                <a:ea typeface="Arial" pitchFamily="34" charset="-122"/>
+                <a:cs typeface="Arial" pitchFamily="34" charset="-120"/>
+              </a:rPr>
+              <a:t>Biggest Item</a:t>
+            </a:r>
+            <a:endParaRPr lang="en-US" sz="1800" dirty="0"/>
           </a:p>
         </p:txBody>
       </p:sp>
       <p:sp>
         <p:nvSpPr>
-          <p:cNvPr id="10" name="Shape 8"/>
+          <p:cNvPr id="14" name="Shape 12"/>
           <p:cNvSpPr/>
           <p:nvPr/>
         </p:nvSpPr>
         <p:spPr>
           <a:xfrm>
-            <a:off x="3516554" y="2560320"/>
-            <a:ext cx="2464994" cy="2148840"/>
+            <a:off x="6575908" y="2606040"/>
+            <a:ext cx="1733474" cy="0"/>
+          </a:xfrm>
+          <a:prstGeom prst="line">
+            <a:avLst/>
+          </a:prstGeom>
+          <a:noFill/>
+          <a:ln w="19050">
+            <a:solidFill>
+              <a:srgbClr val="1F3864"/>
+            </a:solidFill>
+            <a:prstDash val="solid"/>
+          </a:ln>
+        </p:spPr>
+      </p:sp>
+      <p:sp>
+        <p:nvSpPr>
+          <p:cNvPr id="15" name="Text 13"/>
+          <p:cNvSpPr txBox="1"/>
+          <p:nvPr/>
+        </p:nvSpPr>
+        <p:spPr>
+          <a:xfrm>
+            <a:off x="6393028" y="2743200"/>
+            <a:ext cx="2099234" cy="1645920"/>
           </a:xfrm>
           <a:prstGeom prst="rect">
             <a:avLst/>
           </a:prstGeom>
+          <a:noFill/>
+          <a:ln/>
+        </p:spPr>
+        <p:txBody>
+          <a:bodyPr wrap="square" lIns="0" tIns="0" rIns="0" bIns="0" rtlCol="0" anchor="t"/>
+          <a:lstStyle/>
+          <a:p>
+            <a:pPr indent="0" marL="0">
+              <a:buNone/>
+            </a:pPr>
+            <a:r>
+              <a:rPr lang="en-US" sz="1700" dirty="0">
+                <a:solidFill>
+                  <a:srgbClr val="000000"/>
+                </a:solidFill>
+                <a:latin typeface="Arial" pitchFamily="34" charset="0"/>
+                <a:ea typeface="Arial" pitchFamily="34" charset="-122"/>
+                <a:cs typeface="Arial" pitchFamily="34" charset="-120"/>
+              </a:rPr>
+              <a:t>Staff Salaries &amp; Benefits come to $234,000 across all units, 26.3% of the budget.</a:t>
+            </a:r>
+            <a:endParaRPr lang="en-US" sz="1700" dirty="0"/>
+          </a:p>
+        </p:txBody>
+      </p:sp>
+      <p:sp>
+        <p:nvSpPr>
+          <p:cNvPr id="16" name="Shape 14"/>
+          <p:cNvSpPr/>
+          <p:nvPr/>
+        </p:nvSpPr>
+        <p:spPr>
+          <a:xfrm>
+            <a:off x="8903741" y="1691640"/>
+            <a:ext cx="2464994" cy="2788920"/>
+          </a:xfrm>
+          <a:prstGeom prst="rect">
+            <a:avLst/>
+          </a:prstGeom>
           <a:solidFill>
-            <a:srgbClr val="FBE5D6"/>
+            <a:srgbClr val="DEEBF7"/>
           </a:solidFill>
           <a:ln w="12700">
             <a:solidFill>
-              <a:srgbClr val="FBE5D6"/>
+              <a:srgbClr val="DEEBF7"/>
             </a:solidFill>
             <a:prstDash val="solid"/>
           </a:ln>
@@ -7209,14 +7270,14 @@
       </p:sp>
       <p:sp>
         <p:nvSpPr>
-          <p:cNvPr id="11" name="Text 9"/>
+          <p:cNvPr id="17" name="Text 15"/>
           <p:cNvSpPr txBox="1"/>
           <p:nvPr/>
         </p:nvSpPr>
         <p:spPr>
           <a:xfrm>
-            <a:off x="3699434" y="2743200"/>
-            <a:ext cx="2099234" cy="1828800"/>
+            <a:off x="9040901" y="1828800"/>
+            <a:ext cx="2190674" cy="685800"/>
           </a:xfrm>
           <a:prstGeom prst="rect">
             <a:avLst/>
@@ -7225,47 +7286,62 @@
           <a:ln/>
         </p:spPr>
         <p:txBody>
-          <a:bodyPr wrap="square" lIns="0" tIns="0" rIns="0" bIns="0" rtlCol="0" anchor="t"/>
-          <a:lstStyle/>
-          <a:p>
-            <a:pPr indent="0" marL="0">
+          <a:bodyPr wrap="square" lIns="0" tIns="0" rIns="0" bIns="0" rtlCol="0" anchor="ctr"/>
+          <a:lstStyle/>
+          <a:p>
+            <a:pPr algn="ctr" indent="0" marL="0">
               <a:buNone/>
             </a:pPr>
             <a:r>
-              <a:rPr lang="en-US" sz="2000" dirty="0">
-                <a:solidFill>
-                  <a:srgbClr val="262626"/>
-                </a:solidFill>
-                <a:latin typeface="Garamond" pitchFamily="34" charset="0"/>
-                <a:ea typeface="Garamond" pitchFamily="34" charset="-122"/>
-                <a:cs typeface="Garamond" pitchFamily="34" charset="-120"/>
-              </a:rPr>
-              <a:t>$320,000 (36.0% of the total). Media space alone costs $150,000.</a:t>
-            </a:r>
-            <a:endParaRPr lang="en-US" sz="2000" dirty="0"/>
+              <a:rPr lang="en-US" sz="1800" b="1" dirty="0">
+                <a:solidFill>
+                  <a:srgbClr val="000000"/>
+                </a:solidFill>
+                <a:latin typeface="Arial" pitchFamily="34" charset="0"/>
+                <a:ea typeface="Arial" pitchFamily="34" charset="-122"/>
+                <a:cs typeface="Arial" pitchFamily="34" charset="-120"/>
+              </a:rPr>
+              <a:t>Technology Leads</a:t>
+            </a:r>
+            <a:endParaRPr lang="en-US" sz="1800" dirty="0"/>
+          </a:p>
+          <a:p>
+            <a:pPr algn="ctr" indent="0" marL="0">
+              <a:buNone/>
+            </a:pPr>
+            <a:r>
+              <a:rPr lang="en-US" sz="1800" b="1" dirty="0">
+                <a:solidFill>
+                  <a:srgbClr val="000000"/>
+                </a:solidFill>
+                <a:latin typeface="Arial" pitchFamily="34" charset="0"/>
+                <a:ea typeface="Arial" pitchFamily="34" charset="-122"/>
+                <a:cs typeface="Arial" pitchFamily="34" charset="-120"/>
+              </a:rPr>
+              <a:t>e-Business</a:t>
+            </a:r>
+            <a:endParaRPr lang="en-US" sz="1800" dirty="0"/>
           </a:p>
         </p:txBody>
       </p:sp>
       <p:sp>
         <p:nvSpPr>
-          <p:cNvPr id="12" name="Shape 10"/>
+          <p:cNvPr id="18" name="Shape 16"/>
           <p:cNvSpPr/>
           <p:nvPr/>
         </p:nvSpPr>
         <p:spPr>
           <a:xfrm>
-            <a:off x="6210148" y="1691640"/>
-            <a:ext cx="2464994" cy="868680"/>
-          </a:xfrm>
-          <a:prstGeom prst="rect">
-            <a:avLst/>
-          </a:prstGeom>
-          <a:solidFill>
-            <a:srgbClr val="2F5597"/>
-          </a:solidFill>
-          <a:ln w="12700">
+            <a:off x="9269501" y="2606040"/>
+            <a:ext cx="1733474" cy="0"/>
+          </a:xfrm>
+          <a:prstGeom prst="line">
+            <a:avLst/>
+          </a:prstGeom>
+          <a:noFill/>
+          <a:ln w="19050">
             <a:solidFill>
-              <a:srgbClr val="2F5597"/>
+              <a:srgbClr val="1F3864"/>
             </a:solidFill>
             <a:prstDash val="solid"/>
           </a:ln>
@@ -7273,14 +7349,14 @@
       </p:sp>
       <p:sp>
         <p:nvSpPr>
-          <p:cNvPr id="13" name="Text 11"/>
+          <p:cNvPr id="19" name="Text 17"/>
           <p:cNvSpPr txBox="1"/>
           <p:nvPr/>
         </p:nvSpPr>
         <p:spPr>
           <a:xfrm>
-            <a:off x="6319876" y="1691640"/>
-            <a:ext cx="2245538" cy="868680"/>
+            <a:off x="9086621" y="2743200"/>
+            <a:ext cx="2099234" cy="1645920"/>
           </a:xfrm>
           <a:prstGeom prst="rect">
             <a:avLst/>
@@ -7289,47 +7365,45 @@
           <a:ln/>
         </p:spPr>
         <p:txBody>
-          <a:bodyPr wrap="square" lIns="0" tIns="0" rIns="0" bIns="0" rtlCol="0" anchor="ctr"/>
-          <a:lstStyle/>
-          <a:p>
-            <a:pPr algn="ctr" indent="0" marL="0">
+          <a:bodyPr wrap="square" lIns="0" tIns="0" rIns="0" bIns="0" rtlCol="0" anchor="t"/>
+          <a:lstStyle/>
+          <a:p>
+            <a:pPr indent="0" marL="0">
               <a:buNone/>
             </a:pPr>
             <a:r>
-              <a:rPr lang="en-US" sz="1900" b="1" dirty="0">
-                <a:solidFill>
-                  <a:srgbClr val="FFFFFF"/>
-                </a:solidFill>
-                <a:latin typeface="Garamond" pitchFamily="34" charset="0"/>
-                <a:ea typeface="Garamond" pitchFamily="34" charset="-122"/>
-                <a:cs typeface="Garamond" pitchFamily="34" charset="-120"/>
-              </a:rPr>
-              <a:t>Staff Costs Are the Biggest Item</a:t>
-            </a:r>
-            <a:endParaRPr lang="en-US" sz="1900" dirty="0"/>
+              <a:rPr lang="en-US" sz="1700" dirty="0">
+                <a:solidFill>
+                  <a:srgbClr val="000000"/>
+                </a:solidFill>
+                <a:latin typeface="Arial" pitchFamily="34" charset="0"/>
+                <a:ea typeface="Arial" pitchFamily="34" charset="-122"/>
+                <a:cs typeface="Arial" pitchFamily="34" charset="-120"/>
+              </a:rPr>
+              <a:t>$60,000 of its $180,000 (33.3%) goes to digital platforms and technology.</a:t>
+            </a:r>
+            <a:endParaRPr lang="en-US" sz="1700" dirty="0"/>
           </a:p>
         </p:txBody>
       </p:sp>
       <p:sp>
         <p:nvSpPr>
-          <p:cNvPr id="14" name="Shape 12"/>
+          <p:cNvPr id="20" name="Shape 18"/>
           <p:cNvSpPr/>
           <p:nvPr/>
         </p:nvSpPr>
         <p:spPr>
           <a:xfrm>
-            <a:off x="6210148" y="2560320"/>
-            <a:ext cx="2464994" cy="2148840"/>
-          </a:xfrm>
-          <a:prstGeom prst="rect">
-            <a:avLst/>
-          </a:prstGeom>
-          <a:solidFill>
-            <a:srgbClr val="E9DDF2"/>
-          </a:solidFill>
-          <a:ln w="12700">
+            <a:off x="2926080" y="4937760"/>
+            <a:ext cx="6339535" cy="0"/>
+          </a:xfrm>
+          <a:prstGeom prst="line">
+            <a:avLst/>
+          </a:prstGeom>
+          <a:noFill/>
+          <a:ln w="19050">
             <a:solidFill>
-              <a:srgbClr val="E9DDF2"/>
+              <a:srgbClr val="1F3864"/>
             </a:solidFill>
             <a:prstDash val="solid"/>
           </a:ln>
@@ -7337,14 +7411,14 @@
       </p:sp>
       <p:sp>
         <p:nvSpPr>
-          <p:cNvPr id="15" name="Text 13"/>
+          <p:cNvPr id="21" name="Text 19"/>
           <p:cNvSpPr txBox="1"/>
           <p:nvPr/>
         </p:nvSpPr>
         <p:spPr>
           <a:xfrm>
-            <a:off x="6393028" y="2743200"/>
-            <a:ext cx="2099234" cy="1828800"/>
+            <a:off x="731520" y="5120640"/>
+            <a:ext cx="10728655" cy="640080"/>
           </a:xfrm>
           <a:prstGeom prst="rect">
             <a:avLst/>
@@ -7353,70 +7427,6 @@
           <a:ln/>
         </p:spPr>
         <p:txBody>
-          <a:bodyPr wrap="square" lIns="0" tIns="0" rIns="0" bIns="0" rtlCol="0" anchor="t"/>
-          <a:lstStyle/>
-          <a:p>
-            <a:pPr indent="0" marL="0">
-              <a:buNone/>
-            </a:pPr>
-            <a:r>
-              <a:rPr lang="en-US" sz="2000" dirty="0">
-                <a:solidFill>
-                  <a:srgbClr val="262626"/>
-                </a:solidFill>
-                <a:latin typeface="Garamond" pitchFamily="34" charset="0"/>
-                <a:ea typeface="Garamond" pitchFamily="34" charset="-122"/>
-                <a:cs typeface="Garamond" pitchFamily="34" charset="-120"/>
-              </a:rPr>
-              <a:t>Staff Salaries &amp; Benefits come to $234,000 across all units, 26.3% of the budget.</a:t>
-            </a:r>
-            <a:endParaRPr lang="en-US" sz="2000" dirty="0"/>
-          </a:p>
-        </p:txBody>
-      </p:sp>
-      <p:sp>
-        <p:nvSpPr>
-          <p:cNvPr id="16" name="Shape 14"/>
-          <p:cNvSpPr/>
-          <p:nvPr/>
-        </p:nvSpPr>
-        <p:spPr>
-          <a:xfrm>
-            <a:off x="8903741" y="1691640"/>
-            <a:ext cx="2464994" cy="868680"/>
-          </a:xfrm>
-          <a:prstGeom prst="rect">
-            <a:avLst/>
-          </a:prstGeom>
-          <a:solidFill>
-            <a:srgbClr val="2F5597"/>
-          </a:solidFill>
-          <a:ln w="12700">
-            <a:solidFill>
-              <a:srgbClr val="2F5597"/>
-            </a:solidFill>
-            <a:prstDash val="solid"/>
-          </a:ln>
-        </p:spPr>
-      </p:sp>
-      <p:sp>
-        <p:nvSpPr>
-          <p:cNvPr id="17" name="Text 15"/>
-          <p:cNvSpPr txBox="1"/>
-          <p:nvPr/>
-        </p:nvSpPr>
-        <p:spPr>
-          <a:xfrm>
-            <a:off x="9013469" y="1691640"/>
-            <a:ext cx="2245538" cy="868680"/>
-          </a:xfrm>
-          <a:prstGeom prst="rect">
-            <a:avLst/>
-          </a:prstGeom>
-          <a:noFill/>
-          <a:ln/>
-        </p:spPr>
-        <p:txBody>
           <a:bodyPr wrap="square" lIns="0" tIns="0" rIns="0" bIns="0" rtlCol="0" anchor="ctr"/>
           <a:lstStyle/>
           <a:p>
@@ -7424,156 +7434,13 @@
               <a:buNone/>
             </a:pPr>
             <a:r>
-              <a:rPr lang="en-US" sz="1900" b="1" dirty="0">
-                <a:solidFill>
-                  <a:srgbClr val="FFFFFF"/>
-                </a:solidFill>
-                <a:latin typeface="Garamond" pitchFamily="34" charset="0"/>
-                <a:ea typeface="Garamond" pitchFamily="34" charset="-122"/>
-                <a:cs typeface="Garamond" pitchFamily="34" charset="-120"/>
-              </a:rPr>
-              <a:t>Technology Leads</a:t>
-            </a:r>
-            <a:endParaRPr lang="en-US" sz="1900" dirty="0"/>
-          </a:p>
-          <a:p>
-            <a:pPr algn="ctr" indent="0" marL="0">
-              <a:buNone/>
-            </a:pPr>
-            <a:r>
-              <a:rPr lang="en-US" sz="1900" b="1" dirty="0">
-                <a:solidFill>
-                  <a:srgbClr val="FFFFFF"/>
-                </a:solidFill>
-                <a:latin typeface="Garamond" pitchFamily="34" charset="0"/>
-                <a:ea typeface="Garamond" pitchFamily="34" charset="-122"/>
-                <a:cs typeface="Garamond" pitchFamily="34" charset="-120"/>
-              </a:rPr>
-              <a:t>e-Business</a:t>
-            </a:r>
-            <a:endParaRPr lang="en-US" sz="1900" dirty="0"/>
-          </a:p>
-        </p:txBody>
-      </p:sp>
-      <p:sp>
-        <p:nvSpPr>
-          <p:cNvPr id="18" name="Shape 16"/>
-          <p:cNvSpPr/>
-          <p:nvPr/>
-        </p:nvSpPr>
-        <p:spPr>
-          <a:xfrm>
-            <a:off x="8903741" y="2560320"/>
-            <a:ext cx="2464994" cy="2148840"/>
-          </a:xfrm>
-          <a:prstGeom prst="rect">
-            <a:avLst/>
-          </a:prstGeom>
-          <a:solidFill>
-            <a:srgbClr val="E2F0D9"/>
-          </a:solidFill>
-          <a:ln w="12700">
-            <a:solidFill>
-              <a:srgbClr val="E2F0D9"/>
-            </a:solidFill>
-            <a:prstDash val="solid"/>
-          </a:ln>
-        </p:spPr>
-      </p:sp>
-      <p:sp>
-        <p:nvSpPr>
-          <p:cNvPr id="19" name="Text 17"/>
-          <p:cNvSpPr txBox="1"/>
-          <p:nvPr/>
-        </p:nvSpPr>
-        <p:spPr>
-          <a:xfrm>
-            <a:off x="9086621" y="2743200"/>
-            <a:ext cx="2099234" cy="1828800"/>
-          </a:xfrm>
-          <a:prstGeom prst="rect">
-            <a:avLst/>
-          </a:prstGeom>
-          <a:noFill/>
-          <a:ln/>
-        </p:spPr>
-        <p:txBody>
-          <a:bodyPr wrap="square" lIns="0" tIns="0" rIns="0" bIns="0" rtlCol="0" anchor="t"/>
-          <a:lstStyle/>
-          <a:p>
-            <a:pPr indent="0" marL="0">
-              <a:buNone/>
-            </a:pPr>
-            <a:r>
-              <a:rPr lang="en-US" sz="2000" dirty="0">
-                <a:solidFill>
-                  <a:srgbClr val="262626"/>
-                </a:solidFill>
-                <a:latin typeface="Garamond" pitchFamily="34" charset="0"/>
-                <a:ea typeface="Garamond" pitchFamily="34" charset="-122"/>
-                <a:cs typeface="Garamond" pitchFamily="34" charset="-120"/>
-              </a:rPr>
-              <a:t>$60,000 of its $180,000 (33.3%) goes to digital platforms and technology.</a:t>
-            </a:r>
-            <a:endParaRPr lang="en-US" sz="2000" dirty="0"/>
-          </a:p>
-        </p:txBody>
-      </p:sp>
-      <p:sp>
-        <p:nvSpPr>
-          <p:cNvPr id="20" name="Shape 18"/>
-          <p:cNvSpPr/>
-          <p:nvPr/>
-        </p:nvSpPr>
-        <p:spPr>
-          <a:xfrm>
-            <a:off x="2926080" y="5120640"/>
-            <a:ext cx="6339535" cy="0"/>
-          </a:xfrm>
-          <a:prstGeom prst="line">
-            <a:avLst/>
-          </a:prstGeom>
-          <a:noFill/>
-          <a:ln w="19050">
-            <a:solidFill>
-              <a:srgbClr val="2F5597"/>
-            </a:solidFill>
-            <a:prstDash val="solid"/>
-          </a:ln>
-        </p:spPr>
-      </p:sp>
-      <p:sp>
-        <p:nvSpPr>
-          <p:cNvPr id="21" name="Text 19"/>
-          <p:cNvSpPr txBox="1"/>
-          <p:nvPr/>
-        </p:nvSpPr>
-        <p:spPr>
-          <a:xfrm>
-            <a:off x="731520" y="5285232"/>
-            <a:ext cx="10728655" cy="640080"/>
-          </a:xfrm>
-          <a:prstGeom prst="rect">
-            <a:avLst/>
-          </a:prstGeom>
-          <a:noFill/>
-          <a:ln/>
-        </p:spPr>
-        <p:txBody>
-          <a:bodyPr wrap="square" lIns="0" tIns="0" rIns="0" bIns="0" rtlCol="0" anchor="ctr"/>
-          <a:lstStyle/>
-          <a:p>
-            <a:pPr algn="ctr" indent="0" marL="0">
-              <a:buNone/>
-            </a:pPr>
-            <a:r>
-              <a:rPr lang="en-US" sz="3200" b="1" i="1" dirty="0">
-                <a:solidFill>
-                  <a:srgbClr val="C00000"/>
-                </a:solidFill>
-                <a:latin typeface="Garamond" pitchFamily="34" charset="0"/>
-                <a:ea typeface="Garamond" pitchFamily="34" charset="-122"/>
-                <a:cs typeface="Garamond" pitchFamily="34" charset="-120"/>
+              <a:rPr lang="en-US" sz="3200" b="1" dirty="0">
+                <a:solidFill>
+                  <a:srgbClr val="1F3864"/>
+                </a:solidFill>
+                <a:latin typeface="Arial" pitchFamily="34" charset="0"/>
+                <a:ea typeface="Arial" pitchFamily="34" charset="-122"/>
+                <a:cs typeface="Arial" pitchFamily="34" charset="-120"/>
               </a:rPr>
               <a:t>Thank You. Questions?</a:t>
             </a:r>
@@ -7635,7 +7502,7 @@
     </a:clrScheme>
     <a:fontScheme name="Office">
       <a:majorFont>
-        <a:latin typeface="Garamond"/>
+        <a:latin typeface="Arial"/>
         <a:ea typeface=""/>
         <a:cs typeface=""/>
         <a:font script="Jpan" typeface="游ゴシック Light"/>
@@ -7687,7 +7554,7 @@
         <a:font script="Tfng" typeface="Ebrima"/>
       </a:majorFont>
       <a:minorFont>
-        <a:latin typeface="Garamond"/>
+        <a:latin typeface="Arial"/>
         <a:ea typeface=""/>
         <a:cs typeface=""/>
         <a:font script="Jpan" typeface="游ゴシック"/>

</xml_diff>

<commit_message>
Add transitions and automatic animations to the budget deck
Every slide now has a Push transition, and its contents build
themselves when the slide appears. The title and its rule come in
first, then each box, chart or card fades or wipes in, one group after
another ("After Previous"), with no clicks. Slides still advance on a
click.

build_deck.js names every object and writes an animation plan
(deck.anim.json). finish_deck.py turns the plan into PowerPoint timing
XML: one auto-starting group per slide, a Fade (or Wipe for charts)
per object, and build-list entries for shapes and charts. The timing
XML passes the strict schema check, and LibreOffice imports all 91
effects as After/With Previous.

Co-Authored-By: Claude Opus 5.5 <noreply@anthropic.com>
Claude-Session: https://claude.ai/code/session_01WToQxHdrdWhM7bKqXvUa59
</commit_message>
<xml_diff>
--- a/marketing-budget/Marketing_Department_Budget.pptx
+++ b/marketing-budget/Marketing_Department_Budget.pptx
@@ -3409,7 +3409,7 @@
       </p:grpSpPr>
       <p:sp>
         <p:nvSpPr>
-          <p:cNvPr id="2" name="Text 0"/>
+          <p:cNvPr id="2" name="Title"/>
           <p:cNvSpPr txBox="1"/>
           <p:nvPr/>
         </p:nvSpPr>
@@ -3448,7 +3448,7 @@
       </p:sp>
       <p:sp>
         <p:nvSpPr>
-          <p:cNvPr id="3" name="Shape 1"/>
+          <p:cNvPr id="3" name="Title Rule"/>
           <p:cNvSpPr/>
           <p:nvPr/>
         </p:nvSpPr>
@@ -3471,7 +3471,7 @@
       </p:sp>
       <p:sp>
         <p:nvSpPr>
-          <p:cNvPr id="4" name="Text 2"/>
+          <p:cNvPr id="4" name="Subtitle"/>
           <p:cNvSpPr txBox="1"/>
           <p:nvPr/>
         </p:nvSpPr>
@@ -3510,7 +3510,7 @@
       </p:sp>
       <p:sp>
         <p:nvSpPr>
-          <p:cNvPr id="5" name="Text 3"/>
+          <p:cNvPr id="5" name="Units"/>
           <p:cNvSpPr txBox="1"/>
           <p:nvPr/>
         </p:nvSpPr>
@@ -3572,7 +3572,7 @@
       </p:sp>
       <p:sp>
         <p:nvSpPr>
-          <p:cNvPr id="6" name="Text 4"/>
+          <p:cNvPr id="6" name="Source"/>
           <p:cNvSpPr txBox="1"/>
           <p:nvPr/>
         </p:nvSpPr>
@@ -3615,8 +3615,268 @@
     <a:masterClrMapping/>
   </p:clrMapOvr>
   <p:transition spd="med">
-    <p:fade/>
+    <p:push dir="u"/>
   </p:transition>
+  <p:timing>
+    <p:tnLst>
+      <p:par>
+        <p:cTn id="1" dur="indefinite" restart="never" nodeType="tmRoot">
+          <p:childTnLst>
+            <p:seq concurrent="1" nextAc="seek">
+              <p:cTn id="2" dur="indefinite" nodeType="mainSeq">
+                <p:childTnLst>
+                  <p:par>
+                    <p:cTn id="3" fill="hold">
+                      <p:stCondLst>
+                        <p:cond delay="indefinite"/>
+                        <p:cond evt="onBegin" delay="0">
+                          <p:tn val="2"/>
+                        </p:cond>
+                      </p:stCondLst>
+                      <p:childTnLst>
+                        <p:par>
+                          <p:cTn id="4" fill="hold">
+                            <p:stCondLst>
+                              <p:cond delay="0"/>
+                            </p:stCondLst>
+                            <p:childTnLst>
+                              <p:par>
+                                <p:cTn id="5" presetID="10" presetClass="entr" presetSubtype="0" fill="hold" grpId="0" nodeType="afterEffect">
+                                  <p:stCondLst>
+                                    <p:cond delay="0"/>
+                                  </p:stCondLst>
+                                  <p:childTnLst>
+                                    <p:set>
+                                      <p:cBhvr>
+                                        <p:cTn id="6" dur="1" fill="hold">
+                                          <p:stCondLst>
+                                            <p:cond delay="0"/>
+                                          </p:stCondLst>
+                                        </p:cTn>
+                                        <p:tgtEl>
+                                          <p:spTgt spid="2"/>
+                                        </p:tgtEl>
+                                        <p:attrNameLst>
+                                          <p:attrName>style.visibility</p:attrName>
+                                        </p:attrNameLst>
+                                      </p:cBhvr>
+                                      <p:to>
+                                        <p:strVal val="visible"/>
+                                      </p:to>
+                                    </p:set>
+                                    <p:animEffect transition="in" filter="fade">
+                                      <p:cBhvr>
+                                        <p:cTn id="7" dur="500"/>
+                                        <p:tgtEl>
+                                          <p:spTgt spid="2"/>
+                                        </p:tgtEl>
+                                      </p:cBhvr>
+                                    </p:animEffect>
+                                  </p:childTnLst>
+                                </p:cTn>
+                              </p:par>
+                              <p:par>
+                                <p:cTn id="8" presetID="22" presetClass="entr" presetSubtype="8" fill="hold" grpId="0" nodeType="withEffect">
+                                  <p:stCondLst>
+                                    <p:cond delay="0"/>
+                                  </p:stCondLst>
+                                  <p:childTnLst>
+                                    <p:set>
+                                      <p:cBhvr>
+                                        <p:cTn id="9" dur="1" fill="hold">
+                                          <p:stCondLst>
+                                            <p:cond delay="0"/>
+                                          </p:stCondLst>
+                                        </p:cTn>
+                                        <p:tgtEl>
+                                          <p:spTgt spid="3"/>
+                                        </p:tgtEl>
+                                        <p:attrNameLst>
+                                          <p:attrName>style.visibility</p:attrName>
+                                        </p:attrNameLst>
+                                      </p:cBhvr>
+                                      <p:to>
+                                        <p:strVal val="visible"/>
+                                      </p:to>
+                                    </p:set>
+                                    <p:animEffect transition="in" filter="wipe(right)">
+                                      <p:cBhvr>
+                                        <p:cTn id="10" dur="500"/>
+                                        <p:tgtEl>
+                                          <p:spTgt spid="3"/>
+                                        </p:tgtEl>
+                                      </p:cBhvr>
+                                    </p:animEffect>
+                                  </p:childTnLst>
+                                </p:cTn>
+                              </p:par>
+                            </p:childTnLst>
+                          </p:cTn>
+                        </p:par>
+                        <p:par>
+                          <p:cTn id="11" fill="hold">
+                            <p:stCondLst>
+                              <p:cond delay="500"/>
+                            </p:stCondLst>
+                            <p:childTnLst>
+                              <p:par>
+                                <p:cTn id="12" presetID="10" presetClass="entr" presetSubtype="0" fill="hold" grpId="0" nodeType="afterEffect">
+                                  <p:stCondLst>
+                                    <p:cond delay="0"/>
+                                  </p:stCondLst>
+                                  <p:childTnLst>
+                                    <p:set>
+                                      <p:cBhvr>
+                                        <p:cTn id="13" dur="1" fill="hold">
+                                          <p:stCondLst>
+                                            <p:cond delay="0"/>
+                                          </p:stCondLst>
+                                        </p:cTn>
+                                        <p:tgtEl>
+                                          <p:spTgt spid="4"/>
+                                        </p:tgtEl>
+                                        <p:attrNameLst>
+                                          <p:attrName>style.visibility</p:attrName>
+                                        </p:attrNameLst>
+                                      </p:cBhvr>
+                                      <p:to>
+                                        <p:strVal val="visible"/>
+                                      </p:to>
+                                    </p:set>
+                                    <p:animEffect transition="in" filter="fade">
+                                      <p:cBhvr>
+                                        <p:cTn id="14" dur="500"/>
+                                        <p:tgtEl>
+                                          <p:spTgt spid="4"/>
+                                        </p:tgtEl>
+                                      </p:cBhvr>
+                                    </p:animEffect>
+                                  </p:childTnLst>
+                                </p:cTn>
+                              </p:par>
+                            </p:childTnLst>
+                          </p:cTn>
+                        </p:par>
+                        <p:par>
+                          <p:cTn id="15" fill="hold">
+                            <p:stCondLst>
+                              <p:cond delay="1000"/>
+                            </p:stCondLst>
+                            <p:childTnLst>
+                              <p:par>
+                                <p:cTn id="16" presetID="10" presetClass="entr" presetSubtype="0" fill="hold" grpId="0" nodeType="afterEffect">
+                                  <p:stCondLst>
+                                    <p:cond delay="0"/>
+                                  </p:stCondLst>
+                                  <p:childTnLst>
+                                    <p:set>
+                                      <p:cBhvr>
+                                        <p:cTn id="17" dur="1" fill="hold">
+                                          <p:stCondLst>
+                                            <p:cond delay="0"/>
+                                          </p:stCondLst>
+                                        </p:cTn>
+                                        <p:tgtEl>
+                                          <p:spTgt spid="5"/>
+                                        </p:tgtEl>
+                                        <p:attrNameLst>
+                                          <p:attrName>style.visibility</p:attrName>
+                                        </p:attrNameLst>
+                                      </p:cBhvr>
+                                      <p:to>
+                                        <p:strVal val="visible"/>
+                                      </p:to>
+                                    </p:set>
+                                    <p:animEffect transition="in" filter="fade">
+                                      <p:cBhvr>
+                                        <p:cTn id="18" dur="500"/>
+                                        <p:tgtEl>
+                                          <p:spTgt spid="5"/>
+                                        </p:tgtEl>
+                                      </p:cBhvr>
+                                    </p:animEffect>
+                                  </p:childTnLst>
+                                </p:cTn>
+                              </p:par>
+                            </p:childTnLst>
+                          </p:cTn>
+                        </p:par>
+                        <p:par>
+                          <p:cTn id="19" fill="hold">
+                            <p:stCondLst>
+                              <p:cond delay="1500"/>
+                            </p:stCondLst>
+                            <p:childTnLst>
+                              <p:par>
+                                <p:cTn id="20" presetID="10" presetClass="entr" presetSubtype="0" fill="hold" grpId="0" nodeType="afterEffect">
+                                  <p:stCondLst>
+                                    <p:cond delay="0"/>
+                                  </p:stCondLst>
+                                  <p:childTnLst>
+                                    <p:set>
+                                      <p:cBhvr>
+                                        <p:cTn id="21" dur="1" fill="hold">
+                                          <p:stCondLst>
+                                            <p:cond delay="0"/>
+                                          </p:stCondLst>
+                                        </p:cTn>
+                                        <p:tgtEl>
+                                          <p:spTgt spid="6"/>
+                                        </p:tgtEl>
+                                        <p:attrNameLst>
+                                          <p:attrName>style.visibility</p:attrName>
+                                        </p:attrNameLst>
+                                      </p:cBhvr>
+                                      <p:to>
+                                        <p:strVal val="visible"/>
+                                      </p:to>
+                                    </p:set>
+                                    <p:animEffect transition="in" filter="fade">
+                                      <p:cBhvr>
+                                        <p:cTn id="22" dur="500"/>
+                                        <p:tgtEl>
+                                          <p:spTgt spid="6"/>
+                                        </p:tgtEl>
+                                      </p:cBhvr>
+                                    </p:animEffect>
+                                  </p:childTnLst>
+                                </p:cTn>
+                              </p:par>
+                            </p:childTnLst>
+                          </p:cTn>
+                        </p:par>
+                      </p:childTnLst>
+                    </p:cTn>
+                  </p:par>
+                </p:childTnLst>
+              </p:cTn>
+              <p:prevCondLst>
+                <p:cond evt="onPrev" delay="0">
+                  <p:tgtEl>
+                    <p:sldTgt/>
+                  </p:tgtEl>
+                </p:cond>
+              </p:prevCondLst>
+              <p:nextCondLst>
+                <p:cond evt="onNext" delay="0">
+                  <p:tgtEl>
+                    <p:sldTgt/>
+                  </p:tgtEl>
+                </p:cond>
+              </p:nextCondLst>
+            </p:seq>
+          </p:childTnLst>
+        </p:cTn>
+      </p:par>
+    </p:tnLst>
+    <p:bldLst>
+      <p:bldP spid="2" grpId="0" animBg="1"/>
+      <p:bldP spid="3" grpId="0" animBg="1"/>
+      <p:bldP spid="4" grpId="0" animBg="1"/>
+      <p:bldP spid="5" grpId="0" animBg="1"/>
+      <p:bldP spid="6" grpId="0" animBg="1"/>
+    </p:bldLst>
+  </p:timing>
 </p:sld>
 </file>
 
@@ -3639,7 +3899,7 @@
       </p:grpSpPr>
       <p:sp>
         <p:nvSpPr>
-          <p:cNvPr id="2" name="Text 0"/>
+          <p:cNvPr id="2" name="Title"/>
           <p:cNvSpPr txBox="1"/>
           <p:nvPr/>
         </p:nvSpPr>
@@ -3678,7 +3938,7 @@
       </p:sp>
       <p:sp>
         <p:nvSpPr>
-          <p:cNvPr id="3" name="Shape 1"/>
+          <p:cNvPr id="3" name="Title Rule"/>
           <p:cNvSpPr/>
           <p:nvPr/>
         </p:nvSpPr>
@@ -3701,7 +3961,7 @@
       </p:sp>
       <p:sp>
         <p:nvSpPr>
-          <p:cNvPr id="4" name="Text 2"/>
+          <p:cNvPr id="4" name="Subtitle"/>
           <p:cNvSpPr txBox="1"/>
           <p:nvPr/>
         </p:nvSpPr>
@@ -3740,7 +4000,7 @@
       </p:sp>
       <p:sp>
         <p:nvSpPr>
-          <p:cNvPr id="5" name="Shape 3"/>
+          <p:cNvPr id="5" name="Total Box"/>
           <p:cNvSpPr/>
           <p:nvPr/>
         </p:nvSpPr>
@@ -3765,7 +4025,7 @@
       </p:sp>
       <p:sp>
         <p:nvSpPr>
-          <p:cNvPr id="6" name="Text 4"/>
+          <p:cNvPr id="6" name="Total Value"/>
           <p:cNvSpPr txBox="1"/>
           <p:nvPr/>
         </p:nvSpPr>
@@ -3804,7 +4064,7 @@
       </p:sp>
       <p:sp>
         <p:nvSpPr>
-          <p:cNvPr id="7" name="Text 5"/>
+          <p:cNvPr id="7" name="Total Label"/>
           <p:cNvSpPr txBox="1"/>
           <p:nvPr/>
         </p:nvSpPr>
@@ -3843,7 +4103,7 @@
       </p:sp>
       <p:sp>
         <p:nvSpPr>
-          <p:cNvPr id="8" name="Text 6"/>
+          <p:cNvPr id="8" name="Total Formula"/>
           <p:cNvSpPr txBox="1"/>
           <p:nvPr/>
         </p:nvSpPr>
@@ -3882,7 +4142,7 @@
       </p:sp>
       <p:sp>
         <p:nvSpPr>
-          <p:cNvPr id="9" name="Shape 7"/>
+          <p:cNvPr id="9" name="Average Box"/>
           <p:cNvSpPr/>
           <p:nvPr/>
         </p:nvSpPr>
@@ -3907,7 +4167,7 @@
       </p:sp>
       <p:sp>
         <p:nvSpPr>
-          <p:cNvPr id="10" name="Text 8"/>
+          <p:cNvPr id="10" name="Average Value"/>
           <p:cNvSpPr txBox="1"/>
           <p:nvPr/>
         </p:nvSpPr>
@@ -3946,7 +4206,7 @@
       </p:sp>
       <p:sp>
         <p:nvSpPr>
-          <p:cNvPr id="11" name="Text 9"/>
+          <p:cNvPr id="11" name="Average Label"/>
           <p:cNvSpPr txBox="1"/>
           <p:nvPr/>
         </p:nvSpPr>
@@ -3985,7 +4245,7 @@
       </p:sp>
       <p:sp>
         <p:nvSpPr>
-          <p:cNvPr id="12" name="Text 10"/>
+          <p:cNvPr id="12" name="Average Formula"/>
           <p:cNvSpPr txBox="1"/>
           <p:nvPr/>
         </p:nvSpPr>
@@ -4024,7 +4284,7 @@
       </p:sp>
       <p:graphicFrame>
         <p:nvGraphicFramePr>
-          <p:cNvPr id="13" name="Chart 0" descr=""/>
+          <p:cNvPr id="13" name="Share Chart" descr=""/>
           <p:cNvGraphicFramePr/>
           <p:nvPr/>
         </p:nvGraphicFramePr>
@@ -4040,7 +4300,7 @@
       </p:graphicFrame>
       <p:sp>
         <p:nvSpPr>
-          <p:cNvPr id="14" name="Text 11"/>
+          <p:cNvPr id="14" name="Share Label"/>
           <p:cNvSpPr txBox="1"/>
           <p:nvPr/>
         </p:nvSpPr>
@@ -4096,7 +4356,7 @@
       </p:sp>
       <p:sp>
         <p:nvSpPr>
-          <p:cNvPr id="15" name="Shape 12"/>
+          <p:cNvPr id="15" name="Legend Key Advertising"/>
           <p:cNvSpPr/>
           <p:nvPr/>
         </p:nvSpPr>
@@ -4121,7 +4381,7 @@
       </p:sp>
       <p:sp>
         <p:nvSpPr>
-          <p:cNvPr id="16" name="Text 13"/>
+          <p:cNvPr id="16" name="Legend Advertising"/>
           <p:cNvSpPr txBox="1"/>
           <p:nvPr/>
         </p:nvSpPr>
@@ -4177,7 +4437,7 @@
       </p:sp>
       <p:sp>
         <p:nvSpPr>
-          <p:cNvPr id="17" name="Shape 14"/>
+          <p:cNvPr id="17" name="Legend Key Marketing"/>
           <p:cNvSpPr/>
           <p:nvPr/>
         </p:nvSpPr>
@@ -4202,7 +4462,7 @@
       </p:sp>
       <p:sp>
         <p:nvSpPr>
-          <p:cNvPr id="18" name="Text 15"/>
+          <p:cNvPr id="18" name="Legend Marketing"/>
           <p:cNvSpPr txBox="1"/>
           <p:nvPr/>
         </p:nvSpPr>
@@ -4258,7 +4518,7 @@
       </p:sp>
       <p:sp>
         <p:nvSpPr>
-          <p:cNvPr id="19" name="Shape 16"/>
+          <p:cNvPr id="19" name="Legend Key Public Relations"/>
           <p:cNvSpPr/>
           <p:nvPr/>
         </p:nvSpPr>
@@ -4283,7 +4543,7 @@
       </p:sp>
       <p:sp>
         <p:nvSpPr>
-          <p:cNvPr id="20" name="Text 17"/>
+          <p:cNvPr id="20" name="Legend Public Relations"/>
           <p:cNvSpPr txBox="1"/>
           <p:nvPr/>
         </p:nvSpPr>
@@ -4339,7 +4599,7 @@
       </p:sp>
       <p:sp>
         <p:nvSpPr>
-          <p:cNvPr id="21" name="Shape 18"/>
+          <p:cNvPr id="21" name="Legend Key e-Business"/>
           <p:cNvSpPr/>
           <p:nvPr/>
         </p:nvSpPr>
@@ -4364,7 +4624,7 @@
       </p:sp>
       <p:sp>
         <p:nvSpPr>
-          <p:cNvPr id="22" name="Text 19"/>
+          <p:cNvPr id="22" name="Legend e-Business"/>
           <p:cNvSpPr txBox="1"/>
           <p:nvPr/>
         </p:nvSpPr>
@@ -4424,8 +4684,864 @@
     <a:masterClrMapping/>
   </p:clrMapOvr>
   <p:transition spd="med">
-    <p:fade/>
+    <p:push dir="u"/>
   </p:transition>
+  <p:timing>
+    <p:tnLst>
+      <p:par>
+        <p:cTn id="1" dur="indefinite" restart="never" nodeType="tmRoot">
+          <p:childTnLst>
+            <p:seq concurrent="1" nextAc="seek">
+              <p:cTn id="2" dur="indefinite" nodeType="mainSeq">
+                <p:childTnLst>
+                  <p:par>
+                    <p:cTn id="3" fill="hold">
+                      <p:stCondLst>
+                        <p:cond delay="indefinite"/>
+                        <p:cond evt="onBegin" delay="0">
+                          <p:tn val="2"/>
+                        </p:cond>
+                      </p:stCondLst>
+                      <p:childTnLst>
+                        <p:par>
+                          <p:cTn id="4" fill="hold">
+                            <p:stCondLst>
+                              <p:cond delay="0"/>
+                            </p:stCondLst>
+                            <p:childTnLst>
+                              <p:par>
+                                <p:cTn id="5" presetID="10" presetClass="entr" presetSubtype="0" fill="hold" grpId="0" nodeType="afterEffect">
+                                  <p:stCondLst>
+                                    <p:cond delay="0"/>
+                                  </p:stCondLst>
+                                  <p:childTnLst>
+                                    <p:set>
+                                      <p:cBhvr>
+                                        <p:cTn id="6" dur="1" fill="hold">
+                                          <p:stCondLst>
+                                            <p:cond delay="0"/>
+                                          </p:stCondLst>
+                                        </p:cTn>
+                                        <p:tgtEl>
+                                          <p:spTgt spid="2"/>
+                                        </p:tgtEl>
+                                        <p:attrNameLst>
+                                          <p:attrName>style.visibility</p:attrName>
+                                        </p:attrNameLst>
+                                      </p:cBhvr>
+                                      <p:to>
+                                        <p:strVal val="visible"/>
+                                      </p:to>
+                                    </p:set>
+                                    <p:animEffect transition="in" filter="fade">
+                                      <p:cBhvr>
+                                        <p:cTn id="7" dur="500"/>
+                                        <p:tgtEl>
+                                          <p:spTgt spid="2"/>
+                                        </p:tgtEl>
+                                      </p:cBhvr>
+                                    </p:animEffect>
+                                  </p:childTnLst>
+                                </p:cTn>
+                              </p:par>
+                              <p:par>
+                                <p:cTn id="8" presetID="22" presetClass="entr" presetSubtype="8" fill="hold" grpId="0" nodeType="withEffect">
+                                  <p:stCondLst>
+                                    <p:cond delay="0"/>
+                                  </p:stCondLst>
+                                  <p:childTnLst>
+                                    <p:set>
+                                      <p:cBhvr>
+                                        <p:cTn id="9" dur="1" fill="hold">
+                                          <p:stCondLst>
+                                            <p:cond delay="0"/>
+                                          </p:stCondLst>
+                                        </p:cTn>
+                                        <p:tgtEl>
+                                          <p:spTgt spid="3"/>
+                                        </p:tgtEl>
+                                        <p:attrNameLst>
+                                          <p:attrName>style.visibility</p:attrName>
+                                        </p:attrNameLst>
+                                      </p:cBhvr>
+                                      <p:to>
+                                        <p:strVal val="visible"/>
+                                      </p:to>
+                                    </p:set>
+                                    <p:animEffect transition="in" filter="wipe(right)">
+                                      <p:cBhvr>
+                                        <p:cTn id="10" dur="500"/>
+                                        <p:tgtEl>
+                                          <p:spTgt spid="3"/>
+                                        </p:tgtEl>
+                                      </p:cBhvr>
+                                    </p:animEffect>
+                                  </p:childTnLst>
+                                </p:cTn>
+                              </p:par>
+                            </p:childTnLst>
+                          </p:cTn>
+                        </p:par>
+                        <p:par>
+                          <p:cTn id="11" fill="hold">
+                            <p:stCondLst>
+                              <p:cond delay="500"/>
+                            </p:stCondLst>
+                            <p:childTnLst>
+                              <p:par>
+                                <p:cTn id="12" presetID="10" presetClass="entr" presetSubtype="0" fill="hold" grpId="0" nodeType="afterEffect">
+                                  <p:stCondLst>
+                                    <p:cond delay="0"/>
+                                  </p:stCondLst>
+                                  <p:childTnLst>
+                                    <p:set>
+                                      <p:cBhvr>
+                                        <p:cTn id="13" dur="1" fill="hold">
+                                          <p:stCondLst>
+                                            <p:cond delay="0"/>
+                                          </p:stCondLst>
+                                        </p:cTn>
+                                        <p:tgtEl>
+                                          <p:spTgt spid="4"/>
+                                        </p:tgtEl>
+                                        <p:attrNameLst>
+                                          <p:attrName>style.visibility</p:attrName>
+                                        </p:attrNameLst>
+                                      </p:cBhvr>
+                                      <p:to>
+                                        <p:strVal val="visible"/>
+                                      </p:to>
+                                    </p:set>
+                                    <p:animEffect transition="in" filter="fade">
+                                      <p:cBhvr>
+                                        <p:cTn id="14" dur="500"/>
+                                        <p:tgtEl>
+                                          <p:spTgt spid="4"/>
+                                        </p:tgtEl>
+                                      </p:cBhvr>
+                                    </p:animEffect>
+                                  </p:childTnLst>
+                                </p:cTn>
+                              </p:par>
+                            </p:childTnLst>
+                          </p:cTn>
+                        </p:par>
+                        <p:par>
+                          <p:cTn id="15" fill="hold">
+                            <p:stCondLst>
+                              <p:cond delay="1000"/>
+                            </p:stCondLst>
+                            <p:childTnLst>
+                              <p:par>
+                                <p:cTn id="16" presetID="10" presetClass="entr" presetSubtype="0" fill="hold" grpId="0" nodeType="afterEffect">
+                                  <p:stCondLst>
+                                    <p:cond delay="0"/>
+                                  </p:stCondLst>
+                                  <p:childTnLst>
+                                    <p:set>
+                                      <p:cBhvr>
+                                        <p:cTn id="17" dur="1" fill="hold">
+                                          <p:stCondLst>
+                                            <p:cond delay="0"/>
+                                          </p:stCondLst>
+                                        </p:cTn>
+                                        <p:tgtEl>
+                                          <p:spTgt spid="5"/>
+                                        </p:tgtEl>
+                                        <p:attrNameLst>
+                                          <p:attrName>style.visibility</p:attrName>
+                                        </p:attrNameLst>
+                                      </p:cBhvr>
+                                      <p:to>
+                                        <p:strVal val="visible"/>
+                                      </p:to>
+                                    </p:set>
+                                    <p:animEffect transition="in" filter="fade">
+                                      <p:cBhvr>
+                                        <p:cTn id="18" dur="500"/>
+                                        <p:tgtEl>
+                                          <p:spTgt spid="5"/>
+                                        </p:tgtEl>
+                                      </p:cBhvr>
+                                    </p:animEffect>
+                                  </p:childTnLst>
+                                </p:cTn>
+                              </p:par>
+                              <p:par>
+                                <p:cTn id="19" presetID="10" presetClass="entr" presetSubtype="0" fill="hold" grpId="0" nodeType="withEffect">
+                                  <p:stCondLst>
+                                    <p:cond delay="0"/>
+                                  </p:stCondLst>
+                                  <p:childTnLst>
+                                    <p:set>
+                                      <p:cBhvr>
+                                        <p:cTn id="20" dur="1" fill="hold">
+                                          <p:stCondLst>
+                                            <p:cond delay="0"/>
+                                          </p:stCondLst>
+                                        </p:cTn>
+                                        <p:tgtEl>
+                                          <p:spTgt spid="6"/>
+                                        </p:tgtEl>
+                                        <p:attrNameLst>
+                                          <p:attrName>style.visibility</p:attrName>
+                                        </p:attrNameLst>
+                                      </p:cBhvr>
+                                      <p:to>
+                                        <p:strVal val="visible"/>
+                                      </p:to>
+                                    </p:set>
+                                    <p:animEffect transition="in" filter="fade">
+                                      <p:cBhvr>
+                                        <p:cTn id="21" dur="500"/>
+                                        <p:tgtEl>
+                                          <p:spTgt spid="6"/>
+                                        </p:tgtEl>
+                                      </p:cBhvr>
+                                    </p:animEffect>
+                                  </p:childTnLst>
+                                </p:cTn>
+                              </p:par>
+                              <p:par>
+                                <p:cTn id="22" presetID="10" presetClass="entr" presetSubtype="0" fill="hold" grpId="0" nodeType="withEffect">
+                                  <p:stCondLst>
+                                    <p:cond delay="0"/>
+                                  </p:stCondLst>
+                                  <p:childTnLst>
+                                    <p:set>
+                                      <p:cBhvr>
+                                        <p:cTn id="23" dur="1" fill="hold">
+                                          <p:stCondLst>
+                                            <p:cond delay="0"/>
+                                          </p:stCondLst>
+                                        </p:cTn>
+                                        <p:tgtEl>
+                                          <p:spTgt spid="7"/>
+                                        </p:tgtEl>
+                                        <p:attrNameLst>
+                                          <p:attrName>style.visibility</p:attrName>
+                                        </p:attrNameLst>
+                                      </p:cBhvr>
+                                      <p:to>
+                                        <p:strVal val="visible"/>
+                                      </p:to>
+                                    </p:set>
+                                    <p:animEffect transition="in" filter="fade">
+                                      <p:cBhvr>
+                                        <p:cTn id="24" dur="500"/>
+                                        <p:tgtEl>
+                                          <p:spTgt spid="7"/>
+                                        </p:tgtEl>
+                                      </p:cBhvr>
+                                    </p:animEffect>
+                                  </p:childTnLst>
+                                </p:cTn>
+                              </p:par>
+                              <p:par>
+                                <p:cTn id="25" presetID="10" presetClass="entr" presetSubtype="0" fill="hold" grpId="0" nodeType="withEffect">
+                                  <p:stCondLst>
+                                    <p:cond delay="0"/>
+                                  </p:stCondLst>
+                                  <p:childTnLst>
+                                    <p:set>
+                                      <p:cBhvr>
+                                        <p:cTn id="26" dur="1" fill="hold">
+                                          <p:stCondLst>
+                                            <p:cond delay="0"/>
+                                          </p:stCondLst>
+                                        </p:cTn>
+                                        <p:tgtEl>
+                                          <p:spTgt spid="8"/>
+                                        </p:tgtEl>
+                                        <p:attrNameLst>
+                                          <p:attrName>style.visibility</p:attrName>
+                                        </p:attrNameLst>
+                                      </p:cBhvr>
+                                      <p:to>
+                                        <p:strVal val="visible"/>
+                                      </p:to>
+                                    </p:set>
+                                    <p:animEffect transition="in" filter="fade">
+                                      <p:cBhvr>
+                                        <p:cTn id="27" dur="500"/>
+                                        <p:tgtEl>
+                                          <p:spTgt spid="8"/>
+                                        </p:tgtEl>
+                                      </p:cBhvr>
+                                    </p:animEffect>
+                                  </p:childTnLst>
+                                </p:cTn>
+                              </p:par>
+                            </p:childTnLst>
+                          </p:cTn>
+                        </p:par>
+                        <p:par>
+                          <p:cTn id="28" fill="hold">
+                            <p:stCondLst>
+                              <p:cond delay="1500"/>
+                            </p:stCondLst>
+                            <p:childTnLst>
+                              <p:par>
+                                <p:cTn id="29" presetID="10" presetClass="entr" presetSubtype="0" fill="hold" grpId="0" nodeType="afterEffect">
+                                  <p:stCondLst>
+                                    <p:cond delay="0"/>
+                                  </p:stCondLst>
+                                  <p:childTnLst>
+                                    <p:set>
+                                      <p:cBhvr>
+                                        <p:cTn id="30" dur="1" fill="hold">
+                                          <p:stCondLst>
+                                            <p:cond delay="0"/>
+                                          </p:stCondLst>
+                                        </p:cTn>
+                                        <p:tgtEl>
+                                          <p:spTgt spid="9"/>
+                                        </p:tgtEl>
+                                        <p:attrNameLst>
+                                          <p:attrName>style.visibility</p:attrName>
+                                        </p:attrNameLst>
+                                      </p:cBhvr>
+                                      <p:to>
+                                        <p:strVal val="visible"/>
+                                      </p:to>
+                                    </p:set>
+                                    <p:animEffect transition="in" filter="fade">
+                                      <p:cBhvr>
+                                        <p:cTn id="31" dur="500"/>
+                                        <p:tgtEl>
+                                          <p:spTgt spid="9"/>
+                                        </p:tgtEl>
+                                      </p:cBhvr>
+                                    </p:animEffect>
+                                  </p:childTnLst>
+                                </p:cTn>
+                              </p:par>
+                              <p:par>
+                                <p:cTn id="32" presetID="10" presetClass="entr" presetSubtype="0" fill="hold" grpId="0" nodeType="withEffect">
+                                  <p:stCondLst>
+                                    <p:cond delay="0"/>
+                                  </p:stCondLst>
+                                  <p:childTnLst>
+                                    <p:set>
+                                      <p:cBhvr>
+                                        <p:cTn id="33" dur="1" fill="hold">
+                                          <p:stCondLst>
+                                            <p:cond delay="0"/>
+                                          </p:stCondLst>
+                                        </p:cTn>
+                                        <p:tgtEl>
+                                          <p:spTgt spid="10"/>
+                                        </p:tgtEl>
+                                        <p:attrNameLst>
+                                          <p:attrName>style.visibility</p:attrName>
+                                        </p:attrNameLst>
+                                      </p:cBhvr>
+                                      <p:to>
+                                        <p:strVal val="visible"/>
+                                      </p:to>
+                                    </p:set>
+                                    <p:animEffect transition="in" filter="fade">
+                                      <p:cBhvr>
+                                        <p:cTn id="34" dur="500"/>
+                                        <p:tgtEl>
+                                          <p:spTgt spid="10"/>
+                                        </p:tgtEl>
+                                      </p:cBhvr>
+                                    </p:animEffect>
+                                  </p:childTnLst>
+                                </p:cTn>
+                              </p:par>
+                              <p:par>
+                                <p:cTn id="35" presetID="10" presetClass="entr" presetSubtype="0" fill="hold" grpId="0" nodeType="withEffect">
+                                  <p:stCondLst>
+                                    <p:cond delay="0"/>
+                                  </p:stCondLst>
+                                  <p:childTnLst>
+                                    <p:set>
+                                      <p:cBhvr>
+                                        <p:cTn id="36" dur="1" fill="hold">
+                                          <p:stCondLst>
+                                            <p:cond delay="0"/>
+                                          </p:stCondLst>
+                                        </p:cTn>
+                                        <p:tgtEl>
+                                          <p:spTgt spid="11"/>
+                                        </p:tgtEl>
+                                        <p:attrNameLst>
+                                          <p:attrName>style.visibility</p:attrName>
+                                        </p:attrNameLst>
+                                      </p:cBhvr>
+                                      <p:to>
+                                        <p:strVal val="visible"/>
+                                      </p:to>
+                                    </p:set>
+                                    <p:animEffect transition="in" filter="fade">
+                                      <p:cBhvr>
+                                        <p:cTn id="37" dur="500"/>
+                                        <p:tgtEl>
+                                          <p:spTgt spid="11"/>
+                                        </p:tgtEl>
+                                      </p:cBhvr>
+                                    </p:animEffect>
+                                  </p:childTnLst>
+                                </p:cTn>
+                              </p:par>
+                              <p:par>
+                                <p:cTn id="38" presetID="10" presetClass="entr" presetSubtype="0" fill="hold" grpId="0" nodeType="withEffect">
+                                  <p:stCondLst>
+                                    <p:cond delay="0"/>
+                                  </p:stCondLst>
+                                  <p:childTnLst>
+                                    <p:set>
+                                      <p:cBhvr>
+                                        <p:cTn id="39" dur="1" fill="hold">
+                                          <p:stCondLst>
+                                            <p:cond delay="0"/>
+                                          </p:stCondLst>
+                                        </p:cTn>
+                                        <p:tgtEl>
+                                          <p:spTgt spid="12"/>
+                                        </p:tgtEl>
+                                        <p:attrNameLst>
+                                          <p:attrName>style.visibility</p:attrName>
+                                        </p:attrNameLst>
+                                      </p:cBhvr>
+                                      <p:to>
+                                        <p:strVal val="visible"/>
+                                      </p:to>
+                                    </p:set>
+                                    <p:animEffect transition="in" filter="fade">
+                                      <p:cBhvr>
+                                        <p:cTn id="40" dur="500"/>
+                                        <p:tgtEl>
+                                          <p:spTgt spid="12"/>
+                                        </p:tgtEl>
+                                      </p:cBhvr>
+                                    </p:animEffect>
+                                  </p:childTnLst>
+                                </p:cTn>
+                              </p:par>
+                            </p:childTnLst>
+                          </p:cTn>
+                        </p:par>
+                        <p:par>
+                          <p:cTn id="41" fill="hold">
+                            <p:stCondLst>
+                              <p:cond delay="2000"/>
+                            </p:stCondLst>
+                            <p:childTnLst>
+                              <p:par>
+                                <p:cTn id="42" presetID="10" presetClass="entr" presetSubtype="0" fill="hold" grpId="0" nodeType="afterEffect">
+                                  <p:stCondLst>
+                                    <p:cond delay="0"/>
+                                  </p:stCondLst>
+                                  <p:childTnLst>
+                                    <p:set>
+                                      <p:cBhvr>
+                                        <p:cTn id="43" dur="1" fill="hold">
+                                          <p:stCondLst>
+                                            <p:cond delay="0"/>
+                                          </p:stCondLst>
+                                        </p:cTn>
+                                        <p:tgtEl>
+                                          <p:spTgt spid="13"/>
+                                        </p:tgtEl>
+                                        <p:attrNameLst>
+                                          <p:attrName>style.visibility</p:attrName>
+                                        </p:attrNameLst>
+                                      </p:cBhvr>
+                                      <p:to>
+                                        <p:strVal val="visible"/>
+                                      </p:to>
+                                    </p:set>
+                                    <p:animEffect transition="in" filter="fade">
+                                      <p:cBhvr>
+                                        <p:cTn id="44" dur="500"/>
+                                        <p:tgtEl>
+                                          <p:spTgt spid="13"/>
+                                        </p:tgtEl>
+                                      </p:cBhvr>
+                                    </p:animEffect>
+                                  </p:childTnLst>
+                                </p:cTn>
+                              </p:par>
+                              <p:par>
+                                <p:cTn id="45" presetID="10" presetClass="entr" presetSubtype="0" fill="hold" grpId="0" nodeType="withEffect">
+                                  <p:stCondLst>
+                                    <p:cond delay="0"/>
+                                  </p:stCondLst>
+                                  <p:childTnLst>
+                                    <p:set>
+                                      <p:cBhvr>
+                                        <p:cTn id="46" dur="1" fill="hold">
+                                          <p:stCondLst>
+                                            <p:cond delay="0"/>
+                                          </p:stCondLst>
+                                        </p:cTn>
+                                        <p:tgtEl>
+                                          <p:spTgt spid="14"/>
+                                        </p:tgtEl>
+                                        <p:attrNameLst>
+                                          <p:attrName>style.visibility</p:attrName>
+                                        </p:attrNameLst>
+                                      </p:cBhvr>
+                                      <p:to>
+                                        <p:strVal val="visible"/>
+                                      </p:to>
+                                    </p:set>
+                                    <p:animEffect transition="in" filter="fade">
+                                      <p:cBhvr>
+                                        <p:cTn id="47" dur="500"/>
+                                        <p:tgtEl>
+                                          <p:spTgt spid="14"/>
+                                        </p:tgtEl>
+                                      </p:cBhvr>
+                                    </p:animEffect>
+                                  </p:childTnLst>
+                                </p:cTn>
+                              </p:par>
+                            </p:childTnLst>
+                          </p:cTn>
+                        </p:par>
+                        <p:par>
+                          <p:cTn id="48" fill="hold">
+                            <p:stCondLst>
+                              <p:cond delay="2500"/>
+                            </p:stCondLst>
+                            <p:childTnLst>
+                              <p:par>
+                                <p:cTn id="49" presetID="10" presetClass="entr" presetSubtype="0" fill="hold" grpId="0" nodeType="afterEffect">
+                                  <p:stCondLst>
+                                    <p:cond delay="0"/>
+                                  </p:stCondLst>
+                                  <p:childTnLst>
+                                    <p:set>
+                                      <p:cBhvr>
+                                        <p:cTn id="50" dur="1" fill="hold">
+                                          <p:stCondLst>
+                                            <p:cond delay="0"/>
+                                          </p:stCondLst>
+                                        </p:cTn>
+                                        <p:tgtEl>
+                                          <p:spTgt spid="15"/>
+                                        </p:tgtEl>
+                                        <p:attrNameLst>
+                                          <p:attrName>style.visibility</p:attrName>
+                                        </p:attrNameLst>
+                                      </p:cBhvr>
+                                      <p:to>
+                                        <p:strVal val="visible"/>
+                                      </p:to>
+                                    </p:set>
+                                    <p:animEffect transition="in" filter="fade">
+                                      <p:cBhvr>
+                                        <p:cTn id="51" dur="500"/>
+                                        <p:tgtEl>
+                                          <p:spTgt spid="15"/>
+                                        </p:tgtEl>
+                                      </p:cBhvr>
+                                    </p:animEffect>
+                                  </p:childTnLst>
+                                </p:cTn>
+                              </p:par>
+                              <p:par>
+                                <p:cTn id="52" presetID="10" presetClass="entr" presetSubtype="0" fill="hold" grpId="0" nodeType="withEffect">
+                                  <p:stCondLst>
+                                    <p:cond delay="0"/>
+                                  </p:stCondLst>
+                                  <p:childTnLst>
+                                    <p:set>
+                                      <p:cBhvr>
+                                        <p:cTn id="53" dur="1" fill="hold">
+                                          <p:stCondLst>
+                                            <p:cond delay="0"/>
+                                          </p:stCondLst>
+                                        </p:cTn>
+                                        <p:tgtEl>
+                                          <p:spTgt spid="16"/>
+                                        </p:tgtEl>
+                                        <p:attrNameLst>
+                                          <p:attrName>style.visibility</p:attrName>
+                                        </p:attrNameLst>
+                                      </p:cBhvr>
+                                      <p:to>
+                                        <p:strVal val="visible"/>
+                                      </p:to>
+                                    </p:set>
+                                    <p:animEffect transition="in" filter="fade">
+                                      <p:cBhvr>
+                                        <p:cTn id="54" dur="500"/>
+                                        <p:tgtEl>
+                                          <p:spTgt spid="16"/>
+                                        </p:tgtEl>
+                                      </p:cBhvr>
+                                    </p:animEffect>
+                                  </p:childTnLst>
+                                </p:cTn>
+                              </p:par>
+                              <p:par>
+                                <p:cTn id="55" presetID="10" presetClass="entr" presetSubtype="0" fill="hold" grpId="0" nodeType="withEffect">
+                                  <p:stCondLst>
+                                    <p:cond delay="0"/>
+                                  </p:stCondLst>
+                                  <p:childTnLst>
+                                    <p:set>
+                                      <p:cBhvr>
+                                        <p:cTn id="56" dur="1" fill="hold">
+                                          <p:stCondLst>
+                                            <p:cond delay="0"/>
+                                          </p:stCondLst>
+                                        </p:cTn>
+                                        <p:tgtEl>
+                                          <p:spTgt spid="17"/>
+                                        </p:tgtEl>
+                                        <p:attrNameLst>
+                                          <p:attrName>style.visibility</p:attrName>
+                                        </p:attrNameLst>
+                                      </p:cBhvr>
+                                      <p:to>
+                                        <p:strVal val="visible"/>
+                                      </p:to>
+                                    </p:set>
+                                    <p:animEffect transition="in" filter="fade">
+                                      <p:cBhvr>
+                                        <p:cTn id="57" dur="500"/>
+                                        <p:tgtEl>
+                                          <p:spTgt spid="17"/>
+                                        </p:tgtEl>
+                                      </p:cBhvr>
+                                    </p:animEffect>
+                                  </p:childTnLst>
+                                </p:cTn>
+                              </p:par>
+                              <p:par>
+                                <p:cTn id="58" presetID="10" presetClass="entr" presetSubtype="0" fill="hold" grpId="0" nodeType="withEffect">
+                                  <p:stCondLst>
+                                    <p:cond delay="0"/>
+                                  </p:stCondLst>
+                                  <p:childTnLst>
+                                    <p:set>
+                                      <p:cBhvr>
+                                        <p:cTn id="59" dur="1" fill="hold">
+                                          <p:stCondLst>
+                                            <p:cond delay="0"/>
+                                          </p:stCondLst>
+                                        </p:cTn>
+                                        <p:tgtEl>
+                                          <p:spTgt spid="18"/>
+                                        </p:tgtEl>
+                                        <p:attrNameLst>
+                                          <p:attrName>style.visibility</p:attrName>
+                                        </p:attrNameLst>
+                                      </p:cBhvr>
+                                      <p:to>
+                                        <p:strVal val="visible"/>
+                                      </p:to>
+                                    </p:set>
+                                    <p:animEffect transition="in" filter="fade">
+                                      <p:cBhvr>
+                                        <p:cTn id="60" dur="500"/>
+                                        <p:tgtEl>
+                                          <p:spTgt spid="18"/>
+                                        </p:tgtEl>
+                                      </p:cBhvr>
+                                    </p:animEffect>
+                                  </p:childTnLst>
+                                </p:cTn>
+                              </p:par>
+                              <p:par>
+                                <p:cTn id="61" presetID="10" presetClass="entr" presetSubtype="0" fill="hold" grpId="0" nodeType="withEffect">
+                                  <p:stCondLst>
+                                    <p:cond delay="0"/>
+                                  </p:stCondLst>
+                                  <p:childTnLst>
+                                    <p:set>
+                                      <p:cBhvr>
+                                        <p:cTn id="62" dur="1" fill="hold">
+                                          <p:stCondLst>
+                                            <p:cond delay="0"/>
+                                          </p:stCondLst>
+                                        </p:cTn>
+                                        <p:tgtEl>
+                                          <p:spTgt spid="19"/>
+                                        </p:tgtEl>
+                                        <p:attrNameLst>
+                                          <p:attrName>style.visibility</p:attrName>
+                                        </p:attrNameLst>
+                                      </p:cBhvr>
+                                      <p:to>
+                                        <p:strVal val="visible"/>
+                                      </p:to>
+                                    </p:set>
+                                    <p:animEffect transition="in" filter="fade">
+                                      <p:cBhvr>
+                                        <p:cTn id="63" dur="500"/>
+                                        <p:tgtEl>
+                                          <p:spTgt spid="19"/>
+                                        </p:tgtEl>
+                                      </p:cBhvr>
+                                    </p:animEffect>
+                                  </p:childTnLst>
+                                </p:cTn>
+                              </p:par>
+                              <p:par>
+                                <p:cTn id="64" presetID="10" presetClass="entr" presetSubtype="0" fill="hold" grpId="0" nodeType="withEffect">
+                                  <p:stCondLst>
+                                    <p:cond delay="0"/>
+                                  </p:stCondLst>
+                                  <p:childTnLst>
+                                    <p:set>
+                                      <p:cBhvr>
+                                        <p:cTn id="65" dur="1" fill="hold">
+                                          <p:stCondLst>
+                                            <p:cond delay="0"/>
+                                          </p:stCondLst>
+                                        </p:cTn>
+                                        <p:tgtEl>
+                                          <p:spTgt spid="20"/>
+                                        </p:tgtEl>
+                                        <p:attrNameLst>
+                                          <p:attrName>style.visibility</p:attrName>
+                                        </p:attrNameLst>
+                                      </p:cBhvr>
+                                      <p:to>
+                                        <p:strVal val="visible"/>
+                                      </p:to>
+                                    </p:set>
+                                    <p:animEffect transition="in" filter="fade">
+                                      <p:cBhvr>
+                                        <p:cTn id="66" dur="500"/>
+                                        <p:tgtEl>
+                                          <p:spTgt spid="20"/>
+                                        </p:tgtEl>
+                                      </p:cBhvr>
+                                    </p:animEffect>
+                                  </p:childTnLst>
+                                </p:cTn>
+                              </p:par>
+                              <p:par>
+                                <p:cTn id="67" presetID="10" presetClass="entr" presetSubtype="0" fill="hold" grpId="0" nodeType="withEffect">
+                                  <p:stCondLst>
+                                    <p:cond delay="0"/>
+                                  </p:stCondLst>
+                                  <p:childTnLst>
+                                    <p:set>
+                                      <p:cBhvr>
+                                        <p:cTn id="68" dur="1" fill="hold">
+                                          <p:stCondLst>
+                                            <p:cond delay="0"/>
+                                          </p:stCondLst>
+                                        </p:cTn>
+                                        <p:tgtEl>
+                                          <p:spTgt spid="21"/>
+                                        </p:tgtEl>
+                                        <p:attrNameLst>
+                                          <p:attrName>style.visibility</p:attrName>
+                                        </p:attrNameLst>
+                                      </p:cBhvr>
+                                      <p:to>
+                                        <p:strVal val="visible"/>
+                                      </p:to>
+                                    </p:set>
+                                    <p:animEffect transition="in" filter="fade">
+                                      <p:cBhvr>
+                                        <p:cTn id="69" dur="500"/>
+                                        <p:tgtEl>
+                                          <p:spTgt spid="21"/>
+                                        </p:tgtEl>
+                                      </p:cBhvr>
+                                    </p:animEffect>
+                                  </p:childTnLst>
+                                </p:cTn>
+                              </p:par>
+                              <p:par>
+                                <p:cTn id="70" presetID="10" presetClass="entr" presetSubtype="0" fill="hold" grpId="0" nodeType="withEffect">
+                                  <p:stCondLst>
+                                    <p:cond delay="0"/>
+                                  </p:stCondLst>
+                                  <p:childTnLst>
+                                    <p:set>
+                                      <p:cBhvr>
+                                        <p:cTn id="71" dur="1" fill="hold">
+                                          <p:stCondLst>
+                                            <p:cond delay="0"/>
+                                          </p:stCondLst>
+                                        </p:cTn>
+                                        <p:tgtEl>
+                                          <p:spTgt spid="22"/>
+                                        </p:tgtEl>
+                                        <p:attrNameLst>
+                                          <p:attrName>style.visibility</p:attrName>
+                                        </p:attrNameLst>
+                                      </p:cBhvr>
+                                      <p:to>
+                                        <p:strVal val="visible"/>
+                                      </p:to>
+                                    </p:set>
+                                    <p:animEffect transition="in" filter="fade">
+                                      <p:cBhvr>
+                                        <p:cTn id="72" dur="500"/>
+                                        <p:tgtEl>
+                                          <p:spTgt spid="22"/>
+                                        </p:tgtEl>
+                                      </p:cBhvr>
+                                    </p:animEffect>
+                                  </p:childTnLst>
+                                </p:cTn>
+                              </p:par>
+                            </p:childTnLst>
+                          </p:cTn>
+                        </p:par>
+                      </p:childTnLst>
+                    </p:cTn>
+                  </p:par>
+                </p:childTnLst>
+              </p:cTn>
+              <p:prevCondLst>
+                <p:cond evt="onPrev" delay="0">
+                  <p:tgtEl>
+                    <p:sldTgt/>
+                  </p:tgtEl>
+                </p:cond>
+              </p:prevCondLst>
+              <p:nextCondLst>
+                <p:cond evt="onNext" delay="0">
+                  <p:tgtEl>
+                    <p:sldTgt/>
+                  </p:tgtEl>
+                </p:cond>
+              </p:nextCondLst>
+            </p:seq>
+          </p:childTnLst>
+        </p:cTn>
+      </p:par>
+    </p:tnLst>
+    <p:bldLst>
+      <p:bldP spid="2" grpId="0" animBg="1"/>
+      <p:bldP spid="3" grpId="0" animBg="1"/>
+      <p:bldP spid="4" grpId="0" animBg="1"/>
+      <p:bldP spid="5" grpId="0" animBg="1"/>
+      <p:bldP spid="6" grpId="0" animBg="1"/>
+      <p:bldP spid="7" grpId="0" animBg="1"/>
+      <p:bldP spid="8" grpId="0" animBg="1"/>
+      <p:bldP spid="9" grpId="0" animBg="1"/>
+      <p:bldP spid="10" grpId="0" animBg="1"/>
+      <p:bldP spid="11" grpId="0" animBg="1"/>
+      <p:bldP spid="12" grpId="0" animBg="1"/>
+      <p:bldGraphic spid="13" grpId="0">
+        <p:bldAsOne/>
+      </p:bldGraphic>
+      <p:bldP spid="14" grpId="0" animBg="1"/>
+      <p:bldP spid="15" grpId="0" animBg="1"/>
+      <p:bldP spid="16" grpId="0" animBg="1"/>
+      <p:bldP spid="17" grpId="0" animBg="1"/>
+      <p:bldP spid="18" grpId="0" animBg="1"/>
+      <p:bldP spid="19" grpId="0" animBg="1"/>
+      <p:bldP spid="20" grpId="0" animBg="1"/>
+      <p:bldP spid="21" grpId="0" animBg="1"/>
+      <p:bldP spid="22" grpId="0" animBg="1"/>
+    </p:bldLst>
+  </p:timing>
 </p:sld>
 </file>
 
@@ -4448,7 +5564,7 @@
       </p:grpSpPr>
       <p:sp>
         <p:nvSpPr>
-          <p:cNvPr id="2" name="Text 0"/>
+          <p:cNvPr id="2" name="Title"/>
           <p:cNvSpPr txBox="1"/>
           <p:nvPr/>
         </p:nvSpPr>
@@ -4487,7 +5603,7 @@
       </p:sp>
       <p:sp>
         <p:nvSpPr>
-          <p:cNvPr id="3" name="Shape 1"/>
+          <p:cNvPr id="3" name="Title Rule"/>
           <p:cNvSpPr/>
           <p:nvPr/>
         </p:nvSpPr>
@@ -4510,7 +5626,7 @@
       </p:sp>
       <p:sp>
         <p:nvSpPr>
-          <p:cNvPr id="4" name="Text 2"/>
+          <p:cNvPr id="4" name="Subtitle"/>
           <p:cNvSpPr txBox="1"/>
           <p:nvPr/>
         </p:nvSpPr>
@@ -4549,7 +5665,7 @@
       </p:sp>
       <p:sp>
         <p:nvSpPr>
-          <p:cNvPr id="5" name="Shape 3"/>
+          <p:cNvPr id="5" name="Key Figures Box"/>
           <p:cNvSpPr/>
           <p:nvPr/>
         </p:nvSpPr>
@@ -4574,7 +5690,7 @@
       </p:sp>
       <p:sp>
         <p:nvSpPr>
-          <p:cNvPr id="6" name="Text 4"/>
+          <p:cNvPr id="6" name="Key Figures Heading"/>
           <p:cNvSpPr txBox="1"/>
           <p:nvPr/>
         </p:nvSpPr>
@@ -4613,7 +5729,7 @@
       </p:sp>
       <p:sp>
         <p:nvSpPr>
-          <p:cNvPr id="7" name="Text 5"/>
+          <p:cNvPr id="7" name="Key Figures"/>
           <p:cNvSpPr txBox="1"/>
           <p:nvPr/>
         </p:nvSpPr>
@@ -4795,7 +5911,7 @@
       </p:sp>
       <p:sp>
         <p:nvSpPr>
-          <p:cNvPr id="8" name="Text 6"/>
+          <p:cNvPr id="8" name="Chart Heading"/>
           <p:cNvSpPr txBox="1"/>
           <p:nvPr/>
         </p:nvSpPr>
@@ -4834,7 +5950,7 @@
       </p:sp>
       <p:graphicFrame>
         <p:nvGraphicFramePr>
-          <p:cNvPr id="9" name="Chart 0" descr=""/>
+          <p:cNvPr id="9" name="Budget Chart" descr=""/>
           <p:cNvGraphicFramePr/>
           <p:nvPr/>
         </p:nvGraphicFramePr>
@@ -4854,8 +5970,378 @@
     <a:masterClrMapping/>
   </p:clrMapOvr>
   <p:transition spd="med">
-    <p:fade/>
+    <p:push dir="u"/>
   </p:transition>
+  <p:timing>
+    <p:tnLst>
+      <p:par>
+        <p:cTn id="1" dur="indefinite" restart="never" nodeType="tmRoot">
+          <p:childTnLst>
+            <p:seq concurrent="1" nextAc="seek">
+              <p:cTn id="2" dur="indefinite" nodeType="mainSeq">
+                <p:childTnLst>
+                  <p:par>
+                    <p:cTn id="3" fill="hold">
+                      <p:stCondLst>
+                        <p:cond delay="indefinite"/>
+                        <p:cond evt="onBegin" delay="0">
+                          <p:tn val="2"/>
+                        </p:cond>
+                      </p:stCondLst>
+                      <p:childTnLst>
+                        <p:par>
+                          <p:cTn id="4" fill="hold">
+                            <p:stCondLst>
+                              <p:cond delay="0"/>
+                            </p:stCondLst>
+                            <p:childTnLst>
+                              <p:par>
+                                <p:cTn id="5" presetID="10" presetClass="entr" presetSubtype="0" fill="hold" grpId="0" nodeType="afterEffect">
+                                  <p:stCondLst>
+                                    <p:cond delay="0"/>
+                                  </p:stCondLst>
+                                  <p:childTnLst>
+                                    <p:set>
+                                      <p:cBhvr>
+                                        <p:cTn id="6" dur="1" fill="hold">
+                                          <p:stCondLst>
+                                            <p:cond delay="0"/>
+                                          </p:stCondLst>
+                                        </p:cTn>
+                                        <p:tgtEl>
+                                          <p:spTgt spid="2"/>
+                                        </p:tgtEl>
+                                        <p:attrNameLst>
+                                          <p:attrName>style.visibility</p:attrName>
+                                        </p:attrNameLst>
+                                      </p:cBhvr>
+                                      <p:to>
+                                        <p:strVal val="visible"/>
+                                      </p:to>
+                                    </p:set>
+                                    <p:animEffect transition="in" filter="fade">
+                                      <p:cBhvr>
+                                        <p:cTn id="7" dur="500"/>
+                                        <p:tgtEl>
+                                          <p:spTgt spid="2"/>
+                                        </p:tgtEl>
+                                      </p:cBhvr>
+                                    </p:animEffect>
+                                  </p:childTnLst>
+                                </p:cTn>
+                              </p:par>
+                              <p:par>
+                                <p:cTn id="8" presetID="22" presetClass="entr" presetSubtype="8" fill="hold" grpId="0" nodeType="withEffect">
+                                  <p:stCondLst>
+                                    <p:cond delay="0"/>
+                                  </p:stCondLst>
+                                  <p:childTnLst>
+                                    <p:set>
+                                      <p:cBhvr>
+                                        <p:cTn id="9" dur="1" fill="hold">
+                                          <p:stCondLst>
+                                            <p:cond delay="0"/>
+                                          </p:stCondLst>
+                                        </p:cTn>
+                                        <p:tgtEl>
+                                          <p:spTgt spid="3"/>
+                                        </p:tgtEl>
+                                        <p:attrNameLst>
+                                          <p:attrName>style.visibility</p:attrName>
+                                        </p:attrNameLst>
+                                      </p:cBhvr>
+                                      <p:to>
+                                        <p:strVal val="visible"/>
+                                      </p:to>
+                                    </p:set>
+                                    <p:animEffect transition="in" filter="wipe(right)">
+                                      <p:cBhvr>
+                                        <p:cTn id="10" dur="500"/>
+                                        <p:tgtEl>
+                                          <p:spTgt spid="3"/>
+                                        </p:tgtEl>
+                                      </p:cBhvr>
+                                    </p:animEffect>
+                                  </p:childTnLst>
+                                </p:cTn>
+                              </p:par>
+                            </p:childTnLst>
+                          </p:cTn>
+                        </p:par>
+                        <p:par>
+                          <p:cTn id="11" fill="hold">
+                            <p:stCondLst>
+                              <p:cond delay="500"/>
+                            </p:stCondLst>
+                            <p:childTnLst>
+                              <p:par>
+                                <p:cTn id="12" presetID="10" presetClass="entr" presetSubtype="0" fill="hold" grpId="0" nodeType="afterEffect">
+                                  <p:stCondLst>
+                                    <p:cond delay="0"/>
+                                  </p:stCondLst>
+                                  <p:childTnLst>
+                                    <p:set>
+                                      <p:cBhvr>
+                                        <p:cTn id="13" dur="1" fill="hold">
+                                          <p:stCondLst>
+                                            <p:cond delay="0"/>
+                                          </p:stCondLst>
+                                        </p:cTn>
+                                        <p:tgtEl>
+                                          <p:spTgt spid="4"/>
+                                        </p:tgtEl>
+                                        <p:attrNameLst>
+                                          <p:attrName>style.visibility</p:attrName>
+                                        </p:attrNameLst>
+                                      </p:cBhvr>
+                                      <p:to>
+                                        <p:strVal val="visible"/>
+                                      </p:to>
+                                    </p:set>
+                                    <p:animEffect transition="in" filter="fade">
+                                      <p:cBhvr>
+                                        <p:cTn id="14" dur="500"/>
+                                        <p:tgtEl>
+                                          <p:spTgt spid="4"/>
+                                        </p:tgtEl>
+                                      </p:cBhvr>
+                                    </p:animEffect>
+                                  </p:childTnLst>
+                                </p:cTn>
+                              </p:par>
+                            </p:childTnLst>
+                          </p:cTn>
+                        </p:par>
+                        <p:par>
+                          <p:cTn id="15" fill="hold">
+                            <p:stCondLst>
+                              <p:cond delay="1000"/>
+                            </p:stCondLst>
+                            <p:childTnLst>
+                              <p:par>
+                                <p:cTn id="16" presetID="10" presetClass="entr" presetSubtype="0" fill="hold" grpId="0" nodeType="afterEffect">
+                                  <p:stCondLst>
+                                    <p:cond delay="0"/>
+                                  </p:stCondLst>
+                                  <p:childTnLst>
+                                    <p:set>
+                                      <p:cBhvr>
+                                        <p:cTn id="17" dur="1" fill="hold">
+                                          <p:stCondLst>
+                                            <p:cond delay="0"/>
+                                          </p:stCondLst>
+                                        </p:cTn>
+                                        <p:tgtEl>
+                                          <p:spTgt spid="5"/>
+                                        </p:tgtEl>
+                                        <p:attrNameLst>
+                                          <p:attrName>style.visibility</p:attrName>
+                                        </p:attrNameLst>
+                                      </p:cBhvr>
+                                      <p:to>
+                                        <p:strVal val="visible"/>
+                                      </p:to>
+                                    </p:set>
+                                    <p:animEffect transition="in" filter="fade">
+                                      <p:cBhvr>
+                                        <p:cTn id="18" dur="500"/>
+                                        <p:tgtEl>
+                                          <p:spTgt spid="5"/>
+                                        </p:tgtEl>
+                                      </p:cBhvr>
+                                    </p:animEffect>
+                                  </p:childTnLst>
+                                </p:cTn>
+                              </p:par>
+                              <p:par>
+                                <p:cTn id="19" presetID="10" presetClass="entr" presetSubtype="0" fill="hold" grpId="0" nodeType="withEffect">
+                                  <p:stCondLst>
+                                    <p:cond delay="0"/>
+                                  </p:stCondLst>
+                                  <p:childTnLst>
+                                    <p:set>
+                                      <p:cBhvr>
+                                        <p:cTn id="20" dur="1" fill="hold">
+                                          <p:stCondLst>
+                                            <p:cond delay="0"/>
+                                          </p:stCondLst>
+                                        </p:cTn>
+                                        <p:tgtEl>
+                                          <p:spTgt spid="6"/>
+                                        </p:tgtEl>
+                                        <p:attrNameLst>
+                                          <p:attrName>style.visibility</p:attrName>
+                                        </p:attrNameLst>
+                                      </p:cBhvr>
+                                      <p:to>
+                                        <p:strVal val="visible"/>
+                                      </p:to>
+                                    </p:set>
+                                    <p:animEffect transition="in" filter="fade">
+                                      <p:cBhvr>
+                                        <p:cTn id="21" dur="500"/>
+                                        <p:tgtEl>
+                                          <p:spTgt spid="6"/>
+                                        </p:tgtEl>
+                                      </p:cBhvr>
+                                    </p:animEffect>
+                                  </p:childTnLst>
+                                </p:cTn>
+                              </p:par>
+                              <p:par>
+                                <p:cTn id="22" presetID="10" presetClass="entr" presetSubtype="0" fill="hold" grpId="0" nodeType="withEffect">
+                                  <p:stCondLst>
+                                    <p:cond delay="0"/>
+                                  </p:stCondLst>
+                                  <p:childTnLst>
+                                    <p:set>
+                                      <p:cBhvr>
+                                        <p:cTn id="23" dur="1" fill="hold">
+                                          <p:stCondLst>
+                                            <p:cond delay="0"/>
+                                          </p:stCondLst>
+                                        </p:cTn>
+                                        <p:tgtEl>
+                                          <p:spTgt spid="7"/>
+                                        </p:tgtEl>
+                                        <p:attrNameLst>
+                                          <p:attrName>style.visibility</p:attrName>
+                                        </p:attrNameLst>
+                                      </p:cBhvr>
+                                      <p:to>
+                                        <p:strVal val="visible"/>
+                                      </p:to>
+                                    </p:set>
+                                    <p:animEffect transition="in" filter="fade">
+                                      <p:cBhvr>
+                                        <p:cTn id="24" dur="500"/>
+                                        <p:tgtEl>
+                                          <p:spTgt spid="7"/>
+                                        </p:tgtEl>
+                                      </p:cBhvr>
+                                    </p:animEffect>
+                                  </p:childTnLst>
+                                </p:cTn>
+                              </p:par>
+                            </p:childTnLst>
+                          </p:cTn>
+                        </p:par>
+                        <p:par>
+                          <p:cTn id="25" fill="hold">
+                            <p:stCondLst>
+                              <p:cond delay="1500"/>
+                            </p:stCondLst>
+                            <p:childTnLst>
+                              <p:par>
+                                <p:cTn id="26" presetID="10" presetClass="entr" presetSubtype="0" fill="hold" grpId="0" nodeType="afterEffect">
+                                  <p:stCondLst>
+                                    <p:cond delay="0"/>
+                                  </p:stCondLst>
+                                  <p:childTnLst>
+                                    <p:set>
+                                      <p:cBhvr>
+                                        <p:cTn id="27" dur="1" fill="hold">
+                                          <p:stCondLst>
+                                            <p:cond delay="0"/>
+                                          </p:stCondLst>
+                                        </p:cTn>
+                                        <p:tgtEl>
+                                          <p:spTgt spid="8"/>
+                                        </p:tgtEl>
+                                        <p:attrNameLst>
+                                          <p:attrName>style.visibility</p:attrName>
+                                        </p:attrNameLst>
+                                      </p:cBhvr>
+                                      <p:to>
+                                        <p:strVal val="visible"/>
+                                      </p:to>
+                                    </p:set>
+                                    <p:animEffect transition="in" filter="fade">
+                                      <p:cBhvr>
+                                        <p:cTn id="28" dur="500"/>
+                                        <p:tgtEl>
+                                          <p:spTgt spid="8"/>
+                                        </p:tgtEl>
+                                      </p:cBhvr>
+                                    </p:animEffect>
+                                  </p:childTnLst>
+                                </p:cTn>
+                              </p:par>
+                              <p:par>
+                                <p:cTn id="29" presetID="22" presetClass="entr" presetSubtype="8" fill="hold" grpId="0" nodeType="withEffect">
+                                  <p:stCondLst>
+                                    <p:cond delay="0"/>
+                                  </p:stCondLst>
+                                  <p:childTnLst>
+                                    <p:set>
+                                      <p:cBhvr>
+                                        <p:cTn id="30" dur="1" fill="hold">
+                                          <p:stCondLst>
+                                            <p:cond delay="0"/>
+                                          </p:stCondLst>
+                                        </p:cTn>
+                                        <p:tgtEl>
+                                          <p:spTgt spid="9"/>
+                                        </p:tgtEl>
+                                        <p:attrNameLst>
+                                          <p:attrName>style.visibility</p:attrName>
+                                        </p:attrNameLst>
+                                      </p:cBhvr>
+                                      <p:to>
+                                        <p:strVal val="visible"/>
+                                      </p:to>
+                                    </p:set>
+                                    <p:animEffect transition="in" filter="wipe(right)">
+                                      <p:cBhvr>
+                                        <p:cTn id="31" dur="500"/>
+                                        <p:tgtEl>
+                                          <p:spTgt spid="9"/>
+                                        </p:tgtEl>
+                                      </p:cBhvr>
+                                    </p:animEffect>
+                                  </p:childTnLst>
+                                </p:cTn>
+                              </p:par>
+                            </p:childTnLst>
+                          </p:cTn>
+                        </p:par>
+                      </p:childTnLst>
+                    </p:cTn>
+                  </p:par>
+                </p:childTnLst>
+              </p:cTn>
+              <p:prevCondLst>
+                <p:cond evt="onPrev" delay="0">
+                  <p:tgtEl>
+                    <p:sldTgt/>
+                  </p:tgtEl>
+                </p:cond>
+              </p:prevCondLst>
+              <p:nextCondLst>
+                <p:cond evt="onNext" delay="0">
+                  <p:tgtEl>
+                    <p:sldTgt/>
+                  </p:tgtEl>
+                </p:cond>
+              </p:nextCondLst>
+            </p:seq>
+          </p:childTnLst>
+        </p:cTn>
+      </p:par>
+    </p:tnLst>
+    <p:bldLst>
+      <p:bldP spid="2" grpId="0" animBg="1"/>
+      <p:bldP spid="3" grpId="0" animBg="1"/>
+      <p:bldP spid="4" grpId="0" animBg="1"/>
+      <p:bldP spid="5" grpId="0" animBg="1"/>
+      <p:bldP spid="6" grpId="0" animBg="1"/>
+      <p:bldP spid="7" grpId="0" animBg="1"/>
+      <p:bldP spid="8" grpId="0" animBg="1"/>
+      <p:bldGraphic spid="9" grpId="0">
+        <p:bldAsOne/>
+      </p:bldGraphic>
+    </p:bldLst>
+  </p:timing>
 </p:sld>
 </file>
 
@@ -4878,7 +6364,7 @@
       </p:grpSpPr>
       <p:sp>
         <p:nvSpPr>
-          <p:cNvPr id="2" name="Text 0"/>
+          <p:cNvPr id="2" name="Title"/>
           <p:cNvSpPr txBox="1"/>
           <p:nvPr/>
         </p:nvSpPr>
@@ -4917,7 +6403,7 @@
       </p:sp>
       <p:sp>
         <p:nvSpPr>
-          <p:cNvPr id="3" name="Shape 1"/>
+          <p:cNvPr id="3" name="Title Rule"/>
           <p:cNvSpPr/>
           <p:nvPr/>
         </p:nvSpPr>
@@ -4940,7 +6426,7 @@
       </p:sp>
       <p:sp>
         <p:nvSpPr>
-          <p:cNvPr id="4" name="Text 2"/>
+          <p:cNvPr id="4" name="Subtitle"/>
           <p:cNvSpPr txBox="1"/>
           <p:nvPr/>
         </p:nvSpPr>
@@ -4979,7 +6465,7 @@
       </p:sp>
       <p:sp>
         <p:nvSpPr>
-          <p:cNvPr id="5" name="Shape 3"/>
+          <p:cNvPr id="5" name="Key Figures Box"/>
           <p:cNvSpPr/>
           <p:nvPr/>
         </p:nvSpPr>
@@ -5004,7 +6490,7 @@
       </p:sp>
       <p:sp>
         <p:nvSpPr>
-          <p:cNvPr id="6" name="Text 4"/>
+          <p:cNvPr id="6" name="Key Figures Heading"/>
           <p:cNvSpPr txBox="1"/>
           <p:nvPr/>
         </p:nvSpPr>
@@ -5043,7 +6529,7 @@
       </p:sp>
       <p:sp>
         <p:nvSpPr>
-          <p:cNvPr id="7" name="Text 5"/>
+          <p:cNvPr id="7" name="Key Figures"/>
           <p:cNvSpPr txBox="1"/>
           <p:nvPr/>
         </p:nvSpPr>
@@ -5225,7 +6711,7 @@
       </p:sp>
       <p:sp>
         <p:nvSpPr>
-          <p:cNvPr id="8" name="Text 6"/>
+          <p:cNvPr id="8" name="Chart Heading"/>
           <p:cNvSpPr txBox="1"/>
           <p:nvPr/>
         </p:nvSpPr>
@@ -5264,7 +6750,7 @@
       </p:sp>
       <p:graphicFrame>
         <p:nvGraphicFramePr>
-          <p:cNvPr id="9" name="Chart 0" descr=""/>
+          <p:cNvPr id="9" name="Budget Chart" descr=""/>
           <p:cNvGraphicFramePr/>
           <p:nvPr/>
         </p:nvGraphicFramePr>
@@ -5284,8 +6770,378 @@
     <a:masterClrMapping/>
   </p:clrMapOvr>
   <p:transition spd="med">
-    <p:fade/>
+    <p:push dir="u"/>
   </p:transition>
+  <p:timing>
+    <p:tnLst>
+      <p:par>
+        <p:cTn id="1" dur="indefinite" restart="never" nodeType="tmRoot">
+          <p:childTnLst>
+            <p:seq concurrent="1" nextAc="seek">
+              <p:cTn id="2" dur="indefinite" nodeType="mainSeq">
+                <p:childTnLst>
+                  <p:par>
+                    <p:cTn id="3" fill="hold">
+                      <p:stCondLst>
+                        <p:cond delay="indefinite"/>
+                        <p:cond evt="onBegin" delay="0">
+                          <p:tn val="2"/>
+                        </p:cond>
+                      </p:stCondLst>
+                      <p:childTnLst>
+                        <p:par>
+                          <p:cTn id="4" fill="hold">
+                            <p:stCondLst>
+                              <p:cond delay="0"/>
+                            </p:stCondLst>
+                            <p:childTnLst>
+                              <p:par>
+                                <p:cTn id="5" presetID="10" presetClass="entr" presetSubtype="0" fill="hold" grpId="0" nodeType="afterEffect">
+                                  <p:stCondLst>
+                                    <p:cond delay="0"/>
+                                  </p:stCondLst>
+                                  <p:childTnLst>
+                                    <p:set>
+                                      <p:cBhvr>
+                                        <p:cTn id="6" dur="1" fill="hold">
+                                          <p:stCondLst>
+                                            <p:cond delay="0"/>
+                                          </p:stCondLst>
+                                        </p:cTn>
+                                        <p:tgtEl>
+                                          <p:spTgt spid="2"/>
+                                        </p:tgtEl>
+                                        <p:attrNameLst>
+                                          <p:attrName>style.visibility</p:attrName>
+                                        </p:attrNameLst>
+                                      </p:cBhvr>
+                                      <p:to>
+                                        <p:strVal val="visible"/>
+                                      </p:to>
+                                    </p:set>
+                                    <p:animEffect transition="in" filter="fade">
+                                      <p:cBhvr>
+                                        <p:cTn id="7" dur="500"/>
+                                        <p:tgtEl>
+                                          <p:spTgt spid="2"/>
+                                        </p:tgtEl>
+                                      </p:cBhvr>
+                                    </p:animEffect>
+                                  </p:childTnLst>
+                                </p:cTn>
+                              </p:par>
+                              <p:par>
+                                <p:cTn id="8" presetID="22" presetClass="entr" presetSubtype="8" fill="hold" grpId="0" nodeType="withEffect">
+                                  <p:stCondLst>
+                                    <p:cond delay="0"/>
+                                  </p:stCondLst>
+                                  <p:childTnLst>
+                                    <p:set>
+                                      <p:cBhvr>
+                                        <p:cTn id="9" dur="1" fill="hold">
+                                          <p:stCondLst>
+                                            <p:cond delay="0"/>
+                                          </p:stCondLst>
+                                        </p:cTn>
+                                        <p:tgtEl>
+                                          <p:spTgt spid="3"/>
+                                        </p:tgtEl>
+                                        <p:attrNameLst>
+                                          <p:attrName>style.visibility</p:attrName>
+                                        </p:attrNameLst>
+                                      </p:cBhvr>
+                                      <p:to>
+                                        <p:strVal val="visible"/>
+                                      </p:to>
+                                    </p:set>
+                                    <p:animEffect transition="in" filter="wipe(right)">
+                                      <p:cBhvr>
+                                        <p:cTn id="10" dur="500"/>
+                                        <p:tgtEl>
+                                          <p:spTgt spid="3"/>
+                                        </p:tgtEl>
+                                      </p:cBhvr>
+                                    </p:animEffect>
+                                  </p:childTnLst>
+                                </p:cTn>
+                              </p:par>
+                            </p:childTnLst>
+                          </p:cTn>
+                        </p:par>
+                        <p:par>
+                          <p:cTn id="11" fill="hold">
+                            <p:stCondLst>
+                              <p:cond delay="500"/>
+                            </p:stCondLst>
+                            <p:childTnLst>
+                              <p:par>
+                                <p:cTn id="12" presetID="10" presetClass="entr" presetSubtype="0" fill="hold" grpId="0" nodeType="afterEffect">
+                                  <p:stCondLst>
+                                    <p:cond delay="0"/>
+                                  </p:stCondLst>
+                                  <p:childTnLst>
+                                    <p:set>
+                                      <p:cBhvr>
+                                        <p:cTn id="13" dur="1" fill="hold">
+                                          <p:stCondLst>
+                                            <p:cond delay="0"/>
+                                          </p:stCondLst>
+                                        </p:cTn>
+                                        <p:tgtEl>
+                                          <p:spTgt spid="4"/>
+                                        </p:tgtEl>
+                                        <p:attrNameLst>
+                                          <p:attrName>style.visibility</p:attrName>
+                                        </p:attrNameLst>
+                                      </p:cBhvr>
+                                      <p:to>
+                                        <p:strVal val="visible"/>
+                                      </p:to>
+                                    </p:set>
+                                    <p:animEffect transition="in" filter="fade">
+                                      <p:cBhvr>
+                                        <p:cTn id="14" dur="500"/>
+                                        <p:tgtEl>
+                                          <p:spTgt spid="4"/>
+                                        </p:tgtEl>
+                                      </p:cBhvr>
+                                    </p:animEffect>
+                                  </p:childTnLst>
+                                </p:cTn>
+                              </p:par>
+                            </p:childTnLst>
+                          </p:cTn>
+                        </p:par>
+                        <p:par>
+                          <p:cTn id="15" fill="hold">
+                            <p:stCondLst>
+                              <p:cond delay="1000"/>
+                            </p:stCondLst>
+                            <p:childTnLst>
+                              <p:par>
+                                <p:cTn id="16" presetID="10" presetClass="entr" presetSubtype="0" fill="hold" grpId="0" nodeType="afterEffect">
+                                  <p:stCondLst>
+                                    <p:cond delay="0"/>
+                                  </p:stCondLst>
+                                  <p:childTnLst>
+                                    <p:set>
+                                      <p:cBhvr>
+                                        <p:cTn id="17" dur="1" fill="hold">
+                                          <p:stCondLst>
+                                            <p:cond delay="0"/>
+                                          </p:stCondLst>
+                                        </p:cTn>
+                                        <p:tgtEl>
+                                          <p:spTgt spid="5"/>
+                                        </p:tgtEl>
+                                        <p:attrNameLst>
+                                          <p:attrName>style.visibility</p:attrName>
+                                        </p:attrNameLst>
+                                      </p:cBhvr>
+                                      <p:to>
+                                        <p:strVal val="visible"/>
+                                      </p:to>
+                                    </p:set>
+                                    <p:animEffect transition="in" filter="fade">
+                                      <p:cBhvr>
+                                        <p:cTn id="18" dur="500"/>
+                                        <p:tgtEl>
+                                          <p:spTgt spid="5"/>
+                                        </p:tgtEl>
+                                      </p:cBhvr>
+                                    </p:animEffect>
+                                  </p:childTnLst>
+                                </p:cTn>
+                              </p:par>
+                              <p:par>
+                                <p:cTn id="19" presetID="10" presetClass="entr" presetSubtype="0" fill="hold" grpId="0" nodeType="withEffect">
+                                  <p:stCondLst>
+                                    <p:cond delay="0"/>
+                                  </p:stCondLst>
+                                  <p:childTnLst>
+                                    <p:set>
+                                      <p:cBhvr>
+                                        <p:cTn id="20" dur="1" fill="hold">
+                                          <p:stCondLst>
+                                            <p:cond delay="0"/>
+                                          </p:stCondLst>
+                                        </p:cTn>
+                                        <p:tgtEl>
+                                          <p:spTgt spid="6"/>
+                                        </p:tgtEl>
+                                        <p:attrNameLst>
+                                          <p:attrName>style.visibility</p:attrName>
+                                        </p:attrNameLst>
+                                      </p:cBhvr>
+                                      <p:to>
+                                        <p:strVal val="visible"/>
+                                      </p:to>
+                                    </p:set>
+                                    <p:animEffect transition="in" filter="fade">
+                                      <p:cBhvr>
+                                        <p:cTn id="21" dur="500"/>
+                                        <p:tgtEl>
+                                          <p:spTgt spid="6"/>
+                                        </p:tgtEl>
+                                      </p:cBhvr>
+                                    </p:animEffect>
+                                  </p:childTnLst>
+                                </p:cTn>
+                              </p:par>
+                              <p:par>
+                                <p:cTn id="22" presetID="10" presetClass="entr" presetSubtype="0" fill="hold" grpId="0" nodeType="withEffect">
+                                  <p:stCondLst>
+                                    <p:cond delay="0"/>
+                                  </p:stCondLst>
+                                  <p:childTnLst>
+                                    <p:set>
+                                      <p:cBhvr>
+                                        <p:cTn id="23" dur="1" fill="hold">
+                                          <p:stCondLst>
+                                            <p:cond delay="0"/>
+                                          </p:stCondLst>
+                                        </p:cTn>
+                                        <p:tgtEl>
+                                          <p:spTgt spid="7"/>
+                                        </p:tgtEl>
+                                        <p:attrNameLst>
+                                          <p:attrName>style.visibility</p:attrName>
+                                        </p:attrNameLst>
+                                      </p:cBhvr>
+                                      <p:to>
+                                        <p:strVal val="visible"/>
+                                      </p:to>
+                                    </p:set>
+                                    <p:animEffect transition="in" filter="fade">
+                                      <p:cBhvr>
+                                        <p:cTn id="24" dur="500"/>
+                                        <p:tgtEl>
+                                          <p:spTgt spid="7"/>
+                                        </p:tgtEl>
+                                      </p:cBhvr>
+                                    </p:animEffect>
+                                  </p:childTnLst>
+                                </p:cTn>
+                              </p:par>
+                            </p:childTnLst>
+                          </p:cTn>
+                        </p:par>
+                        <p:par>
+                          <p:cTn id="25" fill="hold">
+                            <p:stCondLst>
+                              <p:cond delay="1500"/>
+                            </p:stCondLst>
+                            <p:childTnLst>
+                              <p:par>
+                                <p:cTn id="26" presetID="10" presetClass="entr" presetSubtype="0" fill="hold" grpId="0" nodeType="afterEffect">
+                                  <p:stCondLst>
+                                    <p:cond delay="0"/>
+                                  </p:stCondLst>
+                                  <p:childTnLst>
+                                    <p:set>
+                                      <p:cBhvr>
+                                        <p:cTn id="27" dur="1" fill="hold">
+                                          <p:stCondLst>
+                                            <p:cond delay="0"/>
+                                          </p:stCondLst>
+                                        </p:cTn>
+                                        <p:tgtEl>
+                                          <p:spTgt spid="8"/>
+                                        </p:tgtEl>
+                                        <p:attrNameLst>
+                                          <p:attrName>style.visibility</p:attrName>
+                                        </p:attrNameLst>
+                                      </p:cBhvr>
+                                      <p:to>
+                                        <p:strVal val="visible"/>
+                                      </p:to>
+                                    </p:set>
+                                    <p:animEffect transition="in" filter="fade">
+                                      <p:cBhvr>
+                                        <p:cTn id="28" dur="500"/>
+                                        <p:tgtEl>
+                                          <p:spTgt spid="8"/>
+                                        </p:tgtEl>
+                                      </p:cBhvr>
+                                    </p:animEffect>
+                                  </p:childTnLst>
+                                </p:cTn>
+                              </p:par>
+                              <p:par>
+                                <p:cTn id="29" presetID="22" presetClass="entr" presetSubtype="8" fill="hold" grpId="0" nodeType="withEffect">
+                                  <p:stCondLst>
+                                    <p:cond delay="0"/>
+                                  </p:stCondLst>
+                                  <p:childTnLst>
+                                    <p:set>
+                                      <p:cBhvr>
+                                        <p:cTn id="30" dur="1" fill="hold">
+                                          <p:stCondLst>
+                                            <p:cond delay="0"/>
+                                          </p:stCondLst>
+                                        </p:cTn>
+                                        <p:tgtEl>
+                                          <p:spTgt spid="9"/>
+                                        </p:tgtEl>
+                                        <p:attrNameLst>
+                                          <p:attrName>style.visibility</p:attrName>
+                                        </p:attrNameLst>
+                                      </p:cBhvr>
+                                      <p:to>
+                                        <p:strVal val="visible"/>
+                                      </p:to>
+                                    </p:set>
+                                    <p:animEffect transition="in" filter="wipe(right)">
+                                      <p:cBhvr>
+                                        <p:cTn id="31" dur="500"/>
+                                        <p:tgtEl>
+                                          <p:spTgt spid="9"/>
+                                        </p:tgtEl>
+                                      </p:cBhvr>
+                                    </p:animEffect>
+                                  </p:childTnLst>
+                                </p:cTn>
+                              </p:par>
+                            </p:childTnLst>
+                          </p:cTn>
+                        </p:par>
+                      </p:childTnLst>
+                    </p:cTn>
+                  </p:par>
+                </p:childTnLst>
+              </p:cTn>
+              <p:prevCondLst>
+                <p:cond evt="onPrev" delay="0">
+                  <p:tgtEl>
+                    <p:sldTgt/>
+                  </p:tgtEl>
+                </p:cond>
+              </p:prevCondLst>
+              <p:nextCondLst>
+                <p:cond evt="onNext" delay="0">
+                  <p:tgtEl>
+                    <p:sldTgt/>
+                  </p:tgtEl>
+                </p:cond>
+              </p:nextCondLst>
+            </p:seq>
+          </p:childTnLst>
+        </p:cTn>
+      </p:par>
+    </p:tnLst>
+    <p:bldLst>
+      <p:bldP spid="2" grpId="0" animBg="1"/>
+      <p:bldP spid="3" grpId="0" animBg="1"/>
+      <p:bldP spid="4" grpId="0" animBg="1"/>
+      <p:bldP spid="5" grpId="0" animBg="1"/>
+      <p:bldP spid="6" grpId="0" animBg="1"/>
+      <p:bldP spid="7" grpId="0" animBg="1"/>
+      <p:bldP spid="8" grpId="0" animBg="1"/>
+      <p:bldGraphic spid="9" grpId="0">
+        <p:bldAsOne/>
+      </p:bldGraphic>
+    </p:bldLst>
+  </p:timing>
 </p:sld>
 </file>
 
@@ -5308,7 +7164,7 @@
       </p:grpSpPr>
       <p:sp>
         <p:nvSpPr>
-          <p:cNvPr id="2" name="Text 0"/>
+          <p:cNvPr id="2" name="Title"/>
           <p:cNvSpPr txBox="1"/>
           <p:nvPr/>
         </p:nvSpPr>
@@ -5347,7 +7203,7 @@
       </p:sp>
       <p:sp>
         <p:nvSpPr>
-          <p:cNvPr id="3" name="Shape 1"/>
+          <p:cNvPr id="3" name="Title Rule"/>
           <p:cNvSpPr/>
           <p:nvPr/>
         </p:nvSpPr>
@@ -5370,7 +7226,7 @@
       </p:sp>
       <p:sp>
         <p:nvSpPr>
-          <p:cNvPr id="4" name="Text 2"/>
+          <p:cNvPr id="4" name="Subtitle"/>
           <p:cNvSpPr txBox="1"/>
           <p:nvPr/>
         </p:nvSpPr>
@@ -5409,7 +7265,7 @@
       </p:sp>
       <p:sp>
         <p:nvSpPr>
-          <p:cNvPr id="5" name="Shape 3"/>
+          <p:cNvPr id="5" name="Key Figures Box"/>
           <p:cNvSpPr/>
           <p:nvPr/>
         </p:nvSpPr>
@@ -5434,7 +7290,7 @@
       </p:sp>
       <p:sp>
         <p:nvSpPr>
-          <p:cNvPr id="6" name="Text 4"/>
+          <p:cNvPr id="6" name="Key Figures Heading"/>
           <p:cNvSpPr txBox="1"/>
           <p:nvPr/>
         </p:nvSpPr>
@@ -5473,7 +7329,7 @@
       </p:sp>
       <p:sp>
         <p:nvSpPr>
-          <p:cNvPr id="7" name="Text 5"/>
+          <p:cNvPr id="7" name="Key Figures"/>
           <p:cNvSpPr txBox="1"/>
           <p:nvPr/>
         </p:nvSpPr>
@@ -5655,7 +7511,7 @@
       </p:sp>
       <p:sp>
         <p:nvSpPr>
-          <p:cNvPr id="8" name="Text 6"/>
+          <p:cNvPr id="8" name="Chart Heading"/>
           <p:cNvSpPr txBox="1"/>
           <p:nvPr/>
         </p:nvSpPr>
@@ -5694,7 +7550,7 @@
       </p:sp>
       <p:graphicFrame>
         <p:nvGraphicFramePr>
-          <p:cNvPr id="9" name="Chart 0" descr=""/>
+          <p:cNvPr id="9" name="Budget Chart" descr=""/>
           <p:cNvGraphicFramePr/>
           <p:nvPr/>
         </p:nvGraphicFramePr>
@@ -5714,8 +7570,378 @@
     <a:masterClrMapping/>
   </p:clrMapOvr>
   <p:transition spd="med">
-    <p:fade/>
+    <p:push dir="u"/>
   </p:transition>
+  <p:timing>
+    <p:tnLst>
+      <p:par>
+        <p:cTn id="1" dur="indefinite" restart="never" nodeType="tmRoot">
+          <p:childTnLst>
+            <p:seq concurrent="1" nextAc="seek">
+              <p:cTn id="2" dur="indefinite" nodeType="mainSeq">
+                <p:childTnLst>
+                  <p:par>
+                    <p:cTn id="3" fill="hold">
+                      <p:stCondLst>
+                        <p:cond delay="indefinite"/>
+                        <p:cond evt="onBegin" delay="0">
+                          <p:tn val="2"/>
+                        </p:cond>
+                      </p:stCondLst>
+                      <p:childTnLst>
+                        <p:par>
+                          <p:cTn id="4" fill="hold">
+                            <p:stCondLst>
+                              <p:cond delay="0"/>
+                            </p:stCondLst>
+                            <p:childTnLst>
+                              <p:par>
+                                <p:cTn id="5" presetID="10" presetClass="entr" presetSubtype="0" fill="hold" grpId="0" nodeType="afterEffect">
+                                  <p:stCondLst>
+                                    <p:cond delay="0"/>
+                                  </p:stCondLst>
+                                  <p:childTnLst>
+                                    <p:set>
+                                      <p:cBhvr>
+                                        <p:cTn id="6" dur="1" fill="hold">
+                                          <p:stCondLst>
+                                            <p:cond delay="0"/>
+                                          </p:stCondLst>
+                                        </p:cTn>
+                                        <p:tgtEl>
+                                          <p:spTgt spid="2"/>
+                                        </p:tgtEl>
+                                        <p:attrNameLst>
+                                          <p:attrName>style.visibility</p:attrName>
+                                        </p:attrNameLst>
+                                      </p:cBhvr>
+                                      <p:to>
+                                        <p:strVal val="visible"/>
+                                      </p:to>
+                                    </p:set>
+                                    <p:animEffect transition="in" filter="fade">
+                                      <p:cBhvr>
+                                        <p:cTn id="7" dur="500"/>
+                                        <p:tgtEl>
+                                          <p:spTgt spid="2"/>
+                                        </p:tgtEl>
+                                      </p:cBhvr>
+                                    </p:animEffect>
+                                  </p:childTnLst>
+                                </p:cTn>
+                              </p:par>
+                              <p:par>
+                                <p:cTn id="8" presetID="22" presetClass="entr" presetSubtype="8" fill="hold" grpId="0" nodeType="withEffect">
+                                  <p:stCondLst>
+                                    <p:cond delay="0"/>
+                                  </p:stCondLst>
+                                  <p:childTnLst>
+                                    <p:set>
+                                      <p:cBhvr>
+                                        <p:cTn id="9" dur="1" fill="hold">
+                                          <p:stCondLst>
+                                            <p:cond delay="0"/>
+                                          </p:stCondLst>
+                                        </p:cTn>
+                                        <p:tgtEl>
+                                          <p:spTgt spid="3"/>
+                                        </p:tgtEl>
+                                        <p:attrNameLst>
+                                          <p:attrName>style.visibility</p:attrName>
+                                        </p:attrNameLst>
+                                      </p:cBhvr>
+                                      <p:to>
+                                        <p:strVal val="visible"/>
+                                      </p:to>
+                                    </p:set>
+                                    <p:animEffect transition="in" filter="wipe(right)">
+                                      <p:cBhvr>
+                                        <p:cTn id="10" dur="500"/>
+                                        <p:tgtEl>
+                                          <p:spTgt spid="3"/>
+                                        </p:tgtEl>
+                                      </p:cBhvr>
+                                    </p:animEffect>
+                                  </p:childTnLst>
+                                </p:cTn>
+                              </p:par>
+                            </p:childTnLst>
+                          </p:cTn>
+                        </p:par>
+                        <p:par>
+                          <p:cTn id="11" fill="hold">
+                            <p:stCondLst>
+                              <p:cond delay="500"/>
+                            </p:stCondLst>
+                            <p:childTnLst>
+                              <p:par>
+                                <p:cTn id="12" presetID="10" presetClass="entr" presetSubtype="0" fill="hold" grpId="0" nodeType="afterEffect">
+                                  <p:stCondLst>
+                                    <p:cond delay="0"/>
+                                  </p:stCondLst>
+                                  <p:childTnLst>
+                                    <p:set>
+                                      <p:cBhvr>
+                                        <p:cTn id="13" dur="1" fill="hold">
+                                          <p:stCondLst>
+                                            <p:cond delay="0"/>
+                                          </p:stCondLst>
+                                        </p:cTn>
+                                        <p:tgtEl>
+                                          <p:spTgt spid="4"/>
+                                        </p:tgtEl>
+                                        <p:attrNameLst>
+                                          <p:attrName>style.visibility</p:attrName>
+                                        </p:attrNameLst>
+                                      </p:cBhvr>
+                                      <p:to>
+                                        <p:strVal val="visible"/>
+                                      </p:to>
+                                    </p:set>
+                                    <p:animEffect transition="in" filter="fade">
+                                      <p:cBhvr>
+                                        <p:cTn id="14" dur="500"/>
+                                        <p:tgtEl>
+                                          <p:spTgt spid="4"/>
+                                        </p:tgtEl>
+                                      </p:cBhvr>
+                                    </p:animEffect>
+                                  </p:childTnLst>
+                                </p:cTn>
+                              </p:par>
+                            </p:childTnLst>
+                          </p:cTn>
+                        </p:par>
+                        <p:par>
+                          <p:cTn id="15" fill="hold">
+                            <p:stCondLst>
+                              <p:cond delay="1000"/>
+                            </p:stCondLst>
+                            <p:childTnLst>
+                              <p:par>
+                                <p:cTn id="16" presetID="10" presetClass="entr" presetSubtype="0" fill="hold" grpId="0" nodeType="afterEffect">
+                                  <p:stCondLst>
+                                    <p:cond delay="0"/>
+                                  </p:stCondLst>
+                                  <p:childTnLst>
+                                    <p:set>
+                                      <p:cBhvr>
+                                        <p:cTn id="17" dur="1" fill="hold">
+                                          <p:stCondLst>
+                                            <p:cond delay="0"/>
+                                          </p:stCondLst>
+                                        </p:cTn>
+                                        <p:tgtEl>
+                                          <p:spTgt spid="5"/>
+                                        </p:tgtEl>
+                                        <p:attrNameLst>
+                                          <p:attrName>style.visibility</p:attrName>
+                                        </p:attrNameLst>
+                                      </p:cBhvr>
+                                      <p:to>
+                                        <p:strVal val="visible"/>
+                                      </p:to>
+                                    </p:set>
+                                    <p:animEffect transition="in" filter="fade">
+                                      <p:cBhvr>
+                                        <p:cTn id="18" dur="500"/>
+                                        <p:tgtEl>
+                                          <p:spTgt spid="5"/>
+                                        </p:tgtEl>
+                                      </p:cBhvr>
+                                    </p:animEffect>
+                                  </p:childTnLst>
+                                </p:cTn>
+                              </p:par>
+                              <p:par>
+                                <p:cTn id="19" presetID="10" presetClass="entr" presetSubtype="0" fill="hold" grpId="0" nodeType="withEffect">
+                                  <p:stCondLst>
+                                    <p:cond delay="0"/>
+                                  </p:stCondLst>
+                                  <p:childTnLst>
+                                    <p:set>
+                                      <p:cBhvr>
+                                        <p:cTn id="20" dur="1" fill="hold">
+                                          <p:stCondLst>
+                                            <p:cond delay="0"/>
+                                          </p:stCondLst>
+                                        </p:cTn>
+                                        <p:tgtEl>
+                                          <p:spTgt spid="6"/>
+                                        </p:tgtEl>
+                                        <p:attrNameLst>
+                                          <p:attrName>style.visibility</p:attrName>
+                                        </p:attrNameLst>
+                                      </p:cBhvr>
+                                      <p:to>
+                                        <p:strVal val="visible"/>
+                                      </p:to>
+                                    </p:set>
+                                    <p:animEffect transition="in" filter="fade">
+                                      <p:cBhvr>
+                                        <p:cTn id="21" dur="500"/>
+                                        <p:tgtEl>
+                                          <p:spTgt spid="6"/>
+                                        </p:tgtEl>
+                                      </p:cBhvr>
+                                    </p:animEffect>
+                                  </p:childTnLst>
+                                </p:cTn>
+                              </p:par>
+                              <p:par>
+                                <p:cTn id="22" presetID="10" presetClass="entr" presetSubtype="0" fill="hold" grpId="0" nodeType="withEffect">
+                                  <p:stCondLst>
+                                    <p:cond delay="0"/>
+                                  </p:stCondLst>
+                                  <p:childTnLst>
+                                    <p:set>
+                                      <p:cBhvr>
+                                        <p:cTn id="23" dur="1" fill="hold">
+                                          <p:stCondLst>
+                                            <p:cond delay="0"/>
+                                          </p:stCondLst>
+                                        </p:cTn>
+                                        <p:tgtEl>
+                                          <p:spTgt spid="7"/>
+                                        </p:tgtEl>
+                                        <p:attrNameLst>
+                                          <p:attrName>style.visibility</p:attrName>
+                                        </p:attrNameLst>
+                                      </p:cBhvr>
+                                      <p:to>
+                                        <p:strVal val="visible"/>
+                                      </p:to>
+                                    </p:set>
+                                    <p:animEffect transition="in" filter="fade">
+                                      <p:cBhvr>
+                                        <p:cTn id="24" dur="500"/>
+                                        <p:tgtEl>
+                                          <p:spTgt spid="7"/>
+                                        </p:tgtEl>
+                                      </p:cBhvr>
+                                    </p:animEffect>
+                                  </p:childTnLst>
+                                </p:cTn>
+                              </p:par>
+                            </p:childTnLst>
+                          </p:cTn>
+                        </p:par>
+                        <p:par>
+                          <p:cTn id="25" fill="hold">
+                            <p:stCondLst>
+                              <p:cond delay="1500"/>
+                            </p:stCondLst>
+                            <p:childTnLst>
+                              <p:par>
+                                <p:cTn id="26" presetID="10" presetClass="entr" presetSubtype="0" fill="hold" grpId="0" nodeType="afterEffect">
+                                  <p:stCondLst>
+                                    <p:cond delay="0"/>
+                                  </p:stCondLst>
+                                  <p:childTnLst>
+                                    <p:set>
+                                      <p:cBhvr>
+                                        <p:cTn id="27" dur="1" fill="hold">
+                                          <p:stCondLst>
+                                            <p:cond delay="0"/>
+                                          </p:stCondLst>
+                                        </p:cTn>
+                                        <p:tgtEl>
+                                          <p:spTgt spid="8"/>
+                                        </p:tgtEl>
+                                        <p:attrNameLst>
+                                          <p:attrName>style.visibility</p:attrName>
+                                        </p:attrNameLst>
+                                      </p:cBhvr>
+                                      <p:to>
+                                        <p:strVal val="visible"/>
+                                      </p:to>
+                                    </p:set>
+                                    <p:animEffect transition="in" filter="fade">
+                                      <p:cBhvr>
+                                        <p:cTn id="28" dur="500"/>
+                                        <p:tgtEl>
+                                          <p:spTgt spid="8"/>
+                                        </p:tgtEl>
+                                      </p:cBhvr>
+                                    </p:animEffect>
+                                  </p:childTnLst>
+                                </p:cTn>
+                              </p:par>
+                              <p:par>
+                                <p:cTn id="29" presetID="22" presetClass="entr" presetSubtype="8" fill="hold" grpId="0" nodeType="withEffect">
+                                  <p:stCondLst>
+                                    <p:cond delay="0"/>
+                                  </p:stCondLst>
+                                  <p:childTnLst>
+                                    <p:set>
+                                      <p:cBhvr>
+                                        <p:cTn id="30" dur="1" fill="hold">
+                                          <p:stCondLst>
+                                            <p:cond delay="0"/>
+                                          </p:stCondLst>
+                                        </p:cTn>
+                                        <p:tgtEl>
+                                          <p:spTgt spid="9"/>
+                                        </p:tgtEl>
+                                        <p:attrNameLst>
+                                          <p:attrName>style.visibility</p:attrName>
+                                        </p:attrNameLst>
+                                      </p:cBhvr>
+                                      <p:to>
+                                        <p:strVal val="visible"/>
+                                      </p:to>
+                                    </p:set>
+                                    <p:animEffect transition="in" filter="wipe(right)">
+                                      <p:cBhvr>
+                                        <p:cTn id="31" dur="500"/>
+                                        <p:tgtEl>
+                                          <p:spTgt spid="9"/>
+                                        </p:tgtEl>
+                                      </p:cBhvr>
+                                    </p:animEffect>
+                                  </p:childTnLst>
+                                </p:cTn>
+                              </p:par>
+                            </p:childTnLst>
+                          </p:cTn>
+                        </p:par>
+                      </p:childTnLst>
+                    </p:cTn>
+                  </p:par>
+                </p:childTnLst>
+              </p:cTn>
+              <p:prevCondLst>
+                <p:cond evt="onPrev" delay="0">
+                  <p:tgtEl>
+                    <p:sldTgt/>
+                  </p:tgtEl>
+                </p:cond>
+              </p:prevCondLst>
+              <p:nextCondLst>
+                <p:cond evt="onNext" delay="0">
+                  <p:tgtEl>
+                    <p:sldTgt/>
+                  </p:tgtEl>
+                </p:cond>
+              </p:nextCondLst>
+            </p:seq>
+          </p:childTnLst>
+        </p:cTn>
+      </p:par>
+    </p:tnLst>
+    <p:bldLst>
+      <p:bldP spid="2" grpId="0" animBg="1"/>
+      <p:bldP spid="3" grpId="0" animBg="1"/>
+      <p:bldP spid="4" grpId="0" animBg="1"/>
+      <p:bldP spid="5" grpId="0" animBg="1"/>
+      <p:bldP spid="6" grpId="0" animBg="1"/>
+      <p:bldP spid="7" grpId="0" animBg="1"/>
+      <p:bldP spid="8" grpId="0" animBg="1"/>
+      <p:bldGraphic spid="9" grpId="0">
+        <p:bldAsOne/>
+      </p:bldGraphic>
+    </p:bldLst>
+  </p:timing>
 </p:sld>
 </file>
 
@@ -5738,7 +7964,7 @@
       </p:grpSpPr>
       <p:sp>
         <p:nvSpPr>
-          <p:cNvPr id="2" name="Text 0"/>
+          <p:cNvPr id="2" name="Title"/>
           <p:cNvSpPr txBox="1"/>
           <p:nvPr/>
         </p:nvSpPr>
@@ -5777,7 +8003,7 @@
       </p:sp>
       <p:sp>
         <p:nvSpPr>
-          <p:cNvPr id="3" name="Shape 1"/>
+          <p:cNvPr id="3" name="Title Rule"/>
           <p:cNvSpPr/>
           <p:nvPr/>
         </p:nvSpPr>
@@ -5800,7 +8026,7 @@
       </p:sp>
       <p:sp>
         <p:nvSpPr>
-          <p:cNvPr id="4" name="Text 2"/>
+          <p:cNvPr id="4" name="Subtitle"/>
           <p:cNvSpPr txBox="1"/>
           <p:nvPr/>
         </p:nvSpPr>
@@ -5839,7 +8065,7 @@
       </p:sp>
       <p:sp>
         <p:nvSpPr>
-          <p:cNvPr id="5" name="Shape 3"/>
+          <p:cNvPr id="5" name="Key Figures Box"/>
           <p:cNvSpPr/>
           <p:nvPr/>
         </p:nvSpPr>
@@ -5864,7 +8090,7 @@
       </p:sp>
       <p:sp>
         <p:nvSpPr>
-          <p:cNvPr id="6" name="Text 4"/>
+          <p:cNvPr id="6" name="Key Figures Heading"/>
           <p:cNvSpPr txBox="1"/>
           <p:nvPr/>
         </p:nvSpPr>
@@ -5903,7 +8129,7 @@
       </p:sp>
       <p:sp>
         <p:nvSpPr>
-          <p:cNvPr id="7" name="Text 5"/>
+          <p:cNvPr id="7" name="Key Figures"/>
           <p:cNvSpPr txBox="1"/>
           <p:nvPr/>
         </p:nvSpPr>
@@ -6085,7 +8311,7 @@
       </p:sp>
       <p:sp>
         <p:nvSpPr>
-          <p:cNvPr id="8" name="Text 6"/>
+          <p:cNvPr id="8" name="Chart Heading"/>
           <p:cNvSpPr txBox="1"/>
           <p:nvPr/>
         </p:nvSpPr>
@@ -6124,7 +8350,7 @@
       </p:sp>
       <p:graphicFrame>
         <p:nvGraphicFramePr>
-          <p:cNvPr id="9" name="Chart 0" descr=""/>
+          <p:cNvPr id="9" name="Budget Chart" descr=""/>
           <p:cNvGraphicFramePr/>
           <p:nvPr/>
         </p:nvGraphicFramePr>
@@ -6144,8 +8370,378 @@
     <a:masterClrMapping/>
   </p:clrMapOvr>
   <p:transition spd="med">
-    <p:fade/>
+    <p:push dir="u"/>
   </p:transition>
+  <p:timing>
+    <p:tnLst>
+      <p:par>
+        <p:cTn id="1" dur="indefinite" restart="never" nodeType="tmRoot">
+          <p:childTnLst>
+            <p:seq concurrent="1" nextAc="seek">
+              <p:cTn id="2" dur="indefinite" nodeType="mainSeq">
+                <p:childTnLst>
+                  <p:par>
+                    <p:cTn id="3" fill="hold">
+                      <p:stCondLst>
+                        <p:cond delay="indefinite"/>
+                        <p:cond evt="onBegin" delay="0">
+                          <p:tn val="2"/>
+                        </p:cond>
+                      </p:stCondLst>
+                      <p:childTnLst>
+                        <p:par>
+                          <p:cTn id="4" fill="hold">
+                            <p:stCondLst>
+                              <p:cond delay="0"/>
+                            </p:stCondLst>
+                            <p:childTnLst>
+                              <p:par>
+                                <p:cTn id="5" presetID="10" presetClass="entr" presetSubtype="0" fill="hold" grpId="0" nodeType="afterEffect">
+                                  <p:stCondLst>
+                                    <p:cond delay="0"/>
+                                  </p:stCondLst>
+                                  <p:childTnLst>
+                                    <p:set>
+                                      <p:cBhvr>
+                                        <p:cTn id="6" dur="1" fill="hold">
+                                          <p:stCondLst>
+                                            <p:cond delay="0"/>
+                                          </p:stCondLst>
+                                        </p:cTn>
+                                        <p:tgtEl>
+                                          <p:spTgt spid="2"/>
+                                        </p:tgtEl>
+                                        <p:attrNameLst>
+                                          <p:attrName>style.visibility</p:attrName>
+                                        </p:attrNameLst>
+                                      </p:cBhvr>
+                                      <p:to>
+                                        <p:strVal val="visible"/>
+                                      </p:to>
+                                    </p:set>
+                                    <p:animEffect transition="in" filter="fade">
+                                      <p:cBhvr>
+                                        <p:cTn id="7" dur="500"/>
+                                        <p:tgtEl>
+                                          <p:spTgt spid="2"/>
+                                        </p:tgtEl>
+                                      </p:cBhvr>
+                                    </p:animEffect>
+                                  </p:childTnLst>
+                                </p:cTn>
+                              </p:par>
+                              <p:par>
+                                <p:cTn id="8" presetID="22" presetClass="entr" presetSubtype="8" fill="hold" grpId="0" nodeType="withEffect">
+                                  <p:stCondLst>
+                                    <p:cond delay="0"/>
+                                  </p:stCondLst>
+                                  <p:childTnLst>
+                                    <p:set>
+                                      <p:cBhvr>
+                                        <p:cTn id="9" dur="1" fill="hold">
+                                          <p:stCondLst>
+                                            <p:cond delay="0"/>
+                                          </p:stCondLst>
+                                        </p:cTn>
+                                        <p:tgtEl>
+                                          <p:spTgt spid="3"/>
+                                        </p:tgtEl>
+                                        <p:attrNameLst>
+                                          <p:attrName>style.visibility</p:attrName>
+                                        </p:attrNameLst>
+                                      </p:cBhvr>
+                                      <p:to>
+                                        <p:strVal val="visible"/>
+                                      </p:to>
+                                    </p:set>
+                                    <p:animEffect transition="in" filter="wipe(right)">
+                                      <p:cBhvr>
+                                        <p:cTn id="10" dur="500"/>
+                                        <p:tgtEl>
+                                          <p:spTgt spid="3"/>
+                                        </p:tgtEl>
+                                      </p:cBhvr>
+                                    </p:animEffect>
+                                  </p:childTnLst>
+                                </p:cTn>
+                              </p:par>
+                            </p:childTnLst>
+                          </p:cTn>
+                        </p:par>
+                        <p:par>
+                          <p:cTn id="11" fill="hold">
+                            <p:stCondLst>
+                              <p:cond delay="500"/>
+                            </p:stCondLst>
+                            <p:childTnLst>
+                              <p:par>
+                                <p:cTn id="12" presetID="10" presetClass="entr" presetSubtype="0" fill="hold" grpId="0" nodeType="afterEffect">
+                                  <p:stCondLst>
+                                    <p:cond delay="0"/>
+                                  </p:stCondLst>
+                                  <p:childTnLst>
+                                    <p:set>
+                                      <p:cBhvr>
+                                        <p:cTn id="13" dur="1" fill="hold">
+                                          <p:stCondLst>
+                                            <p:cond delay="0"/>
+                                          </p:stCondLst>
+                                        </p:cTn>
+                                        <p:tgtEl>
+                                          <p:spTgt spid="4"/>
+                                        </p:tgtEl>
+                                        <p:attrNameLst>
+                                          <p:attrName>style.visibility</p:attrName>
+                                        </p:attrNameLst>
+                                      </p:cBhvr>
+                                      <p:to>
+                                        <p:strVal val="visible"/>
+                                      </p:to>
+                                    </p:set>
+                                    <p:animEffect transition="in" filter="fade">
+                                      <p:cBhvr>
+                                        <p:cTn id="14" dur="500"/>
+                                        <p:tgtEl>
+                                          <p:spTgt spid="4"/>
+                                        </p:tgtEl>
+                                      </p:cBhvr>
+                                    </p:animEffect>
+                                  </p:childTnLst>
+                                </p:cTn>
+                              </p:par>
+                            </p:childTnLst>
+                          </p:cTn>
+                        </p:par>
+                        <p:par>
+                          <p:cTn id="15" fill="hold">
+                            <p:stCondLst>
+                              <p:cond delay="1000"/>
+                            </p:stCondLst>
+                            <p:childTnLst>
+                              <p:par>
+                                <p:cTn id="16" presetID="10" presetClass="entr" presetSubtype="0" fill="hold" grpId="0" nodeType="afterEffect">
+                                  <p:stCondLst>
+                                    <p:cond delay="0"/>
+                                  </p:stCondLst>
+                                  <p:childTnLst>
+                                    <p:set>
+                                      <p:cBhvr>
+                                        <p:cTn id="17" dur="1" fill="hold">
+                                          <p:stCondLst>
+                                            <p:cond delay="0"/>
+                                          </p:stCondLst>
+                                        </p:cTn>
+                                        <p:tgtEl>
+                                          <p:spTgt spid="5"/>
+                                        </p:tgtEl>
+                                        <p:attrNameLst>
+                                          <p:attrName>style.visibility</p:attrName>
+                                        </p:attrNameLst>
+                                      </p:cBhvr>
+                                      <p:to>
+                                        <p:strVal val="visible"/>
+                                      </p:to>
+                                    </p:set>
+                                    <p:animEffect transition="in" filter="fade">
+                                      <p:cBhvr>
+                                        <p:cTn id="18" dur="500"/>
+                                        <p:tgtEl>
+                                          <p:spTgt spid="5"/>
+                                        </p:tgtEl>
+                                      </p:cBhvr>
+                                    </p:animEffect>
+                                  </p:childTnLst>
+                                </p:cTn>
+                              </p:par>
+                              <p:par>
+                                <p:cTn id="19" presetID="10" presetClass="entr" presetSubtype="0" fill="hold" grpId="0" nodeType="withEffect">
+                                  <p:stCondLst>
+                                    <p:cond delay="0"/>
+                                  </p:stCondLst>
+                                  <p:childTnLst>
+                                    <p:set>
+                                      <p:cBhvr>
+                                        <p:cTn id="20" dur="1" fill="hold">
+                                          <p:stCondLst>
+                                            <p:cond delay="0"/>
+                                          </p:stCondLst>
+                                        </p:cTn>
+                                        <p:tgtEl>
+                                          <p:spTgt spid="6"/>
+                                        </p:tgtEl>
+                                        <p:attrNameLst>
+                                          <p:attrName>style.visibility</p:attrName>
+                                        </p:attrNameLst>
+                                      </p:cBhvr>
+                                      <p:to>
+                                        <p:strVal val="visible"/>
+                                      </p:to>
+                                    </p:set>
+                                    <p:animEffect transition="in" filter="fade">
+                                      <p:cBhvr>
+                                        <p:cTn id="21" dur="500"/>
+                                        <p:tgtEl>
+                                          <p:spTgt spid="6"/>
+                                        </p:tgtEl>
+                                      </p:cBhvr>
+                                    </p:animEffect>
+                                  </p:childTnLst>
+                                </p:cTn>
+                              </p:par>
+                              <p:par>
+                                <p:cTn id="22" presetID="10" presetClass="entr" presetSubtype="0" fill="hold" grpId="0" nodeType="withEffect">
+                                  <p:stCondLst>
+                                    <p:cond delay="0"/>
+                                  </p:stCondLst>
+                                  <p:childTnLst>
+                                    <p:set>
+                                      <p:cBhvr>
+                                        <p:cTn id="23" dur="1" fill="hold">
+                                          <p:stCondLst>
+                                            <p:cond delay="0"/>
+                                          </p:stCondLst>
+                                        </p:cTn>
+                                        <p:tgtEl>
+                                          <p:spTgt spid="7"/>
+                                        </p:tgtEl>
+                                        <p:attrNameLst>
+                                          <p:attrName>style.visibility</p:attrName>
+                                        </p:attrNameLst>
+                                      </p:cBhvr>
+                                      <p:to>
+                                        <p:strVal val="visible"/>
+                                      </p:to>
+                                    </p:set>
+                                    <p:animEffect transition="in" filter="fade">
+                                      <p:cBhvr>
+                                        <p:cTn id="24" dur="500"/>
+                                        <p:tgtEl>
+                                          <p:spTgt spid="7"/>
+                                        </p:tgtEl>
+                                      </p:cBhvr>
+                                    </p:animEffect>
+                                  </p:childTnLst>
+                                </p:cTn>
+                              </p:par>
+                            </p:childTnLst>
+                          </p:cTn>
+                        </p:par>
+                        <p:par>
+                          <p:cTn id="25" fill="hold">
+                            <p:stCondLst>
+                              <p:cond delay="1500"/>
+                            </p:stCondLst>
+                            <p:childTnLst>
+                              <p:par>
+                                <p:cTn id="26" presetID="10" presetClass="entr" presetSubtype="0" fill="hold" grpId="0" nodeType="afterEffect">
+                                  <p:stCondLst>
+                                    <p:cond delay="0"/>
+                                  </p:stCondLst>
+                                  <p:childTnLst>
+                                    <p:set>
+                                      <p:cBhvr>
+                                        <p:cTn id="27" dur="1" fill="hold">
+                                          <p:stCondLst>
+                                            <p:cond delay="0"/>
+                                          </p:stCondLst>
+                                        </p:cTn>
+                                        <p:tgtEl>
+                                          <p:spTgt spid="8"/>
+                                        </p:tgtEl>
+                                        <p:attrNameLst>
+                                          <p:attrName>style.visibility</p:attrName>
+                                        </p:attrNameLst>
+                                      </p:cBhvr>
+                                      <p:to>
+                                        <p:strVal val="visible"/>
+                                      </p:to>
+                                    </p:set>
+                                    <p:animEffect transition="in" filter="fade">
+                                      <p:cBhvr>
+                                        <p:cTn id="28" dur="500"/>
+                                        <p:tgtEl>
+                                          <p:spTgt spid="8"/>
+                                        </p:tgtEl>
+                                      </p:cBhvr>
+                                    </p:animEffect>
+                                  </p:childTnLst>
+                                </p:cTn>
+                              </p:par>
+                              <p:par>
+                                <p:cTn id="29" presetID="22" presetClass="entr" presetSubtype="8" fill="hold" grpId="0" nodeType="withEffect">
+                                  <p:stCondLst>
+                                    <p:cond delay="0"/>
+                                  </p:stCondLst>
+                                  <p:childTnLst>
+                                    <p:set>
+                                      <p:cBhvr>
+                                        <p:cTn id="30" dur="1" fill="hold">
+                                          <p:stCondLst>
+                                            <p:cond delay="0"/>
+                                          </p:stCondLst>
+                                        </p:cTn>
+                                        <p:tgtEl>
+                                          <p:spTgt spid="9"/>
+                                        </p:tgtEl>
+                                        <p:attrNameLst>
+                                          <p:attrName>style.visibility</p:attrName>
+                                        </p:attrNameLst>
+                                      </p:cBhvr>
+                                      <p:to>
+                                        <p:strVal val="visible"/>
+                                      </p:to>
+                                    </p:set>
+                                    <p:animEffect transition="in" filter="wipe(right)">
+                                      <p:cBhvr>
+                                        <p:cTn id="31" dur="500"/>
+                                        <p:tgtEl>
+                                          <p:spTgt spid="9"/>
+                                        </p:tgtEl>
+                                      </p:cBhvr>
+                                    </p:animEffect>
+                                  </p:childTnLst>
+                                </p:cTn>
+                              </p:par>
+                            </p:childTnLst>
+                          </p:cTn>
+                        </p:par>
+                      </p:childTnLst>
+                    </p:cTn>
+                  </p:par>
+                </p:childTnLst>
+              </p:cTn>
+              <p:prevCondLst>
+                <p:cond evt="onPrev" delay="0">
+                  <p:tgtEl>
+                    <p:sldTgt/>
+                  </p:tgtEl>
+                </p:cond>
+              </p:prevCondLst>
+              <p:nextCondLst>
+                <p:cond evt="onNext" delay="0">
+                  <p:tgtEl>
+                    <p:sldTgt/>
+                  </p:tgtEl>
+                </p:cond>
+              </p:nextCondLst>
+            </p:seq>
+          </p:childTnLst>
+        </p:cTn>
+      </p:par>
+    </p:tnLst>
+    <p:bldLst>
+      <p:bldP spid="2" grpId="0" animBg="1"/>
+      <p:bldP spid="3" grpId="0" animBg="1"/>
+      <p:bldP spid="4" grpId="0" animBg="1"/>
+      <p:bldP spid="5" grpId="0" animBg="1"/>
+      <p:bldP spid="6" grpId="0" animBg="1"/>
+      <p:bldP spid="7" grpId="0" animBg="1"/>
+      <p:bldP spid="8" grpId="0" animBg="1"/>
+      <p:bldGraphic spid="9" grpId="0">
+        <p:bldAsOne/>
+      </p:bldGraphic>
+    </p:bldLst>
+  </p:timing>
 </p:sld>
 </file>
 
@@ -6168,7 +8764,7 @@
       </p:grpSpPr>
       <p:sp>
         <p:nvSpPr>
-          <p:cNvPr id="2" name="Text 0"/>
+          <p:cNvPr id="2" name="Title"/>
           <p:cNvSpPr txBox="1"/>
           <p:nvPr/>
         </p:nvSpPr>
@@ -6207,7 +8803,7 @@
       </p:sp>
       <p:sp>
         <p:nvSpPr>
-          <p:cNvPr id="3" name="Shape 1"/>
+          <p:cNvPr id="3" name="Title Rule"/>
           <p:cNvSpPr/>
           <p:nvPr/>
         </p:nvSpPr>
@@ -6230,7 +8826,7 @@
       </p:sp>
       <p:sp>
         <p:nvSpPr>
-          <p:cNvPr id="4" name="Text 2"/>
+          <p:cNvPr id="4" name="Subtitle"/>
           <p:cNvSpPr txBox="1"/>
           <p:nvPr/>
         </p:nvSpPr>
@@ -6311,7 +8907,7 @@
       </p:graphicFrame>
       <p:sp>
         <p:nvSpPr>
-          <p:cNvPr id="6" name="Text 3"/>
+          <p:cNvPr id="6" name="Caption"/>
           <p:cNvSpPr txBox="1"/>
           <p:nvPr/>
         </p:nvSpPr>
@@ -6365,8 +8961,267 @@
     <a:masterClrMapping/>
   </p:clrMapOvr>
   <p:transition spd="med">
-    <p:fade/>
+    <p:push dir="u"/>
   </p:transition>
+  <p:timing>
+    <p:tnLst>
+      <p:par>
+        <p:cTn id="1" dur="indefinite" restart="never" nodeType="tmRoot">
+          <p:childTnLst>
+            <p:seq concurrent="1" nextAc="seek">
+              <p:cTn id="2" dur="indefinite" nodeType="mainSeq">
+                <p:childTnLst>
+                  <p:par>
+                    <p:cTn id="3" fill="hold">
+                      <p:stCondLst>
+                        <p:cond delay="indefinite"/>
+                        <p:cond evt="onBegin" delay="0">
+                          <p:tn val="2"/>
+                        </p:cond>
+                      </p:stCondLst>
+                      <p:childTnLst>
+                        <p:par>
+                          <p:cTn id="4" fill="hold">
+                            <p:stCondLst>
+                              <p:cond delay="0"/>
+                            </p:stCondLst>
+                            <p:childTnLst>
+                              <p:par>
+                                <p:cTn id="5" presetID="10" presetClass="entr" presetSubtype="0" fill="hold" grpId="0" nodeType="afterEffect">
+                                  <p:stCondLst>
+                                    <p:cond delay="0"/>
+                                  </p:stCondLst>
+                                  <p:childTnLst>
+                                    <p:set>
+                                      <p:cBhvr>
+                                        <p:cTn id="6" dur="1" fill="hold">
+                                          <p:stCondLst>
+                                            <p:cond delay="0"/>
+                                          </p:stCondLst>
+                                        </p:cTn>
+                                        <p:tgtEl>
+                                          <p:spTgt spid="2"/>
+                                        </p:tgtEl>
+                                        <p:attrNameLst>
+                                          <p:attrName>style.visibility</p:attrName>
+                                        </p:attrNameLst>
+                                      </p:cBhvr>
+                                      <p:to>
+                                        <p:strVal val="visible"/>
+                                      </p:to>
+                                    </p:set>
+                                    <p:animEffect transition="in" filter="fade">
+                                      <p:cBhvr>
+                                        <p:cTn id="7" dur="500"/>
+                                        <p:tgtEl>
+                                          <p:spTgt spid="2"/>
+                                        </p:tgtEl>
+                                      </p:cBhvr>
+                                    </p:animEffect>
+                                  </p:childTnLst>
+                                </p:cTn>
+                              </p:par>
+                              <p:par>
+                                <p:cTn id="8" presetID="22" presetClass="entr" presetSubtype="8" fill="hold" grpId="0" nodeType="withEffect">
+                                  <p:stCondLst>
+                                    <p:cond delay="0"/>
+                                  </p:stCondLst>
+                                  <p:childTnLst>
+                                    <p:set>
+                                      <p:cBhvr>
+                                        <p:cTn id="9" dur="1" fill="hold">
+                                          <p:stCondLst>
+                                            <p:cond delay="0"/>
+                                          </p:stCondLst>
+                                        </p:cTn>
+                                        <p:tgtEl>
+                                          <p:spTgt spid="3"/>
+                                        </p:tgtEl>
+                                        <p:attrNameLst>
+                                          <p:attrName>style.visibility</p:attrName>
+                                        </p:attrNameLst>
+                                      </p:cBhvr>
+                                      <p:to>
+                                        <p:strVal val="visible"/>
+                                      </p:to>
+                                    </p:set>
+                                    <p:animEffect transition="in" filter="wipe(right)">
+                                      <p:cBhvr>
+                                        <p:cTn id="10" dur="500"/>
+                                        <p:tgtEl>
+                                          <p:spTgt spid="3"/>
+                                        </p:tgtEl>
+                                      </p:cBhvr>
+                                    </p:animEffect>
+                                  </p:childTnLst>
+                                </p:cTn>
+                              </p:par>
+                            </p:childTnLst>
+                          </p:cTn>
+                        </p:par>
+                        <p:par>
+                          <p:cTn id="11" fill="hold">
+                            <p:stCondLst>
+                              <p:cond delay="500"/>
+                            </p:stCondLst>
+                            <p:childTnLst>
+                              <p:par>
+                                <p:cTn id="12" presetID="10" presetClass="entr" presetSubtype="0" fill="hold" grpId="0" nodeType="afterEffect">
+                                  <p:stCondLst>
+                                    <p:cond delay="0"/>
+                                  </p:stCondLst>
+                                  <p:childTnLst>
+                                    <p:set>
+                                      <p:cBhvr>
+                                        <p:cTn id="13" dur="1" fill="hold">
+                                          <p:stCondLst>
+                                            <p:cond delay="0"/>
+                                          </p:stCondLst>
+                                        </p:cTn>
+                                        <p:tgtEl>
+                                          <p:spTgt spid="4"/>
+                                        </p:tgtEl>
+                                        <p:attrNameLst>
+                                          <p:attrName>style.visibility</p:attrName>
+                                        </p:attrNameLst>
+                                      </p:cBhvr>
+                                      <p:to>
+                                        <p:strVal val="visible"/>
+                                      </p:to>
+                                    </p:set>
+                                    <p:animEffect transition="in" filter="fade">
+                                      <p:cBhvr>
+                                        <p:cTn id="14" dur="500"/>
+                                        <p:tgtEl>
+                                          <p:spTgt spid="4"/>
+                                        </p:tgtEl>
+                                      </p:cBhvr>
+                                    </p:animEffect>
+                                  </p:childTnLst>
+                                </p:cTn>
+                              </p:par>
+                            </p:childTnLst>
+                          </p:cTn>
+                        </p:par>
+                        <p:par>
+                          <p:cTn id="15" fill="hold">
+                            <p:stCondLst>
+                              <p:cond delay="1000"/>
+                            </p:stCondLst>
+                            <p:childTnLst>
+                              <p:par>
+                                <p:cTn id="16" presetID="10" presetClass="entr" presetSubtype="0" fill="hold" nodeType="afterEffect">
+                                  <p:stCondLst>
+                                    <p:cond delay="0"/>
+                                  </p:stCondLst>
+                                  <p:childTnLst>
+                                    <p:set>
+                                      <p:cBhvr>
+                                        <p:cTn id="17" dur="1" fill="hold">
+                                          <p:stCondLst>
+                                            <p:cond delay="0"/>
+                                          </p:stCondLst>
+                                        </p:cTn>
+                                        <p:tgtEl>
+                                          <p:spTgt spid="7"/>
+                                        </p:tgtEl>
+                                        <p:attrNameLst>
+                                          <p:attrName>style.visibility</p:attrName>
+                                        </p:attrNameLst>
+                                      </p:cBhvr>
+                                      <p:to>
+                                        <p:strVal val="visible"/>
+                                      </p:to>
+                                    </p:set>
+                                    <p:animEffect transition="in" filter="fade">
+                                      <p:cBhvr>
+                                        <p:cTn id="18" dur="500"/>
+                                        <p:tgtEl>
+                                          <p:spTgt spid="7"/>
+                                        </p:tgtEl>
+                                      </p:cBhvr>
+                                    </p:animEffect>
+                                  </p:childTnLst>
+                                </p:cTn>
+                              </p:par>
+                            </p:childTnLst>
+                          </p:cTn>
+                        </p:par>
+                        <p:par>
+                          <p:cTn id="19" fill="hold">
+                            <p:stCondLst>
+                              <p:cond delay="1500"/>
+                            </p:stCondLst>
+                            <p:childTnLst>
+                              <p:par>
+                                <p:cTn id="20" presetID="10" presetClass="entr" presetSubtype="0" fill="hold" grpId="0" nodeType="afterEffect">
+                                  <p:stCondLst>
+                                    <p:cond delay="0"/>
+                                  </p:stCondLst>
+                                  <p:childTnLst>
+                                    <p:set>
+                                      <p:cBhvr>
+                                        <p:cTn id="21" dur="1" fill="hold">
+                                          <p:stCondLst>
+                                            <p:cond delay="0"/>
+                                          </p:stCondLst>
+                                        </p:cTn>
+                                        <p:tgtEl>
+                                          <p:spTgt spid="6"/>
+                                        </p:tgtEl>
+                                        <p:attrNameLst>
+                                          <p:attrName>style.visibility</p:attrName>
+                                        </p:attrNameLst>
+                                      </p:cBhvr>
+                                      <p:to>
+                                        <p:strVal val="visible"/>
+                                      </p:to>
+                                    </p:set>
+                                    <p:animEffect transition="in" filter="fade">
+                                      <p:cBhvr>
+                                        <p:cTn id="22" dur="500"/>
+                                        <p:tgtEl>
+                                          <p:spTgt spid="6"/>
+                                        </p:tgtEl>
+                                      </p:cBhvr>
+                                    </p:animEffect>
+                                  </p:childTnLst>
+                                </p:cTn>
+                              </p:par>
+                            </p:childTnLst>
+                          </p:cTn>
+                        </p:par>
+                      </p:childTnLst>
+                    </p:cTn>
+                  </p:par>
+                </p:childTnLst>
+              </p:cTn>
+              <p:prevCondLst>
+                <p:cond evt="onPrev" delay="0">
+                  <p:tgtEl>
+                    <p:sldTgt/>
+                  </p:tgtEl>
+                </p:cond>
+              </p:prevCondLst>
+              <p:nextCondLst>
+                <p:cond evt="onNext" delay="0">
+                  <p:tgtEl>
+                    <p:sldTgt/>
+                  </p:tgtEl>
+                </p:cond>
+              </p:nextCondLst>
+            </p:seq>
+          </p:childTnLst>
+        </p:cTn>
+      </p:par>
+    </p:tnLst>
+    <p:bldLst>
+      <p:bldP spid="2" grpId="0" animBg="1"/>
+      <p:bldP spid="3" grpId="0" animBg="1"/>
+      <p:bldP spid="4" grpId="0" animBg="1"/>
+      <p:bldP spid="6" grpId="0" animBg="1"/>
+    </p:bldLst>
+  </p:timing>
 </p:sld>
 </file>
 
@@ -6389,7 +9244,7 @@
       </p:grpSpPr>
       <p:sp>
         <p:nvSpPr>
-          <p:cNvPr id="2" name="Text 0"/>
+          <p:cNvPr id="2" name="Title"/>
           <p:cNvSpPr txBox="1"/>
           <p:nvPr/>
         </p:nvSpPr>
@@ -6428,7 +9283,7 @@
       </p:sp>
       <p:sp>
         <p:nvSpPr>
-          <p:cNvPr id="3" name="Shape 1"/>
+          <p:cNvPr id="3" name="Title Rule"/>
           <p:cNvSpPr/>
           <p:nvPr/>
         </p:nvSpPr>
@@ -6451,7 +9306,7 @@
       </p:sp>
       <p:sp>
         <p:nvSpPr>
-          <p:cNvPr id="4" name="Text 2"/>
+          <p:cNvPr id="4" name="Subtitle"/>
           <p:cNvSpPr txBox="1"/>
           <p:nvPr/>
         </p:nvSpPr>
@@ -6490,7 +9345,7 @@
       </p:sp>
       <p:graphicFrame>
         <p:nvGraphicFramePr>
-          <p:cNvPr id="5" name="Chart 0" descr=""/>
+          <p:cNvPr id="5" name="Comparison Chart" descr=""/>
           <p:cNvGraphicFramePr/>
           <p:nvPr/>
         </p:nvGraphicFramePr>
@@ -6506,7 +9361,7 @@
       </p:graphicFrame>
       <p:sp>
         <p:nvSpPr>
-          <p:cNvPr id="6" name="Shape 3"/>
+          <p:cNvPr id="6" name="Average Box"/>
           <p:cNvSpPr/>
           <p:nvPr/>
         </p:nvSpPr>
@@ -6531,7 +9386,7 @@
       </p:sp>
       <p:sp>
         <p:nvSpPr>
-          <p:cNvPr id="7" name="Shape 4"/>
+          <p:cNvPr id="7" name="Average Key"/>
           <p:cNvSpPr/>
           <p:nvPr/>
         </p:nvSpPr>
@@ -6554,7 +9409,7 @@
       </p:sp>
       <p:sp>
         <p:nvSpPr>
-          <p:cNvPr id="8" name="Text 5"/>
+          <p:cNvPr id="8" name="Average Label"/>
           <p:cNvSpPr txBox="1"/>
           <p:nvPr/>
         </p:nvSpPr>
@@ -6593,7 +9448,7 @@
       </p:sp>
       <p:sp>
         <p:nvSpPr>
-          <p:cNvPr id="9" name="Text 6"/>
+          <p:cNvPr id="9" name="Above and Below"/>
           <p:cNvSpPr txBox="1"/>
           <p:nvPr/>
         </p:nvSpPr>
@@ -6747,8 +9602,378 @@
     <a:masterClrMapping/>
   </p:clrMapOvr>
   <p:transition spd="med">
-    <p:fade/>
+    <p:push dir="u"/>
   </p:transition>
+  <p:timing>
+    <p:tnLst>
+      <p:par>
+        <p:cTn id="1" dur="indefinite" restart="never" nodeType="tmRoot">
+          <p:childTnLst>
+            <p:seq concurrent="1" nextAc="seek">
+              <p:cTn id="2" dur="indefinite" nodeType="mainSeq">
+                <p:childTnLst>
+                  <p:par>
+                    <p:cTn id="3" fill="hold">
+                      <p:stCondLst>
+                        <p:cond delay="indefinite"/>
+                        <p:cond evt="onBegin" delay="0">
+                          <p:tn val="2"/>
+                        </p:cond>
+                      </p:stCondLst>
+                      <p:childTnLst>
+                        <p:par>
+                          <p:cTn id="4" fill="hold">
+                            <p:stCondLst>
+                              <p:cond delay="0"/>
+                            </p:stCondLst>
+                            <p:childTnLst>
+                              <p:par>
+                                <p:cTn id="5" presetID="10" presetClass="entr" presetSubtype="0" fill="hold" grpId="0" nodeType="afterEffect">
+                                  <p:stCondLst>
+                                    <p:cond delay="0"/>
+                                  </p:stCondLst>
+                                  <p:childTnLst>
+                                    <p:set>
+                                      <p:cBhvr>
+                                        <p:cTn id="6" dur="1" fill="hold">
+                                          <p:stCondLst>
+                                            <p:cond delay="0"/>
+                                          </p:stCondLst>
+                                        </p:cTn>
+                                        <p:tgtEl>
+                                          <p:spTgt spid="2"/>
+                                        </p:tgtEl>
+                                        <p:attrNameLst>
+                                          <p:attrName>style.visibility</p:attrName>
+                                        </p:attrNameLst>
+                                      </p:cBhvr>
+                                      <p:to>
+                                        <p:strVal val="visible"/>
+                                      </p:to>
+                                    </p:set>
+                                    <p:animEffect transition="in" filter="fade">
+                                      <p:cBhvr>
+                                        <p:cTn id="7" dur="500"/>
+                                        <p:tgtEl>
+                                          <p:spTgt spid="2"/>
+                                        </p:tgtEl>
+                                      </p:cBhvr>
+                                    </p:animEffect>
+                                  </p:childTnLst>
+                                </p:cTn>
+                              </p:par>
+                              <p:par>
+                                <p:cTn id="8" presetID="22" presetClass="entr" presetSubtype="8" fill="hold" grpId="0" nodeType="withEffect">
+                                  <p:stCondLst>
+                                    <p:cond delay="0"/>
+                                  </p:stCondLst>
+                                  <p:childTnLst>
+                                    <p:set>
+                                      <p:cBhvr>
+                                        <p:cTn id="9" dur="1" fill="hold">
+                                          <p:stCondLst>
+                                            <p:cond delay="0"/>
+                                          </p:stCondLst>
+                                        </p:cTn>
+                                        <p:tgtEl>
+                                          <p:spTgt spid="3"/>
+                                        </p:tgtEl>
+                                        <p:attrNameLst>
+                                          <p:attrName>style.visibility</p:attrName>
+                                        </p:attrNameLst>
+                                      </p:cBhvr>
+                                      <p:to>
+                                        <p:strVal val="visible"/>
+                                      </p:to>
+                                    </p:set>
+                                    <p:animEffect transition="in" filter="wipe(right)">
+                                      <p:cBhvr>
+                                        <p:cTn id="10" dur="500"/>
+                                        <p:tgtEl>
+                                          <p:spTgt spid="3"/>
+                                        </p:tgtEl>
+                                      </p:cBhvr>
+                                    </p:animEffect>
+                                  </p:childTnLst>
+                                </p:cTn>
+                              </p:par>
+                            </p:childTnLst>
+                          </p:cTn>
+                        </p:par>
+                        <p:par>
+                          <p:cTn id="11" fill="hold">
+                            <p:stCondLst>
+                              <p:cond delay="500"/>
+                            </p:stCondLst>
+                            <p:childTnLst>
+                              <p:par>
+                                <p:cTn id="12" presetID="10" presetClass="entr" presetSubtype="0" fill="hold" grpId="0" nodeType="afterEffect">
+                                  <p:stCondLst>
+                                    <p:cond delay="0"/>
+                                  </p:stCondLst>
+                                  <p:childTnLst>
+                                    <p:set>
+                                      <p:cBhvr>
+                                        <p:cTn id="13" dur="1" fill="hold">
+                                          <p:stCondLst>
+                                            <p:cond delay="0"/>
+                                          </p:stCondLst>
+                                        </p:cTn>
+                                        <p:tgtEl>
+                                          <p:spTgt spid="4"/>
+                                        </p:tgtEl>
+                                        <p:attrNameLst>
+                                          <p:attrName>style.visibility</p:attrName>
+                                        </p:attrNameLst>
+                                      </p:cBhvr>
+                                      <p:to>
+                                        <p:strVal val="visible"/>
+                                      </p:to>
+                                    </p:set>
+                                    <p:animEffect transition="in" filter="fade">
+                                      <p:cBhvr>
+                                        <p:cTn id="14" dur="500"/>
+                                        <p:tgtEl>
+                                          <p:spTgt spid="4"/>
+                                        </p:tgtEl>
+                                      </p:cBhvr>
+                                    </p:animEffect>
+                                  </p:childTnLst>
+                                </p:cTn>
+                              </p:par>
+                            </p:childTnLst>
+                          </p:cTn>
+                        </p:par>
+                        <p:par>
+                          <p:cTn id="15" fill="hold">
+                            <p:stCondLst>
+                              <p:cond delay="1000"/>
+                            </p:stCondLst>
+                            <p:childTnLst>
+                              <p:par>
+                                <p:cTn id="16" presetID="22" presetClass="entr" presetSubtype="4" fill="hold" grpId="0" nodeType="afterEffect">
+                                  <p:stCondLst>
+                                    <p:cond delay="0"/>
+                                  </p:stCondLst>
+                                  <p:childTnLst>
+                                    <p:set>
+                                      <p:cBhvr>
+                                        <p:cTn id="17" dur="1" fill="hold">
+                                          <p:stCondLst>
+                                            <p:cond delay="0"/>
+                                          </p:stCondLst>
+                                        </p:cTn>
+                                        <p:tgtEl>
+                                          <p:spTgt spid="5"/>
+                                        </p:tgtEl>
+                                        <p:attrNameLst>
+                                          <p:attrName>style.visibility</p:attrName>
+                                        </p:attrNameLst>
+                                      </p:cBhvr>
+                                      <p:to>
+                                        <p:strVal val="visible"/>
+                                      </p:to>
+                                    </p:set>
+                                    <p:animEffect transition="in" filter="wipe(up)">
+                                      <p:cBhvr>
+                                        <p:cTn id="18" dur="500"/>
+                                        <p:tgtEl>
+                                          <p:spTgt spid="5"/>
+                                        </p:tgtEl>
+                                      </p:cBhvr>
+                                    </p:animEffect>
+                                  </p:childTnLst>
+                                </p:cTn>
+                              </p:par>
+                            </p:childTnLst>
+                          </p:cTn>
+                        </p:par>
+                        <p:par>
+                          <p:cTn id="19" fill="hold">
+                            <p:stCondLst>
+                              <p:cond delay="1500"/>
+                            </p:stCondLst>
+                            <p:childTnLst>
+                              <p:par>
+                                <p:cTn id="20" presetID="10" presetClass="entr" presetSubtype="0" fill="hold" grpId="0" nodeType="afterEffect">
+                                  <p:stCondLst>
+                                    <p:cond delay="0"/>
+                                  </p:stCondLst>
+                                  <p:childTnLst>
+                                    <p:set>
+                                      <p:cBhvr>
+                                        <p:cTn id="21" dur="1" fill="hold">
+                                          <p:stCondLst>
+                                            <p:cond delay="0"/>
+                                          </p:stCondLst>
+                                        </p:cTn>
+                                        <p:tgtEl>
+                                          <p:spTgt spid="6"/>
+                                        </p:tgtEl>
+                                        <p:attrNameLst>
+                                          <p:attrName>style.visibility</p:attrName>
+                                        </p:attrNameLst>
+                                      </p:cBhvr>
+                                      <p:to>
+                                        <p:strVal val="visible"/>
+                                      </p:to>
+                                    </p:set>
+                                    <p:animEffect transition="in" filter="fade">
+                                      <p:cBhvr>
+                                        <p:cTn id="22" dur="500"/>
+                                        <p:tgtEl>
+                                          <p:spTgt spid="6"/>
+                                        </p:tgtEl>
+                                      </p:cBhvr>
+                                    </p:animEffect>
+                                  </p:childTnLst>
+                                </p:cTn>
+                              </p:par>
+                              <p:par>
+                                <p:cTn id="23" presetID="10" presetClass="entr" presetSubtype="0" fill="hold" grpId="0" nodeType="withEffect">
+                                  <p:stCondLst>
+                                    <p:cond delay="0"/>
+                                  </p:stCondLst>
+                                  <p:childTnLst>
+                                    <p:set>
+                                      <p:cBhvr>
+                                        <p:cTn id="24" dur="1" fill="hold">
+                                          <p:stCondLst>
+                                            <p:cond delay="0"/>
+                                          </p:stCondLst>
+                                        </p:cTn>
+                                        <p:tgtEl>
+                                          <p:spTgt spid="7"/>
+                                        </p:tgtEl>
+                                        <p:attrNameLst>
+                                          <p:attrName>style.visibility</p:attrName>
+                                        </p:attrNameLst>
+                                      </p:cBhvr>
+                                      <p:to>
+                                        <p:strVal val="visible"/>
+                                      </p:to>
+                                    </p:set>
+                                    <p:animEffect transition="in" filter="fade">
+                                      <p:cBhvr>
+                                        <p:cTn id="25" dur="500"/>
+                                        <p:tgtEl>
+                                          <p:spTgt spid="7"/>
+                                        </p:tgtEl>
+                                      </p:cBhvr>
+                                    </p:animEffect>
+                                  </p:childTnLst>
+                                </p:cTn>
+                              </p:par>
+                              <p:par>
+                                <p:cTn id="26" presetID="10" presetClass="entr" presetSubtype="0" fill="hold" grpId="0" nodeType="withEffect">
+                                  <p:stCondLst>
+                                    <p:cond delay="0"/>
+                                  </p:stCondLst>
+                                  <p:childTnLst>
+                                    <p:set>
+                                      <p:cBhvr>
+                                        <p:cTn id="27" dur="1" fill="hold">
+                                          <p:stCondLst>
+                                            <p:cond delay="0"/>
+                                          </p:stCondLst>
+                                        </p:cTn>
+                                        <p:tgtEl>
+                                          <p:spTgt spid="8"/>
+                                        </p:tgtEl>
+                                        <p:attrNameLst>
+                                          <p:attrName>style.visibility</p:attrName>
+                                        </p:attrNameLst>
+                                      </p:cBhvr>
+                                      <p:to>
+                                        <p:strVal val="visible"/>
+                                      </p:to>
+                                    </p:set>
+                                    <p:animEffect transition="in" filter="fade">
+                                      <p:cBhvr>
+                                        <p:cTn id="28" dur="500"/>
+                                        <p:tgtEl>
+                                          <p:spTgt spid="8"/>
+                                        </p:tgtEl>
+                                      </p:cBhvr>
+                                    </p:animEffect>
+                                  </p:childTnLst>
+                                </p:cTn>
+                              </p:par>
+                              <p:par>
+                                <p:cTn id="29" presetID="10" presetClass="entr" presetSubtype="0" fill="hold" grpId="0" nodeType="withEffect">
+                                  <p:stCondLst>
+                                    <p:cond delay="0"/>
+                                  </p:stCondLst>
+                                  <p:childTnLst>
+                                    <p:set>
+                                      <p:cBhvr>
+                                        <p:cTn id="30" dur="1" fill="hold">
+                                          <p:stCondLst>
+                                            <p:cond delay="0"/>
+                                          </p:stCondLst>
+                                        </p:cTn>
+                                        <p:tgtEl>
+                                          <p:spTgt spid="9"/>
+                                        </p:tgtEl>
+                                        <p:attrNameLst>
+                                          <p:attrName>style.visibility</p:attrName>
+                                        </p:attrNameLst>
+                                      </p:cBhvr>
+                                      <p:to>
+                                        <p:strVal val="visible"/>
+                                      </p:to>
+                                    </p:set>
+                                    <p:animEffect transition="in" filter="fade">
+                                      <p:cBhvr>
+                                        <p:cTn id="31" dur="500"/>
+                                        <p:tgtEl>
+                                          <p:spTgt spid="9"/>
+                                        </p:tgtEl>
+                                      </p:cBhvr>
+                                    </p:animEffect>
+                                  </p:childTnLst>
+                                </p:cTn>
+                              </p:par>
+                            </p:childTnLst>
+                          </p:cTn>
+                        </p:par>
+                      </p:childTnLst>
+                    </p:cTn>
+                  </p:par>
+                </p:childTnLst>
+              </p:cTn>
+              <p:prevCondLst>
+                <p:cond evt="onPrev" delay="0">
+                  <p:tgtEl>
+                    <p:sldTgt/>
+                  </p:tgtEl>
+                </p:cond>
+              </p:prevCondLst>
+              <p:nextCondLst>
+                <p:cond evt="onNext" delay="0">
+                  <p:tgtEl>
+                    <p:sldTgt/>
+                  </p:tgtEl>
+                </p:cond>
+              </p:nextCondLst>
+            </p:seq>
+          </p:childTnLst>
+        </p:cTn>
+      </p:par>
+    </p:tnLst>
+    <p:bldLst>
+      <p:bldP spid="2" grpId="0" animBg="1"/>
+      <p:bldP spid="3" grpId="0" animBg="1"/>
+      <p:bldP spid="4" grpId="0" animBg="1"/>
+      <p:bldGraphic spid="5" grpId="0">
+        <p:bldAsOne/>
+      </p:bldGraphic>
+      <p:bldP spid="6" grpId="0" animBg="1"/>
+      <p:bldP spid="7" grpId="0" animBg="1"/>
+      <p:bldP spid="8" grpId="0" animBg="1"/>
+      <p:bldP spid="9" grpId="0" animBg="1"/>
+    </p:bldLst>
+  </p:timing>
 </p:sld>
 </file>
 
@@ -6771,7 +9996,7 @@
       </p:grpSpPr>
       <p:sp>
         <p:nvSpPr>
-          <p:cNvPr id="2" name="Text 0"/>
+          <p:cNvPr id="2" name="Title"/>
           <p:cNvSpPr txBox="1"/>
           <p:nvPr/>
         </p:nvSpPr>
@@ -6810,7 +10035,7 @@
       </p:sp>
       <p:sp>
         <p:nvSpPr>
-          <p:cNvPr id="3" name="Shape 1"/>
+          <p:cNvPr id="3" name="Title Rule"/>
           <p:cNvSpPr/>
           <p:nvPr/>
         </p:nvSpPr>
@@ -6833,7 +10058,7 @@
       </p:sp>
       <p:sp>
         <p:nvSpPr>
-          <p:cNvPr id="4" name="Shape 2"/>
+          <p:cNvPr id="4" name="Takeaway 1 Box"/>
           <p:cNvSpPr/>
           <p:nvPr/>
         </p:nvSpPr>
@@ -6858,7 +10083,7 @@
       </p:sp>
       <p:sp>
         <p:nvSpPr>
-          <p:cNvPr id="5" name="Text 3"/>
+          <p:cNvPr id="5" name="Takeaway 1 Headline"/>
           <p:cNvSpPr txBox="1"/>
           <p:nvPr/>
         </p:nvSpPr>
@@ -6897,7 +10122,7 @@
       </p:sp>
       <p:sp>
         <p:nvSpPr>
-          <p:cNvPr id="6" name="Shape 4"/>
+          <p:cNvPr id="6" name="Takeaway 1 Rule"/>
           <p:cNvSpPr/>
           <p:nvPr/>
         </p:nvSpPr>
@@ -6920,7 +10145,7 @@
       </p:sp>
       <p:sp>
         <p:nvSpPr>
-          <p:cNvPr id="7" name="Text 5"/>
+          <p:cNvPr id="7" name="Takeaway 1 Text"/>
           <p:cNvSpPr txBox="1"/>
           <p:nvPr/>
         </p:nvSpPr>
@@ -6959,7 +10184,7 @@
       </p:sp>
       <p:sp>
         <p:nvSpPr>
-          <p:cNvPr id="8" name="Shape 6"/>
+          <p:cNvPr id="8" name="Takeaway 2 Box"/>
           <p:cNvSpPr/>
           <p:nvPr/>
         </p:nvSpPr>
@@ -6984,7 +10209,7 @@
       </p:sp>
       <p:sp>
         <p:nvSpPr>
-          <p:cNvPr id="9" name="Text 7"/>
+          <p:cNvPr id="9" name="Takeaway 2 Headline"/>
           <p:cNvSpPr txBox="1"/>
           <p:nvPr/>
         </p:nvSpPr>
@@ -7040,7 +10265,7 @@
       </p:sp>
       <p:sp>
         <p:nvSpPr>
-          <p:cNvPr id="10" name="Shape 8"/>
+          <p:cNvPr id="10" name="Takeaway 2 Rule"/>
           <p:cNvSpPr/>
           <p:nvPr/>
         </p:nvSpPr>
@@ -7063,7 +10288,7 @@
       </p:sp>
       <p:sp>
         <p:nvSpPr>
-          <p:cNvPr id="11" name="Text 9"/>
+          <p:cNvPr id="11" name="Takeaway 2 Text"/>
           <p:cNvSpPr txBox="1"/>
           <p:nvPr/>
         </p:nvSpPr>
@@ -7102,7 +10327,7 @@
       </p:sp>
       <p:sp>
         <p:nvSpPr>
-          <p:cNvPr id="12" name="Shape 10"/>
+          <p:cNvPr id="12" name="Takeaway 3 Box"/>
           <p:cNvSpPr/>
           <p:nvPr/>
         </p:nvSpPr>
@@ -7127,7 +10352,7 @@
       </p:sp>
       <p:sp>
         <p:nvSpPr>
-          <p:cNvPr id="13" name="Text 11"/>
+          <p:cNvPr id="13" name="Takeaway 3 Headline"/>
           <p:cNvSpPr txBox="1"/>
           <p:nvPr/>
         </p:nvSpPr>
@@ -7183,7 +10408,7 @@
       </p:sp>
       <p:sp>
         <p:nvSpPr>
-          <p:cNvPr id="14" name="Shape 12"/>
+          <p:cNvPr id="14" name="Takeaway 3 Rule"/>
           <p:cNvSpPr/>
           <p:nvPr/>
         </p:nvSpPr>
@@ -7206,7 +10431,7 @@
       </p:sp>
       <p:sp>
         <p:nvSpPr>
-          <p:cNvPr id="15" name="Text 13"/>
+          <p:cNvPr id="15" name="Takeaway 3 Text"/>
           <p:cNvSpPr txBox="1"/>
           <p:nvPr/>
         </p:nvSpPr>
@@ -7245,7 +10470,7 @@
       </p:sp>
       <p:sp>
         <p:nvSpPr>
-          <p:cNvPr id="16" name="Shape 14"/>
+          <p:cNvPr id="16" name="Takeaway 4 Box"/>
           <p:cNvSpPr/>
           <p:nvPr/>
         </p:nvSpPr>
@@ -7270,7 +10495,7 @@
       </p:sp>
       <p:sp>
         <p:nvSpPr>
-          <p:cNvPr id="17" name="Text 15"/>
+          <p:cNvPr id="17" name="Takeaway 4 Headline"/>
           <p:cNvSpPr txBox="1"/>
           <p:nvPr/>
         </p:nvSpPr>
@@ -7326,7 +10551,7 @@
       </p:sp>
       <p:sp>
         <p:nvSpPr>
-          <p:cNvPr id="18" name="Shape 16"/>
+          <p:cNvPr id="18" name="Takeaway 4 Rule"/>
           <p:cNvSpPr/>
           <p:nvPr/>
         </p:nvSpPr>
@@ -7349,7 +10574,7 @@
       </p:sp>
       <p:sp>
         <p:nvSpPr>
-          <p:cNvPr id="19" name="Text 17"/>
+          <p:cNvPr id="19" name="Takeaway 4 Text"/>
           <p:cNvSpPr txBox="1"/>
           <p:nvPr/>
         </p:nvSpPr>
@@ -7388,7 +10613,7 @@
       </p:sp>
       <p:sp>
         <p:nvSpPr>
-          <p:cNvPr id="20" name="Shape 18"/>
+          <p:cNvPr id="20" name="Closing Rule"/>
           <p:cNvSpPr/>
           <p:nvPr/>
         </p:nvSpPr>
@@ -7411,7 +10636,7 @@
       </p:sp>
       <p:sp>
         <p:nvSpPr>
-          <p:cNvPr id="21" name="Text 19"/>
+          <p:cNvPr id="21" name="Thank You"/>
           <p:cNvSpPr txBox="1"/>
           <p:nvPr/>
         </p:nvSpPr>
@@ -7454,8 +10679,826 @@
     <a:masterClrMapping/>
   </p:clrMapOvr>
   <p:transition spd="med">
-    <p:fade/>
+    <p:push dir="u"/>
   </p:transition>
+  <p:timing>
+    <p:tnLst>
+      <p:par>
+        <p:cTn id="1" dur="indefinite" restart="never" nodeType="tmRoot">
+          <p:childTnLst>
+            <p:seq concurrent="1" nextAc="seek">
+              <p:cTn id="2" dur="indefinite" nodeType="mainSeq">
+                <p:childTnLst>
+                  <p:par>
+                    <p:cTn id="3" fill="hold">
+                      <p:stCondLst>
+                        <p:cond delay="indefinite"/>
+                        <p:cond evt="onBegin" delay="0">
+                          <p:tn val="2"/>
+                        </p:cond>
+                      </p:stCondLst>
+                      <p:childTnLst>
+                        <p:par>
+                          <p:cTn id="4" fill="hold">
+                            <p:stCondLst>
+                              <p:cond delay="0"/>
+                            </p:stCondLst>
+                            <p:childTnLst>
+                              <p:par>
+                                <p:cTn id="5" presetID="10" presetClass="entr" presetSubtype="0" fill="hold" grpId="0" nodeType="afterEffect">
+                                  <p:stCondLst>
+                                    <p:cond delay="0"/>
+                                  </p:stCondLst>
+                                  <p:childTnLst>
+                                    <p:set>
+                                      <p:cBhvr>
+                                        <p:cTn id="6" dur="1" fill="hold">
+                                          <p:stCondLst>
+                                            <p:cond delay="0"/>
+                                          </p:stCondLst>
+                                        </p:cTn>
+                                        <p:tgtEl>
+                                          <p:spTgt spid="2"/>
+                                        </p:tgtEl>
+                                        <p:attrNameLst>
+                                          <p:attrName>style.visibility</p:attrName>
+                                        </p:attrNameLst>
+                                      </p:cBhvr>
+                                      <p:to>
+                                        <p:strVal val="visible"/>
+                                      </p:to>
+                                    </p:set>
+                                    <p:animEffect transition="in" filter="fade">
+                                      <p:cBhvr>
+                                        <p:cTn id="7" dur="500"/>
+                                        <p:tgtEl>
+                                          <p:spTgt spid="2"/>
+                                        </p:tgtEl>
+                                      </p:cBhvr>
+                                    </p:animEffect>
+                                  </p:childTnLst>
+                                </p:cTn>
+                              </p:par>
+                              <p:par>
+                                <p:cTn id="8" presetID="22" presetClass="entr" presetSubtype="8" fill="hold" grpId="0" nodeType="withEffect">
+                                  <p:stCondLst>
+                                    <p:cond delay="0"/>
+                                  </p:stCondLst>
+                                  <p:childTnLst>
+                                    <p:set>
+                                      <p:cBhvr>
+                                        <p:cTn id="9" dur="1" fill="hold">
+                                          <p:stCondLst>
+                                            <p:cond delay="0"/>
+                                          </p:stCondLst>
+                                        </p:cTn>
+                                        <p:tgtEl>
+                                          <p:spTgt spid="3"/>
+                                        </p:tgtEl>
+                                        <p:attrNameLst>
+                                          <p:attrName>style.visibility</p:attrName>
+                                        </p:attrNameLst>
+                                      </p:cBhvr>
+                                      <p:to>
+                                        <p:strVal val="visible"/>
+                                      </p:to>
+                                    </p:set>
+                                    <p:animEffect transition="in" filter="wipe(right)">
+                                      <p:cBhvr>
+                                        <p:cTn id="10" dur="500"/>
+                                        <p:tgtEl>
+                                          <p:spTgt spid="3"/>
+                                        </p:tgtEl>
+                                      </p:cBhvr>
+                                    </p:animEffect>
+                                  </p:childTnLst>
+                                </p:cTn>
+                              </p:par>
+                            </p:childTnLst>
+                          </p:cTn>
+                        </p:par>
+                        <p:par>
+                          <p:cTn id="11" fill="hold">
+                            <p:stCondLst>
+                              <p:cond delay="500"/>
+                            </p:stCondLst>
+                            <p:childTnLst>
+                              <p:par>
+                                <p:cTn id="12" presetID="10" presetClass="entr" presetSubtype="0" fill="hold" grpId="0" nodeType="afterEffect">
+                                  <p:stCondLst>
+                                    <p:cond delay="0"/>
+                                  </p:stCondLst>
+                                  <p:childTnLst>
+                                    <p:set>
+                                      <p:cBhvr>
+                                        <p:cTn id="13" dur="1" fill="hold">
+                                          <p:stCondLst>
+                                            <p:cond delay="0"/>
+                                          </p:stCondLst>
+                                        </p:cTn>
+                                        <p:tgtEl>
+                                          <p:spTgt spid="4"/>
+                                        </p:tgtEl>
+                                        <p:attrNameLst>
+                                          <p:attrName>style.visibility</p:attrName>
+                                        </p:attrNameLst>
+                                      </p:cBhvr>
+                                      <p:to>
+                                        <p:strVal val="visible"/>
+                                      </p:to>
+                                    </p:set>
+                                    <p:animEffect transition="in" filter="fade">
+                                      <p:cBhvr>
+                                        <p:cTn id="14" dur="500"/>
+                                        <p:tgtEl>
+                                          <p:spTgt spid="4"/>
+                                        </p:tgtEl>
+                                      </p:cBhvr>
+                                    </p:animEffect>
+                                  </p:childTnLst>
+                                </p:cTn>
+                              </p:par>
+                              <p:par>
+                                <p:cTn id="15" presetID="10" presetClass="entr" presetSubtype="0" fill="hold" grpId="0" nodeType="withEffect">
+                                  <p:stCondLst>
+                                    <p:cond delay="0"/>
+                                  </p:stCondLst>
+                                  <p:childTnLst>
+                                    <p:set>
+                                      <p:cBhvr>
+                                        <p:cTn id="16" dur="1" fill="hold">
+                                          <p:stCondLst>
+                                            <p:cond delay="0"/>
+                                          </p:stCondLst>
+                                        </p:cTn>
+                                        <p:tgtEl>
+                                          <p:spTgt spid="5"/>
+                                        </p:tgtEl>
+                                        <p:attrNameLst>
+                                          <p:attrName>style.visibility</p:attrName>
+                                        </p:attrNameLst>
+                                      </p:cBhvr>
+                                      <p:to>
+                                        <p:strVal val="visible"/>
+                                      </p:to>
+                                    </p:set>
+                                    <p:animEffect transition="in" filter="fade">
+                                      <p:cBhvr>
+                                        <p:cTn id="17" dur="500"/>
+                                        <p:tgtEl>
+                                          <p:spTgt spid="5"/>
+                                        </p:tgtEl>
+                                      </p:cBhvr>
+                                    </p:animEffect>
+                                  </p:childTnLst>
+                                </p:cTn>
+                              </p:par>
+                              <p:par>
+                                <p:cTn id="18" presetID="10" presetClass="entr" presetSubtype="0" fill="hold" grpId="0" nodeType="withEffect">
+                                  <p:stCondLst>
+                                    <p:cond delay="0"/>
+                                  </p:stCondLst>
+                                  <p:childTnLst>
+                                    <p:set>
+                                      <p:cBhvr>
+                                        <p:cTn id="19" dur="1" fill="hold">
+                                          <p:stCondLst>
+                                            <p:cond delay="0"/>
+                                          </p:stCondLst>
+                                        </p:cTn>
+                                        <p:tgtEl>
+                                          <p:spTgt spid="6"/>
+                                        </p:tgtEl>
+                                        <p:attrNameLst>
+                                          <p:attrName>style.visibility</p:attrName>
+                                        </p:attrNameLst>
+                                      </p:cBhvr>
+                                      <p:to>
+                                        <p:strVal val="visible"/>
+                                      </p:to>
+                                    </p:set>
+                                    <p:animEffect transition="in" filter="fade">
+                                      <p:cBhvr>
+                                        <p:cTn id="20" dur="500"/>
+                                        <p:tgtEl>
+                                          <p:spTgt spid="6"/>
+                                        </p:tgtEl>
+                                      </p:cBhvr>
+                                    </p:animEffect>
+                                  </p:childTnLst>
+                                </p:cTn>
+                              </p:par>
+                              <p:par>
+                                <p:cTn id="21" presetID="10" presetClass="entr" presetSubtype="0" fill="hold" grpId="0" nodeType="withEffect">
+                                  <p:stCondLst>
+                                    <p:cond delay="0"/>
+                                  </p:stCondLst>
+                                  <p:childTnLst>
+                                    <p:set>
+                                      <p:cBhvr>
+                                        <p:cTn id="22" dur="1" fill="hold">
+                                          <p:stCondLst>
+                                            <p:cond delay="0"/>
+                                          </p:stCondLst>
+                                        </p:cTn>
+                                        <p:tgtEl>
+                                          <p:spTgt spid="7"/>
+                                        </p:tgtEl>
+                                        <p:attrNameLst>
+                                          <p:attrName>style.visibility</p:attrName>
+                                        </p:attrNameLst>
+                                      </p:cBhvr>
+                                      <p:to>
+                                        <p:strVal val="visible"/>
+                                      </p:to>
+                                    </p:set>
+                                    <p:animEffect transition="in" filter="fade">
+                                      <p:cBhvr>
+                                        <p:cTn id="23" dur="500"/>
+                                        <p:tgtEl>
+                                          <p:spTgt spid="7"/>
+                                        </p:tgtEl>
+                                      </p:cBhvr>
+                                    </p:animEffect>
+                                  </p:childTnLst>
+                                </p:cTn>
+                              </p:par>
+                            </p:childTnLst>
+                          </p:cTn>
+                        </p:par>
+                        <p:par>
+                          <p:cTn id="24" fill="hold">
+                            <p:stCondLst>
+                              <p:cond delay="1000"/>
+                            </p:stCondLst>
+                            <p:childTnLst>
+                              <p:par>
+                                <p:cTn id="25" presetID="10" presetClass="entr" presetSubtype="0" fill="hold" grpId="0" nodeType="afterEffect">
+                                  <p:stCondLst>
+                                    <p:cond delay="0"/>
+                                  </p:stCondLst>
+                                  <p:childTnLst>
+                                    <p:set>
+                                      <p:cBhvr>
+                                        <p:cTn id="26" dur="1" fill="hold">
+                                          <p:stCondLst>
+                                            <p:cond delay="0"/>
+                                          </p:stCondLst>
+                                        </p:cTn>
+                                        <p:tgtEl>
+                                          <p:spTgt spid="8"/>
+                                        </p:tgtEl>
+                                        <p:attrNameLst>
+                                          <p:attrName>style.visibility</p:attrName>
+                                        </p:attrNameLst>
+                                      </p:cBhvr>
+                                      <p:to>
+                                        <p:strVal val="visible"/>
+                                      </p:to>
+                                    </p:set>
+                                    <p:animEffect transition="in" filter="fade">
+                                      <p:cBhvr>
+                                        <p:cTn id="27" dur="500"/>
+                                        <p:tgtEl>
+                                          <p:spTgt spid="8"/>
+                                        </p:tgtEl>
+                                      </p:cBhvr>
+                                    </p:animEffect>
+                                  </p:childTnLst>
+                                </p:cTn>
+                              </p:par>
+                              <p:par>
+                                <p:cTn id="28" presetID="10" presetClass="entr" presetSubtype="0" fill="hold" grpId="0" nodeType="withEffect">
+                                  <p:stCondLst>
+                                    <p:cond delay="0"/>
+                                  </p:stCondLst>
+                                  <p:childTnLst>
+                                    <p:set>
+                                      <p:cBhvr>
+                                        <p:cTn id="29" dur="1" fill="hold">
+                                          <p:stCondLst>
+                                            <p:cond delay="0"/>
+                                          </p:stCondLst>
+                                        </p:cTn>
+                                        <p:tgtEl>
+                                          <p:spTgt spid="9"/>
+                                        </p:tgtEl>
+                                        <p:attrNameLst>
+                                          <p:attrName>style.visibility</p:attrName>
+                                        </p:attrNameLst>
+                                      </p:cBhvr>
+                                      <p:to>
+                                        <p:strVal val="visible"/>
+                                      </p:to>
+                                    </p:set>
+                                    <p:animEffect transition="in" filter="fade">
+                                      <p:cBhvr>
+                                        <p:cTn id="30" dur="500"/>
+                                        <p:tgtEl>
+                                          <p:spTgt spid="9"/>
+                                        </p:tgtEl>
+                                      </p:cBhvr>
+                                    </p:animEffect>
+                                  </p:childTnLst>
+                                </p:cTn>
+                              </p:par>
+                              <p:par>
+                                <p:cTn id="31" presetID="10" presetClass="entr" presetSubtype="0" fill="hold" grpId="0" nodeType="withEffect">
+                                  <p:stCondLst>
+                                    <p:cond delay="0"/>
+                                  </p:stCondLst>
+                                  <p:childTnLst>
+                                    <p:set>
+                                      <p:cBhvr>
+                                        <p:cTn id="32" dur="1" fill="hold">
+                                          <p:stCondLst>
+                                            <p:cond delay="0"/>
+                                          </p:stCondLst>
+                                        </p:cTn>
+                                        <p:tgtEl>
+                                          <p:spTgt spid="10"/>
+                                        </p:tgtEl>
+                                        <p:attrNameLst>
+                                          <p:attrName>style.visibility</p:attrName>
+                                        </p:attrNameLst>
+                                      </p:cBhvr>
+                                      <p:to>
+                                        <p:strVal val="visible"/>
+                                      </p:to>
+                                    </p:set>
+                                    <p:animEffect transition="in" filter="fade">
+                                      <p:cBhvr>
+                                        <p:cTn id="33" dur="500"/>
+                                        <p:tgtEl>
+                                          <p:spTgt spid="10"/>
+                                        </p:tgtEl>
+                                      </p:cBhvr>
+                                    </p:animEffect>
+                                  </p:childTnLst>
+                                </p:cTn>
+                              </p:par>
+                              <p:par>
+                                <p:cTn id="34" presetID="10" presetClass="entr" presetSubtype="0" fill="hold" grpId="0" nodeType="withEffect">
+                                  <p:stCondLst>
+                                    <p:cond delay="0"/>
+                                  </p:stCondLst>
+                                  <p:childTnLst>
+                                    <p:set>
+                                      <p:cBhvr>
+                                        <p:cTn id="35" dur="1" fill="hold">
+                                          <p:stCondLst>
+                                            <p:cond delay="0"/>
+                                          </p:stCondLst>
+                                        </p:cTn>
+                                        <p:tgtEl>
+                                          <p:spTgt spid="11"/>
+                                        </p:tgtEl>
+                                        <p:attrNameLst>
+                                          <p:attrName>style.visibility</p:attrName>
+                                        </p:attrNameLst>
+                                      </p:cBhvr>
+                                      <p:to>
+                                        <p:strVal val="visible"/>
+                                      </p:to>
+                                    </p:set>
+                                    <p:animEffect transition="in" filter="fade">
+                                      <p:cBhvr>
+                                        <p:cTn id="36" dur="500"/>
+                                        <p:tgtEl>
+                                          <p:spTgt spid="11"/>
+                                        </p:tgtEl>
+                                      </p:cBhvr>
+                                    </p:animEffect>
+                                  </p:childTnLst>
+                                </p:cTn>
+                              </p:par>
+                            </p:childTnLst>
+                          </p:cTn>
+                        </p:par>
+                        <p:par>
+                          <p:cTn id="37" fill="hold">
+                            <p:stCondLst>
+                              <p:cond delay="1500"/>
+                            </p:stCondLst>
+                            <p:childTnLst>
+                              <p:par>
+                                <p:cTn id="38" presetID="10" presetClass="entr" presetSubtype="0" fill="hold" grpId="0" nodeType="afterEffect">
+                                  <p:stCondLst>
+                                    <p:cond delay="0"/>
+                                  </p:stCondLst>
+                                  <p:childTnLst>
+                                    <p:set>
+                                      <p:cBhvr>
+                                        <p:cTn id="39" dur="1" fill="hold">
+                                          <p:stCondLst>
+                                            <p:cond delay="0"/>
+                                          </p:stCondLst>
+                                        </p:cTn>
+                                        <p:tgtEl>
+                                          <p:spTgt spid="12"/>
+                                        </p:tgtEl>
+                                        <p:attrNameLst>
+                                          <p:attrName>style.visibility</p:attrName>
+                                        </p:attrNameLst>
+                                      </p:cBhvr>
+                                      <p:to>
+                                        <p:strVal val="visible"/>
+                                      </p:to>
+                                    </p:set>
+                                    <p:animEffect transition="in" filter="fade">
+                                      <p:cBhvr>
+                                        <p:cTn id="40" dur="500"/>
+                                        <p:tgtEl>
+                                          <p:spTgt spid="12"/>
+                                        </p:tgtEl>
+                                      </p:cBhvr>
+                                    </p:animEffect>
+                                  </p:childTnLst>
+                                </p:cTn>
+                              </p:par>
+                              <p:par>
+                                <p:cTn id="41" presetID="10" presetClass="entr" presetSubtype="0" fill="hold" grpId="0" nodeType="withEffect">
+                                  <p:stCondLst>
+                                    <p:cond delay="0"/>
+                                  </p:stCondLst>
+                                  <p:childTnLst>
+                                    <p:set>
+                                      <p:cBhvr>
+                                        <p:cTn id="42" dur="1" fill="hold">
+                                          <p:stCondLst>
+                                            <p:cond delay="0"/>
+                                          </p:stCondLst>
+                                        </p:cTn>
+                                        <p:tgtEl>
+                                          <p:spTgt spid="13"/>
+                                        </p:tgtEl>
+                                        <p:attrNameLst>
+                                          <p:attrName>style.visibility</p:attrName>
+                                        </p:attrNameLst>
+                                      </p:cBhvr>
+                                      <p:to>
+                                        <p:strVal val="visible"/>
+                                      </p:to>
+                                    </p:set>
+                                    <p:animEffect transition="in" filter="fade">
+                                      <p:cBhvr>
+                                        <p:cTn id="43" dur="500"/>
+                                        <p:tgtEl>
+                                          <p:spTgt spid="13"/>
+                                        </p:tgtEl>
+                                      </p:cBhvr>
+                                    </p:animEffect>
+                                  </p:childTnLst>
+                                </p:cTn>
+                              </p:par>
+                              <p:par>
+                                <p:cTn id="44" presetID="10" presetClass="entr" presetSubtype="0" fill="hold" grpId="0" nodeType="withEffect">
+                                  <p:stCondLst>
+                                    <p:cond delay="0"/>
+                                  </p:stCondLst>
+                                  <p:childTnLst>
+                                    <p:set>
+                                      <p:cBhvr>
+                                        <p:cTn id="45" dur="1" fill="hold">
+                                          <p:stCondLst>
+                                            <p:cond delay="0"/>
+                                          </p:stCondLst>
+                                        </p:cTn>
+                                        <p:tgtEl>
+                                          <p:spTgt spid="14"/>
+                                        </p:tgtEl>
+                                        <p:attrNameLst>
+                                          <p:attrName>style.visibility</p:attrName>
+                                        </p:attrNameLst>
+                                      </p:cBhvr>
+                                      <p:to>
+                                        <p:strVal val="visible"/>
+                                      </p:to>
+                                    </p:set>
+                                    <p:animEffect transition="in" filter="fade">
+                                      <p:cBhvr>
+                                        <p:cTn id="46" dur="500"/>
+                                        <p:tgtEl>
+                                          <p:spTgt spid="14"/>
+                                        </p:tgtEl>
+                                      </p:cBhvr>
+                                    </p:animEffect>
+                                  </p:childTnLst>
+                                </p:cTn>
+                              </p:par>
+                              <p:par>
+                                <p:cTn id="47" presetID="10" presetClass="entr" presetSubtype="0" fill="hold" grpId="0" nodeType="withEffect">
+                                  <p:stCondLst>
+                                    <p:cond delay="0"/>
+                                  </p:stCondLst>
+                                  <p:childTnLst>
+                                    <p:set>
+                                      <p:cBhvr>
+                                        <p:cTn id="48" dur="1" fill="hold">
+                                          <p:stCondLst>
+                                            <p:cond delay="0"/>
+                                          </p:stCondLst>
+                                        </p:cTn>
+                                        <p:tgtEl>
+                                          <p:spTgt spid="15"/>
+                                        </p:tgtEl>
+                                        <p:attrNameLst>
+                                          <p:attrName>style.visibility</p:attrName>
+                                        </p:attrNameLst>
+                                      </p:cBhvr>
+                                      <p:to>
+                                        <p:strVal val="visible"/>
+                                      </p:to>
+                                    </p:set>
+                                    <p:animEffect transition="in" filter="fade">
+                                      <p:cBhvr>
+                                        <p:cTn id="49" dur="500"/>
+                                        <p:tgtEl>
+                                          <p:spTgt spid="15"/>
+                                        </p:tgtEl>
+                                      </p:cBhvr>
+                                    </p:animEffect>
+                                  </p:childTnLst>
+                                </p:cTn>
+                              </p:par>
+                            </p:childTnLst>
+                          </p:cTn>
+                        </p:par>
+                        <p:par>
+                          <p:cTn id="50" fill="hold">
+                            <p:stCondLst>
+                              <p:cond delay="2000"/>
+                            </p:stCondLst>
+                            <p:childTnLst>
+                              <p:par>
+                                <p:cTn id="51" presetID="10" presetClass="entr" presetSubtype="0" fill="hold" grpId="0" nodeType="afterEffect">
+                                  <p:stCondLst>
+                                    <p:cond delay="0"/>
+                                  </p:stCondLst>
+                                  <p:childTnLst>
+                                    <p:set>
+                                      <p:cBhvr>
+                                        <p:cTn id="52" dur="1" fill="hold">
+                                          <p:stCondLst>
+                                            <p:cond delay="0"/>
+                                          </p:stCondLst>
+                                        </p:cTn>
+                                        <p:tgtEl>
+                                          <p:spTgt spid="16"/>
+                                        </p:tgtEl>
+                                        <p:attrNameLst>
+                                          <p:attrName>style.visibility</p:attrName>
+                                        </p:attrNameLst>
+                                      </p:cBhvr>
+                                      <p:to>
+                                        <p:strVal val="visible"/>
+                                      </p:to>
+                                    </p:set>
+                                    <p:animEffect transition="in" filter="fade">
+                                      <p:cBhvr>
+                                        <p:cTn id="53" dur="500"/>
+                                        <p:tgtEl>
+                                          <p:spTgt spid="16"/>
+                                        </p:tgtEl>
+                                      </p:cBhvr>
+                                    </p:animEffect>
+                                  </p:childTnLst>
+                                </p:cTn>
+                              </p:par>
+                              <p:par>
+                                <p:cTn id="54" presetID="10" presetClass="entr" presetSubtype="0" fill="hold" grpId="0" nodeType="withEffect">
+                                  <p:stCondLst>
+                                    <p:cond delay="0"/>
+                                  </p:stCondLst>
+                                  <p:childTnLst>
+                                    <p:set>
+                                      <p:cBhvr>
+                                        <p:cTn id="55" dur="1" fill="hold">
+                                          <p:stCondLst>
+                                            <p:cond delay="0"/>
+                                          </p:stCondLst>
+                                        </p:cTn>
+                                        <p:tgtEl>
+                                          <p:spTgt spid="17"/>
+                                        </p:tgtEl>
+                                        <p:attrNameLst>
+                                          <p:attrName>style.visibility</p:attrName>
+                                        </p:attrNameLst>
+                                      </p:cBhvr>
+                                      <p:to>
+                                        <p:strVal val="visible"/>
+                                      </p:to>
+                                    </p:set>
+                                    <p:animEffect transition="in" filter="fade">
+                                      <p:cBhvr>
+                                        <p:cTn id="56" dur="500"/>
+                                        <p:tgtEl>
+                                          <p:spTgt spid="17"/>
+                                        </p:tgtEl>
+                                      </p:cBhvr>
+                                    </p:animEffect>
+                                  </p:childTnLst>
+                                </p:cTn>
+                              </p:par>
+                              <p:par>
+                                <p:cTn id="57" presetID="10" presetClass="entr" presetSubtype="0" fill="hold" grpId="0" nodeType="withEffect">
+                                  <p:stCondLst>
+                                    <p:cond delay="0"/>
+                                  </p:stCondLst>
+                                  <p:childTnLst>
+                                    <p:set>
+                                      <p:cBhvr>
+                                        <p:cTn id="58" dur="1" fill="hold">
+                                          <p:stCondLst>
+                                            <p:cond delay="0"/>
+                                          </p:stCondLst>
+                                        </p:cTn>
+                                        <p:tgtEl>
+                                          <p:spTgt spid="18"/>
+                                        </p:tgtEl>
+                                        <p:attrNameLst>
+                                          <p:attrName>style.visibility</p:attrName>
+                                        </p:attrNameLst>
+                                      </p:cBhvr>
+                                      <p:to>
+                                        <p:strVal val="visible"/>
+                                      </p:to>
+                                    </p:set>
+                                    <p:animEffect transition="in" filter="fade">
+                                      <p:cBhvr>
+                                        <p:cTn id="59" dur="500"/>
+                                        <p:tgtEl>
+                                          <p:spTgt spid="18"/>
+                                        </p:tgtEl>
+                                      </p:cBhvr>
+                                    </p:animEffect>
+                                  </p:childTnLst>
+                                </p:cTn>
+                              </p:par>
+                              <p:par>
+                                <p:cTn id="60" presetID="10" presetClass="entr" presetSubtype="0" fill="hold" grpId="0" nodeType="withEffect">
+                                  <p:stCondLst>
+                                    <p:cond delay="0"/>
+                                  </p:stCondLst>
+                                  <p:childTnLst>
+                                    <p:set>
+                                      <p:cBhvr>
+                                        <p:cTn id="61" dur="1" fill="hold">
+                                          <p:stCondLst>
+                                            <p:cond delay="0"/>
+                                          </p:stCondLst>
+                                        </p:cTn>
+                                        <p:tgtEl>
+                                          <p:spTgt spid="19"/>
+                                        </p:tgtEl>
+                                        <p:attrNameLst>
+                                          <p:attrName>style.visibility</p:attrName>
+                                        </p:attrNameLst>
+                                      </p:cBhvr>
+                                      <p:to>
+                                        <p:strVal val="visible"/>
+                                      </p:to>
+                                    </p:set>
+                                    <p:animEffect transition="in" filter="fade">
+                                      <p:cBhvr>
+                                        <p:cTn id="62" dur="500"/>
+                                        <p:tgtEl>
+                                          <p:spTgt spid="19"/>
+                                        </p:tgtEl>
+                                      </p:cBhvr>
+                                    </p:animEffect>
+                                  </p:childTnLst>
+                                </p:cTn>
+                              </p:par>
+                            </p:childTnLst>
+                          </p:cTn>
+                        </p:par>
+                        <p:par>
+                          <p:cTn id="63" fill="hold">
+                            <p:stCondLst>
+                              <p:cond delay="2500"/>
+                            </p:stCondLst>
+                            <p:childTnLst>
+                              <p:par>
+                                <p:cTn id="64" presetID="22" presetClass="entr" presetSubtype="8" fill="hold" grpId="0" nodeType="afterEffect">
+                                  <p:stCondLst>
+                                    <p:cond delay="0"/>
+                                  </p:stCondLst>
+                                  <p:childTnLst>
+                                    <p:set>
+                                      <p:cBhvr>
+                                        <p:cTn id="65" dur="1" fill="hold">
+                                          <p:stCondLst>
+                                            <p:cond delay="0"/>
+                                          </p:stCondLst>
+                                        </p:cTn>
+                                        <p:tgtEl>
+                                          <p:spTgt spid="20"/>
+                                        </p:tgtEl>
+                                        <p:attrNameLst>
+                                          <p:attrName>style.visibility</p:attrName>
+                                        </p:attrNameLst>
+                                      </p:cBhvr>
+                                      <p:to>
+                                        <p:strVal val="visible"/>
+                                      </p:to>
+                                    </p:set>
+                                    <p:animEffect transition="in" filter="wipe(right)">
+                                      <p:cBhvr>
+                                        <p:cTn id="66" dur="500"/>
+                                        <p:tgtEl>
+                                          <p:spTgt spid="20"/>
+                                        </p:tgtEl>
+                                      </p:cBhvr>
+                                    </p:animEffect>
+                                  </p:childTnLst>
+                                </p:cTn>
+                              </p:par>
+                              <p:par>
+                                <p:cTn id="67" presetID="10" presetClass="entr" presetSubtype="0" fill="hold" grpId="0" nodeType="withEffect">
+                                  <p:stCondLst>
+                                    <p:cond delay="0"/>
+                                  </p:stCondLst>
+                                  <p:childTnLst>
+                                    <p:set>
+                                      <p:cBhvr>
+                                        <p:cTn id="68" dur="1" fill="hold">
+                                          <p:stCondLst>
+                                            <p:cond delay="0"/>
+                                          </p:stCondLst>
+                                        </p:cTn>
+                                        <p:tgtEl>
+                                          <p:spTgt spid="21"/>
+                                        </p:tgtEl>
+                                        <p:attrNameLst>
+                                          <p:attrName>style.visibility</p:attrName>
+                                        </p:attrNameLst>
+                                      </p:cBhvr>
+                                      <p:to>
+                                        <p:strVal val="visible"/>
+                                      </p:to>
+                                    </p:set>
+                                    <p:animEffect transition="in" filter="fade">
+                                      <p:cBhvr>
+                                        <p:cTn id="69" dur="500"/>
+                                        <p:tgtEl>
+                                          <p:spTgt spid="21"/>
+                                        </p:tgtEl>
+                                      </p:cBhvr>
+                                    </p:animEffect>
+                                  </p:childTnLst>
+                                </p:cTn>
+                              </p:par>
+                            </p:childTnLst>
+                          </p:cTn>
+                        </p:par>
+                      </p:childTnLst>
+                    </p:cTn>
+                  </p:par>
+                </p:childTnLst>
+              </p:cTn>
+              <p:prevCondLst>
+                <p:cond evt="onPrev" delay="0">
+                  <p:tgtEl>
+                    <p:sldTgt/>
+                  </p:tgtEl>
+                </p:cond>
+              </p:prevCondLst>
+              <p:nextCondLst>
+                <p:cond evt="onNext" delay="0">
+                  <p:tgtEl>
+                    <p:sldTgt/>
+                  </p:tgtEl>
+                </p:cond>
+              </p:nextCondLst>
+            </p:seq>
+          </p:childTnLst>
+        </p:cTn>
+      </p:par>
+    </p:tnLst>
+    <p:bldLst>
+      <p:bldP spid="2" grpId="0" animBg="1"/>
+      <p:bldP spid="3" grpId="0" animBg="1"/>
+      <p:bldP spid="4" grpId="0" animBg="1"/>
+      <p:bldP spid="5" grpId="0" animBg="1"/>
+      <p:bldP spid="6" grpId="0" animBg="1"/>
+      <p:bldP spid="7" grpId="0" animBg="1"/>
+      <p:bldP spid="8" grpId="0" animBg="1"/>
+      <p:bldP spid="9" grpId="0" animBg="1"/>
+      <p:bldP spid="10" grpId="0" animBg="1"/>
+      <p:bldP spid="11" grpId="0" animBg="1"/>
+      <p:bldP spid="12" grpId="0" animBg="1"/>
+      <p:bldP spid="13" grpId="0" animBg="1"/>
+      <p:bldP spid="14" grpId="0" animBg="1"/>
+      <p:bldP spid="15" grpId="0" animBg="1"/>
+      <p:bldP spid="16" grpId="0" animBg="1"/>
+      <p:bldP spid="17" grpId="0" animBg="1"/>
+      <p:bldP spid="18" grpId="0" animBg="1"/>
+      <p:bldP spid="19" grpId="0" animBg="1"/>
+      <p:bldP spid="20" grpId="0" animBg="1"/>
+      <p:bldP spid="21" grpId="0" animBg="1"/>
+    </p:bldLst>
+  </p:timing>
 </p:sld>
 </file>
 

</xml_diff>

<commit_message>
Use a plain grey pie and grey bars in the budget deck
The doughnut on slide 2 is now a standard pie chart in four PowerPoint
greys, with its percentages outside the slices and a chart title; the
legend keys use the same greys. Every bar and column chart uses one
dark grey, and the average line is black.

sanitize_charts.py also stops data labels from wrapping, so short
labels such as "36.0%" stay on one line.

Co-Authored-By: Claude Opus 5.5 <noreply@anthropic.com>
Claude-Session: https://claude.ai/code/session_01WToQxHdrdWhM7bKqXvUa59
</commit_message>
<xml_diff>
--- a/marketing-budget/Marketing_Department_Budget.pptx
+++ b/marketing-budget/Marketing_Department_Budget.pptx
@@ -120,10 +120,39 @@
   <c:date1904 val="0"/>
   <c:roundedCorners val="1"/>
   <c:chart>
-    <c:autoTitleDeleted val="1"/>
+    <c:title>
+      <c:tx>
+        <c:rich>
+          <a:bodyPr/>
+          <a:lstStyle/>
+          <a:p>
+            <a:pPr>
+              <a:defRPr sz="1600" b="0" i="0" u="none" strike="noStrike">
+                <a:solidFill>
+                  <a:srgbClr val="000000"/>
+                </a:solidFill>
+                <a:latin typeface="Arial"/>
+              </a:defRPr>
+            </a:pPr>
+            <a:r>
+              <a:rPr sz="1600" b="0" i="0" u="none" strike="noStrike">
+                <a:solidFill>
+                  <a:srgbClr val="000000"/>
+                </a:solidFill>
+                <a:latin typeface="Arial"/>
+              </a:rPr>
+              <a:t>Share of Total Budget</a:t>
+            </a:r>
+          </a:p>
+        </c:rich>
+      </c:tx>
+      <c:layout/>
+      <c:overlay val="0"/>
+    </c:title>
+    <c:autoTitleDeleted val="0"/>
     <c:plotArea>
       <c:layout/>
-      <c:doughnutChart>
+      <c:pieChart>
         <c:varyColors val="1"/>
         <c:ser>
           <c:idx val="0"/>
@@ -157,7 +186,7 @@
             <c:bubble3D val="0"/>
             <c:spPr>
               <a:solidFill>
-                <a:srgbClr val="4472C4"/>
+                <a:srgbClr val="262626"/>
               </a:solidFill>
               <a:ln w="19050" cap="flat">
                 <a:solidFill>
@@ -174,7 +203,7 @@
             <c:bubble3D val="0"/>
             <c:spPr>
               <a:solidFill>
-                <a:srgbClr val="C55A11"/>
+                <a:srgbClr val="A6A6A6"/>
               </a:solidFill>
               <a:ln w="19050" cap="flat">
                 <a:solidFill>
@@ -191,7 +220,7 @@
             <c:bubble3D val="0"/>
             <c:spPr>
               <a:solidFill>
-                <a:srgbClr val="7030A0"/>
+                <a:srgbClr val="595959"/>
               </a:solidFill>
               <a:ln w="19050" cap="flat">
                 <a:solidFill>
@@ -208,7 +237,7 @@
             <c:bubble3D val="0"/>
             <c:spPr>
               <a:solidFill>
-                <a:srgbClr val="548235"/>
+                <a:srgbClr val="D9D9D9"/>
               </a:solidFill>
               <a:ln w="19050" cap="flat">
                 <a:solidFill>
@@ -223,14 +252,14 @@
           <c:dLbls>
             <c:dLbl>
               <c:idx val="0"/>
-              <c:numFmt formatCode="General" sourceLinked="0"/>
+              <c:numFmt formatCode="0.0%" sourceLinked="0"/>
               <c:spPr/>
               <c:txPr>
-                <a:bodyPr/>
+                <a:bodyPr wrap="none"/>
                 <a:lstStyle/>
                 <a:p>
                   <a:pPr>
-                    <a:defRPr sz="1200" b="0" i="0" u="none" strike="noStrike">
+                    <a:defRPr sz="1400" b="1" i="0" u="none" strike="noStrike">
                       <a:solidFill>
                         <a:srgbClr val="000000"/>
                       </a:solidFill>
@@ -239,23 +268,24 @@
                   </a:pPr>
                 </a:p>
               </c:txPr>
+              <c:dLblPos val="outEnd"/>
               <c:showLegendKey val="0"/>
               <c:showVal val="0"/>
               <c:showCatName val="0"/>
               <c:showSerName val="0"/>
-              <c:showPercent val="0"/>
+              <c:showPercent val="1"/>
               <c:showBubbleSize val="0"/>
             </c:dLbl>
             <c:dLbl>
               <c:idx val="1"/>
-              <c:numFmt formatCode="General" sourceLinked="0"/>
+              <c:numFmt formatCode="0.0%" sourceLinked="0"/>
               <c:spPr/>
               <c:txPr>
-                <a:bodyPr/>
+                <a:bodyPr wrap="none"/>
                 <a:lstStyle/>
                 <a:p>
                   <a:pPr>
-                    <a:defRPr sz="1200" b="0" i="0" u="none" strike="noStrike">
+                    <a:defRPr sz="1400" b="1" i="0" u="none" strike="noStrike">
                       <a:solidFill>
                         <a:srgbClr val="000000"/>
                       </a:solidFill>
@@ -264,23 +294,24 @@
                   </a:pPr>
                 </a:p>
               </c:txPr>
+              <c:dLblPos val="outEnd"/>
               <c:showLegendKey val="0"/>
               <c:showVal val="0"/>
               <c:showCatName val="0"/>
               <c:showSerName val="0"/>
-              <c:showPercent val="0"/>
+              <c:showPercent val="1"/>
               <c:showBubbleSize val="0"/>
             </c:dLbl>
             <c:dLbl>
               <c:idx val="2"/>
-              <c:numFmt formatCode="General" sourceLinked="0"/>
+              <c:numFmt formatCode="0.0%" sourceLinked="0"/>
               <c:spPr/>
               <c:txPr>
-                <a:bodyPr/>
+                <a:bodyPr wrap="none"/>
                 <a:lstStyle/>
                 <a:p>
                   <a:pPr>
-                    <a:defRPr sz="1200" b="0" i="0" u="none" strike="noStrike">
+                    <a:defRPr sz="1400" b="1" i="0" u="none" strike="noStrike">
                       <a:solidFill>
                         <a:srgbClr val="000000"/>
                       </a:solidFill>
@@ -289,23 +320,24 @@
                   </a:pPr>
                 </a:p>
               </c:txPr>
+              <c:dLblPos val="outEnd"/>
               <c:showLegendKey val="0"/>
               <c:showVal val="0"/>
               <c:showCatName val="0"/>
               <c:showSerName val="0"/>
-              <c:showPercent val="0"/>
+              <c:showPercent val="1"/>
               <c:showBubbleSize val="0"/>
             </c:dLbl>
             <c:dLbl>
               <c:idx val="3"/>
-              <c:numFmt formatCode="General" sourceLinked="0"/>
+              <c:numFmt formatCode="0.0%" sourceLinked="0"/>
               <c:spPr/>
               <c:txPr>
-                <a:bodyPr/>
+                <a:bodyPr wrap="none"/>
                 <a:lstStyle/>
                 <a:p>
                   <a:pPr>
-                    <a:defRPr sz="1200" b="0" i="0" u="none" strike="noStrike">
+                    <a:defRPr sz="1400" b="1" i="0" u="none" strike="noStrike">
                       <a:solidFill>
                         <a:srgbClr val="000000"/>
                       </a:solidFill>
@@ -314,20 +346,21 @@
                   </a:pPr>
                 </a:p>
               </c:txPr>
+              <c:dLblPos val="outEnd"/>
               <c:showLegendKey val="0"/>
               <c:showVal val="0"/>
               <c:showCatName val="0"/>
               <c:showSerName val="0"/>
-              <c:showPercent val="0"/>
+              <c:showPercent val="1"/>
               <c:showBubbleSize val="0"/>
             </c:dLbl>
-            <c:numFmt formatCode="General" sourceLinked="0"/>
+            <c:numFmt formatCode="0.0%" sourceLinked="0"/>
             <c:txPr>
-              <a:bodyPr/>
+              <a:bodyPr wrap="none"/>
               <a:lstStyle/>
               <a:p>
                 <a:pPr>
-                  <a:defRPr sz="1800" b="0" i="0" u="none" strike="noStrike">
+                  <a:defRPr sz="1800" b="1" i="0" u="none" strike="noStrike">
                     <a:solidFill>
                       <a:srgbClr val="000000"/>
                     </a:solidFill>
@@ -336,6 +369,7 @@
                 </a:pPr>
               </a:p>
             </c:txPr>
+            <c:dLblPos val="ctr"/>
             <c:showLegendKey val="0"/>
             <c:showVal val="0"/>
             <c:showCatName val="1"/>
@@ -386,8 +420,7 @@
           </c:val>
         </c:ser>
         <c:firstSliceAng val="0"/>
-        <c:holeSize val="55"/>
-      </c:doughnutChart>
+      </c:pieChart>
       <c:spPr>
         <a:noFill/>
         <a:ln>
@@ -440,7 +473,7 @@
           </c:tx>
           <c:spPr>
             <a:solidFill>
-              <a:srgbClr val="4472C4"/>
+              <a:srgbClr val="595959"/>
             </a:solidFill>
             <a:effectLst/>
           </c:spPr>
@@ -448,7 +481,7 @@
           <c:dLbls>
             <c:numFmt formatCode="$#,##0" sourceLinked="0"/>
             <c:txPr>
-              <a:bodyPr/>
+              <a:bodyPr wrap="none"/>
               <a:lstStyle/>
               <a:p>
                 <a:pPr>
@@ -540,7 +573,7 @@
         <c:dLbls>
           <c:numFmt formatCode="$#,##0" sourceLinked="0"/>
           <c:txPr>
-            <a:bodyPr/>
+            <a:bodyPr wrap="none"/>
             <a:lstStyle/>
             <a:p>
               <a:pPr>
@@ -698,7 +731,7 @@
           </c:tx>
           <c:spPr>
             <a:solidFill>
-              <a:srgbClr val="C55A11"/>
+              <a:srgbClr val="595959"/>
             </a:solidFill>
             <a:effectLst/>
           </c:spPr>
@@ -706,7 +739,7 @@
           <c:dLbls>
             <c:numFmt formatCode="$#,##0" sourceLinked="0"/>
             <c:txPr>
-              <a:bodyPr/>
+              <a:bodyPr wrap="none"/>
               <a:lstStyle/>
               <a:p>
                 <a:pPr>
@@ -798,7 +831,7 @@
         <c:dLbls>
           <c:numFmt formatCode="$#,##0" sourceLinked="0"/>
           <c:txPr>
-            <a:bodyPr/>
+            <a:bodyPr wrap="none"/>
             <a:lstStyle/>
             <a:p>
               <a:pPr>
@@ -956,7 +989,7 @@
           </c:tx>
           <c:spPr>
             <a:solidFill>
-              <a:srgbClr val="7030A0"/>
+              <a:srgbClr val="595959"/>
             </a:solidFill>
             <a:effectLst/>
           </c:spPr>
@@ -964,7 +997,7 @@
           <c:dLbls>
             <c:numFmt formatCode="$#,##0" sourceLinked="0"/>
             <c:txPr>
-              <a:bodyPr/>
+              <a:bodyPr wrap="none"/>
               <a:lstStyle/>
               <a:p>
                 <a:pPr>
@@ -1056,7 +1089,7 @@
         <c:dLbls>
           <c:numFmt formatCode="$#,##0" sourceLinked="0"/>
           <c:txPr>
-            <a:bodyPr/>
+            <a:bodyPr wrap="none"/>
             <a:lstStyle/>
             <a:p>
               <a:pPr>
@@ -1214,7 +1247,7 @@
           </c:tx>
           <c:spPr>
             <a:solidFill>
-              <a:srgbClr val="548235"/>
+              <a:srgbClr val="595959"/>
             </a:solidFill>
             <a:effectLst/>
           </c:spPr>
@@ -1222,7 +1255,7 @@
           <c:dLbls>
             <c:numFmt formatCode="$#,##0" sourceLinked="0"/>
             <c:txPr>
-              <a:bodyPr/>
+              <a:bodyPr wrap="none"/>
               <a:lstStyle/>
               <a:p>
                 <a:pPr>
@@ -1314,7 +1347,7 @@
         <c:dLbls>
           <c:numFmt formatCode="$#,##0" sourceLinked="0"/>
           <c:txPr>
-            <a:bodyPr/>
+            <a:bodyPr wrap="none"/>
             <a:lstStyle/>
             <a:p>
               <a:pPr>
@@ -1472,59 +1505,15 @@
           </c:tx>
           <c:spPr>
             <a:solidFill>
-              <a:srgbClr val="4472C4"/>
+              <a:srgbClr val="595959"/>
             </a:solidFill>
             <a:effectLst/>
           </c:spPr>
           <c:invertIfNegative val="0"/>
-          <c:dPt>
-            <c:idx val="0"/>
-            <c:invertIfNegative val="0"/>
-            <c:bubble3D val="0"/>
-            <c:spPr>
-              <a:solidFill>
-                <a:srgbClr val="4472C4"/>
-              </a:solidFill>
-              <a:effectLst/>
-            </c:spPr>
-          </c:dPt>
-          <c:dPt>
-            <c:idx val="1"/>
-            <c:invertIfNegative val="0"/>
-            <c:bubble3D val="0"/>
-            <c:spPr>
-              <a:solidFill>
-                <a:srgbClr val="C55A11"/>
-              </a:solidFill>
-              <a:effectLst/>
-            </c:spPr>
-          </c:dPt>
-          <c:dPt>
-            <c:idx val="2"/>
-            <c:invertIfNegative val="0"/>
-            <c:bubble3D val="0"/>
-            <c:spPr>
-              <a:solidFill>
-                <a:srgbClr val="7030A0"/>
-              </a:solidFill>
-              <a:effectLst/>
-            </c:spPr>
-          </c:dPt>
-          <c:dPt>
-            <c:idx val="3"/>
-            <c:invertIfNegative val="0"/>
-            <c:bubble3D val="0"/>
-            <c:spPr>
-              <a:solidFill>
-                <a:srgbClr val="548235"/>
-              </a:solidFill>
-              <a:effectLst/>
-            </c:spPr>
-          </c:dPt>
           <c:dLbls>
             <c:numFmt formatCode="$#,##0" sourceLinked="0"/>
             <c:txPr>
-              <a:bodyPr/>
+              <a:bodyPr wrap="none"/>
               <a:lstStyle/>
               <a:p>
                 <a:pPr>
@@ -1593,7 +1582,7 @@
         <c:dLbls>
           <c:numFmt formatCode="$#,##0" sourceLinked="0"/>
           <c:txPr>
-            <a:bodyPr/>
+            <a:bodyPr wrap="none"/>
             <a:lstStyle/>
             <a:p>
               <a:pPr>
@@ -1670,7 +1659,7 @@
           <c:dLbls>
             <c:numFmt formatCode="$#,##0" sourceLinked="0"/>
             <c:txPr>
-              <a:bodyPr/>
+              <a:bodyPr wrap="none"/>
               <a:lstStyle/>
               <a:p>
                 <a:pPr>
@@ -1740,7 +1729,7 @@
         <c:dLbls>
           <c:numFmt formatCode="$#,##0" sourceLinked="0"/>
           <c:txPr>
-            <a:bodyPr/>
+            <a:bodyPr wrap="none"/>
             <a:lstStyle/>
             <a:p>
               <a:pPr>
@@ -4289,8 +4278,8 @@
           <p:nvPr/>
         </p:nvGraphicFramePr>
         <p:xfrm>
-          <a:off x="4937760" y="2103120"/>
-          <a:ext cx="3931920" cy="3931920"/>
+          <a:off x="4892040" y="2011680"/>
+          <a:ext cx="4023360" cy="4160520"/>
         </p:xfrm>
         <a:graphic xmlns:a="http://schemas.openxmlformats.org/drawingml/2006/main">
           <a:graphicData uri="http://schemas.openxmlformats.org/drawingml/2006/chart">
@@ -4300,63 +4289,7 @@
       </p:graphicFrame>
       <p:sp>
         <p:nvSpPr>
-          <p:cNvPr id="14" name="Share Label"/>
-          <p:cNvSpPr txBox="1"/>
-          <p:nvPr/>
-        </p:nvSpPr>
-        <p:spPr>
-          <a:xfrm>
-            <a:off x="5989320" y="3703320"/>
-            <a:ext cx="1828800" cy="731520"/>
-          </a:xfrm>
-          <a:prstGeom prst="rect">
-            <a:avLst/>
-          </a:prstGeom>
-          <a:noFill/>
-          <a:ln/>
-        </p:spPr>
-        <p:txBody>
-          <a:bodyPr wrap="square" lIns="0" tIns="0" rIns="0" bIns="0" rtlCol="0" anchor="ctr"/>
-          <a:lstStyle/>
-          <a:p>
-            <a:pPr algn="ctr" indent="0" marL="0">
-              <a:buNone/>
-            </a:pPr>
-            <a:r>
-              <a:rPr lang="en-US" sz="1600" b="1" dirty="0">
-                <a:solidFill>
-                  <a:srgbClr val="000000"/>
-                </a:solidFill>
-                <a:latin typeface="Arial" pitchFamily="34" charset="0"/>
-                <a:ea typeface="Arial" pitchFamily="34" charset="-122"/>
-                <a:cs typeface="Arial" pitchFamily="34" charset="-120"/>
-              </a:rPr>
-              <a:t>Share of</a:t>
-            </a:r>
-            <a:endParaRPr lang="en-US" sz="1600" dirty="0"/>
-          </a:p>
-          <a:p>
-            <a:pPr algn="ctr" indent="0" marL="0">
-              <a:buNone/>
-            </a:pPr>
-            <a:r>
-              <a:rPr lang="en-US" sz="1600" b="1" dirty="0">
-                <a:solidFill>
-                  <a:srgbClr val="000000"/>
-                </a:solidFill>
-                <a:latin typeface="Arial" pitchFamily="34" charset="0"/>
-                <a:ea typeface="Arial" pitchFamily="34" charset="-122"/>
-                <a:cs typeface="Arial" pitchFamily="34" charset="-120"/>
-              </a:rPr>
-              <a:t>total budget</a:t>
-            </a:r>
-            <a:endParaRPr lang="en-US" sz="1600" dirty="0"/>
-          </a:p>
-        </p:txBody>
-      </p:sp>
-      <p:sp>
-        <p:nvSpPr>
-          <p:cNvPr id="15" name="Legend Key Advertising"/>
+          <p:cNvPr id="14" name="Legend Key Advertising"/>
           <p:cNvSpPr/>
           <p:nvPr/>
         </p:nvSpPr>
@@ -4369,11 +4302,11 @@
             <a:avLst/>
           </a:prstGeom>
           <a:solidFill>
-            <a:srgbClr val="4472C4"/>
+            <a:srgbClr val="262626"/>
           </a:solidFill>
-          <a:ln w="12700">
+          <a:ln w="9525">
             <a:solidFill>
-              <a:srgbClr val="4472C4"/>
+              <a:srgbClr val="7F7F7F"/>
             </a:solidFill>
             <a:prstDash val="solid"/>
           </a:ln>
@@ -4381,7 +4314,7 @@
       </p:sp>
       <p:sp>
         <p:nvSpPr>
-          <p:cNvPr id="16" name="Legend Advertising"/>
+          <p:cNvPr id="15" name="Legend Advertising"/>
           <p:cNvSpPr txBox="1"/>
           <p:nvPr/>
         </p:nvSpPr>
@@ -4437,7 +4370,7 @@
       </p:sp>
       <p:sp>
         <p:nvSpPr>
-          <p:cNvPr id="17" name="Legend Key Marketing"/>
+          <p:cNvPr id="16" name="Legend Key Marketing"/>
           <p:cNvSpPr/>
           <p:nvPr/>
         </p:nvSpPr>
@@ -4450,11 +4383,11 @@
             <a:avLst/>
           </a:prstGeom>
           <a:solidFill>
-            <a:srgbClr val="C55A11"/>
+            <a:srgbClr val="A6A6A6"/>
           </a:solidFill>
-          <a:ln w="12700">
+          <a:ln w="9525">
             <a:solidFill>
-              <a:srgbClr val="C55A11"/>
+              <a:srgbClr val="7F7F7F"/>
             </a:solidFill>
             <a:prstDash val="solid"/>
           </a:ln>
@@ -4462,7 +4395,7 @@
       </p:sp>
       <p:sp>
         <p:nvSpPr>
-          <p:cNvPr id="18" name="Legend Marketing"/>
+          <p:cNvPr id="17" name="Legend Marketing"/>
           <p:cNvSpPr txBox="1"/>
           <p:nvPr/>
         </p:nvSpPr>
@@ -4518,7 +4451,7 @@
       </p:sp>
       <p:sp>
         <p:nvSpPr>
-          <p:cNvPr id="19" name="Legend Key Public Relations"/>
+          <p:cNvPr id="18" name="Legend Key Public Relations"/>
           <p:cNvSpPr/>
           <p:nvPr/>
         </p:nvSpPr>
@@ -4531,11 +4464,11 @@
             <a:avLst/>
           </a:prstGeom>
           <a:solidFill>
-            <a:srgbClr val="7030A0"/>
+            <a:srgbClr val="595959"/>
           </a:solidFill>
-          <a:ln w="12700">
+          <a:ln w="9525">
             <a:solidFill>
-              <a:srgbClr val="7030A0"/>
+              <a:srgbClr val="7F7F7F"/>
             </a:solidFill>
             <a:prstDash val="solid"/>
           </a:ln>
@@ -4543,7 +4476,7 @@
       </p:sp>
       <p:sp>
         <p:nvSpPr>
-          <p:cNvPr id="20" name="Legend Public Relations"/>
+          <p:cNvPr id="19" name="Legend Public Relations"/>
           <p:cNvSpPr txBox="1"/>
           <p:nvPr/>
         </p:nvSpPr>
@@ -4599,7 +4532,7 @@
       </p:sp>
       <p:sp>
         <p:nvSpPr>
-          <p:cNvPr id="21" name="Legend Key e-Business"/>
+          <p:cNvPr id="20" name="Legend Key e-Business"/>
           <p:cNvSpPr/>
           <p:nvPr/>
         </p:nvSpPr>
@@ -4612,11 +4545,11 @@
             <a:avLst/>
           </a:prstGeom>
           <a:solidFill>
-            <a:srgbClr val="548235"/>
+            <a:srgbClr val="D9D9D9"/>
           </a:solidFill>
-          <a:ln w="12700">
+          <a:ln w="9525">
             <a:solidFill>
-              <a:srgbClr val="548235"/>
+              <a:srgbClr val="7F7F7F"/>
             </a:solidFill>
             <a:prstDash val="solid"/>
           </a:ln>
@@ -4624,7 +4557,7 @@
       </p:sp>
       <p:sp>
         <p:nvSpPr>
-          <p:cNvPr id="22" name="Legend e-Business"/>
+          <p:cNvPr id="21" name="Legend e-Business"/>
           <p:cNvSpPr txBox="1"/>
           <p:nvPr/>
         </p:nvSpPr>
@@ -5165,15 +5098,24 @@
                                   </p:childTnLst>
                                 </p:cTn>
                               </p:par>
+                            </p:childTnLst>
+                          </p:cTn>
+                        </p:par>
+                        <p:par>
+                          <p:cTn id="45" fill="hold">
+                            <p:stCondLst>
+                              <p:cond delay="2500"/>
+                            </p:stCondLst>
+                            <p:childTnLst>
                               <p:par>
-                                <p:cTn id="45" presetID="10" presetClass="entr" presetSubtype="0" fill="hold" grpId="0" nodeType="withEffect">
+                                <p:cTn id="46" presetID="10" presetClass="entr" presetSubtype="0" fill="hold" grpId="0" nodeType="afterEffect">
                                   <p:stCondLst>
                                     <p:cond delay="0"/>
                                   </p:stCondLst>
                                   <p:childTnLst>
                                     <p:set>
                                       <p:cBhvr>
-                                        <p:cTn id="46" dur="1" fill="hold">
+                                        <p:cTn id="47" dur="1" fill="hold">
                                           <p:stCondLst>
                                             <p:cond delay="0"/>
                                           </p:stCondLst>
@@ -5191,7 +5133,7 @@
                                     </p:set>
                                     <p:animEffect transition="in" filter="fade">
                                       <p:cBhvr>
-                                        <p:cTn id="47" dur="500"/>
+                                        <p:cTn id="48" dur="500"/>
                                         <p:tgtEl>
                                           <p:spTgt spid="14"/>
                                         </p:tgtEl>
@@ -5200,17 +5142,8 @@
                                   </p:childTnLst>
                                 </p:cTn>
                               </p:par>
-                            </p:childTnLst>
-                          </p:cTn>
-                        </p:par>
-                        <p:par>
-                          <p:cTn id="48" fill="hold">
-                            <p:stCondLst>
-                              <p:cond delay="2500"/>
-                            </p:stCondLst>
-                            <p:childTnLst>
                               <p:par>
-                                <p:cTn id="49" presetID="10" presetClass="entr" presetSubtype="0" fill="hold" grpId="0" nodeType="afterEffect">
+                                <p:cTn id="49" presetID="10" presetClass="entr" presetSubtype="0" fill="hold" grpId="0" nodeType="withEffect">
                                   <p:stCondLst>
                                     <p:cond delay="0"/>
                                   </p:stCondLst>
@@ -5448,41 +5381,6 @@
                                         <p:cTn id="69" dur="500"/>
                                         <p:tgtEl>
                                           <p:spTgt spid="21"/>
-                                        </p:tgtEl>
-                                      </p:cBhvr>
-                                    </p:animEffect>
-                                  </p:childTnLst>
-                                </p:cTn>
-                              </p:par>
-                              <p:par>
-                                <p:cTn id="70" presetID="10" presetClass="entr" presetSubtype="0" fill="hold" grpId="0" nodeType="withEffect">
-                                  <p:stCondLst>
-                                    <p:cond delay="0"/>
-                                  </p:stCondLst>
-                                  <p:childTnLst>
-                                    <p:set>
-                                      <p:cBhvr>
-                                        <p:cTn id="71" dur="1" fill="hold">
-                                          <p:stCondLst>
-                                            <p:cond delay="0"/>
-                                          </p:stCondLst>
-                                        </p:cTn>
-                                        <p:tgtEl>
-                                          <p:spTgt spid="22"/>
-                                        </p:tgtEl>
-                                        <p:attrNameLst>
-                                          <p:attrName>style.visibility</p:attrName>
-                                        </p:attrNameLst>
-                                      </p:cBhvr>
-                                      <p:to>
-                                        <p:strVal val="visible"/>
-                                      </p:to>
-                                    </p:set>
-                                    <p:animEffect transition="in" filter="fade">
-                                      <p:cBhvr>
-                                        <p:cTn id="72" dur="500"/>
-                                        <p:tgtEl>
-                                          <p:spTgt spid="22"/>
                                         </p:tgtEl>
                                       </p:cBhvr>
                                     </p:animEffect>
@@ -5539,7 +5437,6 @@
       <p:bldP spid="19" grpId="0" animBg="1"/>
       <p:bldP spid="20" grpId="0" animBg="1"/>
       <p:bldP spid="21" grpId="0" animBg="1"/>
-      <p:bldP spid="22" grpId="0" animBg="1"/>
     </p:bldLst>
   </p:timing>
 </p:sld>

</xml_diff>